<commit_message>
Sales: Kohlhammer-Vorlage mit Projektanteil und gewichteter Bilanz
- Neue Folie 'Auch mit anyPIM gibt es ein Projekt': Kohlhammer-Funktionsliste
  grob eingeordnet (Standard / Einrichtung / Projekt -> wird Standard)
- Bilanz gewichtet nach Wirkung (einmalig vs. dauerhaft) statt Kriterien zu zählen
- Entscheidung, Vergleich, Rolle und Fahrplan entsprechend angepasst

Co-Authored-By: Claude Opus 5.5 <noreply@anthropic.com>
Claude-Session: https://claude.ai/code/session_019qs2qjmit64azXVvXyRtsJ
</commit_message>
<xml_diff>
--- a/docs/sales/kohlhammer-anypim-vs-pimcore.pptx
+++ b/docs/sales/kohlhammer-anypim-vs-pimcore.pptx
@@ -780,7 +780,7 @@
           <a:p>
             <a:r>
               <a:rPr lang="en-US" dirty="0"/>
-              <a:t>Neutral ausgezählt: 7 zu 4 bei 5 Unentschieden. Wichtig ist die Gewichtung: Für Kohlhammer zählen laufender Wartungsaufwand, Betriebskomplexität und Lizenz nach Nutzung mehr als ein integriertes CMS oder Portale, weil Website und Shop bestehen bleiben.</a:t>
+              <a:t>Die Bilanz zählt nicht Kriterien, sondern gewichtet nach Wirkung. Pimcores Vorteile – Datenkontinuität beim Umstieg und Plattformbreite – wirken einmalig bzw. nur, wenn Kohlhammer eine Plattform-Konsolidierung will. anyPIMs Vorteile – Updates, Betrieb, Lizenz nach Nutzung und Kohlhammer-Funktionen als Standard – wirken jedes Jahr. Die Plattformfrage offen ansprechen.</a:t>
             </a:r>
             <a:endParaRPr lang="en-US" dirty="0"/>
           </a:p>
@@ -1748,7 +1748,7 @@
           <a:p>
             <a:r>
               <a:rPr lang="en-US" dirty="0"/>
-              <a:t>Transparenz schafft Vertrauen: ONIX ist in beiden Systemen Zusatzaufwand. Bei anyPIM bauen wir es als Standardformat (5-Datei-Konvention über den MappingResolver), wovon Kohlhammer auch bei Updates profitiert.</a:t>
+              <a:t>Bewusst offen: Auch der Wechsel zu anyPIM ist ein Projekt. Die Kohlhammer-Funktionsliste zeigt drei Gruppen – was heute Standard ist, was eingerichtet wird, und was wir bauen. Alles, was wir bauen, wird Teil des Produkts (z. B. EasyCatalog- und ONIX-Export als Standardformate), nicht eine Kundenerweiterung. Das Projekt gibt es auch beim Pimcore-Upgrade – dort als Portierung der Eigenentwicklungen, die danach bei jedem Release wieder gepflegt werden müssen. Herstellung, Honorare und Rechte bleiben in der Verlagssoftware. Ärzteshop und Compu-Anwendung im Workshop klären.</a:t>
             </a:r>
             <a:endParaRPr lang="en-US" dirty="0"/>
           </a:p>
@@ -2931,7 +2931,7 @@
                           <a:ea typeface="Arial" pitchFamily="34" charset="-122"/>
                           <a:cs typeface="Arial" pitchFamily="34" charset="-120"/>
                         </a:rPr>
-                        <a:t>Einmalige Datenübernahme per Export/Import; Pilot in Wochen</a:t>
+                        <a:t>Datenübernahme plus Projekt; Kohlhammer-Funktionen werden Standard im Produkt</a:t>
                       </a:r>
                       <a:endParaRPr lang="en-US" sz="1100" dirty="0">
                         <a:latin typeface="Arial" charset="0"/>
@@ -2999,7 +2999,7 @@
                           <a:ea typeface="Arial" pitchFamily="34" charset="-122"/>
                           <a:cs typeface="Arial" pitchFamily="34" charset="-120"/>
                         </a:rPr>
-                        <a:t>Upgrade über 10 und 11 bis 2026.x; Eigenentwicklungen je Stufe anpassen</a:t>
+                        <a:t>Upgrade über 10 und 11 bis 2026.x; Eigenentwicklungen je Stufe portieren</a:t>
                       </a:r>
                       <a:endParaRPr lang="en-US" sz="1100" dirty="0">
                         <a:latin typeface="Arial" charset="0"/>
@@ -7792,7 +7792,7 @@
                 <a:ea typeface="Arial" pitchFamily="34" charset="-122"/>
                 <a:cs typeface="Arial" pitchFamily="34" charset="-120"/>
               </a:rPr>
-              <a:t>BILANZ</a:t>
+              <a:t>BILANZ: WAS FÜR KOHLHAMMER DEN AUSSCHLAG GIBT</a:t>
             </a:r>
             <a:endParaRPr lang="en-US" sz="3000" dirty="0"/>
           </a:p>
@@ -7831,7 +7831,7 @@
                 <a:ea typeface="Arial" pitchFamily="34" charset="-122"/>
                 <a:cs typeface="Arial" pitchFamily="34" charset="-120"/>
               </a:rPr>
-              <a:t>Ausgezählt über beide Vergleichsfolien.</a:t>
+              <a:t>Nicht die Zahl der Kriterien entscheidet, sondern ob ein Vorteil einmal oder dauerhaft wirkt.</a:t>
             </a:r>
             <a:endParaRPr lang="en-US" sz="1400" dirty="0"/>
           </a:p>
@@ -7915,26 +7915,1976 @@
           </a:p>
         </p:txBody>
       </p:sp>
-      <p:sp>
-        <p:nvSpPr>
-          <p:cNvPr id="6" name="Shape 4"/>
+      <p:graphicFrame>
+        <p:nvGraphicFramePr>
+          <p:cNvPr id="13" name="Table 0"/>
+          <p:cNvGraphicFramePr>
+            <a:graphicFrameLocks noGrp="1"/>
+          </p:cNvGraphicFramePr>
+          <p:nvPr>
+            <p:extLst>
+              <p:ext uri="{D42A27DB-BD31-4B8C-83A1-F6EECF244321}">
+                <p14:modId xmlns:p14="http://schemas.microsoft.com/office/powerpoint/2010/main" val="1579011935"/>
+              </p:ext>
+            </p:extLst>
+          </p:nvPr>
+        </p:nvGraphicFramePr>
+        <p:xfrm>
+          <a:off x="548640" y="1600200"/>
+          <a:ext cx="7406640" cy="914400"/>
+        </p:xfrm>
+        <a:graphic>
+          <a:graphicData uri="http://schemas.openxmlformats.org/drawingml/2006/table">
+            <a:tbl>
+              <a:tblPr/>
+              <a:tblGrid>
+                <a:gridCol w="1737360"/>
+                <a:gridCol w="3611880"/>
+                <a:gridCol w="1005840"/>
+                <a:gridCol w="1051560"/>
+              </a:tblGrid>
+              <a:tr h="384048">
+                <a:tc>
+                  <a:txBody>
+                    <a:bodyPr/>
+                    <a:lstStyle/>
+                    <a:p>
+                      <a:pPr indent="0" marL="0">
+                        <a:buNone/>
+                      </a:pPr>
+                      <a:r>
+                        <a:rPr lang="en-US" sz="1250" dirty="0">
+                          <a:solidFill>
+                            <a:srgbClr val="FFFFFF"/>
+                          </a:solidFill>
+                          <a:latin typeface="Arial" pitchFamily="34" charset="0"/>
+                          <a:ea typeface="Arial" pitchFamily="34" charset="-122"/>
+                          <a:cs typeface="Arial" pitchFamily="34" charset="-120"/>
+                        </a:rPr>
+                        <a:t>Kriterium</a:t>
+                      </a:r>
+                      <a:endParaRPr lang="en-US" sz="1250" dirty="0">
+                        <a:latin typeface="Arial" charset="0"/>
+                        <a:ea typeface="Arial" charset="0"/>
+                        <a:cs typeface="Arial" charset="0"/>
+                      </a:endParaRPr>
+                    </a:p>
+                  </a:txBody>
+                  <a:tcPr marL="91440" marR="91440" marT="64008" marB="64008" anchor="ctr">
+                    <a:lnL w="9525" cap="flat" cmpd="sng" algn="ctr">
+                      <a:solidFill>
+                        <a:srgbClr val="D6DDE3"/>
+                      </a:solidFill>
+                      <a:prstDash val="solid"/>
+                      <a:round/>
+                      <a:headEnd type="none" w="med" len="med"/>
+                      <a:tailEnd type="none" w="med" len="med"/>
+                    </a:lnL>
+                    <a:lnR w="9525" cap="flat" cmpd="sng" algn="ctr">
+                      <a:solidFill>
+                        <a:srgbClr val="D6DDE3"/>
+                      </a:solidFill>
+                      <a:prstDash val="solid"/>
+                      <a:round/>
+                      <a:headEnd type="none" w="med" len="med"/>
+                      <a:tailEnd type="none" w="med" len="med"/>
+                    </a:lnR>
+                    <a:lnT w="9525" cap="flat" cmpd="sng" algn="ctr">
+                      <a:solidFill>
+                        <a:srgbClr val="D6DDE3"/>
+                      </a:solidFill>
+                      <a:prstDash val="solid"/>
+                      <a:round/>
+                      <a:headEnd type="none" w="med" len="med"/>
+                      <a:tailEnd type="none" w="med" len="med"/>
+                    </a:lnT>
+                    <a:lnB w="9525" cap="flat" cmpd="sng" algn="ctr">
+                      <a:solidFill>
+                        <a:srgbClr val="D6DDE3"/>
+                      </a:solidFill>
+                      <a:prstDash val="solid"/>
+                      <a:round/>
+                      <a:headEnd type="none" w="med" len="med"/>
+                      <a:tailEnd type="none" w="med" len="med"/>
+                    </a:lnB>
+                    <a:solidFill>
+                      <a:srgbClr val="000E2F"/>
+                    </a:solidFill>
+                  </a:tcPr>
+                </a:tc>
+                <a:tc>
+                  <a:txBody>
+                    <a:bodyPr/>
+                    <a:lstStyle/>
+                    <a:p>
+                      <a:pPr indent="0" marL="0">
+                        <a:buNone/>
+                      </a:pPr>
+                      <a:r>
+                        <a:rPr lang="en-US" sz="1250" dirty="0">
+                          <a:solidFill>
+                            <a:srgbClr val="FFFFFF"/>
+                          </a:solidFill>
+                          <a:latin typeface="Arial" pitchFamily="34" charset="0"/>
+                          <a:ea typeface="Arial" pitchFamily="34" charset="-122"/>
+                          <a:cs typeface="Arial" pitchFamily="34" charset="-120"/>
+                        </a:rPr>
+                        <a:t>Worum es geht</a:t>
+                      </a:r>
+                      <a:endParaRPr lang="en-US" sz="1250" dirty="0">
+                        <a:latin typeface="Arial" charset="0"/>
+                        <a:ea typeface="Arial" charset="0"/>
+                        <a:cs typeface="Arial" charset="0"/>
+                      </a:endParaRPr>
+                    </a:p>
+                  </a:txBody>
+                  <a:tcPr marL="91440" marR="91440" marT="64008" marB="64008" anchor="ctr">
+                    <a:lnL w="9525" cap="flat" cmpd="sng" algn="ctr">
+                      <a:solidFill>
+                        <a:srgbClr val="D6DDE3"/>
+                      </a:solidFill>
+                      <a:prstDash val="solid"/>
+                      <a:round/>
+                      <a:headEnd type="none" w="med" len="med"/>
+                      <a:tailEnd type="none" w="med" len="med"/>
+                    </a:lnL>
+                    <a:lnR w="9525" cap="flat" cmpd="sng" algn="ctr">
+                      <a:solidFill>
+                        <a:srgbClr val="D6DDE3"/>
+                      </a:solidFill>
+                      <a:prstDash val="solid"/>
+                      <a:round/>
+                      <a:headEnd type="none" w="med" len="med"/>
+                      <a:tailEnd type="none" w="med" len="med"/>
+                    </a:lnR>
+                    <a:lnT w="9525" cap="flat" cmpd="sng" algn="ctr">
+                      <a:solidFill>
+                        <a:srgbClr val="D6DDE3"/>
+                      </a:solidFill>
+                      <a:prstDash val="solid"/>
+                      <a:round/>
+                      <a:headEnd type="none" w="med" len="med"/>
+                      <a:tailEnd type="none" w="med" len="med"/>
+                    </a:lnT>
+                    <a:lnB w="9525" cap="flat" cmpd="sng" algn="ctr">
+                      <a:solidFill>
+                        <a:srgbClr val="D6DDE3"/>
+                      </a:solidFill>
+                      <a:prstDash val="solid"/>
+                      <a:round/>
+                      <a:headEnd type="none" w="med" len="med"/>
+                      <a:tailEnd type="none" w="med" len="med"/>
+                    </a:lnB>
+                    <a:solidFill>
+                      <a:srgbClr val="000E2F"/>
+                    </a:solidFill>
+                  </a:tcPr>
+                </a:tc>
+                <a:tc>
+                  <a:txBody>
+                    <a:bodyPr/>
+                    <a:lstStyle/>
+                    <a:p>
+                      <a:pPr indent="0" marL="0">
+                        <a:buNone/>
+                      </a:pPr>
+                      <a:r>
+                        <a:rPr lang="en-US" sz="1250" dirty="0">
+                          <a:solidFill>
+                            <a:srgbClr val="FFFFFF"/>
+                          </a:solidFill>
+                          <a:latin typeface="Arial" pitchFamily="34" charset="0"/>
+                          <a:ea typeface="Arial" pitchFamily="34" charset="-122"/>
+                          <a:cs typeface="Arial" pitchFamily="34" charset="-120"/>
+                        </a:rPr>
+                        <a:t>Wirkung</a:t>
+                      </a:r>
+                      <a:endParaRPr lang="en-US" sz="1250" dirty="0">
+                        <a:latin typeface="Arial" charset="0"/>
+                        <a:ea typeface="Arial" charset="0"/>
+                        <a:cs typeface="Arial" charset="0"/>
+                      </a:endParaRPr>
+                    </a:p>
+                  </a:txBody>
+                  <a:tcPr marL="91440" marR="91440" marT="64008" marB="64008" anchor="ctr">
+                    <a:lnL w="9525" cap="flat" cmpd="sng" algn="ctr">
+                      <a:solidFill>
+                        <a:srgbClr val="D6DDE3"/>
+                      </a:solidFill>
+                      <a:prstDash val="solid"/>
+                      <a:round/>
+                      <a:headEnd type="none" w="med" len="med"/>
+                      <a:tailEnd type="none" w="med" len="med"/>
+                    </a:lnL>
+                    <a:lnR w="9525" cap="flat" cmpd="sng" algn="ctr">
+                      <a:solidFill>
+                        <a:srgbClr val="D6DDE3"/>
+                      </a:solidFill>
+                      <a:prstDash val="solid"/>
+                      <a:round/>
+                      <a:headEnd type="none" w="med" len="med"/>
+                      <a:tailEnd type="none" w="med" len="med"/>
+                    </a:lnR>
+                    <a:lnT w="9525" cap="flat" cmpd="sng" algn="ctr">
+                      <a:solidFill>
+                        <a:srgbClr val="D6DDE3"/>
+                      </a:solidFill>
+                      <a:prstDash val="solid"/>
+                      <a:round/>
+                      <a:headEnd type="none" w="med" len="med"/>
+                      <a:tailEnd type="none" w="med" len="med"/>
+                    </a:lnT>
+                    <a:lnB w="9525" cap="flat" cmpd="sng" algn="ctr">
+                      <a:solidFill>
+                        <a:srgbClr val="D6DDE3"/>
+                      </a:solidFill>
+                      <a:prstDash val="solid"/>
+                      <a:round/>
+                      <a:headEnd type="none" w="med" len="med"/>
+                      <a:tailEnd type="none" w="med" len="med"/>
+                    </a:lnB>
+                    <a:solidFill>
+                      <a:srgbClr val="000E2F"/>
+                    </a:solidFill>
+                  </a:tcPr>
+                </a:tc>
+                <a:tc>
+                  <a:txBody>
+                    <a:bodyPr/>
+                    <a:lstStyle/>
+                    <a:p>
+                      <a:pPr indent="0" marL="0">
+                        <a:buNone/>
+                      </a:pPr>
+                      <a:r>
+                        <a:rPr lang="en-US" sz="1250" dirty="0">
+                          <a:solidFill>
+                            <a:srgbClr val="FFFFFF"/>
+                          </a:solidFill>
+                          <a:latin typeface="Arial" pitchFamily="34" charset="0"/>
+                          <a:ea typeface="Arial" pitchFamily="34" charset="-122"/>
+                          <a:cs typeface="Arial" pitchFamily="34" charset="-120"/>
+                        </a:rPr>
+                        <a:t>Vorteil</a:t>
+                      </a:r>
+                      <a:endParaRPr lang="en-US" sz="1250" dirty="0">
+                        <a:latin typeface="Arial" charset="0"/>
+                        <a:ea typeface="Arial" charset="0"/>
+                        <a:cs typeface="Arial" charset="0"/>
+                      </a:endParaRPr>
+                    </a:p>
+                  </a:txBody>
+                  <a:tcPr marL="91440" marR="91440" marT="64008" marB="64008" anchor="ctr">
+                    <a:lnL w="9525" cap="flat" cmpd="sng" algn="ctr">
+                      <a:solidFill>
+                        <a:srgbClr val="D6DDE3"/>
+                      </a:solidFill>
+                      <a:prstDash val="solid"/>
+                      <a:round/>
+                      <a:headEnd type="none" w="med" len="med"/>
+                      <a:tailEnd type="none" w="med" len="med"/>
+                    </a:lnL>
+                    <a:lnR w="9525" cap="flat" cmpd="sng" algn="ctr">
+                      <a:solidFill>
+                        <a:srgbClr val="D6DDE3"/>
+                      </a:solidFill>
+                      <a:prstDash val="solid"/>
+                      <a:round/>
+                      <a:headEnd type="none" w="med" len="med"/>
+                      <a:tailEnd type="none" w="med" len="med"/>
+                    </a:lnR>
+                    <a:lnT w="9525" cap="flat" cmpd="sng" algn="ctr">
+                      <a:solidFill>
+                        <a:srgbClr val="D6DDE3"/>
+                      </a:solidFill>
+                      <a:prstDash val="solid"/>
+                      <a:round/>
+                      <a:headEnd type="none" w="med" len="med"/>
+                      <a:tailEnd type="none" w="med" len="med"/>
+                    </a:lnT>
+                    <a:lnB w="9525" cap="flat" cmpd="sng" algn="ctr">
+                      <a:solidFill>
+                        <a:srgbClr val="D6DDE3"/>
+                      </a:solidFill>
+                      <a:prstDash val="solid"/>
+                      <a:round/>
+                      <a:headEnd type="none" w="med" len="med"/>
+                      <a:tailEnd type="none" w="med" len="med"/>
+                    </a:lnB>
+                    <a:solidFill>
+                      <a:srgbClr val="000E2F"/>
+                    </a:solidFill>
+                  </a:tcPr>
+                </a:tc>
+              </a:tr>
+              <a:tr h="603504">
+                <a:tc>
+                  <a:txBody>
+                    <a:bodyPr/>
+                    <a:lstStyle/>
+                    <a:p>
+                      <a:pPr indent="0" marL="0">
+                        <a:buNone/>
+                      </a:pPr>
+                      <a:r>
+                        <a:rPr lang="en-US" sz="1150" b="1" dirty="0">
+                          <a:solidFill>
+                            <a:srgbClr val="16181D"/>
+                          </a:solidFill>
+                          <a:latin typeface="Arial" pitchFamily="34" charset="0"/>
+                          <a:ea typeface="Arial" pitchFamily="34" charset="-122"/>
+                          <a:cs typeface="Arial" pitchFamily="34" charset="-120"/>
+                        </a:rPr>
+                        <a:t>Laufende Updates</a:t>
+                      </a:r>
+                      <a:endParaRPr lang="en-US" sz="1150" dirty="0">
+                        <a:latin typeface="Arial" charset="0"/>
+                        <a:ea typeface="Arial" charset="0"/>
+                        <a:cs typeface="Arial" charset="0"/>
+                      </a:endParaRPr>
+                    </a:p>
+                  </a:txBody>
+                  <a:tcPr marL="91440" marR="91440" marT="64008" marB="64008" anchor="ctr">
+                    <a:lnL w="9525" cap="flat" cmpd="sng" algn="ctr">
+                      <a:solidFill>
+                        <a:srgbClr val="D6DDE3"/>
+                      </a:solidFill>
+                      <a:prstDash val="solid"/>
+                      <a:round/>
+                      <a:headEnd type="none" w="med" len="med"/>
+                      <a:tailEnd type="none" w="med" len="med"/>
+                    </a:lnL>
+                    <a:lnR w="9525" cap="flat" cmpd="sng" algn="ctr">
+                      <a:solidFill>
+                        <a:srgbClr val="D6DDE3"/>
+                      </a:solidFill>
+                      <a:prstDash val="solid"/>
+                      <a:round/>
+                      <a:headEnd type="none" w="med" len="med"/>
+                      <a:tailEnd type="none" w="med" len="med"/>
+                    </a:lnR>
+                    <a:lnT w="9525" cap="flat" cmpd="sng" algn="ctr">
+                      <a:solidFill>
+                        <a:srgbClr val="D6DDE3"/>
+                      </a:solidFill>
+                      <a:prstDash val="solid"/>
+                      <a:round/>
+                      <a:headEnd type="none" w="med" len="med"/>
+                      <a:tailEnd type="none" w="med" len="med"/>
+                    </a:lnT>
+                    <a:lnB w="9525" cap="flat" cmpd="sng" algn="ctr">
+                      <a:solidFill>
+                        <a:srgbClr val="D6DDE3"/>
+                      </a:solidFill>
+                      <a:prstDash val="solid"/>
+                      <a:round/>
+                      <a:headEnd type="none" w="med" len="med"/>
+                      <a:tailEnd type="none" w="med" len="med"/>
+                    </a:lnB>
+                    <a:solidFill>
+                      <a:srgbClr val="FFFFFF"/>
+                    </a:solidFill>
+                  </a:tcPr>
+                </a:tc>
+                <a:tc>
+                  <a:txBody>
+                    <a:bodyPr/>
+                    <a:lstStyle/>
+                    <a:p>
+                      <a:pPr indent="0" marL="0">
+                        <a:buNone/>
+                      </a:pPr>
+                      <a:r>
+                        <a:rPr lang="en-US" sz="1150" dirty="0">
+                          <a:solidFill>
+                            <a:srgbClr val="16181D"/>
+                          </a:solidFill>
+                          <a:latin typeface="Arial" pitchFamily="34" charset="0"/>
+                          <a:ea typeface="Arial" pitchFamily="34" charset="-122"/>
+                          <a:cs typeface="Arial" pitchFamily="34" charset="-120"/>
+                        </a:rPr>
+                        <a:t>Update per Skript statt Nachziehen jedes Pimcore-Releases</a:t>
+                      </a:r>
+                      <a:endParaRPr lang="en-US" sz="1150" dirty="0">
+                        <a:latin typeface="Arial" charset="0"/>
+                        <a:ea typeface="Arial" charset="0"/>
+                        <a:cs typeface="Arial" charset="0"/>
+                      </a:endParaRPr>
+                    </a:p>
+                  </a:txBody>
+                  <a:tcPr marL="91440" marR="91440" marT="64008" marB="64008" anchor="ctr">
+                    <a:lnL w="9525" cap="flat" cmpd="sng" algn="ctr">
+                      <a:solidFill>
+                        <a:srgbClr val="D6DDE3"/>
+                      </a:solidFill>
+                      <a:prstDash val="solid"/>
+                      <a:round/>
+                      <a:headEnd type="none" w="med" len="med"/>
+                      <a:tailEnd type="none" w="med" len="med"/>
+                    </a:lnL>
+                    <a:lnR w="9525" cap="flat" cmpd="sng" algn="ctr">
+                      <a:solidFill>
+                        <a:srgbClr val="D6DDE3"/>
+                      </a:solidFill>
+                      <a:prstDash val="solid"/>
+                      <a:round/>
+                      <a:headEnd type="none" w="med" len="med"/>
+                      <a:tailEnd type="none" w="med" len="med"/>
+                    </a:lnR>
+                    <a:lnT w="9525" cap="flat" cmpd="sng" algn="ctr">
+                      <a:solidFill>
+                        <a:srgbClr val="D6DDE3"/>
+                      </a:solidFill>
+                      <a:prstDash val="solid"/>
+                      <a:round/>
+                      <a:headEnd type="none" w="med" len="med"/>
+                      <a:tailEnd type="none" w="med" len="med"/>
+                    </a:lnT>
+                    <a:lnB w="9525" cap="flat" cmpd="sng" algn="ctr">
+                      <a:solidFill>
+                        <a:srgbClr val="D6DDE3"/>
+                      </a:solidFill>
+                      <a:prstDash val="solid"/>
+                      <a:round/>
+                      <a:headEnd type="none" w="med" len="med"/>
+                      <a:tailEnd type="none" w="med" len="med"/>
+                    </a:lnB>
+                    <a:solidFill>
+                      <a:srgbClr val="FFFFFF"/>
+                    </a:solidFill>
+                  </a:tcPr>
+                </a:tc>
+                <a:tc>
+                  <a:txBody>
+                    <a:bodyPr/>
+                    <a:lstStyle/>
+                    <a:p>
+                      <a:pPr indent="0" marL="0">
+                        <a:buNone/>
+                      </a:pPr>
+                      <a:r>
+                        <a:rPr lang="en-US" sz="1150" b="1" dirty="0">
+                          <a:solidFill>
+                            <a:srgbClr val="000E2F"/>
+                          </a:solidFill>
+                          <a:latin typeface="Arial" pitchFamily="34" charset="0"/>
+                          <a:ea typeface="Arial" pitchFamily="34" charset="-122"/>
+                          <a:cs typeface="Arial" pitchFamily="34" charset="-120"/>
+                        </a:rPr>
+                        <a:t>dauerhaft</a:t>
+                      </a:r>
+                      <a:endParaRPr lang="en-US" sz="1150" dirty="0">
+                        <a:latin typeface="Arial" charset="0"/>
+                        <a:ea typeface="Arial" charset="0"/>
+                        <a:cs typeface="Arial" charset="0"/>
+                      </a:endParaRPr>
+                    </a:p>
+                  </a:txBody>
+                  <a:tcPr marL="91440" marR="91440" marT="64008" marB="64008" anchor="ctr">
+                    <a:lnL w="9525" cap="flat" cmpd="sng" algn="ctr">
+                      <a:solidFill>
+                        <a:srgbClr val="D6DDE3"/>
+                      </a:solidFill>
+                      <a:prstDash val="solid"/>
+                      <a:round/>
+                      <a:headEnd type="none" w="med" len="med"/>
+                      <a:tailEnd type="none" w="med" len="med"/>
+                    </a:lnL>
+                    <a:lnR w="9525" cap="flat" cmpd="sng" algn="ctr">
+                      <a:solidFill>
+                        <a:srgbClr val="D6DDE3"/>
+                      </a:solidFill>
+                      <a:prstDash val="solid"/>
+                      <a:round/>
+                      <a:headEnd type="none" w="med" len="med"/>
+                      <a:tailEnd type="none" w="med" len="med"/>
+                    </a:lnR>
+                    <a:lnT w="9525" cap="flat" cmpd="sng" algn="ctr">
+                      <a:solidFill>
+                        <a:srgbClr val="D6DDE3"/>
+                      </a:solidFill>
+                      <a:prstDash val="solid"/>
+                      <a:round/>
+                      <a:headEnd type="none" w="med" len="med"/>
+                      <a:tailEnd type="none" w="med" len="med"/>
+                    </a:lnT>
+                    <a:lnB w="9525" cap="flat" cmpd="sng" algn="ctr">
+                      <a:solidFill>
+                        <a:srgbClr val="D6DDE3"/>
+                      </a:solidFill>
+                      <a:prstDash val="solid"/>
+                      <a:round/>
+                      <a:headEnd type="none" w="med" len="med"/>
+                      <a:tailEnd type="none" w="med" len="med"/>
+                    </a:lnB>
+                    <a:solidFill>
+                      <a:srgbClr val="FFFFFF"/>
+                    </a:solidFill>
+                  </a:tcPr>
+                </a:tc>
+                <a:tc>
+                  <a:txBody>
+                    <a:bodyPr/>
+                    <a:lstStyle/>
+                    <a:p>
+                      <a:pPr algn="ctr" indent="0" marL="0">
+                        <a:buNone/>
+                      </a:pPr>
+                      <a:r>
+                        <a:rPr lang="en-US" sz="1150" b="1" dirty="0">
+                          <a:solidFill>
+                            <a:srgbClr val="0F7A4D"/>
+                          </a:solidFill>
+                          <a:latin typeface="Arial" pitchFamily="34" charset="0"/>
+                          <a:ea typeface="Arial" pitchFamily="34" charset="-122"/>
+                          <a:cs typeface="Arial" pitchFamily="34" charset="-120"/>
+                        </a:rPr>
+                        <a:t>anyPIM</a:t>
+                      </a:r>
+                      <a:endParaRPr lang="en-US" sz="1150" dirty="0">
+                        <a:latin typeface="Arial" charset="0"/>
+                        <a:ea typeface="Arial" charset="0"/>
+                        <a:cs typeface="Arial" charset="0"/>
+                      </a:endParaRPr>
+                    </a:p>
+                  </a:txBody>
+                  <a:tcPr marL="91440" marR="91440" marT="64008" marB="64008" anchor="ctr">
+                    <a:lnL w="9525" cap="flat" cmpd="sng" algn="ctr">
+                      <a:solidFill>
+                        <a:srgbClr val="D6DDE3"/>
+                      </a:solidFill>
+                      <a:prstDash val="solid"/>
+                      <a:round/>
+                      <a:headEnd type="none" w="med" len="med"/>
+                      <a:tailEnd type="none" w="med" len="med"/>
+                    </a:lnL>
+                    <a:lnR w="9525" cap="flat" cmpd="sng" algn="ctr">
+                      <a:solidFill>
+                        <a:srgbClr val="D6DDE3"/>
+                      </a:solidFill>
+                      <a:prstDash val="solid"/>
+                      <a:round/>
+                      <a:headEnd type="none" w="med" len="med"/>
+                      <a:tailEnd type="none" w="med" len="med"/>
+                    </a:lnR>
+                    <a:lnT w="9525" cap="flat" cmpd="sng" algn="ctr">
+                      <a:solidFill>
+                        <a:srgbClr val="D6DDE3"/>
+                      </a:solidFill>
+                      <a:prstDash val="solid"/>
+                      <a:round/>
+                      <a:headEnd type="none" w="med" len="med"/>
+                      <a:tailEnd type="none" w="med" len="med"/>
+                    </a:lnT>
+                    <a:lnB w="9525" cap="flat" cmpd="sng" algn="ctr">
+                      <a:solidFill>
+                        <a:srgbClr val="D6DDE3"/>
+                      </a:solidFill>
+                      <a:prstDash val="solid"/>
+                      <a:round/>
+                      <a:headEnd type="none" w="med" len="med"/>
+                      <a:tailEnd type="none" w="med" len="med"/>
+                    </a:lnB>
+                    <a:solidFill>
+                      <a:srgbClr val="DFF3EA"/>
+                    </a:solidFill>
+                  </a:tcPr>
+                </a:tc>
+              </a:tr>
+              <a:tr h="603504">
+                <a:tc>
+                  <a:txBody>
+                    <a:bodyPr/>
+                    <a:lstStyle/>
+                    <a:p>
+                      <a:pPr indent="0" marL="0">
+                        <a:buNone/>
+                      </a:pPr>
+                      <a:r>
+                        <a:rPr lang="en-US" sz="1150" b="1" dirty="0">
+                          <a:solidFill>
+                            <a:srgbClr val="16181D"/>
+                          </a:solidFill>
+                          <a:latin typeface="Arial" pitchFamily="34" charset="0"/>
+                          <a:ea typeface="Arial" pitchFamily="34" charset="-122"/>
+                          <a:cs typeface="Arial" pitchFamily="34" charset="-120"/>
+                        </a:rPr>
+                        <a:t>Betrieb</a:t>
+                      </a:r>
+                      <a:endParaRPr lang="en-US" sz="1150" dirty="0">
+                        <a:latin typeface="Arial" charset="0"/>
+                        <a:ea typeface="Arial" charset="0"/>
+                        <a:cs typeface="Arial" charset="0"/>
+                      </a:endParaRPr>
+                    </a:p>
+                  </a:txBody>
+                  <a:tcPr marL="91440" marR="91440" marT="64008" marB="64008" anchor="ctr">
+                    <a:lnL w="9525" cap="flat" cmpd="sng" algn="ctr">
+                      <a:solidFill>
+                        <a:srgbClr val="D6DDE3"/>
+                      </a:solidFill>
+                      <a:prstDash val="solid"/>
+                      <a:round/>
+                      <a:headEnd type="none" w="med" len="med"/>
+                      <a:tailEnd type="none" w="med" len="med"/>
+                    </a:lnL>
+                    <a:lnR w="9525" cap="flat" cmpd="sng" algn="ctr">
+                      <a:solidFill>
+                        <a:srgbClr val="D6DDE3"/>
+                      </a:solidFill>
+                      <a:prstDash val="solid"/>
+                      <a:round/>
+                      <a:headEnd type="none" w="med" len="med"/>
+                      <a:tailEnd type="none" w="med" len="med"/>
+                    </a:lnR>
+                    <a:lnT w="9525" cap="flat" cmpd="sng" algn="ctr">
+                      <a:solidFill>
+                        <a:srgbClr val="D6DDE3"/>
+                      </a:solidFill>
+                      <a:prstDash val="solid"/>
+                      <a:round/>
+                      <a:headEnd type="none" w="med" len="med"/>
+                      <a:tailEnd type="none" w="med" len="med"/>
+                    </a:lnT>
+                    <a:lnB w="9525" cap="flat" cmpd="sng" algn="ctr">
+                      <a:solidFill>
+                        <a:srgbClr val="D6DDE3"/>
+                      </a:solidFill>
+                      <a:prstDash val="solid"/>
+                      <a:round/>
+                      <a:headEnd type="none" w="med" len="med"/>
+                      <a:tailEnd type="none" w="med" len="med"/>
+                    </a:lnB>
+                    <a:solidFill>
+                      <a:srgbClr val="F7F9FA"/>
+                    </a:solidFill>
+                  </a:tcPr>
+                </a:tc>
+                <a:tc>
+                  <a:txBody>
+                    <a:bodyPr/>
+                    <a:lstStyle/>
+                    <a:p>
+                      <a:pPr indent="0" marL="0">
+                        <a:buNone/>
+                      </a:pPr>
+                      <a:r>
+                        <a:rPr lang="en-US" sz="1150" dirty="0">
+                          <a:solidFill>
+                            <a:srgbClr val="16181D"/>
+                          </a:solidFill>
+                          <a:latin typeface="Arial" pitchFamily="34" charset="0"/>
+                          <a:ea typeface="Arial" pitchFamily="34" charset="-122"/>
+                          <a:cs typeface="Arial" pitchFamily="34" charset="-120"/>
+                        </a:rPr>
+                        <a:t>Nativer Betrieb ohne Docker und OpenSearch</a:t>
+                      </a:r>
+                      <a:endParaRPr lang="en-US" sz="1150" dirty="0">
+                        <a:latin typeface="Arial" charset="0"/>
+                        <a:ea typeface="Arial" charset="0"/>
+                        <a:cs typeface="Arial" charset="0"/>
+                      </a:endParaRPr>
+                    </a:p>
+                  </a:txBody>
+                  <a:tcPr marL="91440" marR="91440" marT="64008" marB="64008" anchor="ctr">
+                    <a:lnL w="9525" cap="flat" cmpd="sng" algn="ctr">
+                      <a:solidFill>
+                        <a:srgbClr val="D6DDE3"/>
+                      </a:solidFill>
+                      <a:prstDash val="solid"/>
+                      <a:round/>
+                      <a:headEnd type="none" w="med" len="med"/>
+                      <a:tailEnd type="none" w="med" len="med"/>
+                    </a:lnL>
+                    <a:lnR w="9525" cap="flat" cmpd="sng" algn="ctr">
+                      <a:solidFill>
+                        <a:srgbClr val="D6DDE3"/>
+                      </a:solidFill>
+                      <a:prstDash val="solid"/>
+                      <a:round/>
+                      <a:headEnd type="none" w="med" len="med"/>
+                      <a:tailEnd type="none" w="med" len="med"/>
+                    </a:lnR>
+                    <a:lnT w="9525" cap="flat" cmpd="sng" algn="ctr">
+                      <a:solidFill>
+                        <a:srgbClr val="D6DDE3"/>
+                      </a:solidFill>
+                      <a:prstDash val="solid"/>
+                      <a:round/>
+                      <a:headEnd type="none" w="med" len="med"/>
+                      <a:tailEnd type="none" w="med" len="med"/>
+                    </a:lnT>
+                    <a:lnB w="9525" cap="flat" cmpd="sng" algn="ctr">
+                      <a:solidFill>
+                        <a:srgbClr val="D6DDE3"/>
+                      </a:solidFill>
+                      <a:prstDash val="solid"/>
+                      <a:round/>
+                      <a:headEnd type="none" w="med" len="med"/>
+                      <a:tailEnd type="none" w="med" len="med"/>
+                    </a:lnB>
+                    <a:solidFill>
+                      <a:srgbClr val="F7F9FA"/>
+                    </a:solidFill>
+                  </a:tcPr>
+                </a:tc>
+                <a:tc>
+                  <a:txBody>
+                    <a:bodyPr/>
+                    <a:lstStyle/>
+                    <a:p>
+                      <a:pPr indent="0" marL="0">
+                        <a:buNone/>
+                      </a:pPr>
+                      <a:r>
+                        <a:rPr lang="en-US" sz="1150" b="1" dirty="0">
+                          <a:solidFill>
+                            <a:srgbClr val="000E2F"/>
+                          </a:solidFill>
+                          <a:latin typeface="Arial" pitchFamily="34" charset="0"/>
+                          <a:ea typeface="Arial" pitchFamily="34" charset="-122"/>
+                          <a:cs typeface="Arial" pitchFamily="34" charset="-120"/>
+                        </a:rPr>
+                        <a:t>dauerhaft</a:t>
+                      </a:r>
+                      <a:endParaRPr lang="en-US" sz="1150" dirty="0">
+                        <a:latin typeface="Arial" charset="0"/>
+                        <a:ea typeface="Arial" charset="0"/>
+                        <a:cs typeface="Arial" charset="0"/>
+                      </a:endParaRPr>
+                    </a:p>
+                  </a:txBody>
+                  <a:tcPr marL="91440" marR="91440" marT="64008" marB="64008" anchor="ctr">
+                    <a:lnL w="9525" cap="flat" cmpd="sng" algn="ctr">
+                      <a:solidFill>
+                        <a:srgbClr val="D6DDE3"/>
+                      </a:solidFill>
+                      <a:prstDash val="solid"/>
+                      <a:round/>
+                      <a:headEnd type="none" w="med" len="med"/>
+                      <a:tailEnd type="none" w="med" len="med"/>
+                    </a:lnL>
+                    <a:lnR w="9525" cap="flat" cmpd="sng" algn="ctr">
+                      <a:solidFill>
+                        <a:srgbClr val="D6DDE3"/>
+                      </a:solidFill>
+                      <a:prstDash val="solid"/>
+                      <a:round/>
+                      <a:headEnd type="none" w="med" len="med"/>
+                      <a:tailEnd type="none" w="med" len="med"/>
+                    </a:lnR>
+                    <a:lnT w="9525" cap="flat" cmpd="sng" algn="ctr">
+                      <a:solidFill>
+                        <a:srgbClr val="D6DDE3"/>
+                      </a:solidFill>
+                      <a:prstDash val="solid"/>
+                      <a:round/>
+                      <a:headEnd type="none" w="med" len="med"/>
+                      <a:tailEnd type="none" w="med" len="med"/>
+                    </a:lnT>
+                    <a:lnB w="9525" cap="flat" cmpd="sng" algn="ctr">
+                      <a:solidFill>
+                        <a:srgbClr val="D6DDE3"/>
+                      </a:solidFill>
+                      <a:prstDash val="solid"/>
+                      <a:round/>
+                      <a:headEnd type="none" w="med" len="med"/>
+                      <a:tailEnd type="none" w="med" len="med"/>
+                    </a:lnB>
+                    <a:solidFill>
+                      <a:srgbClr val="F7F9FA"/>
+                    </a:solidFill>
+                  </a:tcPr>
+                </a:tc>
+                <a:tc>
+                  <a:txBody>
+                    <a:bodyPr/>
+                    <a:lstStyle/>
+                    <a:p>
+                      <a:pPr algn="ctr" indent="0" marL="0">
+                        <a:buNone/>
+                      </a:pPr>
+                      <a:r>
+                        <a:rPr lang="en-US" sz="1150" b="1" dirty="0">
+                          <a:solidFill>
+                            <a:srgbClr val="0F7A4D"/>
+                          </a:solidFill>
+                          <a:latin typeface="Arial" pitchFamily="34" charset="0"/>
+                          <a:ea typeface="Arial" pitchFamily="34" charset="-122"/>
+                          <a:cs typeface="Arial" pitchFamily="34" charset="-120"/>
+                        </a:rPr>
+                        <a:t>anyPIM</a:t>
+                      </a:r>
+                      <a:endParaRPr lang="en-US" sz="1150" dirty="0">
+                        <a:latin typeface="Arial" charset="0"/>
+                        <a:ea typeface="Arial" charset="0"/>
+                        <a:cs typeface="Arial" charset="0"/>
+                      </a:endParaRPr>
+                    </a:p>
+                  </a:txBody>
+                  <a:tcPr marL="91440" marR="91440" marT="64008" marB="64008" anchor="ctr">
+                    <a:lnL w="9525" cap="flat" cmpd="sng" algn="ctr">
+                      <a:solidFill>
+                        <a:srgbClr val="D6DDE3"/>
+                      </a:solidFill>
+                      <a:prstDash val="solid"/>
+                      <a:round/>
+                      <a:headEnd type="none" w="med" len="med"/>
+                      <a:tailEnd type="none" w="med" len="med"/>
+                    </a:lnL>
+                    <a:lnR w="9525" cap="flat" cmpd="sng" algn="ctr">
+                      <a:solidFill>
+                        <a:srgbClr val="D6DDE3"/>
+                      </a:solidFill>
+                      <a:prstDash val="solid"/>
+                      <a:round/>
+                      <a:headEnd type="none" w="med" len="med"/>
+                      <a:tailEnd type="none" w="med" len="med"/>
+                    </a:lnR>
+                    <a:lnT w="9525" cap="flat" cmpd="sng" algn="ctr">
+                      <a:solidFill>
+                        <a:srgbClr val="D6DDE3"/>
+                      </a:solidFill>
+                      <a:prstDash val="solid"/>
+                      <a:round/>
+                      <a:headEnd type="none" w="med" len="med"/>
+                      <a:tailEnd type="none" w="med" len="med"/>
+                    </a:lnT>
+                    <a:lnB w="9525" cap="flat" cmpd="sng" algn="ctr">
+                      <a:solidFill>
+                        <a:srgbClr val="D6DDE3"/>
+                      </a:solidFill>
+                      <a:prstDash val="solid"/>
+                      <a:round/>
+                      <a:headEnd type="none" w="med" len="med"/>
+                      <a:tailEnd type="none" w="med" len="med"/>
+                    </a:lnB>
+                    <a:solidFill>
+                      <a:srgbClr val="DFF3EA"/>
+                    </a:solidFill>
+                  </a:tcPr>
+                </a:tc>
+              </a:tr>
+              <a:tr h="603504">
+                <a:tc>
+                  <a:txBody>
+                    <a:bodyPr/>
+                    <a:lstStyle/>
+                    <a:p>
+                      <a:pPr indent="0" marL="0">
+                        <a:buNone/>
+                      </a:pPr>
+                      <a:r>
+                        <a:rPr lang="en-US" sz="1150" b="1" dirty="0">
+                          <a:solidFill>
+                            <a:srgbClr val="16181D"/>
+                          </a:solidFill>
+                          <a:latin typeface="Arial" pitchFamily="34" charset="0"/>
+                          <a:ea typeface="Arial" pitchFamily="34" charset="-122"/>
+                          <a:cs typeface="Arial" pitchFamily="34" charset="-120"/>
+                        </a:rPr>
+                        <a:t>Lizenz</a:t>
+                      </a:r>
+                      <a:endParaRPr lang="en-US" sz="1150" dirty="0">
+                        <a:latin typeface="Arial" charset="0"/>
+                        <a:ea typeface="Arial" charset="0"/>
+                        <a:cs typeface="Arial" charset="0"/>
+                      </a:endParaRPr>
+                    </a:p>
+                  </a:txBody>
+                  <a:tcPr marL="91440" marR="91440" marT="64008" marB="64008" anchor="ctr">
+                    <a:lnL w="9525" cap="flat" cmpd="sng" algn="ctr">
+                      <a:solidFill>
+                        <a:srgbClr val="D6DDE3"/>
+                      </a:solidFill>
+                      <a:prstDash val="solid"/>
+                      <a:round/>
+                      <a:headEnd type="none" w="med" len="med"/>
+                      <a:tailEnd type="none" w="med" len="med"/>
+                    </a:lnL>
+                    <a:lnR w="9525" cap="flat" cmpd="sng" algn="ctr">
+                      <a:solidFill>
+                        <a:srgbClr val="D6DDE3"/>
+                      </a:solidFill>
+                      <a:prstDash val="solid"/>
+                      <a:round/>
+                      <a:headEnd type="none" w="med" len="med"/>
+                      <a:tailEnd type="none" w="med" len="med"/>
+                    </a:lnR>
+                    <a:lnT w="9525" cap="flat" cmpd="sng" algn="ctr">
+                      <a:solidFill>
+                        <a:srgbClr val="D6DDE3"/>
+                      </a:solidFill>
+                      <a:prstDash val="solid"/>
+                      <a:round/>
+                      <a:headEnd type="none" w="med" len="med"/>
+                      <a:tailEnd type="none" w="med" len="med"/>
+                    </a:lnT>
+                    <a:lnB w="9525" cap="flat" cmpd="sng" algn="ctr">
+                      <a:solidFill>
+                        <a:srgbClr val="D6DDE3"/>
+                      </a:solidFill>
+                      <a:prstDash val="solid"/>
+                      <a:round/>
+                      <a:headEnd type="none" w="med" len="med"/>
+                      <a:tailEnd type="none" w="med" len="med"/>
+                    </a:lnB>
+                    <a:solidFill>
+                      <a:srgbClr val="FFFFFF"/>
+                    </a:solidFill>
+                  </a:tcPr>
+                </a:tc>
+                <a:tc>
+                  <a:txBody>
+                    <a:bodyPr/>
+                    <a:lstStyle/>
+                    <a:p>
+                      <a:pPr indent="0" marL="0">
+                        <a:buNone/>
+                      </a:pPr>
+                      <a:r>
+                        <a:rPr lang="en-US" sz="1150" dirty="0">
+                          <a:solidFill>
+                            <a:srgbClr val="16181D"/>
+                          </a:solidFill>
+                          <a:latin typeface="Arial" pitchFamily="34" charset="0"/>
+                          <a:ea typeface="Arial" pitchFamily="34" charset="-122"/>
+                          <a:cs typeface="Arial" pitchFamily="34" charset="-120"/>
+                        </a:rPr>
+                        <a:t>Nur genutzte Module statt Erweiterungen mit wenig Nutzen (Datahub, Portale)</a:t>
+                      </a:r>
+                      <a:endParaRPr lang="en-US" sz="1150" dirty="0">
+                        <a:latin typeface="Arial" charset="0"/>
+                        <a:ea typeface="Arial" charset="0"/>
+                        <a:cs typeface="Arial" charset="0"/>
+                      </a:endParaRPr>
+                    </a:p>
+                  </a:txBody>
+                  <a:tcPr marL="91440" marR="91440" marT="64008" marB="64008" anchor="ctr">
+                    <a:lnL w="9525" cap="flat" cmpd="sng" algn="ctr">
+                      <a:solidFill>
+                        <a:srgbClr val="D6DDE3"/>
+                      </a:solidFill>
+                      <a:prstDash val="solid"/>
+                      <a:round/>
+                      <a:headEnd type="none" w="med" len="med"/>
+                      <a:tailEnd type="none" w="med" len="med"/>
+                    </a:lnL>
+                    <a:lnR w="9525" cap="flat" cmpd="sng" algn="ctr">
+                      <a:solidFill>
+                        <a:srgbClr val="D6DDE3"/>
+                      </a:solidFill>
+                      <a:prstDash val="solid"/>
+                      <a:round/>
+                      <a:headEnd type="none" w="med" len="med"/>
+                      <a:tailEnd type="none" w="med" len="med"/>
+                    </a:lnR>
+                    <a:lnT w="9525" cap="flat" cmpd="sng" algn="ctr">
+                      <a:solidFill>
+                        <a:srgbClr val="D6DDE3"/>
+                      </a:solidFill>
+                      <a:prstDash val="solid"/>
+                      <a:round/>
+                      <a:headEnd type="none" w="med" len="med"/>
+                      <a:tailEnd type="none" w="med" len="med"/>
+                    </a:lnT>
+                    <a:lnB w="9525" cap="flat" cmpd="sng" algn="ctr">
+                      <a:solidFill>
+                        <a:srgbClr val="D6DDE3"/>
+                      </a:solidFill>
+                      <a:prstDash val="solid"/>
+                      <a:round/>
+                      <a:headEnd type="none" w="med" len="med"/>
+                      <a:tailEnd type="none" w="med" len="med"/>
+                    </a:lnB>
+                    <a:solidFill>
+                      <a:srgbClr val="FFFFFF"/>
+                    </a:solidFill>
+                  </a:tcPr>
+                </a:tc>
+                <a:tc>
+                  <a:txBody>
+                    <a:bodyPr/>
+                    <a:lstStyle/>
+                    <a:p>
+                      <a:pPr indent="0" marL="0">
+                        <a:buNone/>
+                      </a:pPr>
+                      <a:r>
+                        <a:rPr lang="en-US" sz="1150" b="1" dirty="0">
+                          <a:solidFill>
+                            <a:srgbClr val="000E2F"/>
+                          </a:solidFill>
+                          <a:latin typeface="Arial" pitchFamily="34" charset="0"/>
+                          <a:ea typeface="Arial" pitchFamily="34" charset="-122"/>
+                          <a:cs typeface="Arial" pitchFamily="34" charset="-120"/>
+                        </a:rPr>
+                        <a:t>dauerhaft</a:t>
+                      </a:r>
+                      <a:endParaRPr lang="en-US" sz="1150" dirty="0">
+                        <a:latin typeface="Arial" charset="0"/>
+                        <a:ea typeface="Arial" charset="0"/>
+                        <a:cs typeface="Arial" charset="0"/>
+                      </a:endParaRPr>
+                    </a:p>
+                  </a:txBody>
+                  <a:tcPr marL="91440" marR="91440" marT="64008" marB="64008" anchor="ctr">
+                    <a:lnL w="9525" cap="flat" cmpd="sng" algn="ctr">
+                      <a:solidFill>
+                        <a:srgbClr val="D6DDE3"/>
+                      </a:solidFill>
+                      <a:prstDash val="solid"/>
+                      <a:round/>
+                      <a:headEnd type="none" w="med" len="med"/>
+                      <a:tailEnd type="none" w="med" len="med"/>
+                    </a:lnL>
+                    <a:lnR w="9525" cap="flat" cmpd="sng" algn="ctr">
+                      <a:solidFill>
+                        <a:srgbClr val="D6DDE3"/>
+                      </a:solidFill>
+                      <a:prstDash val="solid"/>
+                      <a:round/>
+                      <a:headEnd type="none" w="med" len="med"/>
+                      <a:tailEnd type="none" w="med" len="med"/>
+                    </a:lnR>
+                    <a:lnT w="9525" cap="flat" cmpd="sng" algn="ctr">
+                      <a:solidFill>
+                        <a:srgbClr val="D6DDE3"/>
+                      </a:solidFill>
+                      <a:prstDash val="solid"/>
+                      <a:round/>
+                      <a:headEnd type="none" w="med" len="med"/>
+                      <a:tailEnd type="none" w="med" len="med"/>
+                    </a:lnT>
+                    <a:lnB w="9525" cap="flat" cmpd="sng" algn="ctr">
+                      <a:solidFill>
+                        <a:srgbClr val="D6DDE3"/>
+                      </a:solidFill>
+                      <a:prstDash val="solid"/>
+                      <a:round/>
+                      <a:headEnd type="none" w="med" len="med"/>
+                      <a:tailEnd type="none" w="med" len="med"/>
+                    </a:lnB>
+                    <a:solidFill>
+                      <a:srgbClr val="FFFFFF"/>
+                    </a:solidFill>
+                  </a:tcPr>
+                </a:tc>
+                <a:tc>
+                  <a:txBody>
+                    <a:bodyPr/>
+                    <a:lstStyle/>
+                    <a:p>
+                      <a:pPr algn="ctr" indent="0" marL="0">
+                        <a:buNone/>
+                      </a:pPr>
+                      <a:r>
+                        <a:rPr lang="en-US" sz="1150" b="1" dirty="0">
+                          <a:solidFill>
+                            <a:srgbClr val="0F7A4D"/>
+                          </a:solidFill>
+                          <a:latin typeface="Arial" pitchFamily="34" charset="0"/>
+                          <a:ea typeface="Arial" pitchFamily="34" charset="-122"/>
+                          <a:cs typeface="Arial" pitchFamily="34" charset="-120"/>
+                        </a:rPr>
+                        <a:t>anyPIM</a:t>
+                      </a:r>
+                      <a:endParaRPr lang="en-US" sz="1150" dirty="0">
+                        <a:latin typeface="Arial" charset="0"/>
+                        <a:ea typeface="Arial" charset="0"/>
+                        <a:cs typeface="Arial" charset="0"/>
+                      </a:endParaRPr>
+                    </a:p>
+                  </a:txBody>
+                  <a:tcPr marL="91440" marR="91440" marT="64008" marB="64008" anchor="ctr">
+                    <a:lnL w="9525" cap="flat" cmpd="sng" algn="ctr">
+                      <a:solidFill>
+                        <a:srgbClr val="D6DDE3"/>
+                      </a:solidFill>
+                      <a:prstDash val="solid"/>
+                      <a:round/>
+                      <a:headEnd type="none" w="med" len="med"/>
+                      <a:tailEnd type="none" w="med" len="med"/>
+                    </a:lnL>
+                    <a:lnR w="9525" cap="flat" cmpd="sng" algn="ctr">
+                      <a:solidFill>
+                        <a:srgbClr val="D6DDE3"/>
+                      </a:solidFill>
+                      <a:prstDash val="solid"/>
+                      <a:round/>
+                      <a:headEnd type="none" w="med" len="med"/>
+                      <a:tailEnd type="none" w="med" len="med"/>
+                    </a:lnR>
+                    <a:lnT w="9525" cap="flat" cmpd="sng" algn="ctr">
+                      <a:solidFill>
+                        <a:srgbClr val="D6DDE3"/>
+                      </a:solidFill>
+                      <a:prstDash val="solid"/>
+                      <a:round/>
+                      <a:headEnd type="none" w="med" len="med"/>
+                      <a:tailEnd type="none" w="med" len="med"/>
+                    </a:lnT>
+                    <a:lnB w="9525" cap="flat" cmpd="sng" algn="ctr">
+                      <a:solidFill>
+                        <a:srgbClr val="D6DDE3"/>
+                      </a:solidFill>
+                      <a:prstDash val="solid"/>
+                      <a:round/>
+                      <a:headEnd type="none" w="med" len="med"/>
+                      <a:tailEnd type="none" w="med" len="med"/>
+                    </a:lnB>
+                    <a:solidFill>
+                      <a:srgbClr val="DFF3EA"/>
+                    </a:solidFill>
+                  </a:tcPr>
+                </a:tc>
+              </a:tr>
+              <a:tr h="603504">
+                <a:tc>
+                  <a:txBody>
+                    <a:bodyPr/>
+                    <a:lstStyle/>
+                    <a:p>
+                      <a:pPr indent="0" marL="0">
+                        <a:buNone/>
+                      </a:pPr>
+                      <a:r>
+                        <a:rPr lang="en-US" sz="1150" b="1" dirty="0">
+                          <a:solidFill>
+                            <a:srgbClr val="16181D"/>
+                          </a:solidFill>
+                          <a:latin typeface="Arial" pitchFamily="34" charset="0"/>
+                          <a:ea typeface="Arial" pitchFamily="34" charset="-122"/>
+                          <a:cs typeface="Arial" pitchFamily="34" charset="-120"/>
+                        </a:rPr>
+                        <a:t>Kohlhammer-Funktionen</a:t>
+                      </a:r>
+                      <a:endParaRPr lang="en-US" sz="1150" dirty="0">
+                        <a:latin typeface="Arial" charset="0"/>
+                        <a:ea typeface="Arial" charset="0"/>
+                        <a:cs typeface="Arial" charset="0"/>
+                      </a:endParaRPr>
+                    </a:p>
+                  </a:txBody>
+                  <a:tcPr marL="91440" marR="91440" marT="64008" marB="64008" anchor="ctr">
+                    <a:lnL w="9525" cap="flat" cmpd="sng" algn="ctr">
+                      <a:solidFill>
+                        <a:srgbClr val="D6DDE3"/>
+                      </a:solidFill>
+                      <a:prstDash val="solid"/>
+                      <a:round/>
+                      <a:headEnd type="none" w="med" len="med"/>
+                      <a:tailEnd type="none" w="med" len="med"/>
+                    </a:lnL>
+                    <a:lnR w="9525" cap="flat" cmpd="sng" algn="ctr">
+                      <a:solidFill>
+                        <a:srgbClr val="D6DDE3"/>
+                      </a:solidFill>
+                      <a:prstDash val="solid"/>
+                      <a:round/>
+                      <a:headEnd type="none" w="med" len="med"/>
+                      <a:tailEnd type="none" w="med" len="med"/>
+                    </a:lnR>
+                    <a:lnT w="9525" cap="flat" cmpd="sng" algn="ctr">
+                      <a:solidFill>
+                        <a:srgbClr val="D6DDE3"/>
+                      </a:solidFill>
+                      <a:prstDash val="solid"/>
+                      <a:round/>
+                      <a:headEnd type="none" w="med" len="med"/>
+                      <a:tailEnd type="none" w="med" len="med"/>
+                    </a:lnT>
+                    <a:lnB w="9525" cap="flat" cmpd="sng" algn="ctr">
+                      <a:solidFill>
+                        <a:srgbClr val="D6DDE3"/>
+                      </a:solidFill>
+                      <a:prstDash val="solid"/>
+                      <a:round/>
+                      <a:headEnd type="none" w="med" len="med"/>
+                      <a:tailEnd type="none" w="med" len="med"/>
+                    </a:lnB>
+                    <a:solidFill>
+                      <a:srgbClr val="F7F9FA"/>
+                    </a:solidFill>
+                  </a:tcPr>
+                </a:tc>
+                <a:tc>
+                  <a:txBody>
+                    <a:bodyPr/>
+                    <a:lstStyle/>
+                    <a:p>
+                      <a:pPr indent="0" marL="0">
+                        <a:buNone/>
+                      </a:pPr>
+                      <a:r>
+                        <a:rPr lang="en-US" sz="1150" dirty="0">
+                          <a:solidFill>
+                            <a:srgbClr val="16181D"/>
+                          </a:solidFill>
+                          <a:latin typeface="Arial" pitchFamily="34" charset="0"/>
+                          <a:ea typeface="Arial" pitchFamily="34" charset="-122"/>
+                          <a:cs typeface="Arial" pitchFamily="34" charset="-120"/>
+                        </a:rPr>
+                        <a:t>Projekt in beiden Fällen – bei anyPIM danach Standard, bei Pimcore Eigenentwicklung</a:t>
+                      </a:r>
+                      <a:endParaRPr lang="en-US" sz="1150" dirty="0">
+                        <a:latin typeface="Arial" charset="0"/>
+                        <a:ea typeface="Arial" charset="0"/>
+                        <a:cs typeface="Arial" charset="0"/>
+                      </a:endParaRPr>
+                    </a:p>
+                  </a:txBody>
+                  <a:tcPr marL="91440" marR="91440" marT="64008" marB="64008" anchor="ctr">
+                    <a:lnL w="9525" cap="flat" cmpd="sng" algn="ctr">
+                      <a:solidFill>
+                        <a:srgbClr val="D6DDE3"/>
+                      </a:solidFill>
+                      <a:prstDash val="solid"/>
+                      <a:round/>
+                      <a:headEnd type="none" w="med" len="med"/>
+                      <a:tailEnd type="none" w="med" len="med"/>
+                    </a:lnL>
+                    <a:lnR w="9525" cap="flat" cmpd="sng" algn="ctr">
+                      <a:solidFill>
+                        <a:srgbClr val="D6DDE3"/>
+                      </a:solidFill>
+                      <a:prstDash val="solid"/>
+                      <a:round/>
+                      <a:headEnd type="none" w="med" len="med"/>
+                      <a:tailEnd type="none" w="med" len="med"/>
+                    </a:lnR>
+                    <a:lnT w="9525" cap="flat" cmpd="sng" algn="ctr">
+                      <a:solidFill>
+                        <a:srgbClr val="D6DDE3"/>
+                      </a:solidFill>
+                      <a:prstDash val="solid"/>
+                      <a:round/>
+                      <a:headEnd type="none" w="med" len="med"/>
+                      <a:tailEnd type="none" w="med" len="med"/>
+                    </a:lnT>
+                    <a:lnB w="9525" cap="flat" cmpd="sng" algn="ctr">
+                      <a:solidFill>
+                        <a:srgbClr val="D6DDE3"/>
+                      </a:solidFill>
+                      <a:prstDash val="solid"/>
+                      <a:round/>
+                      <a:headEnd type="none" w="med" len="med"/>
+                      <a:tailEnd type="none" w="med" len="med"/>
+                    </a:lnB>
+                    <a:solidFill>
+                      <a:srgbClr val="F7F9FA"/>
+                    </a:solidFill>
+                  </a:tcPr>
+                </a:tc>
+                <a:tc>
+                  <a:txBody>
+                    <a:bodyPr/>
+                    <a:lstStyle/>
+                    <a:p>
+                      <a:pPr indent="0" marL="0">
+                        <a:buNone/>
+                      </a:pPr>
+                      <a:r>
+                        <a:rPr lang="en-US" sz="1150" b="1" dirty="0">
+                          <a:solidFill>
+                            <a:srgbClr val="000E2F"/>
+                          </a:solidFill>
+                          <a:latin typeface="Arial" pitchFamily="34" charset="0"/>
+                          <a:ea typeface="Arial" pitchFamily="34" charset="-122"/>
+                          <a:cs typeface="Arial" pitchFamily="34" charset="-120"/>
+                        </a:rPr>
+                        <a:t>dauerhaft</a:t>
+                      </a:r>
+                      <a:endParaRPr lang="en-US" sz="1150" dirty="0">
+                        <a:latin typeface="Arial" charset="0"/>
+                        <a:ea typeface="Arial" charset="0"/>
+                        <a:cs typeface="Arial" charset="0"/>
+                      </a:endParaRPr>
+                    </a:p>
+                  </a:txBody>
+                  <a:tcPr marL="91440" marR="91440" marT="64008" marB="64008" anchor="ctr">
+                    <a:lnL w="9525" cap="flat" cmpd="sng" algn="ctr">
+                      <a:solidFill>
+                        <a:srgbClr val="D6DDE3"/>
+                      </a:solidFill>
+                      <a:prstDash val="solid"/>
+                      <a:round/>
+                      <a:headEnd type="none" w="med" len="med"/>
+                      <a:tailEnd type="none" w="med" len="med"/>
+                    </a:lnL>
+                    <a:lnR w="9525" cap="flat" cmpd="sng" algn="ctr">
+                      <a:solidFill>
+                        <a:srgbClr val="D6DDE3"/>
+                      </a:solidFill>
+                      <a:prstDash val="solid"/>
+                      <a:round/>
+                      <a:headEnd type="none" w="med" len="med"/>
+                      <a:tailEnd type="none" w="med" len="med"/>
+                    </a:lnR>
+                    <a:lnT w="9525" cap="flat" cmpd="sng" algn="ctr">
+                      <a:solidFill>
+                        <a:srgbClr val="D6DDE3"/>
+                      </a:solidFill>
+                      <a:prstDash val="solid"/>
+                      <a:round/>
+                      <a:headEnd type="none" w="med" len="med"/>
+                      <a:tailEnd type="none" w="med" len="med"/>
+                    </a:lnT>
+                    <a:lnB w="9525" cap="flat" cmpd="sng" algn="ctr">
+                      <a:solidFill>
+                        <a:srgbClr val="D6DDE3"/>
+                      </a:solidFill>
+                      <a:prstDash val="solid"/>
+                      <a:round/>
+                      <a:headEnd type="none" w="med" len="med"/>
+                      <a:tailEnd type="none" w="med" len="med"/>
+                    </a:lnB>
+                    <a:solidFill>
+                      <a:srgbClr val="F7F9FA"/>
+                    </a:solidFill>
+                  </a:tcPr>
+                </a:tc>
+                <a:tc>
+                  <a:txBody>
+                    <a:bodyPr/>
+                    <a:lstStyle/>
+                    <a:p>
+                      <a:pPr algn="ctr" indent="0" marL="0">
+                        <a:buNone/>
+                      </a:pPr>
+                      <a:r>
+                        <a:rPr lang="en-US" sz="1150" b="1" dirty="0">
+                          <a:solidFill>
+                            <a:srgbClr val="0F7A4D"/>
+                          </a:solidFill>
+                          <a:latin typeface="Arial" pitchFamily="34" charset="0"/>
+                          <a:ea typeface="Arial" pitchFamily="34" charset="-122"/>
+                          <a:cs typeface="Arial" pitchFamily="34" charset="-120"/>
+                        </a:rPr>
+                        <a:t>anyPIM</a:t>
+                      </a:r>
+                      <a:endParaRPr lang="en-US" sz="1150" dirty="0">
+                        <a:latin typeface="Arial" charset="0"/>
+                        <a:ea typeface="Arial" charset="0"/>
+                        <a:cs typeface="Arial" charset="0"/>
+                      </a:endParaRPr>
+                    </a:p>
+                  </a:txBody>
+                  <a:tcPr marL="91440" marR="91440" marT="64008" marB="64008" anchor="ctr">
+                    <a:lnL w="9525" cap="flat" cmpd="sng" algn="ctr">
+                      <a:solidFill>
+                        <a:srgbClr val="D6DDE3"/>
+                      </a:solidFill>
+                      <a:prstDash val="solid"/>
+                      <a:round/>
+                      <a:headEnd type="none" w="med" len="med"/>
+                      <a:tailEnd type="none" w="med" len="med"/>
+                    </a:lnL>
+                    <a:lnR w="9525" cap="flat" cmpd="sng" algn="ctr">
+                      <a:solidFill>
+                        <a:srgbClr val="D6DDE3"/>
+                      </a:solidFill>
+                      <a:prstDash val="solid"/>
+                      <a:round/>
+                      <a:headEnd type="none" w="med" len="med"/>
+                      <a:tailEnd type="none" w="med" len="med"/>
+                    </a:lnR>
+                    <a:lnT w="9525" cap="flat" cmpd="sng" algn="ctr">
+                      <a:solidFill>
+                        <a:srgbClr val="D6DDE3"/>
+                      </a:solidFill>
+                      <a:prstDash val="solid"/>
+                      <a:round/>
+                      <a:headEnd type="none" w="med" len="med"/>
+                      <a:tailEnd type="none" w="med" len="med"/>
+                    </a:lnT>
+                    <a:lnB w="9525" cap="flat" cmpd="sng" algn="ctr">
+                      <a:solidFill>
+                        <a:srgbClr val="D6DDE3"/>
+                      </a:solidFill>
+                      <a:prstDash val="solid"/>
+                      <a:round/>
+                      <a:headEnd type="none" w="med" len="med"/>
+                      <a:tailEnd type="none" w="med" len="med"/>
+                    </a:lnB>
+                    <a:solidFill>
+                      <a:srgbClr val="DFF3EA"/>
+                    </a:solidFill>
+                  </a:tcPr>
+                </a:tc>
+              </a:tr>
+              <a:tr h="603504">
+                <a:tc>
+                  <a:txBody>
+                    <a:bodyPr/>
+                    <a:lstStyle/>
+                    <a:p>
+                      <a:pPr indent="0" marL="0">
+                        <a:buNone/>
+                      </a:pPr>
+                      <a:r>
+                        <a:rPr lang="en-US" sz="1150" b="1" dirty="0">
+                          <a:solidFill>
+                            <a:srgbClr val="16181D"/>
+                          </a:solidFill>
+                          <a:latin typeface="Arial" pitchFamily="34" charset="0"/>
+                          <a:ea typeface="Arial" pitchFamily="34" charset="-122"/>
+                          <a:cs typeface="Arial" pitchFamily="34" charset="-120"/>
+                        </a:rPr>
+                        <a:t>Umstellung</a:t>
+                      </a:r>
+                      <a:endParaRPr lang="en-US" sz="1150" dirty="0">
+                        <a:latin typeface="Arial" charset="0"/>
+                        <a:ea typeface="Arial" charset="0"/>
+                        <a:cs typeface="Arial" charset="0"/>
+                      </a:endParaRPr>
+                    </a:p>
+                  </a:txBody>
+                  <a:tcPr marL="91440" marR="91440" marT="64008" marB="64008" anchor="ctr">
+                    <a:lnL w="9525" cap="flat" cmpd="sng" algn="ctr">
+                      <a:solidFill>
+                        <a:srgbClr val="D6DDE3"/>
+                      </a:solidFill>
+                      <a:prstDash val="solid"/>
+                      <a:round/>
+                      <a:headEnd type="none" w="med" len="med"/>
+                      <a:tailEnd type="none" w="med" len="med"/>
+                    </a:lnL>
+                    <a:lnR w="9525" cap="flat" cmpd="sng" algn="ctr">
+                      <a:solidFill>
+                        <a:srgbClr val="D6DDE3"/>
+                      </a:solidFill>
+                      <a:prstDash val="solid"/>
+                      <a:round/>
+                      <a:headEnd type="none" w="med" len="med"/>
+                      <a:tailEnd type="none" w="med" len="med"/>
+                    </a:lnR>
+                    <a:lnT w="9525" cap="flat" cmpd="sng" algn="ctr">
+                      <a:solidFill>
+                        <a:srgbClr val="D6DDE3"/>
+                      </a:solidFill>
+                      <a:prstDash val="solid"/>
+                      <a:round/>
+                      <a:headEnd type="none" w="med" len="med"/>
+                      <a:tailEnd type="none" w="med" len="med"/>
+                    </a:lnT>
+                    <a:lnB w="9525" cap="flat" cmpd="sng" algn="ctr">
+                      <a:solidFill>
+                        <a:srgbClr val="D6DDE3"/>
+                      </a:solidFill>
+                      <a:prstDash val="solid"/>
+                      <a:round/>
+                      <a:headEnd type="none" w="med" len="med"/>
+                      <a:tailEnd type="none" w="med" len="med"/>
+                    </a:lnB>
+                    <a:solidFill>
+                      <a:srgbClr val="FFFFFF"/>
+                    </a:solidFill>
+                  </a:tcPr>
+                </a:tc>
+                <a:tc>
+                  <a:txBody>
+                    <a:bodyPr/>
+                    <a:lstStyle/>
+                    <a:p>
+                      <a:pPr indent="0" marL="0">
+                        <a:buNone/>
+                      </a:pPr>
+                      <a:r>
+                        <a:rPr lang="en-US" sz="1150" dirty="0">
+                          <a:solidFill>
+                            <a:srgbClr val="16181D"/>
+                          </a:solidFill>
+                          <a:latin typeface="Arial" pitchFamily="34" charset="0"/>
+                          <a:ea typeface="Arial" pitchFamily="34" charset="-122"/>
+                          <a:cs typeface="Arial" pitchFamily="34" charset="-120"/>
+                        </a:rPr>
+                        <a:t>Daten bleiben in Pimcore und werden je Version migriert</a:t>
+                      </a:r>
+                      <a:endParaRPr lang="en-US" sz="1150" dirty="0">
+                        <a:latin typeface="Arial" charset="0"/>
+                        <a:ea typeface="Arial" charset="0"/>
+                        <a:cs typeface="Arial" charset="0"/>
+                      </a:endParaRPr>
+                    </a:p>
+                  </a:txBody>
+                  <a:tcPr marL="91440" marR="91440" marT="64008" marB="64008" anchor="ctr">
+                    <a:lnL w="9525" cap="flat" cmpd="sng" algn="ctr">
+                      <a:solidFill>
+                        <a:srgbClr val="D6DDE3"/>
+                      </a:solidFill>
+                      <a:prstDash val="solid"/>
+                      <a:round/>
+                      <a:headEnd type="none" w="med" len="med"/>
+                      <a:tailEnd type="none" w="med" len="med"/>
+                    </a:lnL>
+                    <a:lnR w="9525" cap="flat" cmpd="sng" algn="ctr">
+                      <a:solidFill>
+                        <a:srgbClr val="D6DDE3"/>
+                      </a:solidFill>
+                      <a:prstDash val="solid"/>
+                      <a:round/>
+                      <a:headEnd type="none" w="med" len="med"/>
+                      <a:tailEnd type="none" w="med" len="med"/>
+                    </a:lnR>
+                    <a:lnT w="9525" cap="flat" cmpd="sng" algn="ctr">
+                      <a:solidFill>
+                        <a:srgbClr val="D6DDE3"/>
+                      </a:solidFill>
+                      <a:prstDash val="solid"/>
+                      <a:round/>
+                      <a:headEnd type="none" w="med" len="med"/>
+                      <a:tailEnd type="none" w="med" len="med"/>
+                    </a:lnT>
+                    <a:lnB w="9525" cap="flat" cmpd="sng" algn="ctr">
+                      <a:solidFill>
+                        <a:srgbClr val="D6DDE3"/>
+                      </a:solidFill>
+                      <a:prstDash val="solid"/>
+                      <a:round/>
+                      <a:headEnd type="none" w="med" len="med"/>
+                      <a:tailEnd type="none" w="med" len="med"/>
+                    </a:lnB>
+                    <a:solidFill>
+                      <a:srgbClr val="FFFFFF"/>
+                    </a:solidFill>
+                  </a:tcPr>
+                </a:tc>
+                <a:tc>
+                  <a:txBody>
+                    <a:bodyPr/>
+                    <a:lstStyle/>
+                    <a:p>
+                      <a:pPr indent="0" marL="0">
+                        <a:buNone/>
+                      </a:pPr>
+                      <a:r>
+                        <a:rPr lang="en-US" sz="1150" dirty="0">
+                          <a:solidFill>
+                            <a:srgbClr val="4B5563"/>
+                          </a:solidFill>
+                          <a:latin typeface="Arial" pitchFamily="34" charset="0"/>
+                          <a:ea typeface="Arial" pitchFamily="34" charset="-122"/>
+                          <a:cs typeface="Arial" pitchFamily="34" charset="-120"/>
+                        </a:rPr>
+                        <a:t>einmalig</a:t>
+                      </a:r>
+                      <a:endParaRPr lang="en-US" sz="1150" dirty="0">
+                        <a:latin typeface="Arial" charset="0"/>
+                        <a:ea typeface="Arial" charset="0"/>
+                        <a:cs typeface="Arial" charset="0"/>
+                      </a:endParaRPr>
+                    </a:p>
+                  </a:txBody>
+                  <a:tcPr marL="91440" marR="91440" marT="64008" marB="64008" anchor="ctr">
+                    <a:lnL w="9525" cap="flat" cmpd="sng" algn="ctr">
+                      <a:solidFill>
+                        <a:srgbClr val="D6DDE3"/>
+                      </a:solidFill>
+                      <a:prstDash val="solid"/>
+                      <a:round/>
+                      <a:headEnd type="none" w="med" len="med"/>
+                      <a:tailEnd type="none" w="med" len="med"/>
+                    </a:lnL>
+                    <a:lnR w="9525" cap="flat" cmpd="sng" algn="ctr">
+                      <a:solidFill>
+                        <a:srgbClr val="D6DDE3"/>
+                      </a:solidFill>
+                      <a:prstDash val="solid"/>
+                      <a:round/>
+                      <a:headEnd type="none" w="med" len="med"/>
+                      <a:tailEnd type="none" w="med" len="med"/>
+                    </a:lnR>
+                    <a:lnT w="9525" cap="flat" cmpd="sng" algn="ctr">
+                      <a:solidFill>
+                        <a:srgbClr val="D6DDE3"/>
+                      </a:solidFill>
+                      <a:prstDash val="solid"/>
+                      <a:round/>
+                      <a:headEnd type="none" w="med" len="med"/>
+                      <a:tailEnd type="none" w="med" len="med"/>
+                    </a:lnT>
+                    <a:lnB w="9525" cap="flat" cmpd="sng" algn="ctr">
+                      <a:solidFill>
+                        <a:srgbClr val="D6DDE3"/>
+                      </a:solidFill>
+                      <a:prstDash val="solid"/>
+                      <a:round/>
+                      <a:headEnd type="none" w="med" len="med"/>
+                      <a:tailEnd type="none" w="med" len="med"/>
+                    </a:lnB>
+                    <a:solidFill>
+                      <a:srgbClr val="FFFFFF"/>
+                    </a:solidFill>
+                  </a:tcPr>
+                </a:tc>
+                <a:tc>
+                  <a:txBody>
+                    <a:bodyPr/>
+                    <a:lstStyle/>
+                    <a:p>
+                      <a:pPr algn="ctr" indent="0" marL="0">
+                        <a:buNone/>
+                      </a:pPr>
+                      <a:r>
+                        <a:rPr lang="en-US" sz="1150" b="1" dirty="0">
+                          <a:solidFill>
+                            <a:srgbClr val="1B2D5C"/>
+                          </a:solidFill>
+                          <a:latin typeface="Arial" pitchFamily="34" charset="0"/>
+                          <a:ea typeface="Arial" pitchFamily="34" charset="-122"/>
+                          <a:cs typeface="Arial" pitchFamily="34" charset="-120"/>
+                        </a:rPr>
+                        <a:t>Pimcore</a:t>
+                      </a:r>
+                      <a:endParaRPr lang="en-US" sz="1150" dirty="0">
+                        <a:latin typeface="Arial" charset="0"/>
+                        <a:ea typeface="Arial" charset="0"/>
+                        <a:cs typeface="Arial" charset="0"/>
+                      </a:endParaRPr>
+                    </a:p>
+                  </a:txBody>
+                  <a:tcPr marL="91440" marR="91440" marT="64008" marB="64008" anchor="ctr">
+                    <a:lnL w="9525" cap="flat" cmpd="sng" algn="ctr">
+                      <a:solidFill>
+                        <a:srgbClr val="D6DDE3"/>
+                      </a:solidFill>
+                      <a:prstDash val="solid"/>
+                      <a:round/>
+                      <a:headEnd type="none" w="med" len="med"/>
+                      <a:tailEnd type="none" w="med" len="med"/>
+                    </a:lnL>
+                    <a:lnR w="9525" cap="flat" cmpd="sng" algn="ctr">
+                      <a:solidFill>
+                        <a:srgbClr val="D6DDE3"/>
+                      </a:solidFill>
+                      <a:prstDash val="solid"/>
+                      <a:round/>
+                      <a:headEnd type="none" w="med" len="med"/>
+                      <a:tailEnd type="none" w="med" len="med"/>
+                    </a:lnR>
+                    <a:lnT w="9525" cap="flat" cmpd="sng" algn="ctr">
+                      <a:solidFill>
+                        <a:srgbClr val="D6DDE3"/>
+                      </a:solidFill>
+                      <a:prstDash val="solid"/>
+                      <a:round/>
+                      <a:headEnd type="none" w="med" len="med"/>
+                      <a:tailEnd type="none" w="med" len="med"/>
+                    </a:lnT>
+                    <a:lnB w="9525" cap="flat" cmpd="sng" algn="ctr">
+                      <a:solidFill>
+                        <a:srgbClr val="D6DDE3"/>
+                      </a:solidFill>
+                      <a:prstDash val="solid"/>
+                      <a:round/>
+                      <a:headEnd type="none" w="med" len="med"/>
+                      <a:tailEnd type="none" w="med" len="med"/>
+                    </a:lnB>
+                    <a:solidFill>
+                      <a:srgbClr val="E3E8F4"/>
+                    </a:solidFill>
+                  </a:tcPr>
+                </a:tc>
+              </a:tr>
+              <a:tr h="603504">
+                <a:tc>
+                  <a:txBody>
+                    <a:bodyPr/>
+                    <a:lstStyle/>
+                    <a:p>
+                      <a:pPr indent="0" marL="0">
+                        <a:buNone/>
+                      </a:pPr>
+                      <a:r>
+                        <a:rPr lang="en-US" sz="1150" b="1" dirty="0">
+                          <a:solidFill>
+                            <a:srgbClr val="16181D"/>
+                          </a:solidFill>
+                          <a:latin typeface="Arial" pitchFamily="34" charset="0"/>
+                          <a:ea typeface="Arial" pitchFamily="34" charset="-122"/>
+                          <a:cs typeface="Arial" pitchFamily="34" charset="-120"/>
+                        </a:rPr>
+                        <a:t>Plattformbreite</a:t>
+                      </a:r>
+                      <a:endParaRPr lang="en-US" sz="1150" dirty="0">
+                        <a:latin typeface="Arial" charset="0"/>
+                        <a:ea typeface="Arial" charset="0"/>
+                        <a:cs typeface="Arial" charset="0"/>
+                      </a:endParaRPr>
+                    </a:p>
+                  </a:txBody>
+                  <a:tcPr marL="91440" marR="91440" marT="64008" marB="64008" anchor="ctr">
+                    <a:lnL w="9525" cap="flat" cmpd="sng" algn="ctr">
+                      <a:solidFill>
+                        <a:srgbClr val="D6DDE3"/>
+                      </a:solidFill>
+                      <a:prstDash val="solid"/>
+                      <a:round/>
+                      <a:headEnd type="none" w="med" len="med"/>
+                      <a:tailEnd type="none" w="med" len="med"/>
+                    </a:lnL>
+                    <a:lnR w="9525" cap="flat" cmpd="sng" algn="ctr">
+                      <a:solidFill>
+                        <a:srgbClr val="D6DDE3"/>
+                      </a:solidFill>
+                      <a:prstDash val="solid"/>
+                      <a:round/>
+                      <a:headEnd type="none" w="med" len="med"/>
+                      <a:tailEnd type="none" w="med" len="med"/>
+                    </a:lnR>
+                    <a:lnT w="9525" cap="flat" cmpd="sng" algn="ctr">
+                      <a:solidFill>
+                        <a:srgbClr val="D6DDE3"/>
+                      </a:solidFill>
+                      <a:prstDash val="solid"/>
+                      <a:round/>
+                      <a:headEnd type="none" w="med" len="med"/>
+                      <a:tailEnd type="none" w="med" len="med"/>
+                    </a:lnT>
+                    <a:lnB w="9525" cap="flat" cmpd="sng" algn="ctr">
+                      <a:solidFill>
+                        <a:srgbClr val="D6DDE3"/>
+                      </a:solidFill>
+                      <a:prstDash val="solid"/>
+                      <a:round/>
+                      <a:headEnd type="none" w="med" len="med"/>
+                      <a:tailEnd type="none" w="med" len="med"/>
+                    </a:lnB>
+                    <a:solidFill>
+                      <a:srgbClr val="F7F9FA"/>
+                    </a:solidFill>
+                  </a:tcPr>
+                </a:tc>
+                <a:tc>
+                  <a:txBody>
+                    <a:bodyPr/>
+                    <a:lstStyle/>
+                    <a:p>
+                      <a:pPr indent="0" marL="0">
+                        <a:buNone/>
+                      </a:pPr>
+                      <a:r>
+                        <a:rPr lang="en-US" sz="1150" dirty="0">
+                          <a:solidFill>
+                            <a:srgbClr val="16181D"/>
+                          </a:solidFill>
+                          <a:latin typeface="Arial" pitchFamily="34" charset="0"/>
+                          <a:ea typeface="Arial" pitchFamily="34" charset="-122"/>
+                          <a:cs typeface="Arial" pitchFamily="34" charset="-120"/>
+                        </a:rPr>
+                        <a:t>DAM, CMS und Ökosystem – relevant, wenn Kohlhammer diese konsolidieren will</a:t>
+                      </a:r>
+                      <a:endParaRPr lang="en-US" sz="1150" dirty="0">
+                        <a:latin typeface="Arial" charset="0"/>
+                        <a:ea typeface="Arial" charset="0"/>
+                        <a:cs typeface="Arial" charset="0"/>
+                      </a:endParaRPr>
+                    </a:p>
+                  </a:txBody>
+                  <a:tcPr marL="91440" marR="91440" marT="64008" marB="64008" anchor="ctr">
+                    <a:lnL w="9525" cap="flat" cmpd="sng" algn="ctr">
+                      <a:solidFill>
+                        <a:srgbClr val="D6DDE3"/>
+                      </a:solidFill>
+                      <a:prstDash val="solid"/>
+                      <a:round/>
+                      <a:headEnd type="none" w="med" len="med"/>
+                      <a:tailEnd type="none" w="med" len="med"/>
+                    </a:lnL>
+                    <a:lnR w="9525" cap="flat" cmpd="sng" algn="ctr">
+                      <a:solidFill>
+                        <a:srgbClr val="D6DDE3"/>
+                      </a:solidFill>
+                      <a:prstDash val="solid"/>
+                      <a:round/>
+                      <a:headEnd type="none" w="med" len="med"/>
+                      <a:tailEnd type="none" w="med" len="med"/>
+                    </a:lnR>
+                    <a:lnT w="9525" cap="flat" cmpd="sng" algn="ctr">
+                      <a:solidFill>
+                        <a:srgbClr val="D6DDE3"/>
+                      </a:solidFill>
+                      <a:prstDash val="solid"/>
+                      <a:round/>
+                      <a:headEnd type="none" w="med" len="med"/>
+                      <a:tailEnd type="none" w="med" len="med"/>
+                    </a:lnT>
+                    <a:lnB w="9525" cap="flat" cmpd="sng" algn="ctr">
+                      <a:solidFill>
+                        <a:srgbClr val="D6DDE3"/>
+                      </a:solidFill>
+                      <a:prstDash val="solid"/>
+                      <a:round/>
+                      <a:headEnd type="none" w="med" len="med"/>
+                      <a:tailEnd type="none" w="med" len="med"/>
+                    </a:lnB>
+                    <a:solidFill>
+                      <a:srgbClr val="F7F9FA"/>
+                    </a:solidFill>
+                  </a:tcPr>
+                </a:tc>
+                <a:tc>
+                  <a:txBody>
+                    <a:bodyPr/>
+                    <a:lstStyle/>
+                    <a:p>
+                      <a:pPr indent="0" marL="0">
+                        <a:buNone/>
+                      </a:pPr>
+                      <a:r>
+                        <a:rPr lang="en-US" sz="1150" dirty="0">
+                          <a:solidFill>
+                            <a:srgbClr val="4B5563"/>
+                          </a:solidFill>
+                          <a:latin typeface="Arial" pitchFamily="34" charset="0"/>
+                          <a:ea typeface="Arial" pitchFamily="34" charset="-122"/>
+                          <a:cs typeface="Arial" pitchFamily="34" charset="-120"/>
+                        </a:rPr>
+                        <a:t>nur bei Bedarf</a:t>
+                      </a:r>
+                      <a:endParaRPr lang="en-US" sz="1150" dirty="0">
+                        <a:latin typeface="Arial" charset="0"/>
+                        <a:ea typeface="Arial" charset="0"/>
+                        <a:cs typeface="Arial" charset="0"/>
+                      </a:endParaRPr>
+                    </a:p>
+                  </a:txBody>
+                  <a:tcPr marL="91440" marR="91440" marT="64008" marB="64008" anchor="ctr">
+                    <a:lnL w="9525" cap="flat" cmpd="sng" algn="ctr">
+                      <a:solidFill>
+                        <a:srgbClr val="D6DDE3"/>
+                      </a:solidFill>
+                      <a:prstDash val="solid"/>
+                      <a:round/>
+                      <a:headEnd type="none" w="med" len="med"/>
+                      <a:tailEnd type="none" w="med" len="med"/>
+                    </a:lnL>
+                    <a:lnR w="9525" cap="flat" cmpd="sng" algn="ctr">
+                      <a:solidFill>
+                        <a:srgbClr val="D6DDE3"/>
+                      </a:solidFill>
+                      <a:prstDash val="solid"/>
+                      <a:round/>
+                      <a:headEnd type="none" w="med" len="med"/>
+                      <a:tailEnd type="none" w="med" len="med"/>
+                    </a:lnR>
+                    <a:lnT w="9525" cap="flat" cmpd="sng" algn="ctr">
+                      <a:solidFill>
+                        <a:srgbClr val="D6DDE3"/>
+                      </a:solidFill>
+                      <a:prstDash val="solid"/>
+                      <a:round/>
+                      <a:headEnd type="none" w="med" len="med"/>
+                      <a:tailEnd type="none" w="med" len="med"/>
+                    </a:lnT>
+                    <a:lnB w="9525" cap="flat" cmpd="sng" algn="ctr">
+                      <a:solidFill>
+                        <a:srgbClr val="D6DDE3"/>
+                      </a:solidFill>
+                      <a:prstDash val="solid"/>
+                      <a:round/>
+                      <a:headEnd type="none" w="med" len="med"/>
+                      <a:tailEnd type="none" w="med" len="med"/>
+                    </a:lnB>
+                    <a:solidFill>
+                      <a:srgbClr val="F7F9FA"/>
+                    </a:solidFill>
+                  </a:tcPr>
+                </a:tc>
+                <a:tc>
+                  <a:txBody>
+                    <a:bodyPr/>
+                    <a:lstStyle/>
+                    <a:p>
+                      <a:pPr algn="ctr" indent="0" marL="0">
+                        <a:buNone/>
+                      </a:pPr>
+                      <a:r>
+                        <a:rPr lang="en-US" sz="1150" b="1" dirty="0">
+                          <a:solidFill>
+                            <a:srgbClr val="1B2D5C"/>
+                          </a:solidFill>
+                          <a:latin typeface="Arial" pitchFamily="34" charset="0"/>
+                          <a:ea typeface="Arial" pitchFamily="34" charset="-122"/>
+                          <a:cs typeface="Arial" pitchFamily="34" charset="-120"/>
+                        </a:rPr>
+                        <a:t>Pimcore</a:t>
+                      </a:r>
+                      <a:endParaRPr lang="en-US" sz="1150" dirty="0">
+                        <a:latin typeface="Arial" charset="0"/>
+                        <a:ea typeface="Arial" charset="0"/>
+                        <a:cs typeface="Arial" charset="0"/>
+                      </a:endParaRPr>
+                    </a:p>
+                  </a:txBody>
+                  <a:tcPr marL="91440" marR="91440" marT="64008" marB="64008" anchor="ctr">
+                    <a:lnL w="9525" cap="flat" cmpd="sng" algn="ctr">
+                      <a:solidFill>
+                        <a:srgbClr val="D6DDE3"/>
+                      </a:solidFill>
+                      <a:prstDash val="solid"/>
+                      <a:round/>
+                      <a:headEnd type="none" w="med" len="med"/>
+                      <a:tailEnd type="none" w="med" len="med"/>
+                    </a:lnL>
+                    <a:lnR w="9525" cap="flat" cmpd="sng" algn="ctr">
+                      <a:solidFill>
+                        <a:srgbClr val="D6DDE3"/>
+                      </a:solidFill>
+                      <a:prstDash val="solid"/>
+                      <a:round/>
+                      <a:headEnd type="none" w="med" len="med"/>
+                      <a:tailEnd type="none" w="med" len="med"/>
+                    </a:lnR>
+                    <a:lnT w="9525" cap="flat" cmpd="sng" algn="ctr">
+                      <a:solidFill>
+                        <a:srgbClr val="D6DDE3"/>
+                      </a:solidFill>
+                      <a:prstDash val="solid"/>
+                      <a:round/>
+                      <a:headEnd type="none" w="med" len="med"/>
+                      <a:tailEnd type="none" w="med" len="med"/>
+                    </a:lnT>
+                    <a:lnB w="9525" cap="flat" cmpd="sng" algn="ctr">
+                      <a:solidFill>
+                        <a:srgbClr val="D6DDE3"/>
+                      </a:solidFill>
+                      <a:prstDash val="solid"/>
+                      <a:round/>
+                      <a:headEnd type="none" w="med" len="med"/>
+                      <a:tailEnd type="none" w="med" len="med"/>
+                    </a:lnB>
+                    <a:solidFill>
+                      <a:srgbClr val="E3E8F4"/>
+                    </a:solidFill>
+                  </a:tcPr>
+                </a:tc>
+              </a:tr>
+            </a:tbl>
+          </a:graphicData>
+        </a:graphic>
+      </p:graphicFrame>
+      <p:sp>
+        <p:nvSpPr>
+          <p:cNvPr id="7" name="Shape 4"/>
           <p:cNvSpPr/>
           <p:nvPr/>
         </p:nvSpPr>
         <p:spPr>
           <a:xfrm>
-            <a:off x="548640" y="1645920"/>
-            <a:ext cx="3520440" cy="1463040"/>
+            <a:off x="8275320" y="1600200"/>
+            <a:ext cx="3367735" cy="4023360"/>
           </a:xfrm>
           <a:prstGeom prst="rect">
             <a:avLst/>
           </a:prstGeom>
           <a:solidFill>
-            <a:srgbClr val="FFFFFF"/>
+            <a:srgbClr val="000E2F"/>
           </a:solidFill>
           <a:ln w="12700">
             <a:solidFill>
-              <a:srgbClr val="D6DDE3"/>
+              <a:srgbClr val="000E2F"/>
             </a:solidFill>
             <a:prstDash val="solid"/>
           </a:ln>
@@ -7942,14 +9892,14 @@
       </p:sp>
       <p:sp>
         <p:nvSpPr>
-          <p:cNvPr id="7" name="Text 5"/>
-          <p:cNvSpPr txBox="1"/>
-          <p:nvPr/>
-        </p:nvSpPr>
-        <p:spPr>
-          <a:xfrm>
-            <a:off x="777240" y="1737360"/>
-            <a:ext cx="1097280" cy="1005840"/>
+          <p:cNvPr id="8" name="Text 5"/>
+          <p:cNvSpPr txBox="1"/>
+          <p:nvPr/>
+        </p:nvSpPr>
+        <p:spPr>
+          <a:xfrm>
+            <a:off x="8549640" y="1828800"/>
+            <a:ext cx="2819095" cy="274320"/>
           </a:xfrm>
           <a:prstGeom prst="rect">
             <a:avLst/>
@@ -7965,30 +9915,30 @@
               <a:buNone/>
             </a:pPr>
             <a:r>
-              <a:rPr lang="en-US" sz="6000" dirty="0">
-                <a:solidFill>
-                  <a:srgbClr val="0F7A4D"/>
-                </a:solidFill>
-                <a:latin typeface="Arial" pitchFamily="34" charset="0"/>
-                <a:ea typeface="Arial" pitchFamily="34" charset="-122"/>
-                <a:cs typeface="Arial" pitchFamily="34" charset="-120"/>
-              </a:rPr>
-              <a:t>7</a:t>
-            </a:r>
-            <a:endParaRPr lang="en-US" sz="6000" dirty="0"/>
-          </a:p>
-        </p:txBody>
-      </p:sp>
-      <p:sp>
-        <p:nvSpPr>
-          <p:cNvPr id="8" name="Text 6"/>
-          <p:cNvSpPr txBox="1"/>
-          <p:nvPr/>
-        </p:nvSpPr>
-        <p:spPr>
-          <a:xfrm>
-            <a:off x="1874520" y="1920240"/>
-            <a:ext cx="2057400" cy="457200"/>
+              <a:rPr lang="en-US" sz="1100" b="1" spc="100" kern="0" dirty="0">
+                <a:solidFill>
+                  <a:srgbClr val="C6E6E3"/>
+                </a:solidFill>
+                <a:latin typeface="Arial" pitchFamily="34" charset="0"/>
+                <a:ea typeface="Arial" pitchFamily="34" charset="-122"/>
+                <a:cs typeface="Arial" pitchFamily="34" charset="-120"/>
+              </a:rPr>
+              <a:t>ERGEBNIS</a:t>
+            </a:r>
+            <a:endParaRPr lang="en-US" sz="1100" dirty="0"/>
+          </a:p>
+        </p:txBody>
+      </p:sp>
+      <p:sp>
+        <p:nvSpPr>
+          <p:cNvPr id="9" name="Text 6"/>
+          <p:cNvSpPr txBox="1"/>
+          <p:nvPr/>
+        </p:nvSpPr>
+        <p:spPr>
+          <a:xfrm>
+            <a:off x="8549640" y="2194560"/>
+            <a:ext cx="2819095" cy="731520"/>
           </a:xfrm>
           <a:prstGeom prst="rect">
             <a:avLst/>
@@ -8004,30 +9954,30 @@
               <a:buNone/>
             </a:pPr>
             <a:r>
-              <a:rPr lang="en-US" sz="1400" b="1" dirty="0">
-                <a:solidFill>
-                  <a:srgbClr val="16181D"/>
-                </a:solidFill>
-                <a:latin typeface="Arial" pitchFamily="34" charset="0"/>
-                <a:ea typeface="Arial" pitchFamily="34" charset="-122"/>
-                <a:cs typeface="Arial" pitchFamily="34" charset="-120"/>
-              </a:rPr>
-              <a:t>Kriterien mit Vorteil anyPIM</a:t>
-            </a:r>
-            <a:endParaRPr lang="en-US" sz="1400" dirty="0"/>
-          </a:p>
-        </p:txBody>
-      </p:sp>
-      <p:sp>
-        <p:nvSpPr>
-          <p:cNvPr id="9" name="Text 7"/>
-          <p:cNvSpPr txBox="1"/>
-          <p:nvPr/>
-        </p:nvSpPr>
-        <p:spPr>
-          <a:xfrm>
-            <a:off x="1874520" y="2395728"/>
-            <a:ext cx="2057400" cy="548640"/>
+              <a:rPr lang="en-US" sz="1600" dirty="0">
+                <a:solidFill>
+                  <a:srgbClr val="FFFFFF"/>
+                </a:solidFill>
+                <a:latin typeface="Arial" pitchFamily="34" charset="0"/>
+                <a:ea typeface="Arial" pitchFamily="34" charset="-122"/>
+                <a:cs typeface="Arial" pitchFamily="34" charset="-120"/>
+              </a:rPr>
+              <a:t>Pimcore punktet einmalig beim Umstieg.</a:t>
+            </a:r>
+            <a:endParaRPr lang="en-US" sz="1600" dirty="0"/>
+          </a:p>
+        </p:txBody>
+      </p:sp>
+      <p:sp>
+        <p:nvSpPr>
+          <p:cNvPr id="10" name="Text 7"/>
+          <p:cNvSpPr txBox="1"/>
+          <p:nvPr/>
+        </p:nvSpPr>
+        <p:spPr>
+          <a:xfrm>
+            <a:off x="8549640" y="2971800"/>
+            <a:ext cx="2819095" cy="1188720"/>
           </a:xfrm>
           <a:prstGeom prst="rect">
             <a:avLst/>
@@ -8043,55 +9993,30 @@
               <a:buNone/>
             </a:pPr>
             <a:r>
-              <a:rPr lang="en-US" sz="1100" dirty="0">
-                <a:solidFill>
-                  <a:srgbClr val="4B5563"/>
-                </a:solidFill>
-                <a:latin typeface="Arial" pitchFamily="34" charset="0"/>
-                <a:ea typeface="Arial" pitchFamily="34" charset="-122"/>
-                <a:cs typeface="Arial" pitchFamily="34" charset="-120"/>
-              </a:rPr>
-              <a:t>Updates, Betrieb, Lizenz, Datenmodell, Print</a:t>
-            </a:r>
-            <a:endParaRPr lang="en-US" sz="1100" dirty="0"/>
-          </a:p>
-        </p:txBody>
-      </p:sp>
-      <p:sp>
-        <p:nvSpPr>
-          <p:cNvPr id="10" name="Shape 8"/>
-          <p:cNvSpPr/>
-          <p:nvPr/>
-        </p:nvSpPr>
-        <p:spPr>
-          <a:xfrm>
-            <a:off x="4335628" y="1645920"/>
-            <a:ext cx="3520440" cy="1463040"/>
-          </a:xfrm>
-          <a:prstGeom prst="rect">
-            <a:avLst/>
-          </a:prstGeom>
-          <a:solidFill>
-            <a:srgbClr val="FFFFFF"/>
-          </a:solidFill>
-          <a:ln w="12700">
-            <a:solidFill>
-              <a:srgbClr val="D6DDE3"/>
-            </a:solidFill>
-            <a:prstDash val="solid"/>
-          </a:ln>
-        </p:spPr>
-      </p:sp>
-      <p:sp>
-        <p:nvSpPr>
-          <p:cNvPr id="11" name="Text 9"/>
-          <p:cNvSpPr txBox="1"/>
-          <p:nvPr/>
-        </p:nvSpPr>
-        <p:spPr>
-          <a:xfrm>
-            <a:off x="4564228" y="1737360"/>
-            <a:ext cx="1097280" cy="1005840"/>
+              <a:rPr lang="en-US" sz="1600" b="1" dirty="0">
+                <a:solidFill>
+                  <a:srgbClr val="FFFFFF"/>
+                </a:solidFill>
+                <a:latin typeface="Arial" pitchFamily="34" charset="0"/>
+                <a:ea typeface="Arial" pitchFamily="34" charset="-122"/>
+                <a:cs typeface="Arial" pitchFamily="34" charset="-120"/>
+              </a:rPr>
+              <a:t>anyPIM punktet dauerhaft – bei jedem Release, jedem Betriebstag und jeder Lizenzrechnung.</a:t>
+            </a:r>
+            <a:endParaRPr lang="en-US" sz="1600" dirty="0"/>
+          </a:p>
+        </p:txBody>
+      </p:sp>
+      <p:sp>
+        <p:nvSpPr>
+          <p:cNvPr id="11" name="Text 8"/>
+          <p:cNvSpPr txBox="1"/>
+          <p:nvPr/>
+        </p:nvSpPr>
+        <p:spPr>
+          <a:xfrm>
+            <a:off x="8549640" y="4846320"/>
+            <a:ext cx="2819095" cy="548640"/>
           </a:xfrm>
           <a:prstGeom prst="rect">
             <a:avLst/>
@@ -8107,7 +10032,60 @@
               <a:buNone/>
             </a:pPr>
             <a:r>
-              <a:rPr lang="en-US" sz="6000" dirty="0">
+              <a:rPr lang="en-US" sz="1500" b="1" dirty="0">
+                <a:solidFill>
+                  <a:srgbClr val="C6E6E3"/>
+                </a:solidFill>
+                <a:latin typeface="Arial" pitchFamily="34" charset="0"/>
+                <a:ea typeface="Arial" pitchFamily="34" charset="-122"/>
+                <a:cs typeface="Arial" pitchFamily="34" charset="-120"/>
+              </a:rPr>
+              <a:t>Empfehlung: Wechsel zu anyPIM</a:t>
+            </a:r>
+            <a:endParaRPr lang="en-US" sz="1500" dirty="0"/>
+          </a:p>
+        </p:txBody>
+      </p:sp>
+      <p:sp>
+        <p:nvSpPr>
+          <p:cNvPr id="12" name="Text 9"/>
+          <p:cNvSpPr txBox="1"/>
+          <p:nvPr/>
+        </p:nvSpPr>
+        <p:spPr>
+          <a:xfrm>
+            <a:off x="548640" y="5806440"/>
+            <a:ext cx="11094415" cy="457200"/>
+          </a:xfrm>
+          <a:prstGeom prst="rect">
+            <a:avLst/>
+          </a:prstGeom>
+          <a:noFill/>
+          <a:ln/>
+        </p:spPr>
+        <p:txBody>
+          <a:bodyPr wrap="square" lIns="0" tIns="0" rIns="0" bIns="0" rtlCol="0" anchor="t"/>
+          <a:lstStyle/>
+          <a:p>
+            <a:pPr indent="0" marL="0">
+              <a:buNone/>
+            </a:pPr>
+            <a:r>
+              <a:rPr lang="en-US" sz="1300" b="1" dirty="0">
+                <a:solidFill>
+                  <a:srgbClr val="E2211C"/>
+                </a:solidFill>
+                <a:latin typeface="Arial" pitchFamily="34" charset="0"/>
+                <a:ea typeface="Arial" pitchFamily="34" charset="-122"/>
+                <a:cs typeface="Arial" pitchFamily="34" charset="-120"/>
+              </a:rPr>
+              <a:t>→  </a:t>
+            </a:r>
+            <a:pPr indent="0" marL="0">
+              <a:buNone/>
+            </a:pPr>
+            <a:r>
+              <a:rPr lang="en-US" sz="1300" dirty="0">
                 <a:solidFill>
                   <a:srgbClr val="1B2D5C"/>
                 </a:solidFill>
@@ -8115,567 +10093,7 @@
                 <a:ea typeface="Arial" pitchFamily="34" charset="-122"/>
                 <a:cs typeface="Arial" pitchFamily="34" charset="-120"/>
               </a:rPr>
-              <a:t>4</a:t>
-            </a:r>
-            <a:endParaRPr lang="en-US" sz="6000" dirty="0"/>
-          </a:p>
-        </p:txBody>
-      </p:sp>
-      <p:sp>
-        <p:nvSpPr>
-          <p:cNvPr id="12" name="Text 10"/>
-          <p:cNvSpPr txBox="1"/>
-          <p:nvPr/>
-        </p:nvSpPr>
-        <p:spPr>
-          <a:xfrm>
-            <a:off x="5661508" y="1920240"/>
-            <a:ext cx="2057400" cy="457200"/>
-          </a:xfrm>
-          <a:prstGeom prst="rect">
-            <a:avLst/>
-          </a:prstGeom>
-          <a:noFill/>
-          <a:ln/>
-        </p:spPr>
-        <p:txBody>
-          <a:bodyPr wrap="square" lIns="0" tIns="0" rIns="0" bIns="0" rtlCol="0" anchor="t"/>
-          <a:lstStyle/>
-          <a:p>
-            <a:pPr indent="0" marL="0">
-              <a:buNone/>
-            </a:pPr>
-            <a:r>
-              <a:rPr lang="en-US" sz="1400" b="1" dirty="0">
-                <a:solidFill>
-                  <a:srgbClr val="16181D"/>
-                </a:solidFill>
-                <a:latin typeface="Arial" pitchFamily="34" charset="0"/>
-                <a:ea typeface="Arial" pitchFamily="34" charset="-122"/>
-                <a:cs typeface="Arial" pitchFamily="34" charset="-120"/>
-              </a:rPr>
-              <a:t>Kriterien mit Vorteil Pimcore</a:t>
-            </a:r>
-            <a:endParaRPr lang="en-US" sz="1400" dirty="0"/>
-          </a:p>
-        </p:txBody>
-      </p:sp>
-      <p:sp>
-        <p:nvSpPr>
-          <p:cNvPr id="13" name="Text 11"/>
-          <p:cNvSpPr txBox="1"/>
-          <p:nvPr/>
-        </p:nvSpPr>
-        <p:spPr>
-          <a:xfrm>
-            <a:off x="5661508" y="2395728"/>
-            <a:ext cx="2057400" cy="548640"/>
-          </a:xfrm>
-          <a:prstGeom prst="rect">
-            <a:avLst/>
-          </a:prstGeom>
-          <a:noFill/>
-          <a:ln/>
-        </p:spPr>
-        <p:txBody>
-          <a:bodyPr wrap="square" lIns="0" tIns="0" rIns="0" bIns="0" rtlCol="0" anchor="t"/>
-          <a:lstStyle/>
-          <a:p>
-            <a:pPr indent="0" marL="0">
-              <a:buNone/>
-            </a:pPr>
-            <a:r>
-              <a:rPr lang="en-US" sz="1100" dirty="0">
-                <a:solidFill>
-                  <a:srgbClr val="4B5563"/>
-                </a:solidFill>
-                <a:latin typeface="Arial" pitchFamily="34" charset="0"/>
-                <a:ea typeface="Arial" pitchFamily="34" charset="-122"/>
-                <a:cs typeface="Arial" pitchFamily="34" charset="-120"/>
-              </a:rPr>
-              <a:t>Datenkontinuität, DAM, CMS, Ökosystem</a:t>
-            </a:r>
-            <a:endParaRPr lang="en-US" sz="1100" dirty="0"/>
-          </a:p>
-        </p:txBody>
-      </p:sp>
-      <p:sp>
-        <p:nvSpPr>
-          <p:cNvPr id="14" name="Shape 12"/>
-          <p:cNvSpPr/>
-          <p:nvPr/>
-        </p:nvSpPr>
-        <p:spPr>
-          <a:xfrm>
-            <a:off x="8122615" y="1645920"/>
-            <a:ext cx="3520440" cy="1463040"/>
-          </a:xfrm>
-          <a:prstGeom prst="rect">
-            <a:avLst/>
-          </a:prstGeom>
-          <a:solidFill>
-            <a:srgbClr val="FFFFFF"/>
-          </a:solidFill>
-          <a:ln w="12700">
-            <a:solidFill>
-              <a:srgbClr val="D6DDE3"/>
-            </a:solidFill>
-            <a:prstDash val="solid"/>
-          </a:ln>
-        </p:spPr>
-      </p:sp>
-      <p:sp>
-        <p:nvSpPr>
-          <p:cNvPr id="15" name="Text 13"/>
-          <p:cNvSpPr txBox="1"/>
-          <p:nvPr/>
-        </p:nvSpPr>
-        <p:spPr>
-          <a:xfrm>
-            <a:off x="8351215" y="1737360"/>
-            <a:ext cx="1097280" cy="1005840"/>
-          </a:xfrm>
-          <a:prstGeom prst="rect">
-            <a:avLst/>
-          </a:prstGeom>
-          <a:noFill/>
-          <a:ln/>
-        </p:spPr>
-        <p:txBody>
-          <a:bodyPr wrap="square" lIns="0" tIns="0" rIns="0" bIns="0" rtlCol="0" anchor="t"/>
-          <a:lstStyle/>
-          <a:p>
-            <a:pPr indent="0" marL="0">
-              <a:buNone/>
-            </a:pPr>
-            <a:r>
-              <a:rPr lang="en-US" sz="6000" dirty="0">
-                <a:solidFill>
-                  <a:srgbClr val="6B7280"/>
-                </a:solidFill>
-                <a:latin typeface="Arial" pitchFamily="34" charset="0"/>
-                <a:ea typeface="Arial" pitchFamily="34" charset="-122"/>
-                <a:cs typeface="Arial" pitchFamily="34" charset="-120"/>
-              </a:rPr>
-              <a:t>5</a:t>
-            </a:r>
-            <a:endParaRPr lang="en-US" sz="6000" dirty="0"/>
-          </a:p>
-        </p:txBody>
-      </p:sp>
-      <p:sp>
-        <p:nvSpPr>
-          <p:cNvPr id="16" name="Text 14"/>
-          <p:cNvSpPr txBox="1"/>
-          <p:nvPr/>
-        </p:nvSpPr>
-        <p:spPr>
-          <a:xfrm>
-            <a:off x="9448495" y="1920240"/>
-            <a:ext cx="2057400" cy="457200"/>
-          </a:xfrm>
-          <a:prstGeom prst="rect">
-            <a:avLst/>
-          </a:prstGeom>
-          <a:noFill/>
-          <a:ln/>
-        </p:spPr>
-        <p:txBody>
-          <a:bodyPr wrap="square" lIns="0" tIns="0" rIns="0" bIns="0" rtlCol="0" anchor="t"/>
-          <a:lstStyle/>
-          <a:p>
-            <a:pPr indent="0" marL="0">
-              <a:buNone/>
-            </a:pPr>
-            <a:r>
-              <a:rPr lang="en-US" sz="1400" b="1" dirty="0">
-                <a:solidFill>
-                  <a:srgbClr val="16181D"/>
-                </a:solidFill>
-                <a:latin typeface="Arial" pitchFamily="34" charset="0"/>
-                <a:ea typeface="Arial" pitchFamily="34" charset="-122"/>
-                <a:cs typeface="Arial" pitchFamily="34" charset="-120"/>
-              </a:rPr>
-              <a:t>gleichauf oder abhängig</a:t>
-            </a:r>
-            <a:endParaRPr lang="en-US" sz="1400" dirty="0"/>
-          </a:p>
-        </p:txBody>
-      </p:sp>
-      <p:sp>
-        <p:nvSpPr>
-          <p:cNvPr id="17" name="Text 15"/>
-          <p:cNvSpPr txBox="1"/>
-          <p:nvPr/>
-        </p:nvSpPr>
-        <p:spPr>
-          <a:xfrm>
-            <a:off x="9448495" y="2395728"/>
-            <a:ext cx="2057400" cy="548640"/>
-          </a:xfrm>
-          <a:prstGeom prst="rect">
-            <a:avLst/>
-          </a:prstGeom>
-          <a:noFill/>
-          <a:ln/>
-        </p:spPr>
-        <p:txBody>
-          <a:bodyPr wrap="square" lIns="0" tIns="0" rIns="0" bIns="0" rtlCol="0" anchor="t"/>
-          <a:lstStyle/>
-          <a:p>
-            <a:pPr indent="0" marL="0">
-              <a:buNone/>
-            </a:pPr>
-            <a:r>
-              <a:rPr lang="en-US" sz="1100" dirty="0">
-                <a:solidFill>
-                  <a:srgbClr val="4B5563"/>
-                </a:solidFill>
-                <a:latin typeface="Arial" pitchFamily="34" charset="0"/>
-                <a:ea typeface="Arial" pitchFamily="34" charset="-122"/>
-                <a:cs typeface="Arial" pitchFamily="34" charset="-120"/>
-              </a:rPr>
-              <a:t>Weg, Ausrichtung, Werk/Ausgabe, Suche, ONIX</a:t>
-            </a:r>
-            <a:endParaRPr lang="en-US" sz="1100" dirty="0"/>
-          </a:p>
-        </p:txBody>
-      </p:sp>
-      <p:sp>
-        <p:nvSpPr>
-          <p:cNvPr id="18" name="Shape 16"/>
-          <p:cNvSpPr/>
-          <p:nvPr/>
-        </p:nvSpPr>
-        <p:spPr>
-          <a:xfrm>
-            <a:off x="548640" y="3383280"/>
-            <a:ext cx="5364328" cy="2743200"/>
-          </a:xfrm>
-          <a:prstGeom prst="rect">
-            <a:avLst/>
-          </a:prstGeom>
-          <a:solidFill>
-            <a:srgbClr val="E4F3F1"/>
-          </a:solidFill>
-          <a:ln w="12700">
-            <a:solidFill>
-              <a:srgbClr val="E4F3F1"/>
-            </a:solidFill>
-            <a:prstDash val="solid"/>
-          </a:ln>
-        </p:spPr>
-      </p:sp>
-      <p:sp>
-        <p:nvSpPr>
-          <p:cNvPr id="19" name="Text 17"/>
-          <p:cNvSpPr txBox="1"/>
-          <p:nvPr/>
-        </p:nvSpPr>
-        <p:spPr>
-          <a:xfrm>
-            <a:off x="822960" y="3566160"/>
-            <a:ext cx="4815688" cy="365760"/>
-          </a:xfrm>
-          <a:prstGeom prst="rect">
-            <a:avLst/>
-          </a:prstGeom>
-          <a:noFill/>
-          <a:ln/>
-        </p:spPr>
-        <p:txBody>
-          <a:bodyPr wrap="square" lIns="0" tIns="0" rIns="0" bIns="0" rtlCol="0" anchor="t"/>
-          <a:lstStyle/>
-          <a:p>
-            <a:pPr indent="0" marL="0">
-              <a:buNone/>
-            </a:pPr>
-            <a:r>
-              <a:rPr lang="en-US" sz="1700" b="1" dirty="0">
-                <a:solidFill>
-                  <a:srgbClr val="000E2F"/>
-                </a:solidFill>
-                <a:latin typeface="Arial" pitchFamily="34" charset="0"/>
-                <a:ea typeface="Arial" pitchFamily="34" charset="-122"/>
-                <a:cs typeface="Arial" pitchFamily="34" charset="-120"/>
-              </a:rPr>
-              <a:t>anyPIM passt, wenn …</a:t>
-            </a:r>
-            <a:endParaRPr lang="en-US" sz="1700" dirty="0"/>
-          </a:p>
-        </p:txBody>
-      </p:sp>
-      <p:sp>
-        <p:nvSpPr>
-          <p:cNvPr id="20" name="Text 18"/>
-          <p:cNvSpPr txBox="1"/>
-          <p:nvPr/>
-        </p:nvSpPr>
-        <p:spPr>
-          <a:xfrm>
-            <a:off x="822960" y="4069080"/>
-            <a:ext cx="4815688" cy="1920240"/>
-          </a:xfrm>
-          <a:prstGeom prst="rect">
-            <a:avLst/>
-          </a:prstGeom>
-          <a:noFill/>
-          <a:ln/>
-        </p:spPr>
-        <p:txBody>
-          <a:bodyPr wrap="square" lIns="0" tIns="0" rIns="0" bIns="0" rtlCol="0" anchor="t"/>
-          <a:lstStyle/>
-          <a:p>
-            <a:pPr marL="342900" indent="-342900">
-              <a:spcAft>
-                <a:spcPts val="600"/>
-              </a:spcAft>
-              <a:buSzPct val="100000"/>
-              <a:buChar char="•"/>
-            </a:pPr>
-            <a:r>
-              <a:rPr lang="en-US" sz="1300" dirty="0">
-                <a:solidFill>
-                  <a:srgbClr val="16181D"/>
-                </a:solidFill>
-                <a:latin typeface="Arial" pitchFamily="34" charset="0"/>
-                <a:ea typeface="Arial" pitchFamily="34" charset="-122"/>
-                <a:cs typeface="Arial" pitchFamily="34" charset="-120"/>
-              </a:rPr>
-              <a:t>Update- und Betriebsaufwand dauerhaft sinken soll</a:t>
-            </a:r>
-            <a:endParaRPr lang="en-US" sz="1300" dirty="0"/>
-          </a:p>
-          <a:p>
-            <a:pPr marL="342900" indent="-342900">
-              <a:spcAft>
-                <a:spcPts val="600"/>
-              </a:spcAft>
-              <a:buSzPct val="100000"/>
-              <a:buChar char="•"/>
-            </a:pPr>
-            <a:r>
-              <a:rPr lang="en-US" sz="1300" dirty="0">
-                <a:solidFill>
-                  <a:srgbClr val="16181D"/>
-                </a:solidFill>
-                <a:latin typeface="Arial" pitchFamily="34" charset="0"/>
-                <a:ea typeface="Arial" pitchFamily="34" charset="-122"/>
-                <a:cs typeface="Arial" pitchFamily="34" charset="-120"/>
-              </a:rPr>
-              <a:t>nur die Module lizenziert werden sollen, die Kohlhammer nutzt</a:t>
-            </a:r>
-            <a:endParaRPr lang="en-US" sz="1300" dirty="0"/>
-          </a:p>
-          <a:p>
-            <a:pPr marL="342900" indent="-342900">
-              <a:spcAft>
-                <a:spcPts val="600"/>
-              </a:spcAft>
-              <a:buSzPct val="100000"/>
-              <a:buChar char="•"/>
-            </a:pPr>
-            <a:r>
-              <a:rPr lang="en-US" sz="1300" dirty="0">
-                <a:solidFill>
-                  <a:srgbClr val="16181D"/>
-                </a:solidFill>
-                <a:latin typeface="Arial" pitchFamily="34" charset="0"/>
-                <a:ea typeface="Arial" pitchFamily="34" charset="-122"/>
-                <a:cs typeface="Arial" pitchFamily="34" charset="-120"/>
-              </a:rPr>
-              <a:t>Shop, Website und Verlagssoftware bleiben und angebunden werden</a:t>
-            </a:r>
-            <a:endParaRPr lang="en-US" sz="1300" dirty="0"/>
-          </a:p>
-          <a:p>
-            <a:pPr marL="342900" indent="-342900">
-              <a:spcAft>
-                <a:spcPts val="600"/>
-              </a:spcAft>
-              <a:buSzPct val="100000"/>
-              <a:buChar char="•"/>
-            </a:pPr>
-            <a:r>
-              <a:rPr lang="en-US" sz="1300" dirty="0">
-                <a:solidFill>
-                  <a:srgbClr val="16181D"/>
-                </a:solidFill>
-                <a:latin typeface="Arial" pitchFamily="34" charset="0"/>
-                <a:ea typeface="Arial" pitchFamily="34" charset="-122"/>
-                <a:cs typeface="Arial" pitchFamily="34" charset="-120"/>
-              </a:rPr>
-              <a:t>Vorschauen und Prospekte aus denselben Daten entstehen sollen</a:t>
-            </a:r>
-            <a:endParaRPr lang="en-US" sz="1300" dirty="0"/>
-          </a:p>
-        </p:txBody>
-      </p:sp>
-      <p:sp>
-        <p:nvSpPr>
-          <p:cNvPr id="21" name="Shape 19"/>
-          <p:cNvSpPr/>
-          <p:nvPr/>
-        </p:nvSpPr>
-        <p:spPr>
-          <a:xfrm>
-            <a:off x="6278728" y="3383280"/>
-            <a:ext cx="5364328" cy="2743200"/>
-          </a:xfrm>
-          <a:prstGeom prst="rect">
-            <a:avLst/>
-          </a:prstGeom>
-          <a:solidFill>
-            <a:srgbClr val="F3F5F9"/>
-          </a:solidFill>
-          <a:ln w="12700">
-            <a:solidFill>
-              <a:srgbClr val="F3F5F9"/>
-            </a:solidFill>
-            <a:prstDash val="solid"/>
-          </a:ln>
-        </p:spPr>
-      </p:sp>
-      <p:sp>
-        <p:nvSpPr>
-          <p:cNvPr id="22" name="Text 20"/>
-          <p:cNvSpPr txBox="1"/>
-          <p:nvPr/>
-        </p:nvSpPr>
-        <p:spPr>
-          <a:xfrm>
-            <a:off x="6553048" y="3566160"/>
-            <a:ext cx="4815688" cy="365760"/>
-          </a:xfrm>
-          <a:prstGeom prst="rect">
-            <a:avLst/>
-          </a:prstGeom>
-          <a:noFill/>
-          <a:ln/>
-        </p:spPr>
-        <p:txBody>
-          <a:bodyPr wrap="square" lIns="0" tIns="0" rIns="0" bIns="0" rtlCol="0" anchor="t"/>
-          <a:lstStyle/>
-          <a:p>
-            <a:pPr indent="0" marL="0">
-              <a:buNone/>
-            </a:pPr>
-            <a:r>
-              <a:rPr lang="en-US" sz="1700" b="1" dirty="0">
-                <a:solidFill>
-                  <a:srgbClr val="000E2F"/>
-                </a:solidFill>
-                <a:latin typeface="Arial" pitchFamily="34" charset="0"/>
-                <a:ea typeface="Arial" pitchFamily="34" charset="-122"/>
-                <a:cs typeface="Arial" pitchFamily="34" charset="-120"/>
-              </a:rPr>
-              <a:t>Das Pimcore-Upgrade passt, wenn …</a:t>
-            </a:r>
-            <a:endParaRPr lang="en-US" sz="1700" dirty="0"/>
-          </a:p>
-        </p:txBody>
-      </p:sp>
-      <p:sp>
-        <p:nvSpPr>
-          <p:cNvPr id="23" name="Text 21"/>
-          <p:cNvSpPr txBox="1"/>
-          <p:nvPr/>
-        </p:nvSpPr>
-        <p:spPr>
-          <a:xfrm>
-            <a:off x="6553048" y="4069080"/>
-            <a:ext cx="4815688" cy="1920240"/>
-          </a:xfrm>
-          <a:prstGeom prst="rect">
-            <a:avLst/>
-          </a:prstGeom>
-          <a:noFill/>
-          <a:ln/>
-        </p:spPr>
-        <p:txBody>
-          <a:bodyPr wrap="square" lIns="0" tIns="0" rIns="0" bIns="0" rtlCol="0" anchor="t"/>
-          <a:lstStyle/>
-          <a:p>
-            <a:pPr marL="342900" indent="-342900">
-              <a:spcAft>
-                <a:spcPts val="600"/>
-              </a:spcAft>
-              <a:buSzPct val="100000"/>
-              <a:buChar char="•"/>
-            </a:pPr>
-            <a:r>
-              <a:rPr lang="en-US" sz="1300" dirty="0">
-                <a:solidFill>
-                  <a:srgbClr val="16181D"/>
-                </a:solidFill>
-                <a:latin typeface="Arial" pitchFamily="34" charset="0"/>
-                <a:ea typeface="Arial" pitchFamily="34" charset="-122"/>
-                <a:cs typeface="Arial" pitchFamily="34" charset="-120"/>
-              </a:rPr>
-              <a:t>Website, DAM, PIM und Commerce auf einer Plattform zusammengeführt werden sollen</a:t>
-            </a:r>
-            <a:endParaRPr lang="en-US" sz="1300" dirty="0"/>
-          </a:p>
-          <a:p>
-            <a:pPr marL="342900" indent="-342900">
-              <a:spcAft>
-                <a:spcPts val="600"/>
-              </a:spcAft>
-              <a:buSzPct val="100000"/>
-              <a:buChar char="•"/>
-            </a:pPr>
-            <a:r>
-              <a:rPr lang="en-US" sz="1300" dirty="0">
-                <a:solidFill>
-                  <a:srgbClr val="16181D"/>
-                </a:solidFill>
-                <a:latin typeface="Arial" pitchFamily="34" charset="0"/>
-                <a:ea typeface="Arial" pitchFamily="34" charset="-122"/>
-                <a:cs typeface="Arial" pitchFamily="34" charset="-120"/>
-              </a:rPr>
-              <a:t>Enterprise-Erweiterungen wie Datahub und Portale künftig stark genutzt werden</a:t>
-            </a:r>
-            <a:endParaRPr lang="en-US" sz="1300" dirty="0"/>
-          </a:p>
-          <a:p>
-            <a:pPr marL="342900" indent="-342900">
-              <a:spcAft>
-                <a:spcPts val="600"/>
-              </a:spcAft>
-              <a:buSzPct val="100000"/>
-              <a:buChar char="•"/>
-            </a:pPr>
-            <a:r>
-              <a:rPr lang="en-US" sz="1300" dirty="0">
-                <a:solidFill>
-                  <a:srgbClr val="16181D"/>
-                </a:solidFill>
-                <a:latin typeface="Arial" pitchFamily="34" charset="0"/>
-                <a:ea typeface="Arial" pitchFamily="34" charset="-122"/>
-                <a:cs typeface="Arial" pitchFamily="34" charset="-120"/>
-              </a:rPr>
-              <a:t>Container- und OpenSearch-Betrieb ohnehin IT-Standard ist</a:t>
-            </a:r>
-            <a:endParaRPr lang="en-US" sz="1300" dirty="0"/>
-          </a:p>
-          <a:p>
-            <a:pPr marL="342900" indent="-342900">
-              <a:spcAft>
-                <a:spcPts val="600"/>
-              </a:spcAft>
-              <a:buSzPct val="100000"/>
-              <a:buChar char="•"/>
-            </a:pPr>
-            <a:r>
-              <a:rPr lang="en-US" sz="1300" dirty="0">
-                <a:solidFill>
-                  <a:srgbClr val="16181D"/>
-                </a:solidFill>
-                <a:latin typeface="Arial" pitchFamily="34" charset="0"/>
-                <a:ea typeface="Arial" pitchFamily="34" charset="-122"/>
-                <a:cs typeface="Arial" pitchFamily="34" charset="-120"/>
-              </a:rPr>
-              <a:t>die Eigenentwicklungen in Pimcore 6 gering und leicht portierbar sind</a:t>
+              <a:t>Ergebnisoffen bleibt nur die Plattformfrage: Soll Kohlhammer Website, DAM und PIM auf einem System zusammenführen? Dann spricht mehr für Pimcore.</a:t>
             </a:r>
             <a:endParaRPr lang="en-US" sz="1300" dirty="0"/>
           </a:p>
@@ -9234,7 +10652,7 @@
                 <a:ea typeface="Arial" pitchFamily="34" charset="-122"/>
                 <a:cs typeface="Arial" pitchFamily="34" charset="-120"/>
               </a:rPr>
-              <a:t>Weil das Upgrade einem Neuprojekt gleichkommt, danach dauerhaft Update- und Betriebsaufwand bindet und Lizenzkosten auch für wenig genutzte Erweiterungen auslöst. In anyPIM sind die heutigen Eigenentwicklungen weitgehend Standard.</a:t>
+              <a:t>Weil das Upgrade einem Neuprojekt gleichkommt, danach dauerhaft Update- und Betriebsaufwand bindet und Lizenzkosten auch für wenig genutzte Erweiterungen auslöst. Was heute Eigenentwicklung ist, bauen wir in anyPIM als Standard.</a:t>
             </a:r>
             <a:endParaRPr lang="en-US" sz="1300" dirty="0"/>
           </a:p>
@@ -10022,7 +11440,7 @@
                 <a:ea typeface="Arial" pitchFamily="34" charset="-122"/>
                 <a:cs typeface="Arial" pitchFamily="34" charset="-120"/>
               </a:rPr>
-              <a:t>CA. 4–6 WOCHEN</a:t>
+              <a:t>JE NACH UMFANG</a:t>
             </a:r>
             <a:endParaRPr lang="en-US" sz="1000" dirty="0"/>
           </a:p>
@@ -10061,7 +11479,7 @@
                 <a:ea typeface="Arial" pitchFamily="34" charset="-122"/>
                 <a:cs typeface="Arial" pitchFamily="34" charset="-120"/>
               </a:rPr>
-              <a:t>Kanäle</a:t>
+              <a:t>Projektanteil</a:t>
             </a:r>
             <a:endParaRPr lang="en-US" sz="1800" dirty="0"/>
           </a:p>
@@ -10103,7 +11521,7 @@
                 <a:ea typeface="Arial" pitchFamily="34" charset="-122"/>
                 <a:cs typeface="Arial" pitchFamily="34" charset="-120"/>
               </a:rPr>
-              <a:t>Shop und Handel auf anyPIM umstellen, ONIX-Export, erste Vorschau als PDF, Zugangslinks für Presse und Partner.</a:t>
+              <a:t>Fehlende Funktionen als Standard bauen – EasyCatalog-, Thieme- und ONIX-Export, Cover-Metadaten; Shop und Handel umstellen.</a:t>
             </a:r>
             <a:endParaRPr lang="en-US" sz="1400" dirty="0"/>
           </a:p>
@@ -11324,7 +12742,7 @@
                 <a:ea typeface="Arial" pitchFamily="34" charset="-122"/>
                 <a:cs typeface="Arial" pitchFamily="34" charset="-120"/>
               </a:rPr>
-              <a:t>Einmalige Datenübernahme aus Pimcore 6, danach Standardfunktionen statt Eigenentwicklungen. Nativer Betrieb ohne Docker und OpenSearch; lizenziert werden nur die Module, die Kohlhammer nutzt.</a:t>
+              <a:t>Datenübernahme und ein Projekt für Kohlhammer-Funktionen, die danach Standard im Produkt sind. Nativer Betrieb ohne Docker und OpenSearch; lizenziert werden nur genutzte Module.</a:t>
             </a:r>
             <a:endParaRPr lang="en-US" sz="1500" dirty="0"/>
           </a:p>
@@ -17411,7 +18829,7 @@
                 <a:ea typeface="Arial" pitchFamily="34" charset="-122"/>
                 <a:cs typeface="Arial" pitchFamily="34" charset="-120"/>
               </a:rPr>
-              <a:t>Geplante Export-Jobs per SFTP/Webhook, Excel/CSV/BMEcat, Delta-Export nur geänderter Titel. ONIX: siehe „Was noch fehlt“.</a:t>
+              <a:t>Geplante Export-Jobs per SFTP/Webhook, Excel/CSV/BMEcat, Delta-Export nur geänderter Titel. ONIX: Projektanteil.</a:t>
             </a:r>
             <a:endParaRPr lang="en-US" sz="1150" dirty="0"/>
           </a:p>
@@ -20000,7 +21418,7 @@
                 <a:ea typeface="Arial" pitchFamily="34" charset="-122"/>
                 <a:cs typeface="Arial" pitchFamily="34" charset="-120"/>
               </a:rPr>
-              <a:t>EHRLICH GESAGT: WAS HEUTE NOCH FEHLT</a:t>
+              <a:t>AUCH MIT ANYPIM GIBT ES EIN PROJEKT</a:t>
             </a:r>
             <a:endParaRPr lang="en-US" sz="3000" dirty="0"/>
           </a:p>
@@ -20039,7 +21457,7 @@
                 <a:ea typeface="Arial" pitchFamily="34" charset="-122"/>
                 <a:cs typeface="Arial" pitchFamily="34" charset="-120"/>
               </a:rPr>
-              <a:t>Drei Punkte, die in die Planung gehören – unabhängig vom gewählten System.</a:t>
+              <a:t>Ehrlich gesagt: die Kohlhammer-Funktionsliste, grob eingeordnet – nicht alles ist heute Standard.</a:t>
             </a:r>
             <a:endParaRPr lang="en-US" sz="1400" dirty="0"/>
           </a:p>
@@ -20131,18 +21549,18 @@
         </p:nvSpPr>
         <p:spPr>
           <a:xfrm>
-            <a:off x="548640" y="1691640"/>
-            <a:ext cx="3520440" cy="3657600"/>
+            <a:off x="548640" y="1645920"/>
+            <a:ext cx="3520440" cy="3246120"/>
           </a:xfrm>
           <a:prstGeom prst="rect">
             <a:avLst/>
           </a:prstGeom>
           <a:solidFill>
-            <a:srgbClr val="E4F3F1"/>
+            <a:srgbClr val="FFFFFF"/>
           </a:solidFill>
           <a:ln w="12700">
             <a:solidFill>
-              <a:srgbClr val="E4F3F1"/>
+              <a:srgbClr val="D6DDE3"/>
             </a:solidFill>
             <a:prstDash val="solid"/>
           </a:ln>
@@ -20150,144 +21568,26 @@
       </p:sp>
       <p:sp>
         <p:nvSpPr>
-          <p:cNvPr id="7" name="Text 5"/>
-          <p:cNvSpPr txBox="1"/>
-          <p:nvPr/>
-        </p:nvSpPr>
-        <p:spPr>
-          <a:xfrm>
-            <a:off x="822960" y="1874520"/>
-            <a:ext cx="1371600" cy="640080"/>
-          </a:xfrm>
-          <a:prstGeom prst="rect">
-            <a:avLst/>
-          </a:prstGeom>
-          <a:noFill/>
-          <a:ln/>
-        </p:spPr>
-        <p:txBody>
-          <a:bodyPr wrap="square" lIns="0" tIns="0" rIns="0" bIns="0" rtlCol="0" anchor="t"/>
-          <a:lstStyle/>
-          <a:p>
-            <a:pPr indent="0" marL="0">
-              <a:buNone/>
-            </a:pPr>
-            <a:r>
-              <a:rPr lang="en-US" sz="3600" dirty="0">
-                <a:solidFill>
-                  <a:srgbClr val="1B2D5C"/>
-                </a:solidFill>
-                <a:latin typeface="Arial" pitchFamily="34" charset="0"/>
-                <a:ea typeface="Arial" pitchFamily="34" charset="-122"/>
-                <a:cs typeface="Arial" pitchFamily="34" charset="-120"/>
-              </a:rPr>
-              <a:t>01</a:t>
-            </a:r>
-            <a:endParaRPr lang="en-US" sz="3600" dirty="0"/>
-          </a:p>
-        </p:txBody>
-      </p:sp>
-      <p:sp>
-        <p:nvSpPr>
-          <p:cNvPr id="8" name="Text 6"/>
-          <p:cNvSpPr txBox="1"/>
-          <p:nvPr/>
-        </p:nvSpPr>
-        <p:spPr>
-          <a:xfrm>
-            <a:off x="822960" y="2606040"/>
-            <a:ext cx="2971800" cy="411480"/>
-          </a:xfrm>
-          <a:prstGeom prst="rect">
-            <a:avLst/>
-          </a:prstGeom>
-          <a:noFill/>
-          <a:ln/>
-        </p:spPr>
-        <p:txBody>
-          <a:bodyPr wrap="square" lIns="0" tIns="0" rIns="0" bIns="0" rtlCol="0" anchor="t"/>
-          <a:lstStyle/>
-          <a:p>
-            <a:pPr indent="0" marL="0">
-              <a:buNone/>
-            </a:pPr>
-            <a:r>
-              <a:rPr lang="en-US" sz="1900" b="1" dirty="0">
-                <a:solidFill>
-                  <a:srgbClr val="16181D"/>
-                </a:solidFill>
-                <a:latin typeface="Arial" pitchFamily="34" charset="0"/>
-                <a:ea typeface="Arial" pitchFamily="34" charset="-122"/>
-                <a:cs typeface="Arial" pitchFamily="34" charset="-120"/>
-              </a:rPr>
-              <a:t>ONIX 3.0</a:t>
-            </a:r>
-            <a:endParaRPr lang="en-US" sz="1900" dirty="0"/>
-          </a:p>
-        </p:txBody>
-      </p:sp>
-      <p:sp>
-        <p:nvSpPr>
-          <p:cNvPr id="9" name="Text 7"/>
-          <p:cNvSpPr txBox="1"/>
-          <p:nvPr/>
-        </p:nvSpPr>
-        <p:spPr>
-          <a:xfrm>
-            <a:off x="822960" y="3108960"/>
-            <a:ext cx="2971800" cy="2103120"/>
-          </a:xfrm>
-          <a:prstGeom prst="rect">
-            <a:avLst/>
-          </a:prstGeom>
-          <a:noFill/>
-          <a:ln/>
-        </p:spPr>
-        <p:txBody>
-          <a:bodyPr wrap="square" lIns="0" tIns="0" rIns="0" bIns="0" rtlCol="0" anchor="t"/>
-          <a:lstStyle/>
-          <a:p>
-            <a:pPr indent="0" marL="0">
-              <a:lnSpc>
-                <a:spcPct val="112000"/>
-              </a:lnSpc>
-              <a:buNone/>
-            </a:pPr>
-            <a:r>
-              <a:rPr lang="en-US" sz="1300" dirty="0">
-                <a:solidFill>
-                  <a:srgbClr val="16181D"/>
-                </a:solidFill>
-                <a:latin typeface="Arial" pitchFamily="34" charset="0"/>
-                <a:ea typeface="Arial" pitchFamily="34" charset="-122"/>
-                <a:cs typeface="Arial" pitchFamily="34" charset="-120"/>
-              </a:rPr>
-              <a:t>Für VLB und Barsortimente. In anyPIM nicht im Standard – Umsetzung als eigenes Exportformat über die vorhandene Mapping-Engine, auf demselben Weg wie BMEcat. Pimcore bringt ONIX ebenfalls nicht im Standardumfang mit.</a:t>
-            </a:r>
-            <a:endParaRPr lang="en-US" sz="1300" dirty="0"/>
-          </a:p>
-        </p:txBody>
-      </p:sp>
-      <p:sp>
-        <p:nvSpPr>
-          <p:cNvPr id="10" name="Shape 8"/>
+          <p:cNvPr id="7" name="Shape 5"/>
           <p:cNvSpPr/>
           <p:nvPr/>
         </p:nvSpPr>
         <p:spPr>
           <a:xfrm>
-            <a:off x="4335628" y="1691640"/>
-            <a:ext cx="3520440" cy="3657600"/>
-          </a:xfrm>
-          <a:prstGeom prst="rect">
-            <a:avLst/>
+            <a:off x="777240" y="1874520"/>
+            <a:ext cx="1737360" cy="365760"/>
+          </a:xfrm>
+          <a:prstGeom prst="roundRect">
+            <a:avLst>
+              <a:gd name="adj" fmla="val 50000"/>
+            </a:avLst>
           </a:prstGeom>
           <a:solidFill>
-            <a:srgbClr val="E4F3F1"/>
+            <a:srgbClr val="DFF3EA"/>
           </a:solidFill>
           <a:ln w="12700">
             <a:solidFill>
-              <a:srgbClr val="E4F3F1"/>
+              <a:srgbClr val="DFF3EA"/>
             </a:solidFill>
             <a:prstDash val="solid"/>
           </a:ln>
@@ -20295,14 +21595,53 @@
       </p:sp>
       <p:sp>
         <p:nvSpPr>
-          <p:cNvPr id="11" name="Text 9"/>
-          <p:cNvSpPr txBox="1"/>
-          <p:nvPr/>
-        </p:nvSpPr>
-        <p:spPr>
-          <a:xfrm>
-            <a:off x="4609948" y="1874520"/>
-            <a:ext cx="1371600" cy="640080"/>
+          <p:cNvPr id="8" name="Text 6"/>
+          <p:cNvSpPr txBox="1"/>
+          <p:nvPr/>
+        </p:nvSpPr>
+        <p:spPr>
+          <a:xfrm>
+            <a:off x="777240" y="1874520"/>
+            <a:ext cx="1737360" cy="365760"/>
+          </a:xfrm>
+          <a:prstGeom prst="rect">
+            <a:avLst/>
+          </a:prstGeom>
+          <a:noFill/>
+          <a:ln/>
+        </p:spPr>
+        <p:txBody>
+          <a:bodyPr wrap="square" lIns="0" tIns="0" rIns="0" bIns="0" rtlCol="0" anchor="ctr"/>
+          <a:lstStyle/>
+          <a:p>
+            <a:pPr algn="ctr" indent="0" marL="0">
+              <a:buNone/>
+            </a:pPr>
+            <a:r>
+              <a:rPr lang="en-US" sz="1200" b="1" dirty="0">
+                <a:solidFill>
+                  <a:srgbClr val="0F7A4D"/>
+                </a:solidFill>
+                <a:latin typeface="Arial" pitchFamily="34" charset="0"/>
+                <a:ea typeface="Arial" pitchFamily="34" charset="-122"/>
+                <a:cs typeface="Arial" pitchFamily="34" charset="-120"/>
+              </a:rPr>
+              <a:t>Heute Standard</a:t>
+            </a:r>
+            <a:endParaRPr lang="en-US" sz="1200" dirty="0"/>
+          </a:p>
+        </p:txBody>
+      </p:sp>
+      <p:sp>
+        <p:nvSpPr>
+          <p:cNvPr id="9" name="Text 7"/>
+          <p:cNvSpPr txBox="1"/>
+          <p:nvPr/>
+        </p:nvSpPr>
+        <p:spPr>
+          <a:xfrm>
+            <a:off x="777240" y="2423160"/>
+            <a:ext cx="3108960" cy="2331720"/>
           </a:xfrm>
           <a:prstGeom prst="rect">
             <a:avLst/>
@@ -20314,50 +21653,18 @@
           <a:bodyPr wrap="square" lIns="0" tIns="0" rIns="0" bIns="0" rtlCol="0" anchor="t"/>
           <a:lstStyle/>
           <a:p>
-            <a:pPr indent="0" marL="0">
-              <a:buNone/>
-            </a:pPr>
-            <a:r>
-              <a:rPr lang="en-US" sz="3600" dirty="0">
-                <a:solidFill>
-                  <a:srgbClr val="1B2D5C"/>
-                </a:solidFill>
-                <a:latin typeface="Arial" pitchFamily="34" charset="0"/>
-                <a:ea typeface="Arial" pitchFamily="34" charset="-122"/>
-                <a:cs typeface="Arial" pitchFamily="34" charset="-120"/>
-              </a:rPr>
-              <a:t>02</a:t>
-            </a:r>
-            <a:endParaRPr lang="en-US" sz="3600" dirty="0"/>
-          </a:p>
-        </p:txBody>
-      </p:sp>
-      <p:sp>
-        <p:nvSpPr>
-          <p:cNvPr id="12" name="Text 10"/>
-          <p:cNvSpPr txBox="1"/>
-          <p:nvPr/>
-        </p:nvSpPr>
-        <p:spPr>
-          <a:xfrm>
-            <a:off x="4609948" y="2606040"/>
-            <a:ext cx="2971800" cy="411480"/>
-          </a:xfrm>
-          <a:prstGeom prst="rect">
-            <a:avLst/>
-          </a:prstGeom>
-          <a:noFill/>
-          <a:ln/>
-        </p:spPr>
-        <p:txBody>
-          <a:bodyPr wrap="square" lIns="0" tIns="0" rIns="0" bIns="0" rtlCol="0" anchor="t"/>
-          <a:lstStyle/>
-          <a:p>
-            <a:pPr indent="0" marL="0">
-              <a:buNone/>
-            </a:pPr>
-            <a:r>
-              <a:rPr lang="en-US" sz="1900" b="1" dirty="0">
+            <a:pPr marL="342900" indent="-342900">
+              <a:lnSpc>
+                <a:spcPct val="105000"/>
+              </a:lnSpc>
+              <a:spcAft>
+                <a:spcPts val="600"/>
+              </a:spcAft>
+              <a:buSzPct val="100000"/>
+              <a:buChar char="•"/>
+            </a:pPr>
+            <a:r>
+              <a:rPr lang="en-US" sz="1400" dirty="0">
                 <a:solidFill>
                   <a:srgbClr val="16181D"/>
                 </a:solidFill>
@@ -20365,41 +21672,23 @@
                 <a:ea typeface="Arial" pitchFamily="34" charset="-122"/>
                 <a:cs typeface="Arial" pitchFamily="34" charset="-120"/>
               </a:rPr>
-              <a:t>Branchenklassifikationen</a:t>
-            </a:r>
-            <a:endParaRPr lang="en-US" sz="1900" dirty="0"/>
-          </a:p>
-        </p:txBody>
-      </p:sp>
-      <p:sp>
-        <p:nvSpPr>
-          <p:cNvPr id="13" name="Text 11"/>
-          <p:cNvSpPr txBox="1"/>
-          <p:nvPr/>
-        </p:nvSpPr>
-        <p:spPr>
-          <a:xfrm>
-            <a:off x="4609948" y="3108960"/>
-            <a:ext cx="2971800" cy="2103120"/>
-          </a:xfrm>
-          <a:prstGeom prst="rect">
-            <a:avLst/>
-          </a:prstGeom>
-          <a:noFill/>
-          <a:ln/>
-        </p:spPr>
-        <p:txBody>
-          <a:bodyPr wrap="square" lIns="0" tIns="0" rIns="0" bIns="0" rtlCol="0" anchor="t"/>
-          <a:lstStyle/>
-          <a:p>
-            <a:pPr indent="0" marL="0">
+              <a:t>Berechtigungen über Rollen</a:t>
+            </a:r>
+            <a:endParaRPr lang="en-US" sz="1400" dirty="0"/>
+          </a:p>
+          <a:p>
+            <a:pPr marL="342900" indent="-342900">
               <a:lnSpc>
-                <a:spcPct val="112000"/>
+                <a:spcPct val="105000"/>
               </a:lnSpc>
-              <a:buNone/>
-            </a:pPr>
-            <a:r>
-              <a:rPr lang="en-US" sz="1300" dirty="0">
+              <a:spcAft>
+                <a:spcPts val="600"/>
+              </a:spcAft>
+              <a:buSzPct val="100000"/>
+              <a:buChar char="•"/>
+            </a:pPr>
+            <a:r>
+              <a:rPr lang="en-US" sz="1400" dirty="0">
                 <a:solidFill>
                   <a:srgbClr val="16181D"/>
                 </a:solidFill>
@@ -20407,32 +21696,104 @@
                 <a:ea typeface="Arial" pitchFamily="34" charset="-122"/>
                 <a:cs typeface="Arial" pitchFamily="34" charset="-120"/>
               </a:rPr>
-              <a:t>Thema oder die Warengruppen-Systematik werden als Hierarchie importiert und über Attribut-Mappings befüllt. Ein vorkonfiguriertes Paket gibt es noch nicht.</a:t>
-            </a:r>
-            <a:endParaRPr lang="en-US" sz="1300" dirty="0"/>
-          </a:p>
-        </p:txBody>
-      </p:sp>
-      <p:sp>
-        <p:nvSpPr>
-          <p:cNvPr id="14" name="Shape 12"/>
+              <a:t>Import von Assets</a:t>
+            </a:r>
+            <a:endParaRPr lang="en-US" sz="1400" dirty="0"/>
+          </a:p>
+          <a:p>
+            <a:pPr marL="342900" indent="-342900">
+              <a:lnSpc>
+                <a:spcPct val="105000"/>
+              </a:lnSpc>
+              <a:spcAft>
+                <a:spcPts val="600"/>
+              </a:spcAft>
+              <a:buSzPct val="100000"/>
+              <a:buChar char="•"/>
+            </a:pPr>
+            <a:r>
+              <a:rPr lang="en-US" sz="1400" dirty="0">
+                <a:solidFill>
+                  <a:srgbClr val="16181D"/>
+                </a:solidFill>
+                <a:latin typeface="Arial" pitchFamily="34" charset="0"/>
+                <a:ea typeface="Arial" pitchFamily="34" charset="-122"/>
+                <a:cs typeface="Arial" pitchFamily="34" charset="-120"/>
+              </a:rPr>
+              <a:t>Downloads</a:t>
+            </a:r>
+            <a:endParaRPr lang="en-US" sz="1400" dirty="0"/>
+          </a:p>
+          <a:p>
+            <a:pPr marL="342900" indent="-342900">
+              <a:lnSpc>
+                <a:spcPct val="105000"/>
+              </a:lnSpc>
+              <a:spcAft>
+                <a:spcPts val="600"/>
+              </a:spcAft>
+              <a:buSzPct val="100000"/>
+              <a:buChar char="•"/>
+            </a:pPr>
+            <a:r>
+              <a:rPr lang="en-US" sz="1400" dirty="0">
+                <a:solidFill>
+                  <a:srgbClr val="16181D"/>
+                </a:solidFill>
+                <a:latin typeface="Arial" pitchFamily="34" charset="0"/>
+                <a:ea typeface="Arial" pitchFamily="34" charset="-122"/>
+                <a:cs typeface="Arial" pitchFamily="34" charset="-120"/>
+              </a:rPr>
+              <a:t>Schnittstelle zum Buchshop</a:t>
+            </a:r>
+            <a:endParaRPr lang="en-US" sz="1400" dirty="0"/>
+          </a:p>
+          <a:p>
+            <a:pPr marL="342900" indent="-342900">
+              <a:lnSpc>
+                <a:spcPct val="105000"/>
+              </a:lnSpc>
+              <a:spcAft>
+                <a:spcPts val="600"/>
+              </a:spcAft>
+              <a:buSzPct val="100000"/>
+              <a:buChar char="•"/>
+            </a:pPr>
+            <a:r>
+              <a:rPr lang="en-US" sz="1400" dirty="0">
+                <a:solidFill>
+                  <a:srgbClr val="16181D"/>
+                </a:solidFill>
+                <a:latin typeface="Arial" pitchFamily="34" charset="0"/>
+                <a:ea typeface="Arial" pitchFamily="34" charset="-122"/>
+                <a:cs typeface="Arial" pitchFamily="34" charset="-120"/>
+              </a:rPr>
+              <a:t>Titeldaten, Varianten, Hierarchien</a:t>
+            </a:r>
+            <a:endParaRPr lang="en-US" sz="1400" dirty="0"/>
+          </a:p>
+        </p:txBody>
+      </p:sp>
+      <p:sp>
+        <p:nvSpPr>
+          <p:cNvPr id="10" name="Shape 8"/>
           <p:cNvSpPr/>
           <p:nvPr/>
         </p:nvSpPr>
         <p:spPr>
           <a:xfrm>
-            <a:off x="8122615" y="1691640"/>
-            <a:ext cx="3520440" cy="3657600"/>
+            <a:off x="4335628" y="1645920"/>
+            <a:ext cx="3520440" cy="3246120"/>
           </a:xfrm>
           <a:prstGeom prst="rect">
             <a:avLst/>
           </a:prstGeom>
           <a:solidFill>
-            <a:srgbClr val="E4F3F1"/>
+            <a:srgbClr val="FFFFFF"/>
           </a:solidFill>
           <a:ln w="12700">
             <a:solidFill>
-              <a:srgbClr val="E4F3F1"/>
+              <a:srgbClr val="D6DDE3"/>
             </a:solidFill>
             <a:prstDash val="solid"/>
           </a:ln>
@@ -20440,14 +21801,80 @@
       </p:sp>
       <p:sp>
         <p:nvSpPr>
-          <p:cNvPr id="15" name="Text 13"/>
-          <p:cNvSpPr txBox="1"/>
-          <p:nvPr/>
-        </p:nvSpPr>
-        <p:spPr>
-          <a:xfrm>
-            <a:off x="8396935" y="1874520"/>
-            <a:ext cx="1371600" cy="640080"/>
+          <p:cNvPr id="11" name="Shape 9"/>
+          <p:cNvSpPr/>
+          <p:nvPr/>
+        </p:nvSpPr>
+        <p:spPr>
+          <a:xfrm>
+            <a:off x="4564228" y="1874520"/>
+            <a:ext cx="1737360" cy="365760"/>
+          </a:xfrm>
+          <a:prstGeom prst="roundRect">
+            <a:avLst>
+              <a:gd name="adj" fmla="val 50000"/>
+            </a:avLst>
+          </a:prstGeom>
+          <a:solidFill>
+            <a:srgbClr val="EEF0F2"/>
+          </a:solidFill>
+          <a:ln w="12700">
+            <a:solidFill>
+              <a:srgbClr val="EEF0F2"/>
+            </a:solidFill>
+            <a:prstDash val="solid"/>
+          </a:ln>
+        </p:spPr>
+      </p:sp>
+      <p:sp>
+        <p:nvSpPr>
+          <p:cNvPr id="12" name="Text 10"/>
+          <p:cNvSpPr txBox="1"/>
+          <p:nvPr/>
+        </p:nvSpPr>
+        <p:spPr>
+          <a:xfrm>
+            <a:off x="4564228" y="1874520"/>
+            <a:ext cx="1737360" cy="365760"/>
+          </a:xfrm>
+          <a:prstGeom prst="rect">
+            <a:avLst/>
+          </a:prstGeom>
+          <a:noFill/>
+          <a:ln/>
+        </p:spPr>
+        <p:txBody>
+          <a:bodyPr wrap="square" lIns="0" tIns="0" rIns="0" bIns="0" rtlCol="0" anchor="ctr"/>
+          <a:lstStyle/>
+          <a:p>
+            <a:pPr algn="ctr" indent="0" marL="0">
+              <a:buNone/>
+            </a:pPr>
+            <a:r>
+              <a:rPr lang="en-US" sz="1200" b="1" dirty="0">
+                <a:solidFill>
+                  <a:srgbClr val="1B2D5C"/>
+                </a:solidFill>
+                <a:latin typeface="Arial" pitchFamily="34" charset="0"/>
+                <a:ea typeface="Arial" pitchFamily="34" charset="-122"/>
+                <a:cs typeface="Arial" pitchFamily="34" charset="-120"/>
+              </a:rPr>
+              <a:t>Einrichtung</a:t>
+            </a:r>
+            <a:endParaRPr lang="en-US" sz="1200" dirty="0"/>
+          </a:p>
+        </p:txBody>
+      </p:sp>
+      <p:sp>
+        <p:nvSpPr>
+          <p:cNvPr id="13" name="Text 11"/>
+          <p:cNvSpPr txBox="1"/>
+          <p:nvPr/>
+        </p:nvSpPr>
+        <p:spPr>
+          <a:xfrm>
+            <a:off x="4564228" y="2423160"/>
+            <a:ext cx="3108960" cy="2331720"/>
           </a:xfrm>
           <a:prstGeom prst="rect">
             <a:avLst/>
@@ -20459,155 +21886,502 @@
           <a:bodyPr wrap="square" lIns="0" tIns="0" rIns="0" bIns="0" rtlCol="0" anchor="t"/>
           <a:lstStyle/>
           <a:p>
+            <a:pPr marL="342900" indent="-342900">
+              <a:lnSpc>
+                <a:spcPct val="105000"/>
+              </a:lnSpc>
+              <a:spcAft>
+                <a:spcPts val="600"/>
+              </a:spcAft>
+              <a:buSzPct val="100000"/>
+              <a:buChar char="•"/>
+            </a:pPr>
+            <a:r>
+              <a:rPr lang="en-US" sz="1400" dirty="0">
+                <a:solidFill>
+                  <a:srgbClr val="16181D"/>
+                </a:solidFill>
+                <a:latin typeface="Arial" pitchFamily="34" charset="0"/>
+                <a:ea typeface="Arial" pitchFamily="34" charset="-122"/>
+                <a:cs typeface="Arial" pitchFamily="34" charset="-120"/>
+              </a:rPr>
+              <a:t>Export zum Onlinekatalog</a:t>
+            </a:r>
+            <a:endParaRPr lang="en-US" sz="1400" dirty="0"/>
+          </a:p>
+          <a:p>
+            <a:pPr marL="342900" indent="-342900">
+              <a:lnSpc>
+                <a:spcPct val="105000"/>
+              </a:lnSpc>
+              <a:spcAft>
+                <a:spcPts val="600"/>
+              </a:spcAft>
+              <a:buSzPct val="100000"/>
+              <a:buChar char="•"/>
+            </a:pPr>
+            <a:r>
+              <a:rPr lang="en-US" sz="1400" dirty="0">
+                <a:solidFill>
+                  <a:srgbClr val="16181D"/>
+                </a:solidFill>
+                <a:latin typeface="Arial" pitchFamily="34" charset="0"/>
+                <a:ea typeface="Arial" pitchFamily="34" charset="-122"/>
+                <a:cs typeface="Arial" pitchFamily="34" charset="-120"/>
+              </a:rPr>
+              <a:t>Bestellblöcke und Flyer (PDF-Vorlagen)</a:t>
+            </a:r>
+            <a:endParaRPr lang="en-US" sz="1400" dirty="0"/>
+          </a:p>
+          <a:p>
+            <a:pPr marL="342900" indent="-342900">
+              <a:lnSpc>
+                <a:spcPct val="105000"/>
+              </a:lnSpc>
+              <a:spcAft>
+                <a:spcPts val="600"/>
+              </a:spcAft>
+              <a:buSzPct val="100000"/>
+              <a:buChar char="•"/>
+            </a:pPr>
+            <a:r>
+              <a:rPr lang="en-US" sz="1400" dirty="0">
+                <a:solidFill>
+                  <a:srgbClr val="16181D"/>
+                </a:solidFill>
+                <a:latin typeface="Arial" pitchFamily="34" charset="0"/>
+                <a:ea typeface="Arial" pitchFamily="34" charset="-122"/>
+                <a:cs typeface="Arial" pitchFamily="34" charset="-120"/>
+              </a:rPr>
+              <a:t>Titelübersicht</a:t>
+            </a:r>
+            <a:endParaRPr lang="en-US" sz="1400" dirty="0"/>
+          </a:p>
+          <a:p>
+            <a:pPr marL="342900" indent="-342900">
+              <a:lnSpc>
+                <a:spcPct val="105000"/>
+              </a:lnSpc>
+              <a:spcAft>
+                <a:spcPts val="600"/>
+              </a:spcAft>
+              <a:buSzPct val="100000"/>
+              <a:buChar char="•"/>
+            </a:pPr>
+            <a:r>
+              <a:rPr lang="en-US" sz="1400" dirty="0">
+                <a:solidFill>
+                  <a:srgbClr val="16181D"/>
+                </a:solidFill>
+                <a:latin typeface="Arial" pitchFamily="34" charset="0"/>
+                <a:ea typeface="Arial" pitchFamily="34" charset="-122"/>
+                <a:cs typeface="Arial" pitchFamily="34" charset="-120"/>
+              </a:rPr>
+              <a:t>Textprüfungen (Prüfregeln)</a:t>
+            </a:r>
+            <a:endParaRPr lang="en-US" sz="1400" dirty="0"/>
+          </a:p>
+          <a:p>
+            <a:pPr marL="342900" indent="-342900">
+              <a:lnSpc>
+                <a:spcPct val="105000"/>
+              </a:lnSpc>
+              <a:spcAft>
+                <a:spcPts val="600"/>
+              </a:spcAft>
+              <a:buSzPct val="100000"/>
+              <a:buChar char="•"/>
+            </a:pPr>
+            <a:r>
+              <a:rPr lang="en-US" sz="1400" dirty="0">
+                <a:solidFill>
+                  <a:srgbClr val="16181D"/>
+                </a:solidFill>
+                <a:latin typeface="Arial" pitchFamily="34" charset="0"/>
+                <a:ea typeface="Arial" pitchFamily="34" charset="-122"/>
+                <a:cs typeface="Arial" pitchFamily="34" charset="-120"/>
+              </a:rPr>
+              <a:t>Schnittstelle zum Formularserver</a:t>
+            </a:r>
+            <a:endParaRPr lang="en-US" sz="1400" dirty="0"/>
+          </a:p>
+        </p:txBody>
+      </p:sp>
+      <p:sp>
+        <p:nvSpPr>
+          <p:cNvPr id="14" name="Shape 12"/>
+          <p:cNvSpPr/>
+          <p:nvPr/>
+        </p:nvSpPr>
+        <p:spPr>
+          <a:xfrm>
+            <a:off x="8122615" y="1645920"/>
+            <a:ext cx="3520440" cy="3246120"/>
+          </a:xfrm>
+          <a:prstGeom prst="rect">
+            <a:avLst/>
+          </a:prstGeom>
+          <a:solidFill>
+            <a:srgbClr val="000E2F"/>
+          </a:solidFill>
+          <a:ln w="12700">
+            <a:solidFill>
+              <a:srgbClr val="000E2F"/>
+            </a:solidFill>
+            <a:prstDash val="solid"/>
+          </a:ln>
+        </p:spPr>
+      </p:sp>
+      <p:sp>
+        <p:nvSpPr>
+          <p:cNvPr id="15" name="Shape 13"/>
+          <p:cNvSpPr/>
+          <p:nvPr/>
+        </p:nvSpPr>
+        <p:spPr>
+          <a:xfrm>
+            <a:off x="8351215" y="1874520"/>
+            <a:ext cx="2377440" cy="365760"/>
+          </a:xfrm>
+          <a:prstGeom prst="roundRect">
+            <a:avLst>
+              <a:gd name="adj" fmla="val 50000"/>
+            </a:avLst>
+          </a:prstGeom>
+          <a:solidFill>
+            <a:srgbClr val="FFFFFF"/>
+          </a:solidFill>
+          <a:ln w="12700">
+            <a:solidFill>
+              <a:srgbClr val="FFFFFF"/>
+            </a:solidFill>
+            <a:prstDash val="solid"/>
+          </a:ln>
+        </p:spPr>
+      </p:sp>
+      <p:sp>
+        <p:nvSpPr>
+          <p:cNvPr id="16" name="Text 14"/>
+          <p:cNvSpPr txBox="1"/>
+          <p:nvPr/>
+        </p:nvSpPr>
+        <p:spPr>
+          <a:xfrm>
+            <a:off x="8351215" y="1874520"/>
+            <a:ext cx="2377440" cy="365760"/>
+          </a:xfrm>
+          <a:prstGeom prst="rect">
+            <a:avLst/>
+          </a:prstGeom>
+          <a:noFill/>
+          <a:ln/>
+        </p:spPr>
+        <p:txBody>
+          <a:bodyPr wrap="square" lIns="0" tIns="0" rIns="0" bIns="0" rtlCol="0" anchor="ctr"/>
+          <a:lstStyle/>
+          <a:p>
+            <a:pPr algn="ctr" indent="0" marL="0">
+              <a:buNone/>
+            </a:pPr>
+            <a:r>
+              <a:rPr lang="en-US" sz="1200" b="1" dirty="0">
+                <a:solidFill>
+                  <a:srgbClr val="000E2F"/>
+                </a:solidFill>
+                <a:latin typeface="Arial" pitchFamily="34" charset="0"/>
+                <a:ea typeface="Arial" pitchFamily="34" charset="-122"/>
+                <a:cs typeface="Arial" pitchFamily="34" charset="-120"/>
+              </a:rPr>
+              <a:t>Projekt → wird Standard</a:t>
+            </a:r>
+            <a:endParaRPr lang="en-US" sz="1200" dirty="0"/>
+          </a:p>
+        </p:txBody>
+      </p:sp>
+      <p:sp>
+        <p:nvSpPr>
+          <p:cNvPr id="17" name="Text 15"/>
+          <p:cNvSpPr txBox="1"/>
+          <p:nvPr/>
+        </p:nvSpPr>
+        <p:spPr>
+          <a:xfrm>
+            <a:off x="8351215" y="2423160"/>
+            <a:ext cx="3108960" cy="2331720"/>
+          </a:xfrm>
+          <a:prstGeom prst="rect">
+            <a:avLst/>
+          </a:prstGeom>
+          <a:noFill/>
+          <a:ln/>
+        </p:spPr>
+        <p:txBody>
+          <a:bodyPr wrap="square" lIns="0" tIns="0" rIns="0" bIns="0" rtlCol="0" anchor="t"/>
+          <a:lstStyle/>
+          <a:p>
+            <a:pPr marL="342900" indent="-342900">
+              <a:lnSpc>
+                <a:spcPct val="105000"/>
+              </a:lnSpc>
+              <a:spcAft>
+                <a:spcPts val="600"/>
+              </a:spcAft>
+              <a:buSzPct val="100000"/>
+              <a:buChar char="•"/>
+            </a:pPr>
+            <a:r>
+              <a:rPr lang="en-US" sz="1400" dirty="0">
+                <a:solidFill>
+                  <a:srgbClr val="FFFFFF"/>
+                </a:solidFill>
+                <a:latin typeface="Arial" pitchFamily="34" charset="0"/>
+                <a:ea typeface="Arial" pitchFamily="34" charset="-122"/>
+                <a:cs typeface="Arial" pitchFamily="34" charset="-120"/>
+              </a:rPr>
+              <a:t>Übernahme Metadaten aus Cover</a:t>
+            </a:r>
+            <a:endParaRPr lang="en-US" sz="1400" dirty="0"/>
+          </a:p>
+          <a:p>
+            <a:pPr marL="342900" indent="-342900">
+              <a:lnSpc>
+                <a:spcPct val="105000"/>
+              </a:lnSpc>
+              <a:spcAft>
+                <a:spcPts val="600"/>
+              </a:spcAft>
+              <a:buSzPct val="100000"/>
+              <a:buChar char="•"/>
+            </a:pPr>
+            <a:r>
+              <a:rPr lang="en-US" sz="1400" dirty="0">
+                <a:solidFill>
+                  <a:srgbClr val="FFFFFF"/>
+                </a:solidFill>
+                <a:latin typeface="Arial" pitchFamily="34" charset="0"/>
+                <a:ea typeface="Arial" pitchFamily="34" charset="-122"/>
+                <a:cs typeface="Arial" pitchFamily="34" charset="-120"/>
+              </a:rPr>
+              <a:t>Exporte nach EasyCatalog: Vorschau, Vorschau RS, Buchinfo, Foreign Rights</a:t>
+            </a:r>
+            <a:endParaRPr lang="en-US" sz="1400" dirty="0"/>
+          </a:p>
+          <a:p>
+            <a:pPr marL="342900" indent="-342900">
+              <a:lnSpc>
+                <a:spcPct val="105000"/>
+              </a:lnSpc>
+              <a:spcAft>
+                <a:spcPts val="600"/>
+              </a:spcAft>
+              <a:buSzPct val="100000"/>
+              <a:buChar char="•"/>
+            </a:pPr>
+            <a:r>
+              <a:rPr lang="en-US" sz="1400" dirty="0">
+                <a:solidFill>
+                  <a:srgbClr val="FFFFFF"/>
+                </a:solidFill>
+                <a:latin typeface="Arial" pitchFamily="34" charset="0"/>
+                <a:ea typeface="Arial" pitchFamily="34" charset="-122"/>
+                <a:cs typeface="Arial" pitchFamily="34" charset="-120"/>
+              </a:rPr>
+              <a:t>Export Thieme</a:t>
+            </a:r>
+            <a:endParaRPr lang="en-US" sz="1400" dirty="0"/>
+          </a:p>
+          <a:p>
+            <a:pPr marL="342900" indent="-342900">
+              <a:lnSpc>
+                <a:spcPct val="105000"/>
+              </a:lnSpc>
+              <a:spcAft>
+                <a:spcPts val="600"/>
+              </a:spcAft>
+              <a:buSzPct val="100000"/>
+              <a:buChar char="•"/>
+            </a:pPr>
+            <a:r>
+              <a:rPr lang="en-US" sz="1400" dirty="0">
+                <a:solidFill>
+                  <a:srgbClr val="FFFFFF"/>
+                </a:solidFill>
+                <a:latin typeface="Arial" pitchFamily="34" charset="0"/>
+                <a:ea typeface="Arial" pitchFamily="34" charset="-122"/>
+                <a:cs typeface="Arial" pitchFamily="34" charset="-120"/>
+              </a:rPr>
+              <a:t>XML-Metadaten / ONIX</a:t>
+            </a:r>
+            <a:endParaRPr lang="en-US" sz="1400" dirty="0"/>
+          </a:p>
+          <a:p>
+            <a:pPr marL="342900" indent="-342900">
+              <a:lnSpc>
+                <a:spcPct val="105000"/>
+              </a:lnSpc>
+              <a:spcAft>
+                <a:spcPts val="600"/>
+              </a:spcAft>
+              <a:buSzPct val="100000"/>
+              <a:buChar char="•"/>
+            </a:pPr>
+            <a:r>
+              <a:rPr lang="en-US" sz="1400" dirty="0">
+                <a:solidFill>
+                  <a:srgbClr val="FFFFFF"/>
+                </a:solidFill>
+                <a:latin typeface="Arial" pitchFamily="34" charset="0"/>
+                <a:ea typeface="Arial" pitchFamily="34" charset="-122"/>
+                <a:cs typeface="Arial" pitchFamily="34" charset="-120"/>
+              </a:rPr>
+              <a:t>Uploads im Onlinekatalog</a:t>
+            </a:r>
+            <a:endParaRPr lang="en-US" sz="1400" dirty="0"/>
+          </a:p>
+        </p:txBody>
+      </p:sp>
+      <p:sp>
+        <p:nvSpPr>
+          <p:cNvPr id="18" name="Text 16"/>
+          <p:cNvSpPr txBox="1"/>
+          <p:nvPr/>
+        </p:nvSpPr>
+        <p:spPr>
+          <a:xfrm>
+            <a:off x="548640" y="5029200"/>
+            <a:ext cx="11094415" cy="320040"/>
+          </a:xfrm>
+          <a:prstGeom prst="rect">
+            <a:avLst/>
+          </a:prstGeom>
+          <a:noFill/>
+          <a:ln/>
+        </p:spPr>
+        <p:txBody>
+          <a:bodyPr wrap="square" lIns="0" tIns="0" rIns="0" bIns="0" rtlCol="0" anchor="t"/>
+          <a:lstStyle/>
+          <a:p>
             <a:pPr indent="0" marL="0">
               <a:buNone/>
             </a:pPr>
             <a:r>
-              <a:rPr lang="en-US" sz="3600" dirty="0">
-                <a:solidFill>
-                  <a:srgbClr val="1B2D5C"/>
-                </a:solidFill>
-                <a:latin typeface="Arial" pitchFamily="34" charset="0"/>
-                <a:ea typeface="Arial" pitchFamily="34" charset="-122"/>
-                <a:cs typeface="Arial" pitchFamily="34" charset="-120"/>
-              </a:rPr>
-              <a:t>03</a:t>
-            </a:r>
-            <a:endParaRPr lang="en-US" sz="3600" dirty="0"/>
-          </a:p>
-        </p:txBody>
-      </p:sp>
-      <p:sp>
-        <p:nvSpPr>
-          <p:cNvPr id="16" name="Text 14"/>
-          <p:cNvSpPr txBox="1"/>
-          <p:nvPr/>
-        </p:nvSpPr>
-        <p:spPr>
-          <a:xfrm>
-            <a:off x="8396935" y="2606040"/>
-            <a:ext cx="2971800" cy="411480"/>
-          </a:xfrm>
-          <a:prstGeom prst="rect">
-            <a:avLst/>
-          </a:prstGeom>
-          <a:noFill/>
-          <a:ln/>
-        </p:spPr>
-        <p:txBody>
-          <a:bodyPr wrap="square" lIns="0" tIns="0" rIns="0" bIns="0" rtlCol="0" anchor="t"/>
-          <a:lstStyle/>
-          <a:p>
+              <a:rPr lang="en-US" sz="1200" b="1" dirty="0">
+                <a:solidFill>
+                  <a:srgbClr val="4B5563"/>
+                </a:solidFill>
+                <a:latin typeface="Arial" pitchFamily="34" charset="0"/>
+                <a:ea typeface="Arial" pitchFamily="34" charset="-122"/>
+                <a:cs typeface="Arial" pitchFamily="34" charset="-120"/>
+              </a:rPr>
+              <a:t>Zu klären: </a:t>
+            </a:r>
             <a:pPr indent="0" marL="0">
               <a:buNone/>
             </a:pPr>
             <a:r>
-              <a:rPr lang="en-US" sz="1900" b="1" dirty="0">
-                <a:solidFill>
-                  <a:srgbClr val="16181D"/>
-                </a:solidFill>
-                <a:latin typeface="Arial" pitchFamily="34" charset="0"/>
-                <a:ea typeface="Arial" pitchFamily="34" charset="-122"/>
-                <a:cs typeface="Arial" pitchFamily="34" charset="-120"/>
-              </a:rPr>
-              <a:t>Verlagssoftware</a:t>
-            </a:r>
-            <a:endParaRPr lang="en-US" sz="1900" dirty="0"/>
-          </a:p>
-        </p:txBody>
-      </p:sp>
-      <p:sp>
-        <p:nvSpPr>
-          <p:cNvPr id="17" name="Text 15"/>
-          <p:cNvSpPr txBox="1"/>
-          <p:nvPr/>
-        </p:nvSpPr>
-        <p:spPr>
-          <a:xfrm>
-            <a:off x="8396935" y="3108960"/>
-            <a:ext cx="2971800" cy="2103120"/>
-          </a:xfrm>
-          <a:prstGeom prst="rect">
-            <a:avLst/>
-          </a:prstGeom>
-          <a:noFill/>
-          <a:ln/>
-        </p:spPr>
-        <p:txBody>
-          <a:bodyPr wrap="square" lIns="0" tIns="0" rIns="0" bIns="0" rtlCol="0" anchor="t"/>
+              <a:rPr lang="en-US" sz="1200" dirty="0">
+                <a:solidFill>
+                  <a:srgbClr val="4B5563"/>
+                </a:solidFill>
+                <a:latin typeface="Arial" pitchFamily="34" charset="0"/>
+                <a:ea typeface="Arial" pitchFamily="34" charset="-122"/>
+                <a:cs typeface="Arial" pitchFamily="34" charset="-120"/>
+              </a:rPr>
+              <a:t>Pimcore für den Ärzteshop (eigene Instanz oder eigener Bereich?)  ·  Cloud-Anwendung für Compu</a:t>
+            </a:r>
+            <a:endParaRPr lang="en-US" sz="1200" dirty="0"/>
+          </a:p>
+        </p:txBody>
+      </p:sp>
+      <p:sp>
+        <p:nvSpPr>
+          <p:cNvPr id="19" name="Shape 17"/>
+          <p:cNvSpPr/>
+          <p:nvPr/>
+        </p:nvSpPr>
+        <p:spPr>
+          <a:xfrm>
+            <a:off x="548640" y="5440680"/>
+            <a:ext cx="11094415" cy="777240"/>
+          </a:xfrm>
+          <a:prstGeom prst="rect">
+            <a:avLst/>
+          </a:prstGeom>
+          <a:solidFill>
+            <a:srgbClr val="C6E6E3"/>
+          </a:solidFill>
+          <a:ln w="12700">
+            <a:solidFill>
+              <a:srgbClr val="C6E6E3"/>
+            </a:solidFill>
+            <a:prstDash val="solid"/>
+          </a:ln>
+        </p:spPr>
+      </p:sp>
+      <p:sp>
+        <p:nvSpPr>
+          <p:cNvPr id="20" name="Text 18"/>
+          <p:cNvSpPr txBox="1"/>
+          <p:nvPr/>
+        </p:nvSpPr>
+        <p:spPr>
+          <a:xfrm>
+            <a:off x="777240" y="5440680"/>
+            <a:ext cx="10637215" cy="777240"/>
+          </a:xfrm>
+          <a:prstGeom prst="rect">
+            <a:avLst/>
+          </a:prstGeom>
+          <a:noFill/>
+          <a:ln/>
+        </p:spPr>
+        <p:txBody>
+          <a:bodyPr wrap="square" lIns="0" tIns="0" rIns="0" bIns="0" rtlCol="0" anchor="ctr"/>
           <a:lstStyle/>
           <a:p>
             <a:pPr indent="0" marL="0">
-              <a:lnSpc>
-                <a:spcPct val="112000"/>
-              </a:lnSpc>
-              <a:buNone/>
-            </a:pPr>
-            <a:r>
-              <a:rPr lang="en-US" sz="1300" dirty="0">
-                <a:solidFill>
-                  <a:srgbClr val="16181D"/>
-                </a:solidFill>
-                <a:latin typeface="Arial" pitchFamily="34" charset="0"/>
-                <a:ea typeface="Arial" pitchFamily="34" charset="-122"/>
-                <a:cs typeface="Arial" pitchFamily="34" charset="-120"/>
-              </a:rPr>
-              <a:t>Herstellung, Honorare und Rechte bleiben in der bestehenden Verlagssoftware. anyPIM ergänzt sie als führendes System für Titel- und Vermarktungsdaten – wie heute Pimcore 6.</a:t>
-            </a:r>
-            <a:endParaRPr lang="en-US" sz="1300" dirty="0"/>
-          </a:p>
-        </p:txBody>
-      </p:sp>
-      <p:sp>
-        <p:nvSpPr>
-          <p:cNvPr id="18" name="Text 16"/>
-          <p:cNvSpPr txBox="1"/>
-          <p:nvPr/>
-        </p:nvSpPr>
-        <p:spPr>
-          <a:xfrm>
-            <a:off x="548640" y="5577840"/>
-            <a:ext cx="11094415" cy="457200"/>
-          </a:xfrm>
-          <a:prstGeom prst="rect">
-            <a:avLst/>
-          </a:prstGeom>
-          <a:noFill/>
-          <a:ln/>
-        </p:spPr>
-        <p:txBody>
-          <a:bodyPr wrap="square" lIns="0" tIns="0" rIns="0" bIns="0" rtlCol="0" anchor="t"/>
-          <a:lstStyle/>
-          <a:p>
+              <a:buNone/>
+            </a:pPr>
+            <a:r>
+              <a:rPr lang="en-US" sz="1350" b="1" dirty="0">
+                <a:solidFill>
+                  <a:srgbClr val="E2211C"/>
+                </a:solidFill>
+                <a:latin typeface="Arial" pitchFamily="34" charset="0"/>
+                <a:ea typeface="Arial" pitchFamily="34" charset="-122"/>
+                <a:cs typeface="Arial" pitchFamily="34" charset="-120"/>
+              </a:rPr>
+              <a:t>→  </a:t>
+            </a:r>
             <a:pPr indent="0" marL="0">
               <a:buNone/>
             </a:pPr>
             <a:r>
-              <a:rPr lang="en-US" sz="1500" b="1" dirty="0">
-                <a:solidFill>
-                  <a:srgbClr val="E2211C"/>
-                </a:solidFill>
-                <a:latin typeface="Arial" pitchFamily="34" charset="0"/>
-                <a:ea typeface="Arial" pitchFamily="34" charset="-122"/>
-                <a:cs typeface="Arial" pitchFamily="34" charset="-120"/>
-              </a:rPr>
-              <a:t>→  </a:t>
+              <a:rPr lang="en-US" sz="1350" b="1" dirty="0">
+                <a:solidFill>
+                  <a:srgbClr val="000E2F"/>
+                </a:solidFill>
+                <a:latin typeface="Arial" pitchFamily="34" charset="0"/>
+                <a:ea typeface="Arial" pitchFamily="34" charset="-122"/>
+                <a:cs typeface="Arial" pitchFamily="34" charset="-120"/>
+              </a:rPr>
+              <a:t>Der Unterschied: </a:t>
             </a:r>
             <a:pPr indent="0" marL="0">
               <a:buNone/>
             </a:pPr>
             <a:r>
-              <a:rPr lang="en-US" sz="1500" dirty="0">
-                <a:solidFill>
-                  <a:srgbClr val="1B2D5C"/>
-                </a:solidFill>
-                <a:latin typeface="Arial" pitchFamily="34" charset="0"/>
-                <a:ea typeface="Arial" pitchFamily="34" charset="-122"/>
-                <a:cs typeface="Arial" pitchFamily="34" charset="-120"/>
-              </a:rPr>
-              <a:t>Den ONIX-Export braucht Kohlhammer in beiden Szenarien. Bei anyPIM entsteht er als Standardformat des Produkts.</a:t>
-            </a:r>
-            <a:endParaRPr lang="en-US" sz="1500" dirty="0"/>
+              <a:rPr lang="en-US" sz="1350" dirty="0">
+                <a:solidFill>
+                  <a:srgbClr val="000E2F"/>
+                </a:solidFill>
+                <a:latin typeface="Arial" pitchFamily="34" charset="0"/>
+                <a:ea typeface="Arial" pitchFamily="34" charset="-122"/>
+                <a:cs typeface="Arial" pitchFamily="34" charset="-120"/>
+              </a:rPr>
+              <a:t>Beim Pimcore-Upgrade werden diese Funktionen erneut als Eigenentwicklung portiert und bei jedem Release wieder angefasst. Bei anyPIM bauen wir sie einmal als Standardfunktion – Kohlhammer erhält sie danach mit jedem Update.</a:t>
+            </a:r>
+            <a:endParaRPr lang="en-US" sz="1350" dirty="0"/>
           </a:p>
         </p:txBody>
       </p:sp>

</xml_diff>

<commit_message>
Sales: Kohlhammer-Vorlage um Folie 'Bei anyPIM gestaltet Kohlhammer mit' ergänzt
Open Source, KI-ready (MCP, KI-Texte, semantische Suche), erweiterbar,
dokumentiert – und Kohlhammer-Anforderungen fließen in die Roadmap.

Co-Authored-By: Claude Opus 5.5 <noreply@anthropic.com>
Claude-Session: https://claude.ai/code/session_019qs2qjmit64azXVvXyRtsJ
</commit_message>
<xml_diff>
--- a/docs/sales/kohlhammer-anypim-vs-pimcore.pptx
+++ b/docs/sales/kohlhammer-anypim-vs-pimcore.pptx
@@ -20,9 +20,10 @@
     <p:sldId id="268" r:id="rId14"/>
     <p:sldId id="269" r:id="rId15"/>
     <p:sldId id="270" r:id="rId16"/>
+    <p:sldId id="271" r:id="rId17"/>
   </p:sldIdLst>
   <p:notesMasterIdLst>
-    <p:notesMasterId r:id="rId17"/>
+    <p:notesMasterId r:id="rId18"/>
   </p:notesMasterIdLst>
   <p:sldSz cx="12192000" cy="6858000"/>
   <p:notesSz cx="6858000" cy="12192000"/>
@@ -956,7 +957,7 @@
           <a:p>
             <a:r>
               <a:rPr lang="en-US" dirty="0"/>
-              <a:t>Zeiträume sind Richtwerte und werden in der Bestandsaufnahme geschärft. Der Pilot mit dem Fachbereich Brandschutz liefert eine belastbare Entscheidungsgrundlage auf echten Daten, bevor das ganze Programm umzieht.</a:t>
+              <a:t>Kernbotschaft: Bei anyPIM gestaltet Kohlhammer das Produkt mit. Die vier Säulen machen das möglich: offener Code, KI-Anbindung über MCP und KI-Dienste, klare Erweiterungspunkte und eine Dokumentation, die Menschen und KI-Agenten gleichermaßen nutzen. Was Kohlhammer braucht, wird Standard – und bleibt es bei jedem Update.</a:t>
             </a:r>
             <a:endParaRPr lang="en-US" dirty="0"/>
           </a:p>
@@ -1044,7 +1045,7 @@
           <a:p>
             <a:r>
               <a:rPr lang="en-US" dirty="0"/>
-              <a:t>Abschluss mit konkretem Vorschlag: Workshop und Pilot. So entscheidet Kohlhammer auf Basis eigener Daten, nicht auf Basis von Folien.</a:t>
+              <a:t>Zeiträume sind Richtwerte und werden in der Bestandsaufnahme geschärft. Der Pilot mit dem Fachbereich Brandschutz liefert eine belastbare Entscheidungsgrundlage auf echten Daten, bevor das ganze Programm umzieht.</a:t>
             </a:r>
             <a:endParaRPr lang="en-US" dirty="0"/>
           </a:p>
@@ -1068,6 +1069,94 @@
             <a:fld id="{F7021451-1387-4CA6-816F-3879F97B5CBC}" type="slidenum">
               <a:rPr lang="en-US"/>
               <a:t>15</a:t>
+            </a:fld>
+            <a:endParaRPr lang="en-US"/>
+          </a:p>
+        </p:txBody>
+      </p:sp>
+    </p:spTree>
+    <p:extLst>
+      <p:ext uri="{BB962C8B-B14F-4D97-AF65-F5344CB8AC3E}">
+        <p14:creationId xmlns:p14="http://schemas.microsoft.com/office/powerpoint/2010/main" val="1024086991"/>
+      </p:ext>
+    </p:extLst>
+  </p:cSld>
+  <p:clrMapOvr>
+    <a:masterClrMapping/>
+  </p:clrMapOvr>
+</p:notes>
+</file>
+
+<file path=ppt/notesSlides/notesSlide16.xml><?xml version="1.0" encoding="utf-8"?>
+<p:notes xmlns:a="http://schemas.openxmlformats.org/drawingml/2006/main" xmlns:r="http://schemas.openxmlformats.org/officeDocument/2006/relationships" xmlns:p="http://schemas.openxmlformats.org/presentationml/2006/main">
+  <p:cSld>
+    <p:spTree>
+      <p:nvGrpSpPr>
+        <p:cNvPr id="1" name=""/>
+        <p:cNvGrpSpPr/>
+        <p:nvPr/>
+      </p:nvGrpSpPr>
+      <p:grpSpPr>
+        <a:xfrm>
+          <a:off x="0" y="0"/>
+          <a:ext cx="0" cy="0"/>
+          <a:chOff x="0" y="0"/>
+          <a:chExt cx="0" cy="0"/>
+        </a:xfrm>
+      </p:grpSpPr>
+      <p:sp>
+        <p:nvSpPr>
+          <p:cNvPr id="2" name="Slide Image Placeholder 1"/>
+          <p:cNvSpPr>
+            <a:spLocks noGrp="1" noRot="1" noChangeAspect="1"/>
+          </p:cNvSpPr>
+          <p:nvPr>
+            <p:ph type="sldImg"/>
+          </p:nvPr>
+        </p:nvSpPr>
+        <p:spPr/>
+      </p:sp>
+      <p:sp>
+        <p:nvSpPr>
+          <p:cNvPr id="3" name="Notes Placeholder 2"/>
+          <p:cNvSpPr>
+            <a:spLocks noGrp="1"/>
+          </p:cNvSpPr>
+          <p:nvPr>
+            <p:ph type="body" idx="1"/>
+          </p:nvPr>
+        </p:nvSpPr>
+        <p:spPr/>
+        <p:txBody>
+          <a:bodyPr/>
+          <a:lstStyle/>
+          <a:p>
+            <a:r>
+              <a:rPr lang="en-US" dirty="0"/>
+              <a:t>Abschluss mit konkretem Vorschlag: Workshop und Pilot. So entscheidet Kohlhammer auf Basis eigener Daten, nicht auf Basis von Folien.</a:t>
+            </a:r>
+            <a:endParaRPr lang="en-US" dirty="0"/>
+          </a:p>
+        </p:txBody>
+      </p:sp>
+      <p:sp>
+        <p:nvSpPr>
+          <p:cNvPr id="4" name="Slide Number Placeholder 3"/>
+          <p:cNvSpPr>
+            <a:spLocks noGrp="1"/>
+          </p:cNvSpPr>
+          <p:nvPr>
+            <p:ph type="sldNum" sz="quarter" idx="10"/>
+          </p:nvPr>
+        </p:nvSpPr>
+        <p:spPr/>
+        <p:txBody>
+          <a:bodyPr/>
+          <a:lstStyle/>
+          <a:p>
+            <a:fld id="{F7021451-1387-4CA6-816F-3879F97B5CBC}" type="slidenum">
+              <a:rPr lang="en-US"/>
+              <a:t>16</a:t>
             </a:fld>
             <a:endParaRPr lang="en-US"/>
           </a:p>
@@ -10829,7 +10918,7 @@
                 <a:ea typeface="Arial" pitchFamily="34" charset="-122"/>
                 <a:cs typeface="Arial" pitchFamily="34" charset="-120"/>
               </a:rPr>
-              <a:t>VORGESCHLAGENER FAHRPLAN</a:t>
+              <a:t>BEI ANYPIM GESTALTET KOHLHAMMER MIT</a:t>
             </a:r>
             <a:endParaRPr lang="en-US" sz="3000" dirty="0"/>
           </a:p>
@@ -10868,7 +10957,7 @@
                 <a:ea typeface="Arial" pitchFamily="34" charset="-122"/>
                 <a:cs typeface="Arial" pitchFamily="34" charset="-120"/>
               </a:rPr>
-              <a:t>Richtwerte für den Workshop. Pimcore 6 läuft bis zur Umstellung weiter; ein Fachbereich dient als Pilot.</a:t>
+              <a:t>Offen, KI-ready, erweiterbar und dokumentiert – und die Roadmap entsteht mit den Kunden.</a:t>
             </a:r>
             <a:endParaRPr lang="en-US" sz="1400" dirty="0"/>
           </a:p>
@@ -10960,31 +11049,8 @@
         </p:nvSpPr>
         <p:spPr>
           <a:xfrm>
-            <a:off x="640080" y="2377440"/>
-            <a:ext cx="10911535" cy="0"/>
-          </a:xfrm>
-          <a:prstGeom prst="line">
-            <a:avLst/>
-          </a:prstGeom>
-          <a:noFill/>
-          <a:ln w="19050">
-            <a:solidFill>
-              <a:srgbClr val="1B2D5C"/>
-            </a:solidFill>
-            <a:prstDash val="solid"/>
-          </a:ln>
-        </p:spPr>
-      </p:sp>
-      <p:sp>
-        <p:nvSpPr>
-          <p:cNvPr id="7" name="Shape 5"/>
-          <p:cNvSpPr/>
-          <p:nvPr/>
-        </p:nvSpPr>
-        <p:spPr>
-          <a:xfrm>
-            <a:off x="548640" y="2240280"/>
-            <a:ext cx="274320" cy="274320"/>
+            <a:off x="548640" y="1645920"/>
+            <a:ext cx="2567864" cy="566928"/>
           </a:xfrm>
           <a:prstGeom prst="rect">
             <a:avLst/>
@@ -11002,40 +11068,79 @@
       </p:sp>
       <p:sp>
         <p:nvSpPr>
+          <p:cNvPr id="7" name="Text 5"/>
+          <p:cNvSpPr txBox="1"/>
+          <p:nvPr/>
+        </p:nvSpPr>
+        <p:spPr>
+          <a:xfrm>
+            <a:off x="731520" y="1645920"/>
+            <a:ext cx="1882064" cy="566928"/>
+          </a:xfrm>
+          <a:prstGeom prst="rect">
+            <a:avLst/>
+          </a:prstGeom>
+          <a:noFill/>
+          <a:ln/>
+        </p:spPr>
+        <p:txBody>
+          <a:bodyPr wrap="square" lIns="0" tIns="0" rIns="0" bIns="0" rtlCol="0" anchor="ctr"/>
+          <a:lstStyle/>
+          <a:p>
+            <a:pPr indent="0" marL="0">
+              <a:buNone/>
+            </a:pPr>
+            <a:r>
+              <a:rPr lang="en-US" sz="1500" dirty="0">
+                <a:solidFill>
+                  <a:srgbClr val="FFFFFF"/>
+                </a:solidFill>
+                <a:latin typeface="Arial" pitchFamily="34" charset="0"/>
+                <a:ea typeface="Arial" pitchFamily="34" charset="-122"/>
+                <a:cs typeface="Arial" pitchFamily="34" charset="-120"/>
+              </a:rPr>
+              <a:t>Open Source</a:t>
+            </a:r>
+            <a:endParaRPr lang="en-US" sz="1500" dirty="0"/>
+          </a:p>
+        </p:txBody>
+      </p:sp>
+      <p:sp>
+        <p:nvSpPr>
           <p:cNvPr id="8" name="Text 6"/>
           <p:cNvSpPr txBox="1"/>
           <p:nvPr/>
         </p:nvSpPr>
         <p:spPr>
           <a:xfrm>
-            <a:off x="548640" y="2788920"/>
-            <a:ext cx="2560320" cy="731520"/>
-          </a:xfrm>
-          <a:prstGeom prst="rect">
-            <a:avLst/>
-          </a:prstGeom>
-          <a:noFill/>
-          <a:ln/>
-        </p:spPr>
-        <p:txBody>
-          <a:bodyPr wrap="square" lIns="0" tIns="0" rIns="0" bIns="0" rtlCol="0" anchor="t"/>
-          <a:lstStyle/>
-          <a:p>
-            <a:pPr indent="0" marL="0">
-              <a:buNone/>
-            </a:pPr>
-            <a:r>
-              <a:rPr lang="en-US" sz="4000" dirty="0">
-                <a:solidFill>
-                  <a:srgbClr val="1B2D5C"/>
-                </a:solidFill>
-                <a:latin typeface="Arial" pitchFamily="34" charset="0"/>
-                <a:ea typeface="Arial" pitchFamily="34" charset="-122"/>
-                <a:cs typeface="Arial" pitchFamily="34" charset="-120"/>
-              </a:rPr>
-              <a:t>01</a:t>
-            </a:r>
-            <a:endParaRPr lang="en-US" sz="4000" dirty="0"/>
+            <a:off x="2613584" y="1645920"/>
+            <a:ext cx="365760" cy="566928"/>
+          </a:xfrm>
+          <a:prstGeom prst="rect">
+            <a:avLst/>
+          </a:prstGeom>
+          <a:noFill/>
+          <a:ln/>
+        </p:spPr>
+        <p:txBody>
+          <a:bodyPr wrap="square" lIns="0" tIns="0" rIns="0" bIns="0" rtlCol="0" anchor="ctr"/>
+          <a:lstStyle/>
+          <a:p>
+            <a:pPr algn="r" indent="0" marL="0">
+              <a:buNone/>
+            </a:pPr>
+            <a:r>
+              <a:rPr lang="en-US" sz="1800" dirty="0">
+                <a:solidFill>
+                  <a:srgbClr val="FFFFFF"/>
+                </a:solidFill>
+                <a:latin typeface="Arial" pitchFamily="34" charset="0"/>
+                <a:ea typeface="Arial" pitchFamily="34" charset="-122"/>
+                <a:cs typeface="Arial" pitchFamily="34" charset="-120"/>
+              </a:rPr>
+              <a:t>→</a:t>
+            </a:r>
+            <a:endParaRPr lang="en-US" sz="1800" dirty="0"/>
           </a:p>
         </p:txBody>
       </p:sp>
@@ -11047,86 +11152,8 @@
         </p:nvSpPr>
         <p:spPr>
           <a:xfrm>
-            <a:off x="548640" y="3611880"/>
-            <a:ext cx="2560320" cy="256032"/>
-          </a:xfrm>
-          <a:prstGeom prst="rect">
-            <a:avLst/>
-          </a:prstGeom>
-          <a:noFill/>
-          <a:ln/>
-        </p:spPr>
-        <p:txBody>
-          <a:bodyPr wrap="square" lIns="0" tIns="0" rIns="0" bIns="0" rtlCol="0" anchor="t"/>
-          <a:lstStyle/>
-          <a:p>
-            <a:pPr indent="0" marL="0">
-              <a:buNone/>
-            </a:pPr>
-            <a:r>
-              <a:rPr lang="en-US" sz="1000" b="1" spc="100" kern="0" dirty="0">
-                <a:solidFill>
-                  <a:srgbClr val="4B5563"/>
-                </a:solidFill>
-                <a:latin typeface="Arial" pitchFamily="34" charset="0"/>
-                <a:ea typeface="Arial" pitchFamily="34" charset="-122"/>
-                <a:cs typeface="Arial" pitchFamily="34" charset="-120"/>
-              </a:rPr>
-              <a:t>CA. 2 WOCHEN</a:t>
-            </a:r>
-            <a:endParaRPr lang="en-US" sz="1000" dirty="0"/>
-          </a:p>
-        </p:txBody>
-      </p:sp>
-      <p:sp>
-        <p:nvSpPr>
-          <p:cNvPr id="10" name="Text 8"/>
-          <p:cNvSpPr txBox="1"/>
-          <p:nvPr/>
-        </p:nvSpPr>
-        <p:spPr>
-          <a:xfrm>
-            <a:off x="548640" y="3931920"/>
-            <a:ext cx="2560320" cy="384048"/>
-          </a:xfrm>
-          <a:prstGeom prst="rect">
-            <a:avLst/>
-          </a:prstGeom>
-          <a:noFill/>
-          <a:ln/>
-        </p:spPr>
-        <p:txBody>
-          <a:bodyPr wrap="square" lIns="0" tIns="0" rIns="0" bIns="0" rtlCol="0" anchor="t"/>
-          <a:lstStyle/>
-          <a:p>
-            <a:pPr indent="0" marL="0">
-              <a:buNone/>
-            </a:pPr>
-            <a:r>
-              <a:rPr lang="en-US" sz="1800" b="1" dirty="0">
-                <a:solidFill>
-                  <a:srgbClr val="16181D"/>
-                </a:solidFill>
-                <a:latin typeface="Arial" pitchFamily="34" charset="0"/>
-                <a:ea typeface="Arial" pitchFamily="34" charset="-122"/>
-                <a:cs typeface="Arial" pitchFamily="34" charset="-120"/>
-              </a:rPr>
-              <a:t>Bestandsaufnahme</a:t>
-            </a:r>
-            <a:endParaRPr lang="en-US" sz="1800" dirty="0"/>
-          </a:p>
-        </p:txBody>
-      </p:sp>
-      <p:sp>
-        <p:nvSpPr>
-          <p:cNvPr id="11" name="Text 9"/>
-          <p:cNvSpPr txBox="1"/>
-          <p:nvPr/>
-        </p:nvSpPr>
-        <p:spPr>
-          <a:xfrm>
-            <a:off x="548640" y="4434840"/>
-            <a:ext cx="2560320" cy="1737360"/>
+            <a:off x="548640" y="2377440"/>
+            <a:ext cx="2567864" cy="1828800"/>
           </a:xfrm>
           <a:prstGeom prst="rect">
             <a:avLst/>
@@ -11145,7 +11172,7 @@
               <a:buNone/>
             </a:pPr>
             <a:r>
-              <a:rPr lang="en-US" sz="1400" dirty="0">
+              <a:rPr lang="en-US" sz="1300" dirty="0">
                 <a:solidFill>
                   <a:srgbClr val="16181D"/>
                 </a:solidFill>
@@ -11153,22 +11180,22 @@
                 <a:ea typeface="Arial" pitchFamily="34" charset="-122"/>
                 <a:cs typeface="Arial" pitchFamily="34" charset="-120"/>
               </a:rPr>
-              <a:t>Pimcore-6-Klassen, Eigenentwicklungen und Schnittstellen erfassen; Zielmodell mit Produkttypen, Attributen, Hierarchien und Ausgaben festlegen.</a:t>
-            </a:r>
-            <a:endParaRPr lang="en-US" sz="1400" dirty="0"/>
-          </a:p>
-        </p:txBody>
-      </p:sp>
-      <p:sp>
-        <p:nvSpPr>
-          <p:cNvPr id="12" name="Shape 10"/>
+              <a:t>GPL-Kern, Quellcode vollständig einsehbar. Keine Blackbox, kein Lock-in – Kohlhammer kann jederzeit nachvollziehen, was das System tut.</a:t>
+            </a:r>
+            <a:endParaRPr lang="en-US" sz="1300" dirty="0"/>
+          </a:p>
+        </p:txBody>
+      </p:sp>
+      <p:sp>
+        <p:nvSpPr>
+          <p:cNvPr id="10" name="Shape 8"/>
           <p:cNvSpPr/>
           <p:nvPr/>
         </p:nvSpPr>
         <p:spPr>
           <a:xfrm>
-            <a:off x="3393338" y="2240280"/>
-            <a:ext cx="274320" cy="274320"/>
+            <a:off x="3390824" y="1645920"/>
+            <a:ext cx="2567864" cy="566928"/>
           </a:xfrm>
           <a:prstGeom prst="rect">
             <a:avLst/>
@@ -11186,131 +11213,92 @@
       </p:sp>
       <p:sp>
         <p:nvSpPr>
+          <p:cNvPr id="11" name="Text 9"/>
+          <p:cNvSpPr txBox="1"/>
+          <p:nvPr/>
+        </p:nvSpPr>
+        <p:spPr>
+          <a:xfrm>
+            <a:off x="3573704" y="1645920"/>
+            <a:ext cx="1882064" cy="566928"/>
+          </a:xfrm>
+          <a:prstGeom prst="rect">
+            <a:avLst/>
+          </a:prstGeom>
+          <a:noFill/>
+          <a:ln/>
+        </p:spPr>
+        <p:txBody>
+          <a:bodyPr wrap="square" lIns="0" tIns="0" rIns="0" bIns="0" rtlCol="0" anchor="ctr"/>
+          <a:lstStyle/>
+          <a:p>
+            <a:pPr indent="0" marL="0">
+              <a:buNone/>
+            </a:pPr>
+            <a:r>
+              <a:rPr lang="en-US" sz="1500" dirty="0">
+                <a:solidFill>
+                  <a:srgbClr val="FFFFFF"/>
+                </a:solidFill>
+                <a:latin typeface="Arial" pitchFamily="34" charset="0"/>
+                <a:ea typeface="Arial" pitchFamily="34" charset="-122"/>
+                <a:cs typeface="Arial" pitchFamily="34" charset="-120"/>
+              </a:rPr>
+              <a:t>KI-ready</a:t>
+            </a:r>
+            <a:endParaRPr lang="en-US" sz="1500" dirty="0"/>
+          </a:p>
+        </p:txBody>
+      </p:sp>
+      <p:sp>
+        <p:nvSpPr>
+          <p:cNvPr id="12" name="Text 10"/>
+          <p:cNvSpPr txBox="1"/>
+          <p:nvPr/>
+        </p:nvSpPr>
+        <p:spPr>
+          <a:xfrm>
+            <a:off x="5455768" y="1645920"/>
+            <a:ext cx="365760" cy="566928"/>
+          </a:xfrm>
+          <a:prstGeom prst="rect">
+            <a:avLst/>
+          </a:prstGeom>
+          <a:noFill/>
+          <a:ln/>
+        </p:spPr>
+        <p:txBody>
+          <a:bodyPr wrap="square" lIns="0" tIns="0" rIns="0" bIns="0" rtlCol="0" anchor="ctr"/>
+          <a:lstStyle/>
+          <a:p>
+            <a:pPr algn="r" indent="0" marL="0">
+              <a:buNone/>
+            </a:pPr>
+            <a:r>
+              <a:rPr lang="en-US" sz="1800" dirty="0">
+                <a:solidFill>
+                  <a:srgbClr val="FFFFFF"/>
+                </a:solidFill>
+                <a:latin typeface="Arial" pitchFamily="34" charset="0"/>
+                <a:ea typeface="Arial" pitchFamily="34" charset="-122"/>
+                <a:cs typeface="Arial" pitchFamily="34" charset="-120"/>
+              </a:rPr>
+              <a:t>→</a:t>
+            </a:r>
+            <a:endParaRPr lang="en-US" sz="1800" dirty="0"/>
+          </a:p>
+        </p:txBody>
+      </p:sp>
+      <p:sp>
+        <p:nvSpPr>
           <p:cNvPr id="13" name="Text 11"/>
           <p:cNvSpPr txBox="1"/>
           <p:nvPr/>
         </p:nvSpPr>
         <p:spPr>
           <a:xfrm>
-            <a:off x="3393338" y="2788920"/>
-            <a:ext cx="2560320" cy="731520"/>
-          </a:xfrm>
-          <a:prstGeom prst="rect">
-            <a:avLst/>
-          </a:prstGeom>
-          <a:noFill/>
-          <a:ln/>
-        </p:spPr>
-        <p:txBody>
-          <a:bodyPr wrap="square" lIns="0" tIns="0" rIns="0" bIns="0" rtlCol="0" anchor="t"/>
-          <a:lstStyle/>
-          <a:p>
-            <a:pPr indent="0" marL="0">
-              <a:buNone/>
-            </a:pPr>
-            <a:r>
-              <a:rPr lang="en-US" sz="4000" dirty="0">
-                <a:solidFill>
-                  <a:srgbClr val="1B2D5C"/>
-                </a:solidFill>
-                <a:latin typeface="Arial" pitchFamily="34" charset="0"/>
-                <a:ea typeface="Arial" pitchFamily="34" charset="-122"/>
-                <a:cs typeface="Arial" pitchFamily="34" charset="-120"/>
-              </a:rPr>
-              <a:t>02</a:t>
-            </a:r>
-            <a:endParaRPr lang="en-US" sz="4000" dirty="0"/>
-          </a:p>
-        </p:txBody>
-      </p:sp>
-      <p:sp>
-        <p:nvSpPr>
-          <p:cNvPr id="14" name="Text 12"/>
-          <p:cNvSpPr txBox="1"/>
-          <p:nvPr/>
-        </p:nvSpPr>
-        <p:spPr>
-          <a:xfrm>
-            <a:off x="3393338" y="3611880"/>
-            <a:ext cx="2560320" cy="256032"/>
-          </a:xfrm>
-          <a:prstGeom prst="rect">
-            <a:avLst/>
-          </a:prstGeom>
-          <a:noFill/>
-          <a:ln/>
-        </p:spPr>
-        <p:txBody>
-          <a:bodyPr wrap="square" lIns="0" tIns="0" rIns="0" bIns="0" rtlCol="0" anchor="t"/>
-          <a:lstStyle/>
-          <a:p>
-            <a:pPr indent="0" marL="0">
-              <a:buNone/>
-            </a:pPr>
-            <a:r>
-              <a:rPr lang="en-US" sz="1000" b="1" spc="100" kern="0" dirty="0">
-                <a:solidFill>
-                  <a:srgbClr val="4B5563"/>
-                </a:solidFill>
-                <a:latin typeface="Arial" pitchFamily="34" charset="0"/>
-                <a:ea typeface="Arial" pitchFamily="34" charset="-122"/>
-                <a:cs typeface="Arial" pitchFamily="34" charset="-120"/>
-              </a:rPr>
-              <a:t>CA. 4 WOCHEN</a:t>
-            </a:r>
-            <a:endParaRPr lang="en-US" sz="1000" dirty="0"/>
-          </a:p>
-        </p:txBody>
-      </p:sp>
-      <p:sp>
-        <p:nvSpPr>
-          <p:cNvPr id="15" name="Text 13"/>
-          <p:cNvSpPr txBox="1"/>
-          <p:nvPr/>
-        </p:nvSpPr>
-        <p:spPr>
-          <a:xfrm>
-            <a:off x="3393338" y="3931920"/>
-            <a:ext cx="2560320" cy="384048"/>
-          </a:xfrm>
-          <a:prstGeom prst="rect">
-            <a:avLst/>
-          </a:prstGeom>
-          <a:noFill/>
-          <a:ln/>
-        </p:spPr>
-        <p:txBody>
-          <a:bodyPr wrap="square" lIns="0" tIns="0" rIns="0" bIns="0" rtlCol="0" anchor="t"/>
-          <a:lstStyle/>
-          <a:p>
-            <a:pPr indent="0" marL="0">
-              <a:buNone/>
-            </a:pPr>
-            <a:r>
-              <a:rPr lang="en-US" sz="1800" b="1" dirty="0">
-                <a:solidFill>
-                  <a:srgbClr val="16181D"/>
-                </a:solidFill>
-                <a:latin typeface="Arial" pitchFamily="34" charset="0"/>
-                <a:ea typeface="Arial" pitchFamily="34" charset="-122"/>
-                <a:cs typeface="Arial" pitchFamily="34" charset="-120"/>
-              </a:rPr>
-              <a:t>Pilot Brandschutz</a:t>
-            </a:r>
-            <a:endParaRPr lang="en-US" sz="1800" dirty="0"/>
-          </a:p>
-        </p:txBody>
-      </p:sp>
-      <p:sp>
-        <p:nvSpPr>
-          <p:cNvPr id="16" name="Text 14"/>
-          <p:cNvSpPr txBox="1"/>
-          <p:nvPr/>
-        </p:nvSpPr>
-        <p:spPr>
-          <a:xfrm>
-            <a:off x="3393338" y="4434840"/>
-            <a:ext cx="2560320" cy="1737360"/>
+            <a:off x="3390824" y="2377440"/>
+            <a:ext cx="2567864" cy="1828800"/>
           </a:xfrm>
           <a:prstGeom prst="rect">
             <a:avLst/>
@@ -11329,7 +11317,7 @@
               <a:buNone/>
             </a:pPr>
             <a:r>
-              <a:rPr lang="en-US" sz="1400" dirty="0">
+              <a:rPr lang="en-US" sz="1300" dirty="0">
                 <a:solidFill>
                   <a:srgbClr val="16181D"/>
                 </a:solidFill>
@@ -11337,22 +11325,22 @@
                 <a:ea typeface="Arial" pitchFamily="34" charset="-122"/>
                 <a:cs typeface="Arial" pitchFamily="34" charset="-120"/>
               </a:rPr>
-              <a:t>Titel des Fachbereichs aus Pimcore 6 übernehmen, Werk/Ausgabe-Struktur, Qualitätsprofile; Parallelbetrieb und Datenabgleich.</a:t>
-            </a:r>
-            <a:endParaRPr lang="en-US" sz="1400" dirty="0"/>
-          </a:p>
-        </p:txBody>
-      </p:sp>
-      <p:sp>
-        <p:nvSpPr>
-          <p:cNvPr id="17" name="Shape 15"/>
+              <a:t>MCP-Schnittstelle für KI-Agenten wie Claude, KI-gestützte Texterstellung, semantische Suche mit lokalen Embeddings, DeepL-Übersetzung.</a:t>
+            </a:r>
+            <a:endParaRPr lang="en-US" sz="1300" dirty="0"/>
+          </a:p>
+        </p:txBody>
+      </p:sp>
+      <p:sp>
+        <p:nvSpPr>
+          <p:cNvPr id="14" name="Shape 12"/>
           <p:cNvSpPr/>
           <p:nvPr/>
         </p:nvSpPr>
         <p:spPr>
           <a:xfrm>
-            <a:off x="6238037" y="2240280"/>
-            <a:ext cx="274320" cy="274320"/>
+            <a:off x="6233008" y="1645920"/>
+            <a:ext cx="2567864" cy="566928"/>
           </a:xfrm>
           <a:prstGeom prst="rect">
             <a:avLst/>
@@ -11370,116 +11358,77 @@
       </p:sp>
       <p:sp>
         <p:nvSpPr>
-          <p:cNvPr id="18" name="Text 16"/>
-          <p:cNvSpPr txBox="1"/>
-          <p:nvPr/>
-        </p:nvSpPr>
-        <p:spPr>
-          <a:xfrm>
-            <a:off x="6238037" y="2788920"/>
-            <a:ext cx="2560320" cy="731520"/>
-          </a:xfrm>
-          <a:prstGeom prst="rect">
-            <a:avLst/>
-          </a:prstGeom>
-          <a:noFill/>
-          <a:ln/>
-        </p:spPr>
-        <p:txBody>
-          <a:bodyPr wrap="square" lIns="0" tIns="0" rIns="0" bIns="0" rtlCol="0" anchor="t"/>
+          <p:cNvPr id="15" name="Text 13"/>
+          <p:cNvSpPr txBox="1"/>
+          <p:nvPr/>
+        </p:nvSpPr>
+        <p:spPr>
+          <a:xfrm>
+            <a:off x="6415888" y="1645920"/>
+            <a:ext cx="1882064" cy="566928"/>
+          </a:xfrm>
+          <a:prstGeom prst="rect">
+            <a:avLst/>
+          </a:prstGeom>
+          <a:noFill/>
+          <a:ln/>
+        </p:spPr>
+        <p:txBody>
+          <a:bodyPr wrap="square" lIns="0" tIns="0" rIns="0" bIns="0" rtlCol="0" anchor="ctr"/>
           <a:lstStyle/>
           <a:p>
             <a:pPr indent="0" marL="0">
               <a:buNone/>
             </a:pPr>
             <a:r>
-              <a:rPr lang="en-US" sz="4000" dirty="0">
-                <a:solidFill>
-                  <a:srgbClr val="1B2D5C"/>
-                </a:solidFill>
-                <a:latin typeface="Arial" pitchFamily="34" charset="0"/>
-                <a:ea typeface="Arial" pitchFamily="34" charset="-122"/>
-                <a:cs typeface="Arial" pitchFamily="34" charset="-120"/>
-              </a:rPr>
-              <a:t>03</a:t>
-            </a:r>
-            <a:endParaRPr lang="en-US" sz="4000" dirty="0"/>
-          </a:p>
-        </p:txBody>
-      </p:sp>
-      <p:sp>
-        <p:nvSpPr>
-          <p:cNvPr id="19" name="Text 17"/>
-          <p:cNvSpPr txBox="1"/>
-          <p:nvPr/>
-        </p:nvSpPr>
-        <p:spPr>
-          <a:xfrm>
-            <a:off x="6238037" y="3611880"/>
-            <a:ext cx="2560320" cy="256032"/>
-          </a:xfrm>
-          <a:prstGeom prst="rect">
-            <a:avLst/>
-          </a:prstGeom>
-          <a:noFill/>
-          <a:ln/>
-        </p:spPr>
-        <p:txBody>
-          <a:bodyPr wrap="square" lIns="0" tIns="0" rIns="0" bIns="0" rtlCol="0" anchor="t"/>
-          <a:lstStyle/>
-          <a:p>
-            <a:pPr indent="0" marL="0">
-              <a:buNone/>
-            </a:pPr>
-            <a:r>
-              <a:rPr lang="en-US" sz="1000" b="1" spc="100" kern="0" dirty="0">
-                <a:solidFill>
-                  <a:srgbClr val="4B5563"/>
-                </a:solidFill>
-                <a:latin typeface="Arial" pitchFamily="34" charset="0"/>
-                <a:ea typeface="Arial" pitchFamily="34" charset="-122"/>
-                <a:cs typeface="Arial" pitchFamily="34" charset="-120"/>
-              </a:rPr>
-              <a:t>JE NACH UMFANG</a:t>
-            </a:r>
-            <a:endParaRPr lang="en-US" sz="1000" dirty="0"/>
-          </a:p>
-        </p:txBody>
-      </p:sp>
-      <p:sp>
-        <p:nvSpPr>
-          <p:cNvPr id="20" name="Text 18"/>
-          <p:cNvSpPr txBox="1"/>
-          <p:nvPr/>
-        </p:nvSpPr>
-        <p:spPr>
-          <a:xfrm>
-            <a:off x="6238037" y="3931920"/>
-            <a:ext cx="2560320" cy="384048"/>
-          </a:xfrm>
-          <a:prstGeom prst="rect">
-            <a:avLst/>
-          </a:prstGeom>
-          <a:noFill/>
-          <a:ln/>
-        </p:spPr>
-        <p:txBody>
-          <a:bodyPr wrap="square" lIns="0" tIns="0" rIns="0" bIns="0" rtlCol="0" anchor="t"/>
-          <a:lstStyle/>
-          <a:p>
-            <a:pPr indent="0" marL="0">
-              <a:buNone/>
-            </a:pPr>
-            <a:r>
-              <a:rPr lang="en-US" sz="1800" b="1" dirty="0">
-                <a:solidFill>
-                  <a:srgbClr val="16181D"/>
-                </a:solidFill>
-                <a:latin typeface="Arial" pitchFamily="34" charset="0"/>
-                <a:ea typeface="Arial" pitchFamily="34" charset="-122"/>
-                <a:cs typeface="Arial" pitchFamily="34" charset="-120"/>
-              </a:rPr>
-              <a:t>Projektanteil</a:t>
+              <a:rPr lang="en-US" sz="1500" dirty="0">
+                <a:solidFill>
+                  <a:srgbClr val="FFFFFF"/>
+                </a:solidFill>
+                <a:latin typeface="Arial" pitchFamily="34" charset="0"/>
+                <a:ea typeface="Arial" pitchFamily="34" charset="-122"/>
+                <a:cs typeface="Arial" pitchFamily="34" charset="-120"/>
+              </a:rPr>
+              <a:t>Erweiterbar</a:t>
+            </a:r>
+            <a:endParaRPr lang="en-US" sz="1500" dirty="0"/>
+          </a:p>
+        </p:txBody>
+      </p:sp>
+      <p:sp>
+        <p:nvSpPr>
+          <p:cNvPr id="16" name="Text 14"/>
+          <p:cNvSpPr txBox="1"/>
+          <p:nvPr/>
+        </p:nvSpPr>
+        <p:spPr>
+          <a:xfrm>
+            <a:off x="8297951" y="1645920"/>
+            <a:ext cx="365760" cy="566928"/>
+          </a:xfrm>
+          <a:prstGeom prst="rect">
+            <a:avLst/>
+          </a:prstGeom>
+          <a:noFill/>
+          <a:ln/>
+        </p:spPr>
+        <p:txBody>
+          <a:bodyPr wrap="square" lIns="0" tIns="0" rIns="0" bIns="0" rtlCol="0" anchor="ctr"/>
+          <a:lstStyle/>
+          <a:p>
+            <a:pPr algn="r" indent="0" marL="0">
+              <a:buNone/>
+            </a:pPr>
+            <a:r>
+              <a:rPr lang="en-US" sz="1800" dirty="0">
+                <a:solidFill>
+                  <a:srgbClr val="FFFFFF"/>
+                </a:solidFill>
+                <a:latin typeface="Arial" pitchFamily="34" charset="0"/>
+                <a:ea typeface="Arial" pitchFamily="34" charset="-122"/>
+                <a:cs typeface="Arial" pitchFamily="34" charset="-120"/>
+              </a:rPr>
+              <a:t>→</a:t>
             </a:r>
             <a:endParaRPr lang="en-US" sz="1800" dirty="0"/>
           </a:p>
@@ -11487,14 +11436,14 @@
       </p:sp>
       <p:sp>
         <p:nvSpPr>
-          <p:cNvPr id="21" name="Text 19"/>
-          <p:cNvSpPr txBox="1"/>
-          <p:nvPr/>
-        </p:nvSpPr>
-        <p:spPr>
-          <a:xfrm>
-            <a:off x="6238037" y="4434840"/>
-            <a:ext cx="2560320" cy="1737360"/>
+          <p:cNvPr id="17" name="Text 15"/>
+          <p:cNvSpPr txBox="1"/>
+          <p:nvPr/>
+        </p:nvSpPr>
+        <p:spPr>
+          <a:xfrm>
+            <a:off x="6233008" y="2377440"/>
+            <a:ext cx="2567864" cy="1828800"/>
           </a:xfrm>
           <a:prstGeom prst="rect">
             <a:avLst/>
@@ -11513,7 +11462,7 @@
               <a:buNone/>
             </a:pPr>
             <a:r>
-              <a:rPr lang="en-US" sz="1400" dirty="0">
+              <a:rPr lang="en-US" sz="1300" dirty="0">
                 <a:solidFill>
                   <a:srgbClr val="16181D"/>
                 </a:solidFill>
@@ -11521,32 +11470,32 @@
                 <a:ea typeface="Arial" pitchFamily="34" charset="-122"/>
                 <a:cs typeface="Arial" pitchFamily="34" charset="-120"/>
               </a:rPr>
-              <a:t>Fehlende Funktionen als Standard bauen – EasyCatalog-, Thieme- und ONIX-Export, Cover-Metadaten; Shop und Handel umstellen.</a:t>
-            </a:r>
-            <a:endParaRPr lang="en-US" sz="1400" dirty="0"/>
-          </a:p>
-        </p:txBody>
-      </p:sp>
-      <p:sp>
-        <p:nvSpPr>
-          <p:cNvPr id="22" name="Shape 20"/>
+              <a:t>REST-API, API-Designer, Connector-Schnittstelle und feste Konventionen für neue Exportformate – etwa EasyCatalog oder ONIX.</a:t>
+            </a:r>
+            <a:endParaRPr lang="en-US" sz="1300" dirty="0"/>
+          </a:p>
+        </p:txBody>
+      </p:sp>
+      <p:sp>
+        <p:nvSpPr>
+          <p:cNvPr id="18" name="Shape 16"/>
           <p:cNvSpPr/>
           <p:nvPr/>
         </p:nvSpPr>
         <p:spPr>
           <a:xfrm>
-            <a:off x="9082735" y="2240280"/>
-            <a:ext cx="274320" cy="274320"/>
+            <a:off x="9075191" y="1645920"/>
+            <a:ext cx="2567864" cy="566928"/>
           </a:xfrm>
           <a:prstGeom prst="rect">
             <a:avLst/>
           </a:prstGeom>
           <a:solidFill>
-            <a:srgbClr val="E2211C"/>
+            <a:srgbClr val="000E2F"/>
           </a:solidFill>
           <a:ln w="12700">
             <a:solidFill>
-              <a:srgbClr val="E2211C"/>
+              <a:srgbClr val="000E2F"/>
             </a:solidFill>
             <a:prstDash val="solid"/>
           </a:ln>
@@ -11554,116 +11503,77 @@
       </p:sp>
       <p:sp>
         <p:nvSpPr>
-          <p:cNvPr id="23" name="Text 21"/>
-          <p:cNvSpPr txBox="1"/>
-          <p:nvPr/>
-        </p:nvSpPr>
-        <p:spPr>
-          <a:xfrm>
-            <a:off x="9082735" y="2788920"/>
-            <a:ext cx="2560320" cy="731520"/>
-          </a:xfrm>
-          <a:prstGeom prst="rect">
-            <a:avLst/>
-          </a:prstGeom>
-          <a:noFill/>
-          <a:ln/>
-        </p:spPr>
-        <p:txBody>
-          <a:bodyPr wrap="square" lIns="0" tIns="0" rIns="0" bIns="0" rtlCol="0" anchor="t"/>
+          <p:cNvPr id="19" name="Text 17"/>
+          <p:cNvSpPr txBox="1"/>
+          <p:nvPr/>
+        </p:nvSpPr>
+        <p:spPr>
+          <a:xfrm>
+            <a:off x="9258071" y="1645920"/>
+            <a:ext cx="1882064" cy="566928"/>
+          </a:xfrm>
+          <a:prstGeom prst="rect">
+            <a:avLst/>
+          </a:prstGeom>
+          <a:noFill/>
+          <a:ln/>
+        </p:spPr>
+        <p:txBody>
+          <a:bodyPr wrap="square" lIns="0" tIns="0" rIns="0" bIns="0" rtlCol="0" anchor="ctr"/>
           <a:lstStyle/>
           <a:p>
             <a:pPr indent="0" marL="0">
               <a:buNone/>
             </a:pPr>
             <a:r>
-              <a:rPr lang="en-US" sz="4000" dirty="0">
-                <a:solidFill>
-                  <a:srgbClr val="1B2D5C"/>
-                </a:solidFill>
-                <a:latin typeface="Arial" pitchFamily="34" charset="0"/>
-                <a:ea typeface="Arial" pitchFamily="34" charset="-122"/>
-                <a:cs typeface="Arial" pitchFamily="34" charset="-120"/>
-              </a:rPr>
-              <a:t>04</a:t>
-            </a:r>
-            <a:endParaRPr lang="en-US" sz="4000" dirty="0"/>
-          </a:p>
-        </p:txBody>
-      </p:sp>
-      <p:sp>
-        <p:nvSpPr>
-          <p:cNvPr id="24" name="Text 22"/>
-          <p:cNvSpPr txBox="1"/>
-          <p:nvPr/>
-        </p:nvSpPr>
-        <p:spPr>
-          <a:xfrm>
-            <a:off x="9082735" y="3611880"/>
-            <a:ext cx="2560320" cy="256032"/>
-          </a:xfrm>
-          <a:prstGeom prst="rect">
-            <a:avLst/>
-          </a:prstGeom>
-          <a:noFill/>
-          <a:ln/>
-        </p:spPr>
-        <p:txBody>
-          <a:bodyPr wrap="square" lIns="0" tIns="0" rIns="0" bIns="0" rtlCol="0" anchor="t"/>
-          <a:lstStyle/>
-          <a:p>
-            <a:pPr indent="0" marL="0">
-              <a:buNone/>
-            </a:pPr>
-            <a:r>
-              <a:rPr lang="en-US" sz="1000" b="1" spc="100" kern="0" dirty="0">
-                <a:solidFill>
-                  <a:srgbClr val="4B5563"/>
-                </a:solidFill>
-                <a:latin typeface="Arial" pitchFamily="34" charset="0"/>
-                <a:ea typeface="Arial" pitchFamily="34" charset="-122"/>
-                <a:cs typeface="Arial" pitchFamily="34" charset="-120"/>
-              </a:rPr>
-              <a:t>FORTLAUFEND</a:t>
-            </a:r>
-            <a:endParaRPr lang="en-US" sz="1000" dirty="0"/>
-          </a:p>
-        </p:txBody>
-      </p:sp>
-      <p:sp>
-        <p:nvSpPr>
-          <p:cNvPr id="25" name="Text 23"/>
-          <p:cNvSpPr txBox="1"/>
-          <p:nvPr/>
-        </p:nvSpPr>
-        <p:spPr>
-          <a:xfrm>
-            <a:off x="9082735" y="3931920"/>
-            <a:ext cx="2560320" cy="384048"/>
-          </a:xfrm>
-          <a:prstGeom prst="rect">
-            <a:avLst/>
-          </a:prstGeom>
-          <a:noFill/>
-          <a:ln/>
-        </p:spPr>
-        <p:txBody>
-          <a:bodyPr wrap="square" lIns="0" tIns="0" rIns="0" bIns="0" rtlCol="0" anchor="t"/>
-          <a:lstStyle/>
-          <a:p>
-            <a:pPr indent="0" marL="0">
-              <a:buNone/>
-            </a:pPr>
-            <a:r>
-              <a:rPr lang="en-US" sz="1800" b="1" dirty="0">
-                <a:solidFill>
-                  <a:srgbClr val="16181D"/>
-                </a:solidFill>
-                <a:latin typeface="Arial" pitchFamily="34" charset="0"/>
-                <a:ea typeface="Arial" pitchFamily="34" charset="-122"/>
-                <a:cs typeface="Arial" pitchFamily="34" charset="-120"/>
-              </a:rPr>
-              <a:t>Ablösung</a:t>
+              <a:rPr lang="en-US" sz="1500" dirty="0">
+                <a:solidFill>
+                  <a:srgbClr val="FFFFFF"/>
+                </a:solidFill>
+                <a:latin typeface="Arial" pitchFamily="34" charset="0"/>
+                <a:ea typeface="Arial" pitchFamily="34" charset="-122"/>
+                <a:cs typeface="Arial" pitchFamily="34" charset="-120"/>
+              </a:rPr>
+              <a:t>Dokumentation</a:t>
+            </a:r>
+            <a:endParaRPr lang="en-US" sz="1500" dirty="0"/>
+          </a:p>
+        </p:txBody>
+      </p:sp>
+      <p:sp>
+        <p:nvSpPr>
+          <p:cNvPr id="20" name="Text 18"/>
+          <p:cNvSpPr txBox="1"/>
+          <p:nvPr/>
+        </p:nvSpPr>
+        <p:spPr>
+          <a:xfrm>
+            <a:off x="11140135" y="1645920"/>
+            <a:ext cx="365760" cy="566928"/>
+          </a:xfrm>
+          <a:prstGeom prst="rect">
+            <a:avLst/>
+          </a:prstGeom>
+          <a:noFill/>
+          <a:ln/>
+        </p:spPr>
+        <p:txBody>
+          <a:bodyPr wrap="square" lIns="0" tIns="0" rIns="0" bIns="0" rtlCol="0" anchor="ctr"/>
+          <a:lstStyle/>
+          <a:p>
+            <a:pPr algn="r" indent="0" marL="0">
+              <a:buNone/>
+            </a:pPr>
+            <a:r>
+              <a:rPr lang="en-US" sz="1800" dirty="0">
+                <a:solidFill>
+                  <a:srgbClr val="FFFFFF"/>
+                </a:solidFill>
+                <a:latin typeface="Arial" pitchFamily="34" charset="0"/>
+                <a:ea typeface="Arial" pitchFamily="34" charset="-122"/>
+                <a:cs typeface="Arial" pitchFamily="34" charset="-120"/>
+              </a:rPr>
+              <a:t>→</a:t>
             </a:r>
             <a:endParaRPr lang="en-US" sz="1800" dirty="0"/>
           </a:p>
@@ -11671,14 +11581,14 @@
       </p:sp>
       <p:sp>
         <p:nvSpPr>
-          <p:cNvPr id="26" name="Text 24"/>
-          <p:cNvSpPr txBox="1"/>
-          <p:nvPr/>
-        </p:nvSpPr>
-        <p:spPr>
-          <a:xfrm>
-            <a:off x="9082735" y="4434840"/>
-            <a:ext cx="2560320" cy="1737360"/>
+          <p:cNvPr id="21" name="Text 19"/>
+          <p:cNvSpPr txBox="1"/>
+          <p:nvPr/>
+        </p:nvSpPr>
+        <p:spPr>
+          <a:xfrm>
+            <a:off x="9075191" y="2377440"/>
+            <a:ext cx="2567864" cy="1828800"/>
           </a:xfrm>
           <a:prstGeom prst="rect">
             <a:avLst/>
@@ -11697,6 +11607,116 @@
               <a:buNone/>
             </a:pPr>
             <a:r>
+              <a:rPr lang="en-US" sz="1300" dirty="0">
+                <a:solidFill>
+                  <a:srgbClr val="16181D"/>
+                </a:solidFill>
+                <a:latin typeface="Arial" pitchFamily="34" charset="0"/>
+                <a:ea typeface="Arial" pitchFamily="34" charset="-122"/>
+                <a:cs typeface="Arial" pitchFamily="34" charset="-120"/>
+              </a:rPr>
+              <a:t>Hilfe-Portal auf Deutsch und Englisch, 25 Architektur-Spezifikationen, API-Referenz – plus Leitfäden, nach denen auch KI-Agenten regelkonform erweitern.</a:t>
+            </a:r>
+            <a:endParaRPr lang="en-US" sz="1300" dirty="0"/>
+          </a:p>
+        </p:txBody>
+      </p:sp>
+      <p:sp>
+        <p:nvSpPr>
+          <p:cNvPr id="22" name="Shape 20"/>
+          <p:cNvSpPr/>
+          <p:nvPr/>
+        </p:nvSpPr>
+        <p:spPr>
+          <a:xfrm>
+            <a:off x="548640" y="4343400"/>
+            <a:ext cx="11094415" cy="1783080"/>
+          </a:xfrm>
+          <a:prstGeom prst="rect">
+            <a:avLst/>
+          </a:prstGeom>
+          <a:solidFill>
+            <a:srgbClr val="C6E6E3"/>
+          </a:solidFill>
+          <a:ln w="12700">
+            <a:solidFill>
+              <a:srgbClr val="C6E6E3"/>
+            </a:solidFill>
+            <a:prstDash val="solid"/>
+          </a:ln>
+        </p:spPr>
+      </p:sp>
+      <p:sp>
+        <p:nvSpPr>
+          <p:cNvPr id="23" name="Text 21"/>
+          <p:cNvSpPr txBox="1"/>
+          <p:nvPr/>
+        </p:nvSpPr>
+        <p:spPr>
+          <a:xfrm>
+            <a:off x="868680" y="4572000"/>
+            <a:ext cx="3108960" cy="457200"/>
+          </a:xfrm>
+          <a:prstGeom prst="rect">
+            <a:avLst/>
+          </a:prstGeom>
+          <a:noFill/>
+          <a:ln/>
+        </p:spPr>
+        <p:txBody>
+          <a:bodyPr wrap="square" lIns="0" tIns="0" rIns="0" bIns="0" rtlCol="0" anchor="t"/>
+          <a:lstStyle/>
+          <a:p>
+            <a:pPr indent="0" marL="0">
+              <a:buNone/>
+            </a:pPr>
+            <a:r>
+              <a:rPr lang="en-US" sz="2000" b="1" dirty="0">
+                <a:solidFill>
+                  <a:srgbClr val="000E2F"/>
+                </a:solidFill>
+                <a:latin typeface="Arial" pitchFamily="34" charset="0"/>
+                <a:ea typeface="Arial" pitchFamily="34" charset="-122"/>
+                <a:cs typeface="Arial" pitchFamily="34" charset="-120"/>
+              </a:rPr>
+              <a:t>Mitgestalten heißt:</a:t>
+            </a:r>
+            <a:endParaRPr lang="en-US" sz="2000" dirty="0"/>
+          </a:p>
+        </p:txBody>
+      </p:sp>
+      <p:sp>
+        <p:nvSpPr>
+          <p:cNvPr id="24" name="Text 22"/>
+          <p:cNvSpPr txBox="1"/>
+          <p:nvPr/>
+        </p:nvSpPr>
+        <p:spPr>
+          <a:xfrm>
+            <a:off x="4114800" y="4572000"/>
+            <a:ext cx="7208215" cy="1371600"/>
+          </a:xfrm>
+          <a:prstGeom prst="rect">
+            <a:avLst/>
+          </a:prstGeom>
+          <a:noFill/>
+          <a:ln/>
+        </p:spPr>
+        <p:txBody>
+          <a:bodyPr wrap="square" lIns="0" tIns="0" rIns="0" bIns="0" rtlCol="0" anchor="t"/>
+          <a:lstStyle/>
+          <a:p>
+            <a:pPr marL="342900" indent="-342900">
+              <a:lnSpc>
+                <a:spcPct val="110000"/>
+              </a:lnSpc>
+              <a:spcAft>
+                <a:spcPts val="600"/>
+              </a:spcAft>
+              <a:buSzPct val="100000"/>
+              <a:buChar char="•"/>
+            </a:pPr>
+            <a:r>
               <a:rPr lang="en-US" sz="1400" dirty="0">
                 <a:solidFill>
                   <a:srgbClr val="16181D"/>
@@ -11705,7 +11725,55 @@
                 <a:ea typeface="Arial" pitchFamily="34" charset="-122"/>
                 <a:cs typeface="Arial" pitchFamily="34" charset="-120"/>
               </a:rPr>
-              <a:t>Weitere Fachbereiche, Zeitschriften, Formulare und Seminare; Schulung der Redaktionen; Abschaltung von Pimcore 6.</a:t>
+              <a:t>Anforderungen aus der Kohlhammer-Funktionsliste fließen direkt in die Produkt-Roadmap.</a:t>
+            </a:r>
+            <a:endParaRPr lang="en-US" sz="1400" dirty="0"/>
+          </a:p>
+          <a:p>
+            <a:pPr marL="342900" indent="-342900">
+              <a:lnSpc>
+                <a:spcPct val="110000"/>
+              </a:lnSpc>
+              <a:spcAft>
+                <a:spcPts val="600"/>
+              </a:spcAft>
+              <a:buSzPct val="100000"/>
+              <a:buChar char="•"/>
+            </a:pPr>
+            <a:r>
+              <a:rPr lang="en-US" sz="1400" dirty="0">
+                <a:solidFill>
+                  <a:srgbClr val="16181D"/>
+                </a:solidFill>
+                <a:latin typeface="Arial" pitchFamily="34" charset="0"/>
+                <a:ea typeface="Arial" pitchFamily="34" charset="-122"/>
+                <a:cs typeface="Arial" pitchFamily="34" charset="-120"/>
+              </a:rPr>
+              <a:t>Was für Kohlhammer gebaut wird, wird Standard – und kommt mit jedem Update mit.</a:t>
+            </a:r>
+            <a:endParaRPr lang="en-US" sz="1400" dirty="0"/>
+          </a:p>
+          <a:p>
+            <a:pPr marL="342900" indent="-342900">
+              <a:lnSpc>
+                <a:spcPct val="110000"/>
+              </a:lnSpc>
+              <a:spcAft>
+                <a:spcPts val="600"/>
+              </a:spcAft>
+              <a:buSzPct val="100000"/>
+              <a:buChar char="•"/>
+            </a:pPr>
+            <a:r>
+              <a:rPr lang="en-US" sz="1400" dirty="0">
+                <a:solidFill>
+                  <a:srgbClr val="16181D"/>
+                </a:solidFill>
+                <a:latin typeface="Arial" pitchFamily="34" charset="0"/>
+                <a:ea typeface="Arial" pitchFamily="34" charset="-122"/>
+                <a:cs typeface="Arial" pitchFamily="34" charset="-120"/>
+              </a:rPr>
+              <a:t>Kurzer Weg zum Hersteller, gemeinsame Priorisierung, transparente Umsetzung im offenen Code.</a:t>
             </a:r>
             <a:endParaRPr lang="en-US" sz="1400" dirty="0"/>
           </a:p>
@@ -11722,6 +11790,953 @@
 <file path=ppt/slides/slide15.xml><?xml version="1.0" encoding="utf-8"?>
 <p:sld xmlns:a="http://schemas.openxmlformats.org/drawingml/2006/main" xmlns:r="http://schemas.openxmlformats.org/officeDocument/2006/relationships" xmlns:p="http://schemas.openxmlformats.org/presentationml/2006/main">
   <p:cSld name="Slide 15">
+    <p:bg>
+      <p:bgPr>
+        <a:solidFill>
+          <a:srgbClr val="FFFFFF"/>
+        </a:solidFill>
+      </p:bgPr>
+    </p:bg>
+    <p:spTree>
+      <p:nvGrpSpPr>
+        <p:cNvPr id="1" name=""/>
+        <p:cNvGrpSpPr/>
+        <p:nvPr/>
+      </p:nvGrpSpPr>
+      <p:grpSpPr>
+        <a:xfrm>
+          <a:off x="0" y="0"/>
+          <a:ext cx="0" cy="0"/>
+          <a:chOff x="0" y="0"/>
+          <a:chExt cx="0" cy="0"/>
+        </a:xfrm>
+      </p:grpSpPr>
+      <p:sp>
+        <p:nvSpPr>
+          <p:cNvPr id="2" name="Text 0"/>
+          <p:cNvSpPr txBox="1"/>
+          <p:nvPr/>
+        </p:nvSpPr>
+        <p:spPr>
+          <a:xfrm>
+            <a:off x="548640" y="411480"/>
+            <a:ext cx="11094415" cy="594360"/>
+          </a:xfrm>
+          <a:prstGeom prst="rect">
+            <a:avLst/>
+          </a:prstGeom>
+          <a:noFill/>
+          <a:ln/>
+        </p:spPr>
+        <p:txBody>
+          <a:bodyPr wrap="square" lIns="0" tIns="0" rIns="0" bIns="0" rtlCol="0" anchor="b"/>
+          <a:lstStyle/>
+          <a:p>
+            <a:pPr indent="0" marL="0">
+              <a:buNone/>
+            </a:pPr>
+            <a:r>
+              <a:rPr lang="en-US" sz="3000" dirty="0">
+                <a:solidFill>
+                  <a:srgbClr val="16181D"/>
+                </a:solidFill>
+                <a:latin typeface="Arial" pitchFamily="34" charset="0"/>
+                <a:ea typeface="Arial" pitchFamily="34" charset="-122"/>
+                <a:cs typeface="Arial" pitchFamily="34" charset="-120"/>
+              </a:rPr>
+              <a:t>VORGESCHLAGENER FAHRPLAN</a:t>
+            </a:r>
+            <a:endParaRPr lang="en-US" sz="3000" dirty="0"/>
+          </a:p>
+        </p:txBody>
+      </p:sp>
+      <p:sp>
+        <p:nvSpPr>
+          <p:cNvPr id="3" name="Text 1"/>
+          <p:cNvSpPr txBox="1"/>
+          <p:nvPr/>
+        </p:nvSpPr>
+        <p:spPr>
+          <a:xfrm>
+            <a:off x="548640" y="1033272"/>
+            <a:ext cx="11094415" cy="365760"/>
+          </a:xfrm>
+          <a:prstGeom prst="rect">
+            <a:avLst/>
+          </a:prstGeom>
+          <a:noFill/>
+          <a:ln/>
+        </p:spPr>
+        <p:txBody>
+          <a:bodyPr wrap="square" lIns="0" tIns="0" rIns="0" bIns="0" rtlCol="0" anchor="t"/>
+          <a:lstStyle/>
+          <a:p>
+            <a:pPr indent="0" marL="0">
+              <a:buNone/>
+            </a:pPr>
+            <a:r>
+              <a:rPr lang="en-US" sz="1400" dirty="0">
+                <a:solidFill>
+                  <a:srgbClr val="4B5563"/>
+                </a:solidFill>
+                <a:latin typeface="Arial" pitchFamily="34" charset="0"/>
+                <a:ea typeface="Arial" pitchFamily="34" charset="-122"/>
+                <a:cs typeface="Arial" pitchFamily="34" charset="-120"/>
+              </a:rPr>
+              <a:t>Richtwerte für den Workshop. Pimcore 6 läuft bis zur Umstellung weiter; ein Fachbereich dient als Pilot.</a:t>
+            </a:r>
+            <a:endParaRPr lang="en-US" sz="1400" dirty="0"/>
+          </a:p>
+        </p:txBody>
+      </p:sp>
+      <p:sp>
+        <p:nvSpPr>
+          <p:cNvPr id="4" name="Text 2"/>
+          <p:cNvSpPr txBox="1"/>
+          <p:nvPr/>
+        </p:nvSpPr>
+        <p:spPr>
+          <a:xfrm>
+            <a:off x="548640" y="6400800"/>
+            <a:ext cx="7315200" cy="228600"/>
+          </a:xfrm>
+          <a:prstGeom prst="rect">
+            <a:avLst/>
+          </a:prstGeom>
+          <a:noFill/>
+          <a:ln/>
+        </p:spPr>
+        <p:txBody>
+          <a:bodyPr wrap="square" lIns="0" tIns="0" rIns="0" bIns="0" rtlCol="0" anchor="t"/>
+          <a:lstStyle/>
+          <a:p>
+            <a:pPr indent="0" marL="0">
+              <a:buNone/>
+            </a:pPr>
+            <a:r>
+              <a:rPr lang="en-US" sz="900" dirty="0">
+                <a:solidFill>
+                  <a:srgbClr val="4B5563"/>
+                </a:solidFill>
+                <a:latin typeface="Arial" pitchFamily="34" charset="0"/>
+                <a:ea typeface="Arial" pitchFamily="34" charset="-122"/>
+                <a:cs typeface="Arial" pitchFamily="34" charset="-120"/>
+              </a:rPr>
+              <a:t>anyPIM für Kohlhammer  ·  Entscheidungsvorlage  ·  September 2026</a:t>
+            </a:r>
+            <a:endParaRPr lang="en-US" sz="900" dirty="0"/>
+          </a:p>
+        </p:txBody>
+      </p:sp>
+      <p:sp>
+        <p:nvSpPr>
+          <p:cNvPr id="5" name="Text 3"/>
+          <p:cNvSpPr txBox="1"/>
+          <p:nvPr/>
+        </p:nvSpPr>
+        <p:spPr>
+          <a:xfrm>
+            <a:off x="10728655" y="6400800"/>
+            <a:ext cx="914400" cy="228600"/>
+          </a:xfrm>
+          <a:prstGeom prst="rect">
+            <a:avLst/>
+          </a:prstGeom>
+          <a:noFill/>
+          <a:ln/>
+        </p:spPr>
+        <p:txBody>
+          <a:bodyPr wrap="square" lIns="0" tIns="0" rIns="0" bIns="0" rtlCol="0" anchor="t"/>
+          <a:lstStyle/>
+          <a:p>
+            <a:pPr algn="r" indent="0" marL="0">
+              <a:buNone/>
+            </a:pPr>
+            <a:r>
+              <a:rPr lang="en-US" sz="900" dirty="0">
+                <a:solidFill>
+                  <a:srgbClr val="4B5563"/>
+                </a:solidFill>
+                <a:latin typeface="Arial" pitchFamily="34" charset="0"/>
+                <a:ea typeface="Arial" pitchFamily="34" charset="-122"/>
+                <a:cs typeface="Arial" pitchFamily="34" charset="-120"/>
+              </a:rPr>
+              <a:t>15</a:t>
+            </a:r>
+            <a:endParaRPr lang="en-US" sz="900" dirty="0"/>
+          </a:p>
+        </p:txBody>
+      </p:sp>
+      <p:sp>
+        <p:nvSpPr>
+          <p:cNvPr id="6" name="Shape 4"/>
+          <p:cNvSpPr/>
+          <p:nvPr/>
+        </p:nvSpPr>
+        <p:spPr>
+          <a:xfrm>
+            <a:off x="640080" y="2377440"/>
+            <a:ext cx="10911535" cy="0"/>
+          </a:xfrm>
+          <a:prstGeom prst="line">
+            <a:avLst/>
+          </a:prstGeom>
+          <a:noFill/>
+          <a:ln w="19050">
+            <a:solidFill>
+              <a:srgbClr val="1B2D5C"/>
+            </a:solidFill>
+            <a:prstDash val="solid"/>
+          </a:ln>
+        </p:spPr>
+      </p:sp>
+      <p:sp>
+        <p:nvSpPr>
+          <p:cNvPr id="7" name="Shape 5"/>
+          <p:cNvSpPr/>
+          <p:nvPr/>
+        </p:nvSpPr>
+        <p:spPr>
+          <a:xfrm>
+            <a:off x="548640" y="2240280"/>
+            <a:ext cx="274320" cy="274320"/>
+          </a:xfrm>
+          <a:prstGeom prst="rect">
+            <a:avLst/>
+          </a:prstGeom>
+          <a:solidFill>
+            <a:srgbClr val="000E2F"/>
+          </a:solidFill>
+          <a:ln w="12700">
+            <a:solidFill>
+              <a:srgbClr val="000E2F"/>
+            </a:solidFill>
+            <a:prstDash val="solid"/>
+          </a:ln>
+        </p:spPr>
+      </p:sp>
+      <p:sp>
+        <p:nvSpPr>
+          <p:cNvPr id="8" name="Text 6"/>
+          <p:cNvSpPr txBox="1"/>
+          <p:nvPr/>
+        </p:nvSpPr>
+        <p:spPr>
+          <a:xfrm>
+            <a:off x="548640" y="2788920"/>
+            <a:ext cx="2560320" cy="731520"/>
+          </a:xfrm>
+          <a:prstGeom prst="rect">
+            <a:avLst/>
+          </a:prstGeom>
+          <a:noFill/>
+          <a:ln/>
+        </p:spPr>
+        <p:txBody>
+          <a:bodyPr wrap="square" lIns="0" tIns="0" rIns="0" bIns="0" rtlCol="0" anchor="t"/>
+          <a:lstStyle/>
+          <a:p>
+            <a:pPr indent="0" marL="0">
+              <a:buNone/>
+            </a:pPr>
+            <a:r>
+              <a:rPr lang="en-US" sz="4000" dirty="0">
+                <a:solidFill>
+                  <a:srgbClr val="1B2D5C"/>
+                </a:solidFill>
+                <a:latin typeface="Arial" pitchFamily="34" charset="0"/>
+                <a:ea typeface="Arial" pitchFamily="34" charset="-122"/>
+                <a:cs typeface="Arial" pitchFamily="34" charset="-120"/>
+              </a:rPr>
+              <a:t>01</a:t>
+            </a:r>
+            <a:endParaRPr lang="en-US" sz="4000" dirty="0"/>
+          </a:p>
+        </p:txBody>
+      </p:sp>
+      <p:sp>
+        <p:nvSpPr>
+          <p:cNvPr id="9" name="Text 7"/>
+          <p:cNvSpPr txBox="1"/>
+          <p:nvPr/>
+        </p:nvSpPr>
+        <p:spPr>
+          <a:xfrm>
+            <a:off x="548640" y="3611880"/>
+            <a:ext cx="2560320" cy="256032"/>
+          </a:xfrm>
+          <a:prstGeom prst="rect">
+            <a:avLst/>
+          </a:prstGeom>
+          <a:noFill/>
+          <a:ln/>
+        </p:spPr>
+        <p:txBody>
+          <a:bodyPr wrap="square" lIns="0" tIns="0" rIns="0" bIns="0" rtlCol="0" anchor="t"/>
+          <a:lstStyle/>
+          <a:p>
+            <a:pPr indent="0" marL="0">
+              <a:buNone/>
+            </a:pPr>
+            <a:r>
+              <a:rPr lang="en-US" sz="1000" b="1" spc="100" kern="0" dirty="0">
+                <a:solidFill>
+                  <a:srgbClr val="4B5563"/>
+                </a:solidFill>
+                <a:latin typeface="Arial" pitchFamily="34" charset="0"/>
+                <a:ea typeface="Arial" pitchFamily="34" charset="-122"/>
+                <a:cs typeface="Arial" pitchFamily="34" charset="-120"/>
+              </a:rPr>
+              <a:t>CA. 2 WOCHEN</a:t>
+            </a:r>
+            <a:endParaRPr lang="en-US" sz="1000" dirty="0"/>
+          </a:p>
+        </p:txBody>
+      </p:sp>
+      <p:sp>
+        <p:nvSpPr>
+          <p:cNvPr id="10" name="Text 8"/>
+          <p:cNvSpPr txBox="1"/>
+          <p:nvPr/>
+        </p:nvSpPr>
+        <p:spPr>
+          <a:xfrm>
+            <a:off x="548640" y="3931920"/>
+            <a:ext cx="2560320" cy="384048"/>
+          </a:xfrm>
+          <a:prstGeom prst="rect">
+            <a:avLst/>
+          </a:prstGeom>
+          <a:noFill/>
+          <a:ln/>
+        </p:spPr>
+        <p:txBody>
+          <a:bodyPr wrap="square" lIns="0" tIns="0" rIns="0" bIns="0" rtlCol="0" anchor="t"/>
+          <a:lstStyle/>
+          <a:p>
+            <a:pPr indent="0" marL="0">
+              <a:buNone/>
+            </a:pPr>
+            <a:r>
+              <a:rPr lang="en-US" sz="1800" b="1" dirty="0">
+                <a:solidFill>
+                  <a:srgbClr val="16181D"/>
+                </a:solidFill>
+                <a:latin typeface="Arial" pitchFamily="34" charset="0"/>
+                <a:ea typeface="Arial" pitchFamily="34" charset="-122"/>
+                <a:cs typeface="Arial" pitchFamily="34" charset="-120"/>
+              </a:rPr>
+              <a:t>Bestandsaufnahme</a:t>
+            </a:r>
+            <a:endParaRPr lang="en-US" sz="1800" dirty="0"/>
+          </a:p>
+        </p:txBody>
+      </p:sp>
+      <p:sp>
+        <p:nvSpPr>
+          <p:cNvPr id="11" name="Text 9"/>
+          <p:cNvSpPr txBox="1"/>
+          <p:nvPr/>
+        </p:nvSpPr>
+        <p:spPr>
+          <a:xfrm>
+            <a:off x="548640" y="4434840"/>
+            <a:ext cx="2560320" cy="1737360"/>
+          </a:xfrm>
+          <a:prstGeom prst="rect">
+            <a:avLst/>
+          </a:prstGeom>
+          <a:noFill/>
+          <a:ln/>
+        </p:spPr>
+        <p:txBody>
+          <a:bodyPr wrap="square" lIns="0" tIns="0" rIns="0" bIns="0" rtlCol="0" anchor="t"/>
+          <a:lstStyle/>
+          <a:p>
+            <a:pPr indent="0" marL="0">
+              <a:lnSpc>
+                <a:spcPct val="112000"/>
+              </a:lnSpc>
+              <a:buNone/>
+            </a:pPr>
+            <a:r>
+              <a:rPr lang="en-US" sz="1400" dirty="0">
+                <a:solidFill>
+                  <a:srgbClr val="16181D"/>
+                </a:solidFill>
+                <a:latin typeface="Arial" pitchFamily="34" charset="0"/>
+                <a:ea typeface="Arial" pitchFamily="34" charset="-122"/>
+                <a:cs typeface="Arial" pitchFamily="34" charset="-120"/>
+              </a:rPr>
+              <a:t>Pimcore-6-Klassen, Eigenentwicklungen und Schnittstellen erfassen; Zielmodell mit Produkttypen, Attributen, Hierarchien und Ausgaben festlegen.</a:t>
+            </a:r>
+            <a:endParaRPr lang="en-US" sz="1400" dirty="0"/>
+          </a:p>
+        </p:txBody>
+      </p:sp>
+      <p:sp>
+        <p:nvSpPr>
+          <p:cNvPr id="12" name="Shape 10"/>
+          <p:cNvSpPr/>
+          <p:nvPr/>
+        </p:nvSpPr>
+        <p:spPr>
+          <a:xfrm>
+            <a:off x="3393338" y="2240280"/>
+            <a:ext cx="274320" cy="274320"/>
+          </a:xfrm>
+          <a:prstGeom prst="rect">
+            <a:avLst/>
+          </a:prstGeom>
+          <a:solidFill>
+            <a:srgbClr val="000E2F"/>
+          </a:solidFill>
+          <a:ln w="12700">
+            <a:solidFill>
+              <a:srgbClr val="000E2F"/>
+            </a:solidFill>
+            <a:prstDash val="solid"/>
+          </a:ln>
+        </p:spPr>
+      </p:sp>
+      <p:sp>
+        <p:nvSpPr>
+          <p:cNvPr id="13" name="Text 11"/>
+          <p:cNvSpPr txBox="1"/>
+          <p:nvPr/>
+        </p:nvSpPr>
+        <p:spPr>
+          <a:xfrm>
+            <a:off x="3393338" y="2788920"/>
+            <a:ext cx="2560320" cy="731520"/>
+          </a:xfrm>
+          <a:prstGeom prst="rect">
+            <a:avLst/>
+          </a:prstGeom>
+          <a:noFill/>
+          <a:ln/>
+        </p:spPr>
+        <p:txBody>
+          <a:bodyPr wrap="square" lIns="0" tIns="0" rIns="0" bIns="0" rtlCol="0" anchor="t"/>
+          <a:lstStyle/>
+          <a:p>
+            <a:pPr indent="0" marL="0">
+              <a:buNone/>
+            </a:pPr>
+            <a:r>
+              <a:rPr lang="en-US" sz="4000" dirty="0">
+                <a:solidFill>
+                  <a:srgbClr val="1B2D5C"/>
+                </a:solidFill>
+                <a:latin typeface="Arial" pitchFamily="34" charset="0"/>
+                <a:ea typeface="Arial" pitchFamily="34" charset="-122"/>
+                <a:cs typeface="Arial" pitchFamily="34" charset="-120"/>
+              </a:rPr>
+              <a:t>02</a:t>
+            </a:r>
+            <a:endParaRPr lang="en-US" sz="4000" dirty="0"/>
+          </a:p>
+        </p:txBody>
+      </p:sp>
+      <p:sp>
+        <p:nvSpPr>
+          <p:cNvPr id="14" name="Text 12"/>
+          <p:cNvSpPr txBox="1"/>
+          <p:nvPr/>
+        </p:nvSpPr>
+        <p:spPr>
+          <a:xfrm>
+            <a:off x="3393338" y="3611880"/>
+            <a:ext cx="2560320" cy="256032"/>
+          </a:xfrm>
+          <a:prstGeom prst="rect">
+            <a:avLst/>
+          </a:prstGeom>
+          <a:noFill/>
+          <a:ln/>
+        </p:spPr>
+        <p:txBody>
+          <a:bodyPr wrap="square" lIns="0" tIns="0" rIns="0" bIns="0" rtlCol="0" anchor="t"/>
+          <a:lstStyle/>
+          <a:p>
+            <a:pPr indent="0" marL="0">
+              <a:buNone/>
+            </a:pPr>
+            <a:r>
+              <a:rPr lang="en-US" sz="1000" b="1" spc="100" kern="0" dirty="0">
+                <a:solidFill>
+                  <a:srgbClr val="4B5563"/>
+                </a:solidFill>
+                <a:latin typeface="Arial" pitchFamily="34" charset="0"/>
+                <a:ea typeface="Arial" pitchFamily="34" charset="-122"/>
+                <a:cs typeface="Arial" pitchFamily="34" charset="-120"/>
+              </a:rPr>
+              <a:t>CA. 4 WOCHEN</a:t>
+            </a:r>
+            <a:endParaRPr lang="en-US" sz="1000" dirty="0"/>
+          </a:p>
+        </p:txBody>
+      </p:sp>
+      <p:sp>
+        <p:nvSpPr>
+          <p:cNvPr id="15" name="Text 13"/>
+          <p:cNvSpPr txBox="1"/>
+          <p:nvPr/>
+        </p:nvSpPr>
+        <p:spPr>
+          <a:xfrm>
+            <a:off x="3393338" y="3931920"/>
+            <a:ext cx="2560320" cy="384048"/>
+          </a:xfrm>
+          <a:prstGeom prst="rect">
+            <a:avLst/>
+          </a:prstGeom>
+          <a:noFill/>
+          <a:ln/>
+        </p:spPr>
+        <p:txBody>
+          <a:bodyPr wrap="square" lIns="0" tIns="0" rIns="0" bIns="0" rtlCol="0" anchor="t"/>
+          <a:lstStyle/>
+          <a:p>
+            <a:pPr indent="0" marL="0">
+              <a:buNone/>
+            </a:pPr>
+            <a:r>
+              <a:rPr lang="en-US" sz="1800" b="1" dirty="0">
+                <a:solidFill>
+                  <a:srgbClr val="16181D"/>
+                </a:solidFill>
+                <a:latin typeface="Arial" pitchFamily="34" charset="0"/>
+                <a:ea typeface="Arial" pitchFamily="34" charset="-122"/>
+                <a:cs typeface="Arial" pitchFamily="34" charset="-120"/>
+              </a:rPr>
+              <a:t>Pilot Brandschutz</a:t>
+            </a:r>
+            <a:endParaRPr lang="en-US" sz="1800" dirty="0"/>
+          </a:p>
+        </p:txBody>
+      </p:sp>
+      <p:sp>
+        <p:nvSpPr>
+          <p:cNvPr id="16" name="Text 14"/>
+          <p:cNvSpPr txBox="1"/>
+          <p:nvPr/>
+        </p:nvSpPr>
+        <p:spPr>
+          <a:xfrm>
+            <a:off x="3393338" y="4434840"/>
+            <a:ext cx="2560320" cy="1737360"/>
+          </a:xfrm>
+          <a:prstGeom prst="rect">
+            <a:avLst/>
+          </a:prstGeom>
+          <a:noFill/>
+          <a:ln/>
+        </p:spPr>
+        <p:txBody>
+          <a:bodyPr wrap="square" lIns="0" tIns="0" rIns="0" bIns="0" rtlCol="0" anchor="t"/>
+          <a:lstStyle/>
+          <a:p>
+            <a:pPr indent="0" marL="0">
+              <a:lnSpc>
+                <a:spcPct val="112000"/>
+              </a:lnSpc>
+              <a:buNone/>
+            </a:pPr>
+            <a:r>
+              <a:rPr lang="en-US" sz="1400" dirty="0">
+                <a:solidFill>
+                  <a:srgbClr val="16181D"/>
+                </a:solidFill>
+                <a:latin typeface="Arial" pitchFamily="34" charset="0"/>
+                <a:ea typeface="Arial" pitchFamily="34" charset="-122"/>
+                <a:cs typeface="Arial" pitchFamily="34" charset="-120"/>
+              </a:rPr>
+              <a:t>Titel des Fachbereichs aus Pimcore 6 übernehmen, Werk/Ausgabe-Struktur, Qualitätsprofile; Parallelbetrieb und Datenabgleich.</a:t>
+            </a:r>
+            <a:endParaRPr lang="en-US" sz="1400" dirty="0"/>
+          </a:p>
+        </p:txBody>
+      </p:sp>
+      <p:sp>
+        <p:nvSpPr>
+          <p:cNvPr id="17" name="Shape 15"/>
+          <p:cNvSpPr/>
+          <p:nvPr/>
+        </p:nvSpPr>
+        <p:spPr>
+          <a:xfrm>
+            <a:off x="6238037" y="2240280"/>
+            <a:ext cx="274320" cy="274320"/>
+          </a:xfrm>
+          <a:prstGeom prst="rect">
+            <a:avLst/>
+          </a:prstGeom>
+          <a:solidFill>
+            <a:srgbClr val="000E2F"/>
+          </a:solidFill>
+          <a:ln w="12700">
+            <a:solidFill>
+              <a:srgbClr val="000E2F"/>
+            </a:solidFill>
+            <a:prstDash val="solid"/>
+          </a:ln>
+        </p:spPr>
+      </p:sp>
+      <p:sp>
+        <p:nvSpPr>
+          <p:cNvPr id="18" name="Text 16"/>
+          <p:cNvSpPr txBox="1"/>
+          <p:nvPr/>
+        </p:nvSpPr>
+        <p:spPr>
+          <a:xfrm>
+            <a:off x="6238037" y="2788920"/>
+            <a:ext cx="2560320" cy="731520"/>
+          </a:xfrm>
+          <a:prstGeom prst="rect">
+            <a:avLst/>
+          </a:prstGeom>
+          <a:noFill/>
+          <a:ln/>
+        </p:spPr>
+        <p:txBody>
+          <a:bodyPr wrap="square" lIns="0" tIns="0" rIns="0" bIns="0" rtlCol="0" anchor="t"/>
+          <a:lstStyle/>
+          <a:p>
+            <a:pPr indent="0" marL="0">
+              <a:buNone/>
+            </a:pPr>
+            <a:r>
+              <a:rPr lang="en-US" sz="4000" dirty="0">
+                <a:solidFill>
+                  <a:srgbClr val="1B2D5C"/>
+                </a:solidFill>
+                <a:latin typeface="Arial" pitchFamily="34" charset="0"/>
+                <a:ea typeface="Arial" pitchFamily="34" charset="-122"/>
+                <a:cs typeface="Arial" pitchFamily="34" charset="-120"/>
+              </a:rPr>
+              <a:t>03</a:t>
+            </a:r>
+            <a:endParaRPr lang="en-US" sz="4000" dirty="0"/>
+          </a:p>
+        </p:txBody>
+      </p:sp>
+      <p:sp>
+        <p:nvSpPr>
+          <p:cNvPr id="19" name="Text 17"/>
+          <p:cNvSpPr txBox="1"/>
+          <p:nvPr/>
+        </p:nvSpPr>
+        <p:spPr>
+          <a:xfrm>
+            <a:off x="6238037" y="3611880"/>
+            <a:ext cx="2560320" cy="256032"/>
+          </a:xfrm>
+          <a:prstGeom prst="rect">
+            <a:avLst/>
+          </a:prstGeom>
+          <a:noFill/>
+          <a:ln/>
+        </p:spPr>
+        <p:txBody>
+          <a:bodyPr wrap="square" lIns="0" tIns="0" rIns="0" bIns="0" rtlCol="0" anchor="t"/>
+          <a:lstStyle/>
+          <a:p>
+            <a:pPr indent="0" marL="0">
+              <a:buNone/>
+            </a:pPr>
+            <a:r>
+              <a:rPr lang="en-US" sz="1000" b="1" spc="100" kern="0" dirty="0">
+                <a:solidFill>
+                  <a:srgbClr val="4B5563"/>
+                </a:solidFill>
+                <a:latin typeface="Arial" pitchFamily="34" charset="0"/>
+                <a:ea typeface="Arial" pitchFamily="34" charset="-122"/>
+                <a:cs typeface="Arial" pitchFamily="34" charset="-120"/>
+              </a:rPr>
+              <a:t>JE NACH UMFANG</a:t>
+            </a:r>
+            <a:endParaRPr lang="en-US" sz="1000" dirty="0"/>
+          </a:p>
+        </p:txBody>
+      </p:sp>
+      <p:sp>
+        <p:nvSpPr>
+          <p:cNvPr id="20" name="Text 18"/>
+          <p:cNvSpPr txBox="1"/>
+          <p:nvPr/>
+        </p:nvSpPr>
+        <p:spPr>
+          <a:xfrm>
+            <a:off x="6238037" y="3931920"/>
+            <a:ext cx="2560320" cy="384048"/>
+          </a:xfrm>
+          <a:prstGeom prst="rect">
+            <a:avLst/>
+          </a:prstGeom>
+          <a:noFill/>
+          <a:ln/>
+        </p:spPr>
+        <p:txBody>
+          <a:bodyPr wrap="square" lIns="0" tIns="0" rIns="0" bIns="0" rtlCol="0" anchor="t"/>
+          <a:lstStyle/>
+          <a:p>
+            <a:pPr indent="0" marL="0">
+              <a:buNone/>
+            </a:pPr>
+            <a:r>
+              <a:rPr lang="en-US" sz="1800" b="1" dirty="0">
+                <a:solidFill>
+                  <a:srgbClr val="16181D"/>
+                </a:solidFill>
+                <a:latin typeface="Arial" pitchFamily="34" charset="0"/>
+                <a:ea typeface="Arial" pitchFamily="34" charset="-122"/>
+                <a:cs typeface="Arial" pitchFamily="34" charset="-120"/>
+              </a:rPr>
+              <a:t>Projektanteil</a:t>
+            </a:r>
+            <a:endParaRPr lang="en-US" sz="1800" dirty="0"/>
+          </a:p>
+        </p:txBody>
+      </p:sp>
+      <p:sp>
+        <p:nvSpPr>
+          <p:cNvPr id="21" name="Text 19"/>
+          <p:cNvSpPr txBox="1"/>
+          <p:nvPr/>
+        </p:nvSpPr>
+        <p:spPr>
+          <a:xfrm>
+            <a:off x="6238037" y="4434840"/>
+            <a:ext cx="2560320" cy="1737360"/>
+          </a:xfrm>
+          <a:prstGeom prst="rect">
+            <a:avLst/>
+          </a:prstGeom>
+          <a:noFill/>
+          <a:ln/>
+        </p:spPr>
+        <p:txBody>
+          <a:bodyPr wrap="square" lIns="0" tIns="0" rIns="0" bIns="0" rtlCol="0" anchor="t"/>
+          <a:lstStyle/>
+          <a:p>
+            <a:pPr indent="0" marL="0">
+              <a:lnSpc>
+                <a:spcPct val="112000"/>
+              </a:lnSpc>
+              <a:buNone/>
+            </a:pPr>
+            <a:r>
+              <a:rPr lang="en-US" sz="1400" dirty="0">
+                <a:solidFill>
+                  <a:srgbClr val="16181D"/>
+                </a:solidFill>
+                <a:latin typeface="Arial" pitchFamily="34" charset="0"/>
+                <a:ea typeface="Arial" pitchFamily="34" charset="-122"/>
+                <a:cs typeface="Arial" pitchFamily="34" charset="-120"/>
+              </a:rPr>
+              <a:t>Fehlende Funktionen als Standard bauen – EasyCatalog-, Thieme- und ONIX-Export, Cover-Metadaten; Shop und Handel umstellen.</a:t>
+            </a:r>
+            <a:endParaRPr lang="en-US" sz="1400" dirty="0"/>
+          </a:p>
+        </p:txBody>
+      </p:sp>
+      <p:sp>
+        <p:nvSpPr>
+          <p:cNvPr id="22" name="Shape 20"/>
+          <p:cNvSpPr/>
+          <p:nvPr/>
+        </p:nvSpPr>
+        <p:spPr>
+          <a:xfrm>
+            <a:off x="9082735" y="2240280"/>
+            <a:ext cx="274320" cy="274320"/>
+          </a:xfrm>
+          <a:prstGeom prst="rect">
+            <a:avLst/>
+          </a:prstGeom>
+          <a:solidFill>
+            <a:srgbClr val="E2211C"/>
+          </a:solidFill>
+          <a:ln w="12700">
+            <a:solidFill>
+              <a:srgbClr val="E2211C"/>
+            </a:solidFill>
+            <a:prstDash val="solid"/>
+          </a:ln>
+        </p:spPr>
+      </p:sp>
+      <p:sp>
+        <p:nvSpPr>
+          <p:cNvPr id="23" name="Text 21"/>
+          <p:cNvSpPr txBox="1"/>
+          <p:nvPr/>
+        </p:nvSpPr>
+        <p:spPr>
+          <a:xfrm>
+            <a:off x="9082735" y="2788920"/>
+            <a:ext cx="2560320" cy="731520"/>
+          </a:xfrm>
+          <a:prstGeom prst="rect">
+            <a:avLst/>
+          </a:prstGeom>
+          <a:noFill/>
+          <a:ln/>
+        </p:spPr>
+        <p:txBody>
+          <a:bodyPr wrap="square" lIns="0" tIns="0" rIns="0" bIns="0" rtlCol="0" anchor="t"/>
+          <a:lstStyle/>
+          <a:p>
+            <a:pPr indent="0" marL="0">
+              <a:buNone/>
+            </a:pPr>
+            <a:r>
+              <a:rPr lang="en-US" sz="4000" dirty="0">
+                <a:solidFill>
+                  <a:srgbClr val="1B2D5C"/>
+                </a:solidFill>
+                <a:latin typeface="Arial" pitchFamily="34" charset="0"/>
+                <a:ea typeface="Arial" pitchFamily="34" charset="-122"/>
+                <a:cs typeface="Arial" pitchFamily="34" charset="-120"/>
+              </a:rPr>
+              <a:t>04</a:t>
+            </a:r>
+            <a:endParaRPr lang="en-US" sz="4000" dirty="0"/>
+          </a:p>
+        </p:txBody>
+      </p:sp>
+      <p:sp>
+        <p:nvSpPr>
+          <p:cNvPr id="24" name="Text 22"/>
+          <p:cNvSpPr txBox="1"/>
+          <p:nvPr/>
+        </p:nvSpPr>
+        <p:spPr>
+          <a:xfrm>
+            <a:off x="9082735" y="3611880"/>
+            <a:ext cx="2560320" cy="256032"/>
+          </a:xfrm>
+          <a:prstGeom prst="rect">
+            <a:avLst/>
+          </a:prstGeom>
+          <a:noFill/>
+          <a:ln/>
+        </p:spPr>
+        <p:txBody>
+          <a:bodyPr wrap="square" lIns="0" tIns="0" rIns="0" bIns="0" rtlCol="0" anchor="t"/>
+          <a:lstStyle/>
+          <a:p>
+            <a:pPr indent="0" marL="0">
+              <a:buNone/>
+            </a:pPr>
+            <a:r>
+              <a:rPr lang="en-US" sz="1000" b="1" spc="100" kern="0" dirty="0">
+                <a:solidFill>
+                  <a:srgbClr val="4B5563"/>
+                </a:solidFill>
+                <a:latin typeface="Arial" pitchFamily="34" charset="0"/>
+                <a:ea typeface="Arial" pitchFamily="34" charset="-122"/>
+                <a:cs typeface="Arial" pitchFamily="34" charset="-120"/>
+              </a:rPr>
+              <a:t>FORTLAUFEND</a:t>
+            </a:r>
+            <a:endParaRPr lang="en-US" sz="1000" dirty="0"/>
+          </a:p>
+        </p:txBody>
+      </p:sp>
+      <p:sp>
+        <p:nvSpPr>
+          <p:cNvPr id="25" name="Text 23"/>
+          <p:cNvSpPr txBox="1"/>
+          <p:nvPr/>
+        </p:nvSpPr>
+        <p:spPr>
+          <a:xfrm>
+            <a:off x="9082735" y="3931920"/>
+            <a:ext cx="2560320" cy="384048"/>
+          </a:xfrm>
+          <a:prstGeom prst="rect">
+            <a:avLst/>
+          </a:prstGeom>
+          <a:noFill/>
+          <a:ln/>
+        </p:spPr>
+        <p:txBody>
+          <a:bodyPr wrap="square" lIns="0" tIns="0" rIns="0" bIns="0" rtlCol="0" anchor="t"/>
+          <a:lstStyle/>
+          <a:p>
+            <a:pPr indent="0" marL="0">
+              <a:buNone/>
+            </a:pPr>
+            <a:r>
+              <a:rPr lang="en-US" sz="1800" b="1" dirty="0">
+                <a:solidFill>
+                  <a:srgbClr val="16181D"/>
+                </a:solidFill>
+                <a:latin typeface="Arial" pitchFamily="34" charset="0"/>
+                <a:ea typeface="Arial" pitchFamily="34" charset="-122"/>
+                <a:cs typeface="Arial" pitchFamily="34" charset="-120"/>
+              </a:rPr>
+              <a:t>Ablösung</a:t>
+            </a:r>
+            <a:endParaRPr lang="en-US" sz="1800" dirty="0"/>
+          </a:p>
+        </p:txBody>
+      </p:sp>
+      <p:sp>
+        <p:nvSpPr>
+          <p:cNvPr id="26" name="Text 24"/>
+          <p:cNvSpPr txBox="1"/>
+          <p:nvPr/>
+        </p:nvSpPr>
+        <p:spPr>
+          <a:xfrm>
+            <a:off x="9082735" y="4434840"/>
+            <a:ext cx="2560320" cy="1737360"/>
+          </a:xfrm>
+          <a:prstGeom prst="rect">
+            <a:avLst/>
+          </a:prstGeom>
+          <a:noFill/>
+          <a:ln/>
+        </p:spPr>
+        <p:txBody>
+          <a:bodyPr wrap="square" lIns="0" tIns="0" rIns="0" bIns="0" rtlCol="0" anchor="t"/>
+          <a:lstStyle/>
+          <a:p>
+            <a:pPr indent="0" marL="0">
+              <a:lnSpc>
+                <a:spcPct val="112000"/>
+              </a:lnSpc>
+              <a:buNone/>
+            </a:pPr>
+            <a:r>
+              <a:rPr lang="en-US" sz="1400" dirty="0">
+                <a:solidFill>
+                  <a:srgbClr val="16181D"/>
+                </a:solidFill>
+                <a:latin typeface="Arial" pitchFamily="34" charset="0"/>
+                <a:ea typeface="Arial" pitchFamily="34" charset="-122"/>
+                <a:cs typeface="Arial" pitchFamily="34" charset="-120"/>
+              </a:rPr>
+              <a:t>Weitere Fachbereiche, Zeitschriften, Formulare und Seminare; Schulung der Redaktionen; Abschaltung von Pimcore 6.</a:t>
+            </a:r>
+            <a:endParaRPr lang="en-US" sz="1400" dirty="0"/>
+          </a:p>
+        </p:txBody>
+      </p:sp>
+    </p:spTree>
+  </p:cSld>
+  <p:clrMapOvr>
+    <a:masterClrMapping/>
+  </p:clrMapOvr>
+</p:sld>
+</file>
+
+<file path=ppt/slides/slide16.xml><?xml version="1.0" encoding="utf-8"?>
+<p:sld xmlns:a="http://schemas.openxmlformats.org/drawingml/2006/main" xmlns:r="http://schemas.openxmlformats.org/officeDocument/2006/relationships" xmlns:p="http://schemas.openxmlformats.org/presentationml/2006/main">
+  <p:cSld name="Slide 16">
     <p:bg>
       <p:bgPr>
         <a:solidFill>

</xml_diff>

<commit_message>
Sales: Kohlhammer-Vorlage um Folie 'Wir entwickeln mit KI' ergänzt
KI-gestützte Entwicklung mit Vier-Augen-Prinzip, Enablement über Claude und
GitHub, Risikominimierung durch Wissen im Repository.

Co-Authored-By: Claude Opus 5.5 <noreply@anthropic.com>
Claude-Session: https://claude.ai/code/session_019qs2qjmit64azXVvXyRtsJ
</commit_message>
<xml_diff>
--- a/docs/sales/kohlhammer-anypim-vs-pimcore.pptx
+++ b/docs/sales/kohlhammer-anypim-vs-pimcore.pptx
@@ -21,9 +21,10 @@
     <p:sldId id="269" r:id="rId15"/>
     <p:sldId id="270" r:id="rId16"/>
     <p:sldId id="271" r:id="rId17"/>
+    <p:sldId id="272" r:id="rId18"/>
   </p:sldIdLst>
   <p:notesMasterIdLst>
-    <p:notesMasterId r:id="rId18"/>
+    <p:notesMasterId r:id="rId19"/>
   </p:notesMasterIdLst>
   <p:sldSz cx="12192000" cy="6858000"/>
   <p:notesSz cx="6858000" cy="12192000"/>
@@ -1045,7 +1046,7 @@
           <a:p>
             <a:r>
               <a:rPr lang="en-US" dirty="0"/>
-              <a:t>Zeiträume sind Richtwerte und werden in der Bestandsaufnahme geschärft. Der Pilot mit dem Fachbereich Brandschutz liefert eine belastbare Entscheidungsgrundlage auf echten Daten, bevor das ganze Programm umzieht.</a:t>
+              <a:t>Wir entwickeln anyPIM mit KI (Claude Code). Die Regeln dafür liegen im Repository – etwa wie ein neues Exportformat gebaut wird – und gelten für Menschen und KI gleichermaßen. Kohlhammer muss dafür keinen Code lesen: Wünsche werden in Fachsprache formuliert, jede Änderung wird von incoxx geprüft und als nachvollziehbarer Pull Request dokumentiert. Mit Zugang zu Claude und GitHub kann Kohlhammer selbst Fragen zum System stellen und Änderungen verfolgen. Das senkt das Risiko: Das Wissen ist nicht an einzelne Personen gebunden.</a:t>
             </a:r>
             <a:endParaRPr lang="en-US" dirty="0"/>
           </a:p>
@@ -1133,7 +1134,7 @@
           <a:p>
             <a:r>
               <a:rPr lang="en-US" dirty="0"/>
-              <a:t>Abschluss mit konkretem Vorschlag: Workshop und Pilot. So entscheidet Kohlhammer auf Basis eigener Daten, nicht auf Basis von Folien.</a:t>
+              <a:t>Zeiträume sind Richtwerte und werden in der Bestandsaufnahme geschärft. Der Pilot mit dem Fachbereich Brandschutz liefert eine belastbare Entscheidungsgrundlage auf echten Daten, bevor das ganze Programm umzieht.</a:t>
             </a:r>
             <a:endParaRPr lang="en-US" dirty="0"/>
           </a:p>
@@ -1157,6 +1158,94 @@
             <a:fld id="{F7021451-1387-4CA6-816F-3879F97B5CBC}" type="slidenum">
               <a:rPr lang="en-US"/>
               <a:t>16</a:t>
+            </a:fld>
+            <a:endParaRPr lang="en-US"/>
+          </a:p>
+        </p:txBody>
+      </p:sp>
+    </p:spTree>
+    <p:extLst>
+      <p:ext uri="{BB962C8B-B14F-4D97-AF65-F5344CB8AC3E}">
+        <p14:creationId xmlns:p14="http://schemas.microsoft.com/office/powerpoint/2010/main" val="1024086991"/>
+      </p:ext>
+    </p:extLst>
+  </p:cSld>
+  <p:clrMapOvr>
+    <a:masterClrMapping/>
+  </p:clrMapOvr>
+</p:notes>
+</file>
+
+<file path=ppt/notesSlides/notesSlide17.xml><?xml version="1.0" encoding="utf-8"?>
+<p:notes xmlns:a="http://schemas.openxmlformats.org/drawingml/2006/main" xmlns:r="http://schemas.openxmlformats.org/officeDocument/2006/relationships" xmlns:p="http://schemas.openxmlformats.org/presentationml/2006/main">
+  <p:cSld>
+    <p:spTree>
+      <p:nvGrpSpPr>
+        <p:cNvPr id="1" name=""/>
+        <p:cNvGrpSpPr/>
+        <p:nvPr/>
+      </p:nvGrpSpPr>
+      <p:grpSpPr>
+        <a:xfrm>
+          <a:off x="0" y="0"/>
+          <a:ext cx="0" cy="0"/>
+          <a:chOff x="0" y="0"/>
+          <a:chExt cx="0" cy="0"/>
+        </a:xfrm>
+      </p:grpSpPr>
+      <p:sp>
+        <p:nvSpPr>
+          <p:cNvPr id="2" name="Slide Image Placeholder 1"/>
+          <p:cNvSpPr>
+            <a:spLocks noGrp="1" noRot="1" noChangeAspect="1"/>
+          </p:cNvSpPr>
+          <p:nvPr>
+            <p:ph type="sldImg"/>
+          </p:nvPr>
+        </p:nvSpPr>
+        <p:spPr/>
+      </p:sp>
+      <p:sp>
+        <p:nvSpPr>
+          <p:cNvPr id="3" name="Notes Placeholder 2"/>
+          <p:cNvSpPr>
+            <a:spLocks noGrp="1"/>
+          </p:cNvSpPr>
+          <p:nvPr>
+            <p:ph type="body" idx="1"/>
+          </p:nvPr>
+        </p:nvSpPr>
+        <p:spPr/>
+        <p:txBody>
+          <a:bodyPr/>
+          <a:lstStyle/>
+          <a:p>
+            <a:r>
+              <a:rPr lang="en-US" dirty="0"/>
+              <a:t>Abschluss mit konkretem Vorschlag: Workshop und Pilot. So entscheidet Kohlhammer auf Basis eigener Daten, nicht auf Basis von Folien.</a:t>
+            </a:r>
+            <a:endParaRPr lang="en-US" dirty="0"/>
+          </a:p>
+        </p:txBody>
+      </p:sp>
+      <p:sp>
+        <p:nvSpPr>
+          <p:cNvPr id="4" name="Slide Number Placeholder 3"/>
+          <p:cNvSpPr>
+            <a:spLocks noGrp="1"/>
+          </p:cNvSpPr>
+          <p:nvPr>
+            <p:ph type="sldNum" sz="quarter" idx="10"/>
+          </p:nvPr>
+        </p:nvSpPr>
+        <p:spPr/>
+        <p:txBody>
+          <a:bodyPr/>
+          <a:lstStyle/>
+          <a:p>
+            <a:fld id="{F7021451-1387-4CA6-816F-3879F97B5CBC}" type="slidenum">
+              <a:rPr lang="en-US"/>
+              <a:t>17</a:t>
             </a:fld>
             <a:endParaRPr lang="en-US"/>
           </a:p>
@@ -11844,7 +11933,7 @@
                 <a:ea typeface="Arial" pitchFamily="34" charset="-122"/>
                 <a:cs typeface="Arial" pitchFamily="34" charset="-120"/>
               </a:rPr>
-              <a:t>VORGESCHLAGENER FAHRPLAN</a:t>
+              <a:t>WIR ENTWICKELN MIT KI</a:t>
             </a:r>
             <a:endParaRPr lang="en-US" sz="3000" dirty="0"/>
           </a:p>
@@ -11883,7 +11972,7 @@
                 <a:ea typeface="Arial" pitchFamily="34" charset="-122"/>
                 <a:cs typeface="Arial" pitchFamily="34" charset="-120"/>
               </a:rPr>
-              <a:t>Richtwerte für den Workshop. Pimcore 6 läuft bis zur Umstellung weiter; ein Fachbereich dient als Pilot.</a:t>
+              <a:t>Kohlhammer muss den Code nicht kennen – wir befähigen das Team, mitzureden, mitzuprüfen und nachzuvollziehen.</a:t>
             </a:r>
             <a:endParaRPr lang="en-US" sz="1400" dirty="0"/>
           </a:p>
@@ -11975,14 +12064,16 @@
         </p:nvSpPr>
         <p:spPr>
           <a:xfrm>
-            <a:off x="640080" y="2377440"/>
-            <a:ext cx="10911535" cy="0"/>
-          </a:xfrm>
-          <a:prstGeom prst="line">
-            <a:avLst/>
-          </a:prstGeom>
-          <a:noFill/>
-          <a:ln w="19050">
+            <a:off x="548640" y="1645920"/>
+            <a:ext cx="777240" cy="777240"/>
+          </a:xfrm>
+          <a:prstGeom prst="ellipse">
+            <a:avLst/>
+          </a:prstGeom>
+          <a:solidFill>
+            <a:srgbClr val="FFFFFF"/>
+          </a:solidFill>
+          <a:ln w="25400">
             <a:solidFill>
               <a:srgbClr val="1B2D5C"/>
             </a:solidFill>
@@ -11992,14 +12083,844 @@
       </p:sp>
       <p:sp>
         <p:nvSpPr>
-          <p:cNvPr id="7" name="Shape 5"/>
+          <p:cNvPr id="7" name="Text 5"/>
+          <p:cNvSpPr txBox="1"/>
+          <p:nvPr/>
+        </p:nvSpPr>
+        <p:spPr>
+          <a:xfrm>
+            <a:off x="548640" y="1645920"/>
+            <a:ext cx="777240" cy="777240"/>
+          </a:xfrm>
+          <a:prstGeom prst="rect">
+            <a:avLst/>
+          </a:prstGeom>
+          <a:noFill/>
+          <a:ln/>
+        </p:spPr>
+        <p:txBody>
+          <a:bodyPr wrap="square" lIns="0" tIns="0" rIns="0" bIns="0" rtlCol="0" anchor="ctr"/>
+          <a:lstStyle/>
+          <a:p>
+            <a:pPr algn="ctr" indent="0" marL="0">
+              <a:buNone/>
+            </a:pPr>
+            <a:r>
+              <a:rPr lang="en-US" sz="2600" dirty="0">
+                <a:solidFill>
+                  <a:srgbClr val="1B2D5C"/>
+                </a:solidFill>
+                <a:latin typeface="Arial" pitchFamily="34" charset="0"/>
+                <a:ea typeface="Arial" pitchFamily="34" charset="-122"/>
+                <a:cs typeface="Arial" pitchFamily="34" charset="-120"/>
+              </a:rPr>
+              <a:t>1</a:t>
+            </a:r>
+            <a:endParaRPr lang="en-US" sz="2600" dirty="0"/>
+          </a:p>
+        </p:txBody>
+      </p:sp>
+      <p:sp>
+        <p:nvSpPr>
+          <p:cNvPr id="8" name="Text 6"/>
+          <p:cNvSpPr txBox="1"/>
+          <p:nvPr/>
+        </p:nvSpPr>
+        <p:spPr>
+          <a:xfrm>
+            <a:off x="1417320" y="1645920"/>
+            <a:ext cx="1699184" cy="777240"/>
+          </a:xfrm>
+          <a:prstGeom prst="rect">
+            <a:avLst/>
+          </a:prstGeom>
+          <a:noFill/>
+          <a:ln/>
+        </p:spPr>
+        <p:txBody>
+          <a:bodyPr wrap="square" lIns="0" tIns="0" rIns="0" bIns="0" rtlCol="0" anchor="ctr"/>
+          <a:lstStyle/>
+          <a:p>
+            <a:pPr algn="ctr" indent="0" marL="0">
+              <a:buNone/>
+            </a:pPr>
+            <a:r>
+              <a:rPr lang="en-US" sz="2400" dirty="0">
+                <a:solidFill>
+                  <a:srgbClr val="1B2D5C"/>
+                </a:solidFill>
+                <a:latin typeface="Arial" pitchFamily="34" charset="0"/>
+                <a:ea typeface="Arial" pitchFamily="34" charset="-122"/>
+                <a:cs typeface="Arial" pitchFamily="34" charset="-120"/>
+              </a:rPr>
+              <a:t>→</a:t>
+            </a:r>
+            <a:endParaRPr lang="en-US" sz="2400" dirty="0"/>
+          </a:p>
+        </p:txBody>
+      </p:sp>
+      <p:sp>
+        <p:nvSpPr>
+          <p:cNvPr id="9" name="Text 7"/>
+          <p:cNvSpPr txBox="1"/>
+          <p:nvPr/>
+        </p:nvSpPr>
+        <p:spPr>
+          <a:xfrm>
+            <a:off x="548640" y="2560320"/>
+            <a:ext cx="2567864" cy="320040"/>
+          </a:xfrm>
+          <a:prstGeom prst="rect">
+            <a:avLst/>
+          </a:prstGeom>
+          <a:noFill/>
+          <a:ln/>
+        </p:spPr>
+        <p:txBody>
+          <a:bodyPr wrap="square" lIns="0" tIns="0" rIns="0" bIns="0" rtlCol="0" anchor="t"/>
+          <a:lstStyle/>
+          <a:p>
+            <a:pPr indent="0" marL="0">
+              <a:buNone/>
+            </a:pPr>
+            <a:r>
+              <a:rPr lang="en-US" sz="1400" b="1" dirty="0">
+                <a:solidFill>
+                  <a:srgbClr val="16181D"/>
+                </a:solidFill>
+                <a:latin typeface="Arial" pitchFamily="34" charset="0"/>
+                <a:ea typeface="Arial" pitchFamily="34" charset="-122"/>
+                <a:cs typeface="Arial" pitchFamily="34" charset="-120"/>
+              </a:rPr>
+              <a:t>Wunsch in Fachsprache</a:t>
+            </a:r>
+            <a:endParaRPr lang="en-US" sz="1400" dirty="0"/>
+          </a:p>
+        </p:txBody>
+      </p:sp>
+      <p:sp>
+        <p:nvSpPr>
+          <p:cNvPr id="10" name="Text 8"/>
+          <p:cNvSpPr txBox="1"/>
+          <p:nvPr/>
+        </p:nvSpPr>
+        <p:spPr>
+          <a:xfrm>
+            <a:off x="548640" y="2898648"/>
+            <a:ext cx="2567864" cy="822960"/>
+          </a:xfrm>
+          <a:prstGeom prst="rect">
+            <a:avLst/>
+          </a:prstGeom>
+          <a:noFill/>
+          <a:ln/>
+        </p:spPr>
+        <p:txBody>
+          <a:bodyPr wrap="square" lIns="0" tIns="0" rIns="0" bIns="0" rtlCol="0" anchor="t"/>
+          <a:lstStyle/>
+          <a:p>
+            <a:pPr indent="0" marL="0">
+              <a:lnSpc>
+                <a:spcPct val="108000"/>
+              </a:lnSpc>
+              <a:buNone/>
+            </a:pPr>
+            <a:r>
+              <a:rPr lang="en-US" sz="1200" dirty="0">
+                <a:solidFill>
+                  <a:srgbClr val="4B5563"/>
+                </a:solidFill>
+                <a:latin typeface="Arial" pitchFamily="34" charset="0"/>
+                <a:ea typeface="Arial" pitchFamily="34" charset="-122"/>
+                <a:cs typeface="Arial" pitchFamily="34" charset="-120"/>
+              </a:rPr>
+              <a:t>Kohlhammer beschreibt, was gebraucht wird – im Gespräch oder als GitHub-Issue.</a:t>
+            </a:r>
+            <a:endParaRPr lang="en-US" sz="1200" dirty="0"/>
+          </a:p>
+        </p:txBody>
+      </p:sp>
+      <p:sp>
+        <p:nvSpPr>
+          <p:cNvPr id="11" name="Shape 9"/>
           <p:cNvSpPr/>
           <p:nvPr/>
         </p:nvSpPr>
         <p:spPr>
           <a:xfrm>
-            <a:off x="548640" y="2240280"/>
-            <a:ext cx="274320" cy="274320"/>
+            <a:off x="3390824" y="1645920"/>
+            <a:ext cx="777240" cy="777240"/>
+          </a:xfrm>
+          <a:prstGeom prst="ellipse">
+            <a:avLst/>
+          </a:prstGeom>
+          <a:solidFill>
+            <a:srgbClr val="FFFFFF"/>
+          </a:solidFill>
+          <a:ln w="25400">
+            <a:solidFill>
+              <a:srgbClr val="1B2D5C"/>
+            </a:solidFill>
+            <a:prstDash val="solid"/>
+          </a:ln>
+        </p:spPr>
+      </p:sp>
+      <p:sp>
+        <p:nvSpPr>
+          <p:cNvPr id="12" name="Text 10"/>
+          <p:cNvSpPr txBox="1"/>
+          <p:nvPr/>
+        </p:nvSpPr>
+        <p:spPr>
+          <a:xfrm>
+            <a:off x="3390824" y="1645920"/>
+            <a:ext cx="777240" cy="777240"/>
+          </a:xfrm>
+          <a:prstGeom prst="rect">
+            <a:avLst/>
+          </a:prstGeom>
+          <a:noFill/>
+          <a:ln/>
+        </p:spPr>
+        <p:txBody>
+          <a:bodyPr wrap="square" lIns="0" tIns="0" rIns="0" bIns="0" rtlCol="0" anchor="ctr"/>
+          <a:lstStyle/>
+          <a:p>
+            <a:pPr algn="ctr" indent="0" marL="0">
+              <a:buNone/>
+            </a:pPr>
+            <a:r>
+              <a:rPr lang="en-US" sz="2600" dirty="0">
+                <a:solidFill>
+                  <a:srgbClr val="1B2D5C"/>
+                </a:solidFill>
+                <a:latin typeface="Arial" pitchFamily="34" charset="0"/>
+                <a:ea typeface="Arial" pitchFamily="34" charset="-122"/>
+                <a:cs typeface="Arial" pitchFamily="34" charset="-120"/>
+              </a:rPr>
+              <a:t>2</a:t>
+            </a:r>
+            <a:endParaRPr lang="en-US" sz="2600" dirty="0"/>
+          </a:p>
+        </p:txBody>
+      </p:sp>
+      <p:sp>
+        <p:nvSpPr>
+          <p:cNvPr id="13" name="Text 11"/>
+          <p:cNvSpPr txBox="1"/>
+          <p:nvPr/>
+        </p:nvSpPr>
+        <p:spPr>
+          <a:xfrm>
+            <a:off x="4259504" y="1645920"/>
+            <a:ext cx="1699184" cy="777240"/>
+          </a:xfrm>
+          <a:prstGeom prst="rect">
+            <a:avLst/>
+          </a:prstGeom>
+          <a:noFill/>
+          <a:ln/>
+        </p:spPr>
+        <p:txBody>
+          <a:bodyPr wrap="square" lIns="0" tIns="0" rIns="0" bIns="0" rtlCol="0" anchor="ctr"/>
+          <a:lstStyle/>
+          <a:p>
+            <a:pPr algn="ctr" indent="0" marL="0">
+              <a:buNone/>
+            </a:pPr>
+            <a:r>
+              <a:rPr lang="en-US" sz="2400" dirty="0">
+                <a:solidFill>
+                  <a:srgbClr val="1B2D5C"/>
+                </a:solidFill>
+                <a:latin typeface="Arial" pitchFamily="34" charset="0"/>
+                <a:ea typeface="Arial" pitchFamily="34" charset="-122"/>
+                <a:cs typeface="Arial" pitchFamily="34" charset="-120"/>
+              </a:rPr>
+              <a:t>→</a:t>
+            </a:r>
+            <a:endParaRPr lang="en-US" sz="2400" dirty="0"/>
+          </a:p>
+        </p:txBody>
+      </p:sp>
+      <p:sp>
+        <p:nvSpPr>
+          <p:cNvPr id="14" name="Text 12"/>
+          <p:cNvSpPr txBox="1"/>
+          <p:nvPr/>
+        </p:nvSpPr>
+        <p:spPr>
+          <a:xfrm>
+            <a:off x="3390824" y="2560320"/>
+            <a:ext cx="2567864" cy="320040"/>
+          </a:xfrm>
+          <a:prstGeom prst="rect">
+            <a:avLst/>
+          </a:prstGeom>
+          <a:noFill/>
+          <a:ln/>
+        </p:spPr>
+        <p:txBody>
+          <a:bodyPr wrap="square" lIns="0" tIns="0" rIns="0" bIns="0" rtlCol="0" anchor="t"/>
+          <a:lstStyle/>
+          <a:p>
+            <a:pPr indent="0" marL="0">
+              <a:buNone/>
+            </a:pPr>
+            <a:r>
+              <a:rPr lang="en-US" sz="1400" b="1" dirty="0">
+                <a:solidFill>
+                  <a:srgbClr val="16181D"/>
+                </a:solidFill>
+                <a:latin typeface="Arial" pitchFamily="34" charset="0"/>
+                <a:ea typeface="Arial" pitchFamily="34" charset="-122"/>
+                <a:cs typeface="Arial" pitchFamily="34" charset="-120"/>
+              </a:rPr>
+              <a:t>KI entwickelt nach Regeln</a:t>
+            </a:r>
+            <a:endParaRPr lang="en-US" sz="1400" dirty="0"/>
+          </a:p>
+        </p:txBody>
+      </p:sp>
+      <p:sp>
+        <p:nvSpPr>
+          <p:cNvPr id="15" name="Text 13"/>
+          <p:cNvSpPr txBox="1"/>
+          <p:nvPr/>
+        </p:nvSpPr>
+        <p:spPr>
+          <a:xfrm>
+            <a:off x="3390824" y="2898648"/>
+            <a:ext cx="2567864" cy="822960"/>
+          </a:xfrm>
+          <a:prstGeom prst="rect">
+            <a:avLst/>
+          </a:prstGeom>
+          <a:noFill/>
+          <a:ln/>
+        </p:spPr>
+        <p:txBody>
+          <a:bodyPr wrap="square" lIns="0" tIns="0" rIns="0" bIns="0" rtlCol="0" anchor="t"/>
+          <a:lstStyle/>
+          <a:p>
+            <a:pPr indent="0" marL="0">
+              <a:lnSpc>
+                <a:spcPct val="108000"/>
+              </a:lnSpc>
+              <a:buNone/>
+            </a:pPr>
+            <a:r>
+              <a:rPr lang="en-US" sz="1200" dirty="0">
+                <a:solidFill>
+                  <a:srgbClr val="4B5563"/>
+                </a:solidFill>
+                <a:latin typeface="Arial" pitchFamily="34" charset="0"/>
+                <a:ea typeface="Arial" pitchFamily="34" charset="-122"/>
+                <a:cs typeface="Arial" pitchFamily="34" charset="-120"/>
+              </a:rPr>
+              <a:t>Claude setzt um, nach festen Projektregeln und mit automatischen Tests.</a:t>
+            </a:r>
+            <a:endParaRPr lang="en-US" sz="1200" dirty="0"/>
+          </a:p>
+        </p:txBody>
+      </p:sp>
+      <p:sp>
+        <p:nvSpPr>
+          <p:cNvPr id="16" name="Shape 14"/>
+          <p:cNvSpPr/>
+          <p:nvPr/>
+        </p:nvSpPr>
+        <p:spPr>
+          <a:xfrm>
+            <a:off x="6233008" y="1645920"/>
+            <a:ext cx="777240" cy="777240"/>
+          </a:xfrm>
+          <a:prstGeom prst="ellipse">
+            <a:avLst/>
+          </a:prstGeom>
+          <a:solidFill>
+            <a:srgbClr val="FFFFFF"/>
+          </a:solidFill>
+          <a:ln w="25400">
+            <a:solidFill>
+              <a:srgbClr val="1B2D5C"/>
+            </a:solidFill>
+            <a:prstDash val="solid"/>
+          </a:ln>
+        </p:spPr>
+      </p:sp>
+      <p:sp>
+        <p:nvSpPr>
+          <p:cNvPr id="17" name="Text 15"/>
+          <p:cNvSpPr txBox="1"/>
+          <p:nvPr/>
+        </p:nvSpPr>
+        <p:spPr>
+          <a:xfrm>
+            <a:off x="6233008" y="1645920"/>
+            <a:ext cx="777240" cy="777240"/>
+          </a:xfrm>
+          <a:prstGeom prst="rect">
+            <a:avLst/>
+          </a:prstGeom>
+          <a:noFill/>
+          <a:ln/>
+        </p:spPr>
+        <p:txBody>
+          <a:bodyPr wrap="square" lIns="0" tIns="0" rIns="0" bIns="0" rtlCol="0" anchor="ctr"/>
+          <a:lstStyle/>
+          <a:p>
+            <a:pPr algn="ctr" indent="0" marL="0">
+              <a:buNone/>
+            </a:pPr>
+            <a:r>
+              <a:rPr lang="en-US" sz="2600" dirty="0">
+                <a:solidFill>
+                  <a:srgbClr val="1B2D5C"/>
+                </a:solidFill>
+                <a:latin typeface="Arial" pitchFamily="34" charset="0"/>
+                <a:ea typeface="Arial" pitchFamily="34" charset="-122"/>
+                <a:cs typeface="Arial" pitchFamily="34" charset="-120"/>
+              </a:rPr>
+              <a:t>3</a:t>
+            </a:r>
+            <a:endParaRPr lang="en-US" sz="2600" dirty="0"/>
+          </a:p>
+        </p:txBody>
+      </p:sp>
+      <p:sp>
+        <p:nvSpPr>
+          <p:cNvPr id="18" name="Text 16"/>
+          <p:cNvSpPr txBox="1"/>
+          <p:nvPr/>
+        </p:nvSpPr>
+        <p:spPr>
+          <a:xfrm>
+            <a:off x="7101688" y="1645920"/>
+            <a:ext cx="1699184" cy="777240"/>
+          </a:xfrm>
+          <a:prstGeom prst="rect">
+            <a:avLst/>
+          </a:prstGeom>
+          <a:noFill/>
+          <a:ln/>
+        </p:spPr>
+        <p:txBody>
+          <a:bodyPr wrap="square" lIns="0" tIns="0" rIns="0" bIns="0" rtlCol="0" anchor="ctr"/>
+          <a:lstStyle/>
+          <a:p>
+            <a:pPr algn="ctr" indent="0" marL="0">
+              <a:buNone/>
+            </a:pPr>
+            <a:r>
+              <a:rPr lang="en-US" sz="2400" dirty="0">
+                <a:solidFill>
+                  <a:srgbClr val="1B2D5C"/>
+                </a:solidFill>
+                <a:latin typeface="Arial" pitchFamily="34" charset="0"/>
+                <a:ea typeface="Arial" pitchFamily="34" charset="-122"/>
+                <a:cs typeface="Arial" pitchFamily="34" charset="-120"/>
+              </a:rPr>
+              <a:t>→</a:t>
+            </a:r>
+            <a:endParaRPr lang="en-US" sz="2400" dirty="0"/>
+          </a:p>
+        </p:txBody>
+      </p:sp>
+      <p:sp>
+        <p:nvSpPr>
+          <p:cNvPr id="19" name="Text 17"/>
+          <p:cNvSpPr txBox="1"/>
+          <p:nvPr/>
+        </p:nvSpPr>
+        <p:spPr>
+          <a:xfrm>
+            <a:off x="6233008" y="2560320"/>
+            <a:ext cx="2567864" cy="320040"/>
+          </a:xfrm>
+          <a:prstGeom prst="rect">
+            <a:avLst/>
+          </a:prstGeom>
+          <a:noFill/>
+          <a:ln/>
+        </p:spPr>
+        <p:txBody>
+          <a:bodyPr wrap="square" lIns="0" tIns="0" rIns="0" bIns="0" rtlCol="0" anchor="t"/>
+          <a:lstStyle/>
+          <a:p>
+            <a:pPr indent="0" marL="0">
+              <a:buNone/>
+            </a:pPr>
+            <a:r>
+              <a:rPr lang="en-US" sz="1400" b="1" dirty="0">
+                <a:solidFill>
+                  <a:srgbClr val="16181D"/>
+                </a:solidFill>
+                <a:latin typeface="Arial" pitchFamily="34" charset="0"/>
+                <a:ea typeface="Arial" pitchFamily="34" charset="-122"/>
+                <a:cs typeface="Arial" pitchFamily="34" charset="-120"/>
+              </a:rPr>
+              <a:t>Mensch prüft und gibt frei</a:t>
+            </a:r>
+            <a:endParaRPr lang="en-US" sz="1400" dirty="0"/>
+          </a:p>
+        </p:txBody>
+      </p:sp>
+      <p:sp>
+        <p:nvSpPr>
+          <p:cNvPr id="20" name="Text 18"/>
+          <p:cNvSpPr txBox="1"/>
+          <p:nvPr/>
+        </p:nvSpPr>
+        <p:spPr>
+          <a:xfrm>
+            <a:off x="6233008" y="2898648"/>
+            <a:ext cx="2567864" cy="822960"/>
+          </a:xfrm>
+          <a:prstGeom prst="rect">
+            <a:avLst/>
+          </a:prstGeom>
+          <a:noFill/>
+          <a:ln/>
+        </p:spPr>
+        <p:txBody>
+          <a:bodyPr wrap="square" lIns="0" tIns="0" rIns="0" bIns="0" rtlCol="0" anchor="t"/>
+          <a:lstStyle/>
+          <a:p>
+            <a:pPr indent="0" marL="0">
+              <a:lnSpc>
+                <a:spcPct val="108000"/>
+              </a:lnSpc>
+              <a:buNone/>
+            </a:pPr>
+            <a:r>
+              <a:rPr lang="en-US" sz="1200" dirty="0">
+                <a:solidFill>
+                  <a:srgbClr val="4B5563"/>
+                </a:solidFill>
+                <a:latin typeface="Arial" pitchFamily="34" charset="0"/>
+                <a:ea typeface="Arial" pitchFamily="34" charset="-122"/>
+                <a:cs typeface="Arial" pitchFamily="34" charset="-120"/>
+              </a:rPr>
+              <a:t>incoxx prüft jede Änderung im Vier-Augen-Prinzip, bevor sie live geht.</a:t>
+            </a:r>
+            <a:endParaRPr lang="en-US" sz="1200" dirty="0"/>
+          </a:p>
+        </p:txBody>
+      </p:sp>
+      <p:sp>
+        <p:nvSpPr>
+          <p:cNvPr id="21" name="Shape 19"/>
+          <p:cNvSpPr/>
+          <p:nvPr/>
+        </p:nvSpPr>
+        <p:spPr>
+          <a:xfrm>
+            <a:off x="9075191" y="1645920"/>
+            <a:ext cx="777240" cy="777240"/>
+          </a:xfrm>
+          <a:prstGeom prst="ellipse">
+            <a:avLst/>
+          </a:prstGeom>
+          <a:solidFill>
+            <a:srgbClr val="1B2D5C"/>
+          </a:solidFill>
+          <a:ln w="25400">
+            <a:solidFill>
+              <a:srgbClr val="1B2D5C"/>
+            </a:solidFill>
+            <a:prstDash val="solid"/>
+          </a:ln>
+        </p:spPr>
+      </p:sp>
+      <p:sp>
+        <p:nvSpPr>
+          <p:cNvPr id="22" name="Text 20"/>
+          <p:cNvSpPr txBox="1"/>
+          <p:nvPr/>
+        </p:nvSpPr>
+        <p:spPr>
+          <a:xfrm>
+            <a:off x="9075191" y="1645920"/>
+            <a:ext cx="777240" cy="777240"/>
+          </a:xfrm>
+          <a:prstGeom prst="rect">
+            <a:avLst/>
+          </a:prstGeom>
+          <a:noFill/>
+          <a:ln/>
+        </p:spPr>
+        <p:txBody>
+          <a:bodyPr wrap="square" lIns="0" tIns="0" rIns="0" bIns="0" rtlCol="0" anchor="ctr"/>
+          <a:lstStyle/>
+          <a:p>
+            <a:pPr algn="ctr" indent="0" marL="0">
+              <a:buNone/>
+            </a:pPr>
+            <a:r>
+              <a:rPr lang="en-US" sz="2600" dirty="0">
+                <a:solidFill>
+                  <a:srgbClr val="FFFFFF"/>
+                </a:solidFill>
+                <a:latin typeface="Arial" pitchFamily="34" charset="0"/>
+                <a:ea typeface="Arial" pitchFamily="34" charset="-122"/>
+                <a:cs typeface="Arial" pitchFamily="34" charset="-120"/>
+              </a:rPr>
+              <a:t>4</a:t>
+            </a:r>
+            <a:endParaRPr lang="en-US" sz="2600" dirty="0"/>
+          </a:p>
+        </p:txBody>
+      </p:sp>
+      <p:sp>
+        <p:nvSpPr>
+          <p:cNvPr id="23" name="Text 21"/>
+          <p:cNvSpPr txBox="1"/>
+          <p:nvPr/>
+        </p:nvSpPr>
+        <p:spPr>
+          <a:xfrm>
+            <a:off x="9075191" y="2560320"/>
+            <a:ext cx="2567864" cy="320040"/>
+          </a:xfrm>
+          <a:prstGeom prst="rect">
+            <a:avLst/>
+          </a:prstGeom>
+          <a:noFill/>
+          <a:ln/>
+        </p:spPr>
+        <p:txBody>
+          <a:bodyPr wrap="square" lIns="0" tIns="0" rIns="0" bIns="0" rtlCol="0" anchor="t"/>
+          <a:lstStyle/>
+          <a:p>
+            <a:pPr indent="0" marL="0">
+              <a:buNone/>
+            </a:pPr>
+            <a:r>
+              <a:rPr lang="en-US" sz="1400" b="1" dirty="0">
+                <a:solidFill>
+                  <a:srgbClr val="16181D"/>
+                </a:solidFill>
+                <a:latin typeface="Arial" pitchFamily="34" charset="0"/>
+                <a:ea typeface="Arial" pitchFamily="34" charset="-122"/>
+                <a:cs typeface="Arial" pitchFamily="34" charset="-120"/>
+              </a:rPr>
+              <a:t>Nachvollziehbar dokumentiert</a:t>
+            </a:r>
+            <a:endParaRPr lang="en-US" sz="1400" dirty="0"/>
+          </a:p>
+        </p:txBody>
+      </p:sp>
+      <p:sp>
+        <p:nvSpPr>
+          <p:cNvPr id="24" name="Text 22"/>
+          <p:cNvSpPr txBox="1"/>
+          <p:nvPr/>
+        </p:nvSpPr>
+        <p:spPr>
+          <a:xfrm>
+            <a:off x="9075191" y="2898648"/>
+            <a:ext cx="2567864" cy="822960"/>
+          </a:xfrm>
+          <a:prstGeom prst="rect">
+            <a:avLst/>
+          </a:prstGeom>
+          <a:noFill/>
+          <a:ln/>
+        </p:spPr>
+        <p:txBody>
+          <a:bodyPr wrap="square" lIns="0" tIns="0" rIns="0" bIns="0" rtlCol="0" anchor="t"/>
+          <a:lstStyle/>
+          <a:p>
+            <a:pPr indent="0" marL="0">
+              <a:lnSpc>
+                <a:spcPct val="108000"/>
+              </a:lnSpc>
+              <a:buNone/>
+            </a:pPr>
+            <a:r>
+              <a:rPr lang="en-US" sz="1200" dirty="0">
+                <a:solidFill>
+                  <a:srgbClr val="4B5563"/>
+                </a:solidFill>
+                <a:latin typeface="Arial" pitchFamily="34" charset="0"/>
+                <a:ea typeface="Arial" pitchFamily="34" charset="-122"/>
+                <a:cs typeface="Arial" pitchFamily="34" charset="-120"/>
+              </a:rPr>
+              <a:t>Jede Änderung als Pull Request mit Beschreibung, Dokumentation wächst mit.</a:t>
+            </a:r>
+            <a:endParaRPr lang="en-US" sz="1200" dirty="0"/>
+          </a:p>
+        </p:txBody>
+      </p:sp>
+      <p:sp>
+        <p:nvSpPr>
+          <p:cNvPr id="25" name="Shape 23"/>
+          <p:cNvSpPr/>
+          <p:nvPr/>
+        </p:nvSpPr>
+        <p:spPr>
+          <a:xfrm>
+            <a:off x="548640" y="3931920"/>
+            <a:ext cx="5364328" cy="2240280"/>
+          </a:xfrm>
+          <a:prstGeom prst="rect">
+            <a:avLst/>
+          </a:prstGeom>
+          <a:solidFill>
+            <a:srgbClr val="C6E6E3"/>
+          </a:solidFill>
+          <a:ln w="12700">
+            <a:solidFill>
+              <a:srgbClr val="C6E6E3"/>
+            </a:solidFill>
+            <a:prstDash val="solid"/>
+          </a:ln>
+        </p:spPr>
+      </p:sp>
+      <p:sp>
+        <p:nvSpPr>
+          <p:cNvPr id="26" name="Text 24"/>
+          <p:cNvSpPr txBox="1"/>
+          <p:nvPr/>
+        </p:nvSpPr>
+        <p:spPr>
+          <a:xfrm>
+            <a:off x="822960" y="4114800"/>
+            <a:ext cx="4815688" cy="365760"/>
+          </a:xfrm>
+          <a:prstGeom prst="rect">
+            <a:avLst/>
+          </a:prstGeom>
+          <a:noFill/>
+          <a:ln/>
+        </p:spPr>
+        <p:txBody>
+          <a:bodyPr wrap="square" lIns="0" tIns="0" rIns="0" bIns="0" rtlCol="0" anchor="t"/>
+          <a:lstStyle/>
+          <a:p>
+            <a:pPr indent="0" marL="0">
+              <a:buNone/>
+            </a:pPr>
+            <a:r>
+              <a:rPr lang="en-US" sz="1700" b="1" dirty="0">
+                <a:solidFill>
+                  <a:srgbClr val="000E2F"/>
+                </a:solidFill>
+                <a:latin typeface="Arial" pitchFamily="34" charset="0"/>
+                <a:ea typeface="Arial" pitchFamily="34" charset="-122"/>
+                <a:cs typeface="Arial" pitchFamily="34" charset="-120"/>
+              </a:rPr>
+              <a:t>Wir befähigen Kohlhammer</a:t>
+            </a:r>
+            <a:endParaRPr lang="en-US" sz="1700" dirty="0"/>
+          </a:p>
+        </p:txBody>
+      </p:sp>
+      <p:sp>
+        <p:nvSpPr>
+          <p:cNvPr id="27" name="Text 25"/>
+          <p:cNvSpPr txBox="1"/>
+          <p:nvPr/>
+        </p:nvSpPr>
+        <p:spPr>
+          <a:xfrm>
+            <a:off x="822960" y="4572000"/>
+            <a:ext cx="4815688" cy="1463040"/>
+          </a:xfrm>
+          <a:prstGeom prst="rect">
+            <a:avLst/>
+          </a:prstGeom>
+          <a:noFill/>
+          <a:ln/>
+        </p:spPr>
+        <p:txBody>
+          <a:bodyPr wrap="square" lIns="0" tIns="0" rIns="0" bIns="0" rtlCol="0" anchor="t"/>
+          <a:lstStyle/>
+          <a:p>
+            <a:pPr marL="342900" indent="-342900">
+              <a:lnSpc>
+                <a:spcPct val="105000"/>
+              </a:lnSpc>
+              <a:spcAft>
+                <a:spcPts val="600"/>
+              </a:spcAft>
+              <a:buSzPct val="100000"/>
+              <a:buChar char="•"/>
+            </a:pPr>
+            <a:r>
+              <a:rPr lang="en-US" sz="1300" dirty="0">
+                <a:solidFill>
+                  <a:srgbClr val="16181D"/>
+                </a:solidFill>
+                <a:latin typeface="Arial" pitchFamily="34" charset="0"/>
+                <a:ea typeface="Arial" pitchFamily="34" charset="-122"/>
+                <a:cs typeface="Arial" pitchFamily="34" charset="-120"/>
+              </a:rPr>
+              <a:t>Claude mit Projektwissen: Fragen zum System in normaler Sprache stellen</a:t>
+            </a:r>
+            <a:endParaRPr lang="en-US" sz="1300" dirty="0"/>
+          </a:p>
+          <a:p>
+            <a:pPr marL="342900" indent="-342900">
+              <a:lnSpc>
+                <a:spcPct val="105000"/>
+              </a:lnSpc>
+              <a:spcAft>
+                <a:spcPts val="600"/>
+              </a:spcAft>
+              <a:buSzPct val="100000"/>
+              <a:buChar char="•"/>
+            </a:pPr>
+            <a:r>
+              <a:rPr lang="en-US" sz="1300" dirty="0">
+                <a:solidFill>
+                  <a:srgbClr val="16181D"/>
+                </a:solidFill>
+                <a:latin typeface="Arial" pitchFamily="34" charset="0"/>
+                <a:ea typeface="Arial" pitchFamily="34" charset="-122"/>
+                <a:cs typeface="Arial" pitchFamily="34" charset="-120"/>
+              </a:rPr>
+              <a:t>GitHub: Wünsche als Issue einbringen, jede Änderung einsehen</a:t>
+            </a:r>
+            <a:endParaRPr lang="en-US" sz="1300" dirty="0"/>
+          </a:p>
+          <a:p>
+            <a:pPr marL="342900" indent="-342900">
+              <a:lnSpc>
+                <a:spcPct val="105000"/>
+              </a:lnSpc>
+              <a:spcAft>
+                <a:spcPts val="600"/>
+              </a:spcAft>
+              <a:buSzPct val="100000"/>
+              <a:buChar char="•"/>
+            </a:pPr>
+            <a:r>
+              <a:rPr lang="en-US" sz="1300" dirty="0">
+                <a:solidFill>
+                  <a:srgbClr val="16181D"/>
+                </a:solidFill>
+                <a:latin typeface="Arial" pitchFamily="34" charset="0"/>
+                <a:ea typeface="Arial" pitchFamily="34" charset="-122"/>
+                <a:cs typeface="Arial" pitchFamily="34" charset="-120"/>
+              </a:rPr>
+              <a:t>Einführung und Begleitung durch incoxx – ohne Programmierkenntnisse</a:t>
+            </a:r>
+            <a:endParaRPr lang="en-US" sz="1300" dirty="0"/>
+          </a:p>
+        </p:txBody>
+      </p:sp>
+      <p:sp>
+        <p:nvSpPr>
+          <p:cNvPr id="28" name="Shape 26"/>
+          <p:cNvSpPr/>
+          <p:nvPr/>
+        </p:nvSpPr>
+        <p:spPr>
+          <a:xfrm>
+            <a:off x="6278728" y="3931920"/>
+            <a:ext cx="5364328" cy="2240280"/>
           </a:xfrm>
           <a:prstGeom prst="rect">
             <a:avLst/>
@@ -12017,14 +12938,14 @@
       </p:sp>
       <p:sp>
         <p:nvSpPr>
-          <p:cNvPr id="8" name="Text 6"/>
-          <p:cNvSpPr txBox="1"/>
-          <p:nvPr/>
-        </p:nvSpPr>
-        <p:spPr>
-          <a:xfrm>
-            <a:off x="548640" y="2788920"/>
-            <a:ext cx="2560320" cy="731520"/>
+          <p:cNvPr id="29" name="Text 27"/>
+          <p:cNvSpPr txBox="1"/>
+          <p:nvPr/>
+        </p:nvSpPr>
+        <p:spPr>
+          <a:xfrm>
+            <a:off x="6553048" y="4114800"/>
+            <a:ext cx="4815688" cy="365760"/>
           </a:xfrm>
           <a:prstGeom prst="rect">
             <a:avLst/>
@@ -12040,30 +12961,30 @@
               <a:buNone/>
             </a:pPr>
             <a:r>
-              <a:rPr lang="en-US" sz="4000" dirty="0">
-                <a:solidFill>
-                  <a:srgbClr val="1B2D5C"/>
-                </a:solidFill>
-                <a:latin typeface="Arial" pitchFamily="34" charset="0"/>
-                <a:ea typeface="Arial" pitchFamily="34" charset="-122"/>
-                <a:cs typeface="Arial" pitchFamily="34" charset="-120"/>
-              </a:rPr>
-              <a:t>01</a:t>
-            </a:r>
-            <a:endParaRPr lang="en-US" sz="4000" dirty="0"/>
-          </a:p>
-        </p:txBody>
-      </p:sp>
-      <p:sp>
-        <p:nvSpPr>
-          <p:cNvPr id="9" name="Text 7"/>
-          <p:cNvSpPr txBox="1"/>
-          <p:nvPr/>
-        </p:nvSpPr>
-        <p:spPr>
-          <a:xfrm>
-            <a:off x="548640" y="3611880"/>
-            <a:ext cx="2560320" cy="256032"/>
+              <a:rPr lang="en-US" sz="1700" b="1" dirty="0">
+                <a:solidFill>
+                  <a:srgbClr val="FFFFFF"/>
+                </a:solidFill>
+                <a:latin typeface="Arial" pitchFamily="34" charset="0"/>
+                <a:ea typeface="Arial" pitchFamily="34" charset="-122"/>
+                <a:cs typeface="Arial" pitchFamily="34" charset="-120"/>
+              </a:rPr>
+              <a:t>Risiko minimiert</a:t>
+            </a:r>
+            <a:endParaRPr lang="en-US" sz="1700" dirty="0"/>
+          </a:p>
+        </p:txBody>
+      </p:sp>
+      <p:sp>
+        <p:nvSpPr>
+          <p:cNvPr id="30" name="Text 28"/>
+          <p:cNvSpPr txBox="1"/>
+          <p:nvPr/>
+        </p:nvSpPr>
+        <p:spPr>
+          <a:xfrm>
+            <a:off x="6553048" y="4572000"/>
+            <a:ext cx="4815688" cy="1463040"/>
           </a:xfrm>
           <a:prstGeom prst="rect">
             <a:avLst/>
@@ -12075,654 +12996,76 @@
           <a:bodyPr wrap="square" lIns="0" tIns="0" rIns="0" bIns="0" rtlCol="0" anchor="t"/>
           <a:lstStyle/>
           <a:p>
-            <a:pPr indent="0" marL="0">
-              <a:buNone/>
-            </a:pPr>
-            <a:r>
-              <a:rPr lang="en-US" sz="1000" b="1" spc="100" kern="0" dirty="0">
-                <a:solidFill>
-                  <a:srgbClr val="4B5563"/>
-                </a:solidFill>
-                <a:latin typeface="Arial" pitchFamily="34" charset="0"/>
-                <a:ea typeface="Arial" pitchFamily="34" charset="-122"/>
-                <a:cs typeface="Arial" pitchFamily="34" charset="-120"/>
-              </a:rPr>
-              <a:t>CA. 2 WOCHEN</a:t>
-            </a:r>
-            <a:endParaRPr lang="en-US" sz="1000" dirty="0"/>
-          </a:p>
-        </p:txBody>
-      </p:sp>
-      <p:sp>
-        <p:nvSpPr>
-          <p:cNvPr id="10" name="Text 8"/>
-          <p:cNvSpPr txBox="1"/>
-          <p:nvPr/>
-        </p:nvSpPr>
-        <p:spPr>
-          <a:xfrm>
-            <a:off x="548640" y="3931920"/>
-            <a:ext cx="2560320" cy="384048"/>
-          </a:xfrm>
-          <a:prstGeom prst="rect">
-            <a:avLst/>
-          </a:prstGeom>
-          <a:noFill/>
-          <a:ln/>
-        </p:spPr>
-        <p:txBody>
-          <a:bodyPr wrap="square" lIns="0" tIns="0" rIns="0" bIns="0" rtlCol="0" anchor="t"/>
-          <a:lstStyle/>
-          <a:p>
-            <a:pPr indent="0" marL="0">
-              <a:buNone/>
-            </a:pPr>
-            <a:r>
-              <a:rPr lang="en-US" sz="1800" b="1" dirty="0">
-                <a:solidFill>
-                  <a:srgbClr val="16181D"/>
-                </a:solidFill>
-                <a:latin typeface="Arial" pitchFamily="34" charset="0"/>
-                <a:ea typeface="Arial" pitchFamily="34" charset="-122"/>
-                <a:cs typeface="Arial" pitchFamily="34" charset="-120"/>
-              </a:rPr>
-              <a:t>Bestandsaufnahme</a:t>
-            </a:r>
-            <a:endParaRPr lang="en-US" sz="1800" dirty="0"/>
-          </a:p>
-        </p:txBody>
-      </p:sp>
-      <p:sp>
-        <p:nvSpPr>
-          <p:cNvPr id="11" name="Text 9"/>
-          <p:cNvSpPr txBox="1"/>
-          <p:nvPr/>
-        </p:nvSpPr>
-        <p:spPr>
-          <a:xfrm>
-            <a:off x="548640" y="4434840"/>
-            <a:ext cx="2560320" cy="1737360"/>
-          </a:xfrm>
-          <a:prstGeom prst="rect">
-            <a:avLst/>
-          </a:prstGeom>
-          <a:noFill/>
-          <a:ln/>
-        </p:spPr>
-        <p:txBody>
-          <a:bodyPr wrap="square" lIns="0" tIns="0" rIns="0" bIns="0" rtlCol="0" anchor="t"/>
-          <a:lstStyle/>
-          <a:p>
-            <a:pPr indent="0" marL="0">
+            <a:pPr marL="342900" indent="-342900">
               <a:lnSpc>
-                <a:spcPct val="112000"/>
+                <a:spcPct val="105000"/>
               </a:lnSpc>
-              <a:buNone/>
-            </a:pPr>
-            <a:r>
-              <a:rPr lang="en-US" sz="1400" dirty="0">
-                <a:solidFill>
-                  <a:srgbClr val="16181D"/>
-                </a:solidFill>
-                <a:latin typeface="Arial" pitchFamily="34" charset="0"/>
-                <a:ea typeface="Arial" pitchFamily="34" charset="-122"/>
-                <a:cs typeface="Arial" pitchFamily="34" charset="-120"/>
-              </a:rPr>
-              <a:t>Pimcore-6-Klassen, Eigenentwicklungen und Schnittstellen erfassen; Zielmodell mit Produkttypen, Attributen, Hierarchien und Ausgaben festlegen.</a:t>
-            </a:r>
-            <a:endParaRPr lang="en-US" sz="1400" dirty="0"/>
-          </a:p>
-        </p:txBody>
-      </p:sp>
-      <p:sp>
-        <p:nvSpPr>
-          <p:cNvPr id="12" name="Shape 10"/>
-          <p:cNvSpPr/>
-          <p:nvPr/>
-        </p:nvSpPr>
-        <p:spPr>
-          <a:xfrm>
-            <a:off x="3393338" y="2240280"/>
-            <a:ext cx="274320" cy="274320"/>
-          </a:xfrm>
-          <a:prstGeom prst="rect">
-            <a:avLst/>
-          </a:prstGeom>
-          <a:solidFill>
-            <a:srgbClr val="000E2F"/>
-          </a:solidFill>
-          <a:ln w="12700">
-            <a:solidFill>
-              <a:srgbClr val="000E2F"/>
-            </a:solidFill>
-            <a:prstDash val="solid"/>
-          </a:ln>
-        </p:spPr>
-      </p:sp>
-      <p:sp>
-        <p:nvSpPr>
-          <p:cNvPr id="13" name="Text 11"/>
-          <p:cNvSpPr txBox="1"/>
-          <p:nvPr/>
-        </p:nvSpPr>
-        <p:spPr>
-          <a:xfrm>
-            <a:off x="3393338" y="2788920"/>
-            <a:ext cx="2560320" cy="731520"/>
-          </a:xfrm>
-          <a:prstGeom prst="rect">
-            <a:avLst/>
-          </a:prstGeom>
-          <a:noFill/>
-          <a:ln/>
-        </p:spPr>
-        <p:txBody>
-          <a:bodyPr wrap="square" lIns="0" tIns="0" rIns="0" bIns="0" rtlCol="0" anchor="t"/>
-          <a:lstStyle/>
-          <a:p>
-            <a:pPr indent="0" marL="0">
-              <a:buNone/>
-            </a:pPr>
-            <a:r>
-              <a:rPr lang="en-US" sz="4000" dirty="0">
-                <a:solidFill>
-                  <a:srgbClr val="1B2D5C"/>
-                </a:solidFill>
-                <a:latin typeface="Arial" pitchFamily="34" charset="0"/>
-                <a:ea typeface="Arial" pitchFamily="34" charset="-122"/>
-                <a:cs typeface="Arial" pitchFamily="34" charset="-120"/>
-              </a:rPr>
-              <a:t>02</a:t>
-            </a:r>
-            <a:endParaRPr lang="en-US" sz="4000" dirty="0"/>
-          </a:p>
-        </p:txBody>
-      </p:sp>
-      <p:sp>
-        <p:nvSpPr>
-          <p:cNvPr id="14" name="Text 12"/>
-          <p:cNvSpPr txBox="1"/>
-          <p:nvPr/>
-        </p:nvSpPr>
-        <p:spPr>
-          <a:xfrm>
-            <a:off x="3393338" y="3611880"/>
-            <a:ext cx="2560320" cy="256032"/>
-          </a:xfrm>
-          <a:prstGeom prst="rect">
-            <a:avLst/>
-          </a:prstGeom>
-          <a:noFill/>
-          <a:ln/>
-        </p:spPr>
-        <p:txBody>
-          <a:bodyPr wrap="square" lIns="0" tIns="0" rIns="0" bIns="0" rtlCol="0" anchor="t"/>
-          <a:lstStyle/>
-          <a:p>
-            <a:pPr indent="0" marL="0">
-              <a:buNone/>
-            </a:pPr>
-            <a:r>
-              <a:rPr lang="en-US" sz="1000" b="1" spc="100" kern="0" dirty="0">
-                <a:solidFill>
-                  <a:srgbClr val="4B5563"/>
-                </a:solidFill>
-                <a:latin typeface="Arial" pitchFamily="34" charset="0"/>
-                <a:ea typeface="Arial" pitchFamily="34" charset="-122"/>
-                <a:cs typeface="Arial" pitchFamily="34" charset="-120"/>
-              </a:rPr>
-              <a:t>CA. 4 WOCHEN</a:t>
-            </a:r>
-            <a:endParaRPr lang="en-US" sz="1000" dirty="0"/>
-          </a:p>
-        </p:txBody>
-      </p:sp>
-      <p:sp>
-        <p:nvSpPr>
-          <p:cNvPr id="15" name="Text 13"/>
-          <p:cNvSpPr txBox="1"/>
-          <p:nvPr/>
-        </p:nvSpPr>
-        <p:spPr>
-          <a:xfrm>
-            <a:off x="3393338" y="3931920"/>
-            <a:ext cx="2560320" cy="384048"/>
-          </a:xfrm>
-          <a:prstGeom prst="rect">
-            <a:avLst/>
-          </a:prstGeom>
-          <a:noFill/>
-          <a:ln/>
-        </p:spPr>
-        <p:txBody>
-          <a:bodyPr wrap="square" lIns="0" tIns="0" rIns="0" bIns="0" rtlCol="0" anchor="t"/>
-          <a:lstStyle/>
-          <a:p>
-            <a:pPr indent="0" marL="0">
-              <a:buNone/>
-            </a:pPr>
-            <a:r>
-              <a:rPr lang="en-US" sz="1800" b="1" dirty="0">
-                <a:solidFill>
-                  <a:srgbClr val="16181D"/>
-                </a:solidFill>
-                <a:latin typeface="Arial" pitchFamily="34" charset="0"/>
-                <a:ea typeface="Arial" pitchFamily="34" charset="-122"/>
-                <a:cs typeface="Arial" pitchFamily="34" charset="-120"/>
-              </a:rPr>
-              <a:t>Pilot Brandschutz</a:t>
-            </a:r>
-            <a:endParaRPr lang="en-US" sz="1800" dirty="0"/>
-          </a:p>
-        </p:txBody>
-      </p:sp>
-      <p:sp>
-        <p:nvSpPr>
-          <p:cNvPr id="16" name="Text 14"/>
-          <p:cNvSpPr txBox="1"/>
-          <p:nvPr/>
-        </p:nvSpPr>
-        <p:spPr>
-          <a:xfrm>
-            <a:off x="3393338" y="4434840"/>
-            <a:ext cx="2560320" cy="1737360"/>
-          </a:xfrm>
-          <a:prstGeom prst="rect">
-            <a:avLst/>
-          </a:prstGeom>
-          <a:noFill/>
-          <a:ln/>
-        </p:spPr>
-        <p:txBody>
-          <a:bodyPr wrap="square" lIns="0" tIns="0" rIns="0" bIns="0" rtlCol="0" anchor="t"/>
-          <a:lstStyle/>
-          <a:p>
-            <a:pPr indent="0" marL="0">
+              <a:spcAft>
+                <a:spcPts val="600"/>
+              </a:spcAft>
+              <a:buSzPct val="100000"/>
+              <a:buChar char="•"/>
+            </a:pPr>
+            <a:r>
+              <a:rPr lang="en-US" sz="1300" dirty="0">
+                <a:solidFill>
+                  <a:srgbClr val="FFFFFF"/>
+                </a:solidFill>
+                <a:latin typeface="Arial" pitchFamily="34" charset="0"/>
+                <a:ea typeface="Arial" pitchFamily="34" charset="-122"/>
+                <a:cs typeface="Arial" pitchFamily="34" charset="-120"/>
+              </a:rPr>
+              <a:t>Wissen steckt im Repository, nicht in einzelnen Köpfen</a:t>
+            </a:r>
+            <a:endParaRPr lang="en-US" sz="1300" dirty="0"/>
+          </a:p>
+          <a:p>
+            <a:pPr marL="342900" indent="-342900">
               <a:lnSpc>
-                <a:spcPct val="112000"/>
+                <a:spcPct val="105000"/>
               </a:lnSpc>
-              <a:buNone/>
-            </a:pPr>
-            <a:r>
-              <a:rPr lang="en-US" sz="1400" dirty="0">
-                <a:solidFill>
-                  <a:srgbClr val="16181D"/>
-                </a:solidFill>
-                <a:latin typeface="Arial" pitchFamily="34" charset="0"/>
-                <a:ea typeface="Arial" pitchFamily="34" charset="-122"/>
-                <a:cs typeface="Arial" pitchFamily="34" charset="-120"/>
-              </a:rPr>
-              <a:t>Titel des Fachbereichs aus Pimcore 6 übernehmen, Werk/Ausgabe-Struktur, Qualitätsprofile; Parallelbetrieb und Datenabgleich.</a:t>
-            </a:r>
-            <a:endParaRPr lang="en-US" sz="1400" dirty="0"/>
-          </a:p>
-        </p:txBody>
-      </p:sp>
-      <p:sp>
-        <p:nvSpPr>
-          <p:cNvPr id="17" name="Shape 15"/>
-          <p:cNvSpPr/>
-          <p:nvPr/>
-        </p:nvSpPr>
-        <p:spPr>
-          <a:xfrm>
-            <a:off x="6238037" y="2240280"/>
-            <a:ext cx="274320" cy="274320"/>
-          </a:xfrm>
-          <a:prstGeom prst="rect">
-            <a:avLst/>
-          </a:prstGeom>
-          <a:solidFill>
-            <a:srgbClr val="000E2F"/>
-          </a:solidFill>
-          <a:ln w="12700">
-            <a:solidFill>
-              <a:srgbClr val="000E2F"/>
-            </a:solidFill>
-            <a:prstDash val="solid"/>
-          </a:ln>
-        </p:spPr>
-      </p:sp>
-      <p:sp>
-        <p:nvSpPr>
-          <p:cNvPr id="18" name="Text 16"/>
-          <p:cNvSpPr txBox="1"/>
-          <p:nvPr/>
-        </p:nvSpPr>
-        <p:spPr>
-          <a:xfrm>
-            <a:off x="6238037" y="2788920"/>
-            <a:ext cx="2560320" cy="731520"/>
-          </a:xfrm>
-          <a:prstGeom prst="rect">
-            <a:avLst/>
-          </a:prstGeom>
-          <a:noFill/>
-          <a:ln/>
-        </p:spPr>
-        <p:txBody>
-          <a:bodyPr wrap="square" lIns="0" tIns="0" rIns="0" bIns="0" rtlCol="0" anchor="t"/>
-          <a:lstStyle/>
-          <a:p>
-            <a:pPr indent="0" marL="0">
-              <a:buNone/>
-            </a:pPr>
-            <a:r>
-              <a:rPr lang="en-US" sz="4000" dirty="0">
-                <a:solidFill>
-                  <a:srgbClr val="1B2D5C"/>
-                </a:solidFill>
-                <a:latin typeface="Arial" pitchFamily="34" charset="0"/>
-                <a:ea typeface="Arial" pitchFamily="34" charset="-122"/>
-                <a:cs typeface="Arial" pitchFamily="34" charset="-120"/>
-              </a:rPr>
-              <a:t>03</a:t>
-            </a:r>
-            <a:endParaRPr lang="en-US" sz="4000" dirty="0"/>
-          </a:p>
-        </p:txBody>
-      </p:sp>
-      <p:sp>
-        <p:nvSpPr>
-          <p:cNvPr id="19" name="Text 17"/>
-          <p:cNvSpPr txBox="1"/>
-          <p:nvPr/>
-        </p:nvSpPr>
-        <p:spPr>
-          <a:xfrm>
-            <a:off x="6238037" y="3611880"/>
-            <a:ext cx="2560320" cy="256032"/>
-          </a:xfrm>
-          <a:prstGeom prst="rect">
-            <a:avLst/>
-          </a:prstGeom>
-          <a:noFill/>
-          <a:ln/>
-        </p:spPr>
-        <p:txBody>
-          <a:bodyPr wrap="square" lIns="0" tIns="0" rIns="0" bIns="0" rtlCol="0" anchor="t"/>
-          <a:lstStyle/>
-          <a:p>
-            <a:pPr indent="0" marL="0">
-              <a:buNone/>
-            </a:pPr>
-            <a:r>
-              <a:rPr lang="en-US" sz="1000" b="1" spc="100" kern="0" dirty="0">
-                <a:solidFill>
-                  <a:srgbClr val="4B5563"/>
-                </a:solidFill>
-                <a:latin typeface="Arial" pitchFamily="34" charset="0"/>
-                <a:ea typeface="Arial" pitchFamily="34" charset="-122"/>
-                <a:cs typeface="Arial" pitchFamily="34" charset="-120"/>
-              </a:rPr>
-              <a:t>JE NACH UMFANG</a:t>
-            </a:r>
-            <a:endParaRPr lang="en-US" sz="1000" dirty="0"/>
-          </a:p>
-        </p:txBody>
-      </p:sp>
-      <p:sp>
-        <p:nvSpPr>
-          <p:cNvPr id="20" name="Text 18"/>
-          <p:cNvSpPr txBox="1"/>
-          <p:nvPr/>
-        </p:nvSpPr>
-        <p:spPr>
-          <a:xfrm>
-            <a:off x="6238037" y="3931920"/>
-            <a:ext cx="2560320" cy="384048"/>
-          </a:xfrm>
-          <a:prstGeom prst="rect">
-            <a:avLst/>
-          </a:prstGeom>
-          <a:noFill/>
-          <a:ln/>
-        </p:spPr>
-        <p:txBody>
-          <a:bodyPr wrap="square" lIns="0" tIns="0" rIns="0" bIns="0" rtlCol="0" anchor="t"/>
-          <a:lstStyle/>
-          <a:p>
-            <a:pPr indent="0" marL="0">
-              <a:buNone/>
-            </a:pPr>
-            <a:r>
-              <a:rPr lang="en-US" sz="1800" b="1" dirty="0">
-                <a:solidFill>
-                  <a:srgbClr val="16181D"/>
-                </a:solidFill>
-                <a:latin typeface="Arial" pitchFamily="34" charset="0"/>
-                <a:ea typeface="Arial" pitchFamily="34" charset="-122"/>
-                <a:cs typeface="Arial" pitchFamily="34" charset="-120"/>
-              </a:rPr>
-              <a:t>Projektanteil</a:t>
-            </a:r>
-            <a:endParaRPr lang="en-US" sz="1800" dirty="0"/>
-          </a:p>
-        </p:txBody>
-      </p:sp>
-      <p:sp>
-        <p:nvSpPr>
-          <p:cNvPr id="21" name="Text 19"/>
-          <p:cNvSpPr txBox="1"/>
-          <p:nvPr/>
-        </p:nvSpPr>
-        <p:spPr>
-          <a:xfrm>
-            <a:off x="6238037" y="4434840"/>
-            <a:ext cx="2560320" cy="1737360"/>
-          </a:xfrm>
-          <a:prstGeom prst="rect">
-            <a:avLst/>
-          </a:prstGeom>
-          <a:noFill/>
-          <a:ln/>
-        </p:spPr>
-        <p:txBody>
-          <a:bodyPr wrap="square" lIns="0" tIns="0" rIns="0" bIns="0" rtlCol="0" anchor="t"/>
-          <a:lstStyle/>
-          <a:p>
-            <a:pPr indent="0" marL="0">
+              <a:spcAft>
+                <a:spcPts val="600"/>
+              </a:spcAft>
+              <a:buSzPct val="100000"/>
+              <a:buChar char="•"/>
+            </a:pPr>
+            <a:r>
+              <a:rPr lang="en-US" sz="1300" dirty="0">
+                <a:solidFill>
+                  <a:srgbClr val="FFFFFF"/>
+                </a:solidFill>
+                <a:latin typeface="Arial" pitchFamily="34" charset="0"/>
+                <a:ea typeface="Arial" pitchFamily="34" charset="-122"/>
+                <a:cs typeface="Arial" pitchFamily="34" charset="-120"/>
+              </a:rPr>
+              <a:t>Jede Änderung geprüft, getestet und jederzeit rückverfolgbar</a:t>
+            </a:r>
+            <a:endParaRPr lang="en-US" sz="1300" dirty="0"/>
+          </a:p>
+          <a:p>
+            <a:pPr marL="342900" indent="-342900">
               <a:lnSpc>
-                <a:spcPct val="112000"/>
+                <a:spcPct val="105000"/>
               </a:lnSpc>
-              <a:buNone/>
-            </a:pPr>
-            <a:r>
-              <a:rPr lang="en-US" sz="1400" dirty="0">
-                <a:solidFill>
-                  <a:srgbClr val="16181D"/>
-                </a:solidFill>
-                <a:latin typeface="Arial" pitchFamily="34" charset="0"/>
-                <a:ea typeface="Arial" pitchFamily="34" charset="-122"/>
-                <a:cs typeface="Arial" pitchFamily="34" charset="-120"/>
-              </a:rPr>
-              <a:t>Fehlende Funktionen als Standard bauen – EasyCatalog-, Thieme- und ONIX-Export, Cover-Metadaten; Shop und Handel umstellen.</a:t>
-            </a:r>
-            <a:endParaRPr lang="en-US" sz="1400" dirty="0"/>
-          </a:p>
-        </p:txBody>
-      </p:sp>
-      <p:sp>
-        <p:nvSpPr>
-          <p:cNvPr id="22" name="Shape 20"/>
-          <p:cNvSpPr/>
-          <p:nvPr/>
-        </p:nvSpPr>
-        <p:spPr>
-          <a:xfrm>
-            <a:off x="9082735" y="2240280"/>
-            <a:ext cx="274320" cy="274320"/>
-          </a:xfrm>
-          <a:prstGeom prst="rect">
-            <a:avLst/>
-          </a:prstGeom>
-          <a:solidFill>
-            <a:srgbClr val="E2211C"/>
-          </a:solidFill>
-          <a:ln w="12700">
-            <a:solidFill>
-              <a:srgbClr val="E2211C"/>
-            </a:solidFill>
-            <a:prstDash val="solid"/>
-          </a:ln>
-        </p:spPr>
-      </p:sp>
-      <p:sp>
-        <p:nvSpPr>
-          <p:cNvPr id="23" name="Text 21"/>
-          <p:cNvSpPr txBox="1"/>
-          <p:nvPr/>
-        </p:nvSpPr>
-        <p:spPr>
-          <a:xfrm>
-            <a:off x="9082735" y="2788920"/>
-            <a:ext cx="2560320" cy="731520"/>
-          </a:xfrm>
-          <a:prstGeom prst="rect">
-            <a:avLst/>
-          </a:prstGeom>
-          <a:noFill/>
-          <a:ln/>
-        </p:spPr>
-        <p:txBody>
-          <a:bodyPr wrap="square" lIns="0" tIns="0" rIns="0" bIns="0" rtlCol="0" anchor="t"/>
-          <a:lstStyle/>
-          <a:p>
-            <a:pPr indent="0" marL="0">
-              <a:buNone/>
-            </a:pPr>
-            <a:r>
-              <a:rPr lang="en-US" sz="4000" dirty="0">
-                <a:solidFill>
-                  <a:srgbClr val="1B2D5C"/>
-                </a:solidFill>
-                <a:latin typeface="Arial" pitchFamily="34" charset="0"/>
-                <a:ea typeface="Arial" pitchFamily="34" charset="-122"/>
-                <a:cs typeface="Arial" pitchFamily="34" charset="-120"/>
-              </a:rPr>
-              <a:t>04</a:t>
-            </a:r>
-            <a:endParaRPr lang="en-US" sz="4000" dirty="0"/>
-          </a:p>
-        </p:txBody>
-      </p:sp>
-      <p:sp>
-        <p:nvSpPr>
-          <p:cNvPr id="24" name="Text 22"/>
-          <p:cNvSpPr txBox="1"/>
-          <p:nvPr/>
-        </p:nvSpPr>
-        <p:spPr>
-          <a:xfrm>
-            <a:off x="9082735" y="3611880"/>
-            <a:ext cx="2560320" cy="256032"/>
-          </a:xfrm>
-          <a:prstGeom prst="rect">
-            <a:avLst/>
-          </a:prstGeom>
-          <a:noFill/>
-          <a:ln/>
-        </p:spPr>
-        <p:txBody>
-          <a:bodyPr wrap="square" lIns="0" tIns="0" rIns="0" bIns="0" rtlCol="0" anchor="t"/>
-          <a:lstStyle/>
-          <a:p>
-            <a:pPr indent="0" marL="0">
-              <a:buNone/>
-            </a:pPr>
-            <a:r>
-              <a:rPr lang="en-US" sz="1000" b="1" spc="100" kern="0" dirty="0">
-                <a:solidFill>
-                  <a:srgbClr val="4B5563"/>
-                </a:solidFill>
-                <a:latin typeface="Arial" pitchFamily="34" charset="0"/>
-                <a:ea typeface="Arial" pitchFamily="34" charset="-122"/>
-                <a:cs typeface="Arial" pitchFamily="34" charset="-120"/>
-              </a:rPr>
-              <a:t>FORTLAUFEND</a:t>
-            </a:r>
-            <a:endParaRPr lang="en-US" sz="1000" dirty="0"/>
-          </a:p>
-        </p:txBody>
-      </p:sp>
-      <p:sp>
-        <p:nvSpPr>
-          <p:cNvPr id="25" name="Text 23"/>
-          <p:cNvSpPr txBox="1"/>
-          <p:nvPr/>
-        </p:nvSpPr>
-        <p:spPr>
-          <a:xfrm>
-            <a:off x="9082735" y="3931920"/>
-            <a:ext cx="2560320" cy="384048"/>
-          </a:xfrm>
-          <a:prstGeom prst="rect">
-            <a:avLst/>
-          </a:prstGeom>
-          <a:noFill/>
-          <a:ln/>
-        </p:spPr>
-        <p:txBody>
-          <a:bodyPr wrap="square" lIns="0" tIns="0" rIns="0" bIns="0" rtlCol="0" anchor="t"/>
-          <a:lstStyle/>
-          <a:p>
-            <a:pPr indent="0" marL="0">
-              <a:buNone/>
-            </a:pPr>
-            <a:r>
-              <a:rPr lang="en-US" sz="1800" b="1" dirty="0">
-                <a:solidFill>
-                  <a:srgbClr val="16181D"/>
-                </a:solidFill>
-                <a:latin typeface="Arial" pitchFamily="34" charset="0"/>
-                <a:ea typeface="Arial" pitchFamily="34" charset="-122"/>
-                <a:cs typeface="Arial" pitchFamily="34" charset="-120"/>
-              </a:rPr>
-              <a:t>Ablösung</a:t>
-            </a:r>
-            <a:endParaRPr lang="en-US" sz="1800" dirty="0"/>
-          </a:p>
-        </p:txBody>
-      </p:sp>
-      <p:sp>
-        <p:nvSpPr>
-          <p:cNvPr id="26" name="Text 24"/>
-          <p:cNvSpPr txBox="1"/>
-          <p:nvPr/>
-        </p:nvSpPr>
-        <p:spPr>
-          <a:xfrm>
-            <a:off x="9082735" y="4434840"/>
-            <a:ext cx="2560320" cy="1737360"/>
-          </a:xfrm>
-          <a:prstGeom prst="rect">
-            <a:avLst/>
-          </a:prstGeom>
-          <a:noFill/>
-          <a:ln/>
-        </p:spPr>
-        <p:txBody>
-          <a:bodyPr wrap="square" lIns="0" tIns="0" rIns="0" bIns="0" rtlCol="0" anchor="t"/>
-          <a:lstStyle/>
-          <a:p>
-            <a:pPr indent="0" marL="0">
-              <a:lnSpc>
-                <a:spcPct val="112000"/>
-              </a:lnSpc>
-              <a:buNone/>
-            </a:pPr>
-            <a:r>
-              <a:rPr lang="en-US" sz="1400" dirty="0">
-                <a:solidFill>
-                  <a:srgbClr val="16181D"/>
-                </a:solidFill>
-                <a:latin typeface="Arial" pitchFamily="34" charset="0"/>
-                <a:ea typeface="Arial" pitchFamily="34" charset="-122"/>
-                <a:cs typeface="Arial" pitchFamily="34" charset="-120"/>
-              </a:rPr>
-              <a:t>Weitere Fachbereiche, Zeitschriften, Formulare und Seminare; Schulung der Redaktionen; Abschaltung von Pimcore 6.</a:t>
-            </a:r>
-            <a:endParaRPr lang="en-US" sz="1400" dirty="0"/>
+              <a:spcAft>
+                <a:spcPts val="600"/>
+              </a:spcAft>
+              <a:buSzPct val="100000"/>
+              <a:buChar char="•"/>
+            </a:pPr>
+            <a:r>
+              <a:rPr lang="en-US" sz="1300" dirty="0">
+                <a:solidFill>
+                  <a:srgbClr val="FFFFFF"/>
+                </a:solidFill>
+                <a:latin typeface="Arial" pitchFamily="34" charset="0"/>
+                <a:ea typeface="Arial" pitchFamily="34" charset="-122"/>
+                <a:cs typeface="Arial" pitchFamily="34" charset="-120"/>
+              </a:rPr>
+              <a:t>Offener Code – keine Abhängigkeit, auch nicht von incoxx</a:t>
+            </a:r>
+            <a:endParaRPr lang="en-US" sz="1300" dirty="0"/>
           </a:p>
         </p:txBody>
       </p:sp>
@@ -12737,6 +13080,953 @@
 <file path=ppt/slides/slide16.xml><?xml version="1.0" encoding="utf-8"?>
 <p:sld xmlns:a="http://schemas.openxmlformats.org/drawingml/2006/main" xmlns:r="http://schemas.openxmlformats.org/officeDocument/2006/relationships" xmlns:p="http://schemas.openxmlformats.org/presentationml/2006/main">
   <p:cSld name="Slide 16">
+    <p:bg>
+      <p:bgPr>
+        <a:solidFill>
+          <a:srgbClr val="FFFFFF"/>
+        </a:solidFill>
+      </p:bgPr>
+    </p:bg>
+    <p:spTree>
+      <p:nvGrpSpPr>
+        <p:cNvPr id="1" name=""/>
+        <p:cNvGrpSpPr/>
+        <p:nvPr/>
+      </p:nvGrpSpPr>
+      <p:grpSpPr>
+        <a:xfrm>
+          <a:off x="0" y="0"/>
+          <a:ext cx="0" cy="0"/>
+          <a:chOff x="0" y="0"/>
+          <a:chExt cx="0" cy="0"/>
+        </a:xfrm>
+      </p:grpSpPr>
+      <p:sp>
+        <p:nvSpPr>
+          <p:cNvPr id="2" name="Text 0"/>
+          <p:cNvSpPr txBox="1"/>
+          <p:nvPr/>
+        </p:nvSpPr>
+        <p:spPr>
+          <a:xfrm>
+            <a:off x="548640" y="411480"/>
+            <a:ext cx="11094415" cy="594360"/>
+          </a:xfrm>
+          <a:prstGeom prst="rect">
+            <a:avLst/>
+          </a:prstGeom>
+          <a:noFill/>
+          <a:ln/>
+        </p:spPr>
+        <p:txBody>
+          <a:bodyPr wrap="square" lIns="0" tIns="0" rIns="0" bIns="0" rtlCol="0" anchor="b"/>
+          <a:lstStyle/>
+          <a:p>
+            <a:pPr indent="0" marL="0">
+              <a:buNone/>
+            </a:pPr>
+            <a:r>
+              <a:rPr lang="en-US" sz="3000" dirty="0">
+                <a:solidFill>
+                  <a:srgbClr val="16181D"/>
+                </a:solidFill>
+                <a:latin typeface="Arial" pitchFamily="34" charset="0"/>
+                <a:ea typeface="Arial" pitchFamily="34" charset="-122"/>
+                <a:cs typeface="Arial" pitchFamily="34" charset="-120"/>
+              </a:rPr>
+              <a:t>VORGESCHLAGENER FAHRPLAN</a:t>
+            </a:r>
+            <a:endParaRPr lang="en-US" sz="3000" dirty="0"/>
+          </a:p>
+        </p:txBody>
+      </p:sp>
+      <p:sp>
+        <p:nvSpPr>
+          <p:cNvPr id="3" name="Text 1"/>
+          <p:cNvSpPr txBox="1"/>
+          <p:nvPr/>
+        </p:nvSpPr>
+        <p:spPr>
+          <a:xfrm>
+            <a:off x="548640" y="1033272"/>
+            <a:ext cx="11094415" cy="365760"/>
+          </a:xfrm>
+          <a:prstGeom prst="rect">
+            <a:avLst/>
+          </a:prstGeom>
+          <a:noFill/>
+          <a:ln/>
+        </p:spPr>
+        <p:txBody>
+          <a:bodyPr wrap="square" lIns="0" tIns="0" rIns="0" bIns="0" rtlCol="0" anchor="t"/>
+          <a:lstStyle/>
+          <a:p>
+            <a:pPr indent="0" marL="0">
+              <a:buNone/>
+            </a:pPr>
+            <a:r>
+              <a:rPr lang="en-US" sz="1400" dirty="0">
+                <a:solidFill>
+                  <a:srgbClr val="4B5563"/>
+                </a:solidFill>
+                <a:latin typeface="Arial" pitchFamily="34" charset="0"/>
+                <a:ea typeface="Arial" pitchFamily="34" charset="-122"/>
+                <a:cs typeface="Arial" pitchFamily="34" charset="-120"/>
+              </a:rPr>
+              <a:t>Richtwerte für den Workshop. Pimcore 6 läuft bis zur Umstellung weiter; ein Fachbereich dient als Pilot.</a:t>
+            </a:r>
+            <a:endParaRPr lang="en-US" sz="1400" dirty="0"/>
+          </a:p>
+        </p:txBody>
+      </p:sp>
+      <p:sp>
+        <p:nvSpPr>
+          <p:cNvPr id="4" name="Text 2"/>
+          <p:cNvSpPr txBox="1"/>
+          <p:nvPr/>
+        </p:nvSpPr>
+        <p:spPr>
+          <a:xfrm>
+            <a:off x="548640" y="6400800"/>
+            <a:ext cx="7315200" cy="228600"/>
+          </a:xfrm>
+          <a:prstGeom prst="rect">
+            <a:avLst/>
+          </a:prstGeom>
+          <a:noFill/>
+          <a:ln/>
+        </p:spPr>
+        <p:txBody>
+          <a:bodyPr wrap="square" lIns="0" tIns="0" rIns="0" bIns="0" rtlCol="0" anchor="t"/>
+          <a:lstStyle/>
+          <a:p>
+            <a:pPr indent="0" marL="0">
+              <a:buNone/>
+            </a:pPr>
+            <a:r>
+              <a:rPr lang="en-US" sz="900" dirty="0">
+                <a:solidFill>
+                  <a:srgbClr val="4B5563"/>
+                </a:solidFill>
+                <a:latin typeface="Arial" pitchFamily="34" charset="0"/>
+                <a:ea typeface="Arial" pitchFamily="34" charset="-122"/>
+                <a:cs typeface="Arial" pitchFamily="34" charset="-120"/>
+              </a:rPr>
+              <a:t>anyPIM für Kohlhammer  ·  Entscheidungsvorlage  ·  September 2026</a:t>
+            </a:r>
+            <a:endParaRPr lang="en-US" sz="900" dirty="0"/>
+          </a:p>
+        </p:txBody>
+      </p:sp>
+      <p:sp>
+        <p:nvSpPr>
+          <p:cNvPr id="5" name="Text 3"/>
+          <p:cNvSpPr txBox="1"/>
+          <p:nvPr/>
+        </p:nvSpPr>
+        <p:spPr>
+          <a:xfrm>
+            <a:off x="10728655" y="6400800"/>
+            <a:ext cx="914400" cy="228600"/>
+          </a:xfrm>
+          <a:prstGeom prst="rect">
+            <a:avLst/>
+          </a:prstGeom>
+          <a:noFill/>
+          <a:ln/>
+        </p:spPr>
+        <p:txBody>
+          <a:bodyPr wrap="square" lIns="0" tIns="0" rIns="0" bIns="0" rtlCol="0" anchor="t"/>
+          <a:lstStyle/>
+          <a:p>
+            <a:pPr algn="r" indent="0" marL="0">
+              <a:buNone/>
+            </a:pPr>
+            <a:r>
+              <a:rPr lang="en-US" sz="900" dirty="0">
+                <a:solidFill>
+                  <a:srgbClr val="4B5563"/>
+                </a:solidFill>
+                <a:latin typeface="Arial" pitchFamily="34" charset="0"/>
+                <a:ea typeface="Arial" pitchFamily="34" charset="-122"/>
+                <a:cs typeface="Arial" pitchFamily="34" charset="-120"/>
+              </a:rPr>
+              <a:t>16</a:t>
+            </a:r>
+            <a:endParaRPr lang="en-US" sz="900" dirty="0"/>
+          </a:p>
+        </p:txBody>
+      </p:sp>
+      <p:sp>
+        <p:nvSpPr>
+          <p:cNvPr id="6" name="Shape 4"/>
+          <p:cNvSpPr/>
+          <p:nvPr/>
+        </p:nvSpPr>
+        <p:spPr>
+          <a:xfrm>
+            <a:off x="640080" y="2377440"/>
+            <a:ext cx="10911535" cy="0"/>
+          </a:xfrm>
+          <a:prstGeom prst="line">
+            <a:avLst/>
+          </a:prstGeom>
+          <a:noFill/>
+          <a:ln w="19050">
+            <a:solidFill>
+              <a:srgbClr val="1B2D5C"/>
+            </a:solidFill>
+            <a:prstDash val="solid"/>
+          </a:ln>
+        </p:spPr>
+      </p:sp>
+      <p:sp>
+        <p:nvSpPr>
+          <p:cNvPr id="7" name="Shape 5"/>
+          <p:cNvSpPr/>
+          <p:nvPr/>
+        </p:nvSpPr>
+        <p:spPr>
+          <a:xfrm>
+            <a:off x="548640" y="2240280"/>
+            <a:ext cx="274320" cy="274320"/>
+          </a:xfrm>
+          <a:prstGeom prst="rect">
+            <a:avLst/>
+          </a:prstGeom>
+          <a:solidFill>
+            <a:srgbClr val="000E2F"/>
+          </a:solidFill>
+          <a:ln w="12700">
+            <a:solidFill>
+              <a:srgbClr val="000E2F"/>
+            </a:solidFill>
+            <a:prstDash val="solid"/>
+          </a:ln>
+        </p:spPr>
+      </p:sp>
+      <p:sp>
+        <p:nvSpPr>
+          <p:cNvPr id="8" name="Text 6"/>
+          <p:cNvSpPr txBox="1"/>
+          <p:nvPr/>
+        </p:nvSpPr>
+        <p:spPr>
+          <a:xfrm>
+            <a:off x="548640" y="2788920"/>
+            <a:ext cx="2560320" cy="731520"/>
+          </a:xfrm>
+          <a:prstGeom prst="rect">
+            <a:avLst/>
+          </a:prstGeom>
+          <a:noFill/>
+          <a:ln/>
+        </p:spPr>
+        <p:txBody>
+          <a:bodyPr wrap="square" lIns="0" tIns="0" rIns="0" bIns="0" rtlCol="0" anchor="t"/>
+          <a:lstStyle/>
+          <a:p>
+            <a:pPr indent="0" marL="0">
+              <a:buNone/>
+            </a:pPr>
+            <a:r>
+              <a:rPr lang="en-US" sz="4000" dirty="0">
+                <a:solidFill>
+                  <a:srgbClr val="1B2D5C"/>
+                </a:solidFill>
+                <a:latin typeface="Arial" pitchFamily="34" charset="0"/>
+                <a:ea typeface="Arial" pitchFamily="34" charset="-122"/>
+                <a:cs typeface="Arial" pitchFamily="34" charset="-120"/>
+              </a:rPr>
+              <a:t>01</a:t>
+            </a:r>
+            <a:endParaRPr lang="en-US" sz="4000" dirty="0"/>
+          </a:p>
+        </p:txBody>
+      </p:sp>
+      <p:sp>
+        <p:nvSpPr>
+          <p:cNvPr id="9" name="Text 7"/>
+          <p:cNvSpPr txBox="1"/>
+          <p:nvPr/>
+        </p:nvSpPr>
+        <p:spPr>
+          <a:xfrm>
+            <a:off x="548640" y="3611880"/>
+            <a:ext cx="2560320" cy="256032"/>
+          </a:xfrm>
+          <a:prstGeom prst="rect">
+            <a:avLst/>
+          </a:prstGeom>
+          <a:noFill/>
+          <a:ln/>
+        </p:spPr>
+        <p:txBody>
+          <a:bodyPr wrap="square" lIns="0" tIns="0" rIns="0" bIns="0" rtlCol="0" anchor="t"/>
+          <a:lstStyle/>
+          <a:p>
+            <a:pPr indent="0" marL="0">
+              <a:buNone/>
+            </a:pPr>
+            <a:r>
+              <a:rPr lang="en-US" sz="1000" b="1" spc="100" kern="0" dirty="0">
+                <a:solidFill>
+                  <a:srgbClr val="4B5563"/>
+                </a:solidFill>
+                <a:latin typeface="Arial" pitchFamily="34" charset="0"/>
+                <a:ea typeface="Arial" pitchFamily="34" charset="-122"/>
+                <a:cs typeface="Arial" pitchFamily="34" charset="-120"/>
+              </a:rPr>
+              <a:t>CA. 2 WOCHEN</a:t>
+            </a:r>
+            <a:endParaRPr lang="en-US" sz="1000" dirty="0"/>
+          </a:p>
+        </p:txBody>
+      </p:sp>
+      <p:sp>
+        <p:nvSpPr>
+          <p:cNvPr id="10" name="Text 8"/>
+          <p:cNvSpPr txBox="1"/>
+          <p:nvPr/>
+        </p:nvSpPr>
+        <p:spPr>
+          <a:xfrm>
+            <a:off x="548640" y="3931920"/>
+            <a:ext cx="2560320" cy="384048"/>
+          </a:xfrm>
+          <a:prstGeom prst="rect">
+            <a:avLst/>
+          </a:prstGeom>
+          <a:noFill/>
+          <a:ln/>
+        </p:spPr>
+        <p:txBody>
+          <a:bodyPr wrap="square" lIns="0" tIns="0" rIns="0" bIns="0" rtlCol="0" anchor="t"/>
+          <a:lstStyle/>
+          <a:p>
+            <a:pPr indent="0" marL="0">
+              <a:buNone/>
+            </a:pPr>
+            <a:r>
+              <a:rPr lang="en-US" sz="1800" b="1" dirty="0">
+                <a:solidFill>
+                  <a:srgbClr val="16181D"/>
+                </a:solidFill>
+                <a:latin typeface="Arial" pitchFamily="34" charset="0"/>
+                <a:ea typeface="Arial" pitchFamily="34" charset="-122"/>
+                <a:cs typeface="Arial" pitchFamily="34" charset="-120"/>
+              </a:rPr>
+              <a:t>Bestandsaufnahme</a:t>
+            </a:r>
+            <a:endParaRPr lang="en-US" sz="1800" dirty="0"/>
+          </a:p>
+        </p:txBody>
+      </p:sp>
+      <p:sp>
+        <p:nvSpPr>
+          <p:cNvPr id="11" name="Text 9"/>
+          <p:cNvSpPr txBox="1"/>
+          <p:nvPr/>
+        </p:nvSpPr>
+        <p:spPr>
+          <a:xfrm>
+            <a:off x="548640" y="4434840"/>
+            <a:ext cx="2560320" cy="1737360"/>
+          </a:xfrm>
+          <a:prstGeom prst="rect">
+            <a:avLst/>
+          </a:prstGeom>
+          <a:noFill/>
+          <a:ln/>
+        </p:spPr>
+        <p:txBody>
+          <a:bodyPr wrap="square" lIns="0" tIns="0" rIns="0" bIns="0" rtlCol="0" anchor="t"/>
+          <a:lstStyle/>
+          <a:p>
+            <a:pPr indent="0" marL="0">
+              <a:lnSpc>
+                <a:spcPct val="112000"/>
+              </a:lnSpc>
+              <a:buNone/>
+            </a:pPr>
+            <a:r>
+              <a:rPr lang="en-US" sz="1400" dirty="0">
+                <a:solidFill>
+                  <a:srgbClr val="16181D"/>
+                </a:solidFill>
+                <a:latin typeface="Arial" pitchFamily="34" charset="0"/>
+                <a:ea typeface="Arial" pitchFamily="34" charset="-122"/>
+                <a:cs typeface="Arial" pitchFamily="34" charset="-120"/>
+              </a:rPr>
+              <a:t>Pimcore-6-Klassen, Eigenentwicklungen und Schnittstellen erfassen; Zielmodell mit Produkttypen, Attributen, Hierarchien und Ausgaben festlegen.</a:t>
+            </a:r>
+            <a:endParaRPr lang="en-US" sz="1400" dirty="0"/>
+          </a:p>
+        </p:txBody>
+      </p:sp>
+      <p:sp>
+        <p:nvSpPr>
+          <p:cNvPr id="12" name="Shape 10"/>
+          <p:cNvSpPr/>
+          <p:nvPr/>
+        </p:nvSpPr>
+        <p:spPr>
+          <a:xfrm>
+            <a:off x="3393338" y="2240280"/>
+            <a:ext cx="274320" cy="274320"/>
+          </a:xfrm>
+          <a:prstGeom prst="rect">
+            <a:avLst/>
+          </a:prstGeom>
+          <a:solidFill>
+            <a:srgbClr val="000E2F"/>
+          </a:solidFill>
+          <a:ln w="12700">
+            <a:solidFill>
+              <a:srgbClr val="000E2F"/>
+            </a:solidFill>
+            <a:prstDash val="solid"/>
+          </a:ln>
+        </p:spPr>
+      </p:sp>
+      <p:sp>
+        <p:nvSpPr>
+          <p:cNvPr id="13" name="Text 11"/>
+          <p:cNvSpPr txBox="1"/>
+          <p:nvPr/>
+        </p:nvSpPr>
+        <p:spPr>
+          <a:xfrm>
+            <a:off x="3393338" y="2788920"/>
+            <a:ext cx="2560320" cy="731520"/>
+          </a:xfrm>
+          <a:prstGeom prst="rect">
+            <a:avLst/>
+          </a:prstGeom>
+          <a:noFill/>
+          <a:ln/>
+        </p:spPr>
+        <p:txBody>
+          <a:bodyPr wrap="square" lIns="0" tIns="0" rIns="0" bIns="0" rtlCol="0" anchor="t"/>
+          <a:lstStyle/>
+          <a:p>
+            <a:pPr indent="0" marL="0">
+              <a:buNone/>
+            </a:pPr>
+            <a:r>
+              <a:rPr lang="en-US" sz="4000" dirty="0">
+                <a:solidFill>
+                  <a:srgbClr val="1B2D5C"/>
+                </a:solidFill>
+                <a:latin typeface="Arial" pitchFamily="34" charset="0"/>
+                <a:ea typeface="Arial" pitchFamily="34" charset="-122"/>
+                <a:cs typeface="Arial" pitchFamily="34" charset="-120"/>
+              </a:rPr>
+              <a:t>02</a:t>
+            </a:r>
+            <a:endParaRPr lang="en-US" sz="4000" dirty="0"/>
+          </a:p>
+        </p:txBody>
+      </p:sp>
+      <p:sp>
+        <p:nvSpPr>
+          <p:cNvPr id="14" name="Text 12"/>
+          <p:cNvSpPr txBox="1"/>
+          <p:nvPr/>
+        </p:nvSpPr>
+        <p:spPr>
+          <a:xfrm>
+            <a:off x="3393338" y="3611880"/>
+            <a:ext cx="2560320" cy="256032"/>
+          </a:xfrm>
+          <a:prstGeom prst="rect">
+            <a:avLst/>
+          </a:prstGeom>
+          <a:noFill/>
+          <a:ln/>
+        </p:spPr>
+        <p:txBody>
+          <a:bodyPr wrap="square" lIns="0" tIns="0" rIns="0" bIns="0" rtlCol="0" anchor="t"/>
+          <a:lstStyle/>
+          <a:p>
+            <a:pPr indent="0" marL="0">
+              <a:buNone/>
+            </a:pPr>
+            <a:r>
+              <a:rPr lang="en-US" sz="1000" b="1" spc="100" kern="0" dirty="0">
+                <a:solidFill>
+                  <a:srgbClr val="4B5563"/>
+                </a:solidFill>
+                <a:latin typeface="Arial" pitchFamily="34" charset="0"/>
+                <a:ea typeface="Arial" pitchFamily="34" charset="-122"/>
+                <a:cs typeface="Arial" pitchFamily="34" charset="-120"/>
+              </a:rPr>
+              <a:t>CA. 4 WOCHEN</a:t>
+            </a:r>
+            <a:endParaRPr lang="en-US" sz="1000" dirty="0"/>
+          </a:p>
+        </p:txBody>
+      </p:sp>
+      <p:sp>
+        <p:nvSpPr>
+          <p:cNvPr id="15" name="Text 13"/>
+          <p:cNvSpPr txBox="1"/>
+          <p:nvPr/>
+        </p:nvSpPr>
+        <p:spPr>
+          <a:xfrm>
+            <a:off x="3393338" y="3931920"/>
+            <a:ext cx="2560320" cy="384048"/>
+          </a:xfrm>
+          <a:prstGeom prst="rect">
+            <a:avLst/>
+          </a:prstGeom>
+          <a:noFill/>
+          <a:ln/>
+        </p:spPr>
+        <p:txBody>
+          <a:bodyPr wrap="square" lIns="0" tIns="0" rIns="0" bIns="0" rtlCol="0" anchor="t"/>
+          <a:lstStyle/>
+          <a:p>
+            <a:pPr indent="0" marL="0">
+              <a:buNone/>
+            </a:pPr>
+            <a:r>
+              <a:rPr lang="en-US" sz="1800" b="1" dirty="0">
+                <a:solidFill>
+                  <a:srgbClr val="16181D"/>
+                </a:solidFill>
+                <a:latin typeface="Arial" pitchFamily="34" charset="0"/>
+                <a:ea typeface="Arial" pitchFamily="34" charset="-122"/>
+                <a:cs typeface="Arial" pitchFamily="34" charset="-120"/>
+              </a:rPr>
+              <a:t>Pilot Brandschutz</a:t>
+            </a:r>
+            <a:endParaRPr lang="en-US" sz="1800" dirty="0"/>
+          </a:p>
+        </p:txBody>
+      </p:sp>
+      <p:sp>
+        <p:nvSpPr>
+          <p:cNvPr id="16" name="Text 14"/>
+          <p:cNvSpPr txBox="1"/>
+          <p:nvPr/>
+        </p:nvSpPr>
+        <p:spPr>
+          <a:xfrm>
+            <a:off x="3393338" y="4434840"/>
+            <a:ext cx="2560320" cy="1737360"/>
+          </a:xfrm>
+          <a:prstGeom prst="rect">
+            <a:avLst/>
+          </a:prstGeom>
+          <a:noFill/>
+          <a:ln/>
+        </p:spPr>
+        <p:txBody>
+          <a:bodyPr wrap="square" lIns="0" tIns="0" rIns="0" bIns="0" rtlCol="0" anchor="t"/>
+          <a:lstStyle/>
+          <a:p>
+            <a:pPr indent="0" marL="0">
+              <a:lnSpc>
+                <a:spcPct val="112000"/>
+              </a:lnSpc>
+              <a:buNone/>
+            </a:pPr>
+            <a:r>
+              <a:rPr lang="en-US" sz="1400" dirty="0">
+                <a:solidFill>
+                  <a:srgbClr val="16181D"/>
+                </a:solidFill>
+                <a:latin typeface="Arial" pitchFamily="34" charset="0"/>
+                <a:ea typeface="Arial" pitchFamily="34" charset="-122"/>
+                <a:cs typeface="Arial" pitchFamily="34" charset="-120"/>
+              </a:rPr>
+              <a:t>Titel des Fachbereichs aus Pimcore 6 übernehmen, Werk/Ausgabe-Struktur, Qualitätsprofile; Parallelbetrieb und Datenabgleich.</a:t>
+            </a:r>
+            <a:endParaRPr lang="en-US" sz="1400" dirty="0"/>
+          </a:p>
+        </p:txBody>
+      </p:sp>
+      <p:sp>
+        <p:nvSpPr>
+          <p:cNvPr id="17" name="Shape 15"/>
+          <p:cNvSpPr/>
+          <p:nvPr/>
+        </p:nvSpPr>
+        <p:spPr>
+          <a:xfrm>
+            <a:off x="6238037" y="2240280"/>
+            <a:ext cx="274320" cy="274320"/>
+          </a:xfrm>
+          <a:prstGeom prst="rect">
+            <a:avLst/>
+          </a:prstGeom>
+          <a:solidFill>
+            <a:srgbClr val="000E2F"/>
+          </a:solidFill>
+          <a:ln w="12700">
+            <a:solidFill>
+              <a:srgbClr val="000E2F"/>
+            </a:solidFill>
+            <a:prstDash val="solid"/>
+          </a:ln>
+        </p:spPr>
+      </p:sp>
+      <p:sp>
+        <p:nvSpPr>
+          <p:cNvPr id="18" name="Text 16"/>
+          <p:cNvSpPr txBox="1"/>
+          <p:nvPr/>
+        </p:nvSpPr>
+        <p:spPr>
+          <a:xfrm>
+            <a:off x="6238037" y="2788920"/>
+            <a:ext cx="2560320" cy="731520"/>
+          </a:xfrm>
+          <a:prstGeom prst="rect">
+            <a:avLst/>
+          </a:prstGeom>
+          <a:noFill/>
+          <a:ln/>
+        </p:spPr>
+        <p:txBody>
+          <a:bodyPr wrap="square" lIns="0" tIns="0" rIns="0" bIns="0" rtlCol="0" anchor="t"/>
+          <a:lstStyle/>
+          <a:p>
+            <a:pPr indent="0" marL="0">
+              <a:buNone/>
+            </a:pPr>
+            <a:r>
+              <a:rPr lang="en-US" sz="4000" dirty="0">
+                <a:solidFill>
+                  <a:srgbClr val="1B2D5C"/>
+                </a:solidFill>
+                <a:latin typeface="Arial" pitchFamily="34" charset="0"/>
+                <a:ea typeface="Arial" pitchFamily="34" charset="-122"/>
+                <a:cs typeface="Arial" pitchFamily="34" charset="-120"/>
+              </a:rPr>
+              <a:t>03</a:t>
+            </a:r>
+            <a:endParaRPr lang="en-US" sz="4000" dirty="0"/>
+          </a:p>
+        </p:txBody>
+      </p:sp>
+      <p:sp>
+        <p:nvSpPr>
+          <p:cNvPr id="19" name="Text 17"/>
+          <p:cNvSpPr txBox="1"/>
+          <p:nvPr/>
+        </p:nvSpPr>
+        <p:spPr>
+          <a:xfrm>
+            <a:off x="6238037" y="3611880"/>
+            <a:ext cx="2560320" cy="256032"/>
+          </a:xfrm>
+          <a:prstGeom prst="rect">
+            <a:avLst/>
+          </a:prstGeom>
+          <a:noFill/>
+          <a:ln/>
+        </p:spPr>
+        <p:txBody>
+          <a:bodyPr wrap="square" lIns="0" tIns="0" rIns="0" bIns="0" rtlCol="0" anchor="t"/>
+          <a:lstStyle/>
+          <a:p>
+            <a:pPr indent="0" marL="0">
+              <a:buNone/>
+            </a:pPr>
+            <a:r>
+              <a:rPr lang="en-US" sz="1000" b="1" spc="100" kern="0" dirty="0">
+                <a:solidFill>
+                  <a:srgbClr val="4B5563"/>
+                </a:solidFill>
+                <a:latin typeface="Arial" pitchFamily="34" charset="0"/>
+                <a:ea typeface="Arial" pitchFamily="34" charset="-122"/>
+                <a:cs typeface="Arial" pitchFamily="34" charset="-120"/>
+              </a:rPr>
+              <a:t>JE NACH UMFANG</a:t>
+            </a:r>
+            <a:endParaRPr lang="en-US" sz="1000" dirty="0"/>
+          </a:p>
+        </p:txBody>
+      </p:sp>
+      <p:sp>
+        <p:nvSpPr>
+          <p:cNvPr id="20" name="Text 18"/>
+          <p:cNvSpPr txBox="1"/>
+          <p:nvPr/>
+        </p:nvSpPr>
+        <p:spPr>
+          <a:xfrm>
+            <a:off x="6238037" y="3931920"/>
+            <a:ext cx="2560320" cy="384048"/>
+          </a:xfrm>
+          <a:prstGeom prst="rect">
+            <a:avLst/>
+          </a:prstGeom>
+          <a:noFill/>
+          <a:ln/>
+        </p:spPr>
+        <p:txBody>
+          <a:bodyPr wrap="square" lIns="0" tIns="0" rIns="0" bIns="0" rtlCol="0" anchor="t"/>
+          <a:lstStyle/>
+          <a:p>
+            <a:pPr indent="0" marL="0">
+              <a:buNone/>
+            </a:pPr>
+            <a:r>
+              <a:rPr lang="en-US" sz="1800" b="1" dirty="0">
+                <a:solidFill>
+                  <a:srgbClr val="16181D"/>
+                </a:solidFill>
+                <a:latin typeface="Arial" pitchFamily="34" charset="0"/>
+                <a:ea typeface="Arial" pitchFamily="34" charset="-122"/>
+                <a:cs typeface="Arial" pitchFamily="34" charset="-120"/>
+              </a:rPr>
+              <a:t>Projektanteil</a:t>
+            </a:r>
+            <a:endParaRPr lang="en-US" sz="1800" dirty="0"/>
+          </a:p>
+        </p:txBody>
+      </p:sp>
+      <p:sp>
+        <p:nvSpPr>
+          <p:cNvPr id="21" name="Text 19"/>
+          <p:cNvSpPr txBox="1"/>
+          <p:nvPr/>
+        </p:nvSpPr>
+        <p:spPr>
+          <a:xfrm>
+            <a:off x="6238037" y="4434840"/>
+            <a:ext cx="2560320" cy="1737360"/>
+          </a:xfrm>
+          <a:prstGeom prst="rect">
+            <a:avLst/>
+          </a:prstGeom>
+          <a:noFill/>
+          <a:ln/>
+        </p:spPr>
+        <p:txBody>
+          <a:bodyPr wrap="square" lIns="0" tIns="0" rIns="0" bIns="0" rtlCol="0" anchor="t"/>
+          <a:lstStyle/>
+          <a:p>
+            <a:pPr indent="0" marL="0">
+              <a:lnSpc>
+                <a:spcPct val="112000"/>
+              </a:lnSpc>
+              <a:buNone/>
+            </a:pPr>
+            <a:r>
+              <a:rPr lang="en-US" sz="1400" dirty="0">
+                <a:solidFill>
+                  <a:srgbClr val="16181D"/>
+                </a:solidFill>
+                <a:latin typeface="Arial" pitchFamily="34" charset="0"/>
+                <a:ea typeface="Arial" pitchFamily="34" charset="-122"/>
+                <a:cs typeface="Arial" pitchFamily="34" charset="-120"/>
+              </a:rPr>
+              <a:t>Fehlende Funktionen als Standard bauen – EasyCatalog-, Thieme- und ONIX-Export, Cover-Metadaten; Shop und Handel umstellen.</a:t>
+            </a:r>
+            <a:endParaRPr lang="en-US" sz="1400" dirty="0"/>
+          </a:p>
+        </p:txBody>
+      </p:sp>
+      <p:sp>
+        <p:nvSpPr>
+          <p:cNvPr id="22" name="Shape 20"/>
+          <p:cNvSpPr/>
+          <p:nvPr/>
+        </p:nvSpPr>
+        <p:spPr>
+          <a:xfrm>
+            <a:off x="9082735" y="2240280"/>
+            <a:ext cx="274320" cy="274320"/>
+          </a:xfrm>
+          <a:prstGeom prst="rect">
+            <a:avLst/>
+          </a:prstGeom>
+          <a:solidFill>
+            <a:srgbClr val="E2211C"/>
+          </a:solidFill>
+          <a:ln w="12700">
+            <a:solidFill>
+              <a:srgbClr val="E2211C"/>
+            </a:solidFill>
+            <a:prstDash val="solid"/>
+          </a:ln>
+        </p:spPr>
+      </p:sp>
+      <p:sp>
+        <p:nvSpPr>
+          <p:cNvPr id="23" name="Text 21"/>
+          <p:cNvSpPr txBox="1"/>
+          <p:nvPr/>
+        </p:nvSpPr>
+        <p:spPr>
+          <a:xfrm>
+            <a:off x="9082735" y="2788920"/>
+            <a:ext cx="2560320" cy="731520"/>
+          </a:xfrm>
+          <a:prstGeom prst="rect">
+            <a:avLst/>
+          </a:prstGeom>
+          <a:noFill/>
+          <a:ln/>
+        </p:spPr>
+        <p:txBody>
+          <a:bodyPr wrap="square" lIns="0" tIns="0" rIns="0" bIns="0" rtlCol="0" anchor="t"/>
+          <a:lstStyle/>
+          <a:p>
+            <a:pPr indent="0" marL="0">
+              <a:buNone/>
+            </a:pPr>
+            <a:r>
+              <a:rPr lang="en-US" sz="4000" dirty="0">
+                <a:solidFill>
+                  <a:srgbClr val="1B2D5C"/>
+                </a:solidFill>
+                <a:latin typeface="Arial" pitchFamily="34" charset="0"/>
+                <a:ea typeface="Arial" pitchFamily="34" charset="-122"/>
+                <a:cs typeface="Arial" pitchFamily="34" charset="-120"/>
+              </a:rPr>
+              <a:t>04</a:t>
+            </a:r>
+            <a:endParaRPr lang="en-US" sz="4000" dirty="0"/>
+          </a:p>
+        </p:txBody>
+      </p:sp>
+      <p:sp>
+        <p:nvSpPr>
+          <p:cNvPr id="24" name="Text 22"/>
+          <p:cNvSpPr txBox="1"/>
+          <p:nvPr/>
+        </p:nvSpPr>
+        <p:spPr>
+          <a:xfrm>
+            <a:off x="9082735" y="3611880"/>
+            <a:ext cx="2560320" cy="256032"/>
+          </a:xfrm>
+          <a:prstGeom prst="rect">
+            <a:avLst/>
+          </a:prstGeom>
+          <a:noFill/>
+          <a:ln/>
+        </p:spPr>
+        <p:txBody>
+          <a:bodyPr wrap="square" lIns="0" tIns="0" rIns="0" bIns="0" rtlCol="0" anchor="t"/>
+          <a:lstStyle/>
+          <a:p>
+            <a:pPr indent="0" marL="0">
+              <a:buNone/>
+            </a:pPr>
+            <a:r>
+              <a:rPr lang="en-US" sz="1000" b="1" spc="100" kern="0" dirty="0">
+                <a:solidFill>
+                  <a:srgbClr val="4B5563"/>
+                </a:solidFill>
+                <a:latin typeface="Arial" pitchFamily="34" charset="0"/>
+                <a:ea typeface="Arial" pitchFamily="34" charset="-122"/>
+                <a:cs typeface="Arial" pitchFamily="34" charset="-120"/>
+              </a:rPr>
+              <a:t>FORTLAUFEND</a:t>
+            </a:r>
+            <a:endParaRPr lang="en-US" sz="1000" dirty="0"/>
+          </a:p>
+        </p:txBody>
+      </p:sp>
+      <p:sp>
+        <p:nvSpPr>
+          <p:cNvPr id="25" name="Text 23"/>
+          <p:cNvSpPr txBox="1"/>
+          <p:nvPr/>
+        </p:nvSpPr>
+        <p:spPr>
+          <a:xfrm>
+            <a:off x="9082735" y="3931920"/>
+            <a:ext cx="2560320" cy="384048"/>
+          </a:xfrm>
+          <a:prstGeom prst="rect">
+            <a:avLst/>
+          </a:prstGeom>
+          <a:noFill/>
+          <a:ln/>
+        </p:spPr>
+        <p:txBody>
+          <a:bodyPr wrap="square" lIns="0" tIns="0" rIns="0" bIns="0" rtlCol="0" anchor="t"/>
+          <a:lstStyle/>
+          <a:p>
+            <a:pPr indent="0" marL="0">
+              <a:buNone/>
+            </a:pPr>
+            <a:r>
+              <a:rPr lang="en-US" sz="1800" b="1" dirty="0">
+                <a:solidFill>
+                  <a:srgbClr val="16181D"/>
+                </a:solidFill>
+                <a:latin typeface="Arial" pitchFamily="34" charset="0"/>
+                <a:ea typeface="Arial" pitchFamily="34" charset="-122"/>
+                <a:cs typeface="Arial" pitchFamily="34" charset="-120"/>
+              </a:rPr>
+              <a:t>Ablösung</a:t>
+            </a:r>
+            <a:endParaRPr lang="en-US" sz="1800" dirty="0"/>
+          </a:p>
+        </p:txBody>
+      </p:sp>
+      <p:sp>
+        <p:nvSpPr>
+          <p:cNvPr id="26" name="Text 24"/>
+          <p:cNvSpPr txBox="1"/>
+          <p:nvPr/>
+        </p:nvSpPr>
+        <p:spPr>
+          <a:xfrm>
+            <a:off x="9082735" y="4434840"/>
+            <a:ext cx="2560320" cy="1737360"/>
+          </a:xfrm>
+          <a:prstGeom prst="rect">
+            <a:avLst/>
+          </a:prstGeom>
+          <a:noFill/>
+          <a:ln/>
+        </p:spPr>
+        <p:txBody>
+          <a:bodyPr wrap="square" lIns="0" tIns="0" rIns="0" bIns="0" rtlCol="0" anchor="t"/>
+          <a:lstStyle/>
+          <a:p>
+            <a:pPr indent="0" marL="0">
+              <a:lnSpc>
+                <a:spcPct val="112000"/>
+              </a:lnSpc>
+              <a:buNone/>
+            </a:pPr>
+            <a:r>
+              <a:rPr lang="en-US" sz="1400" dirty="0">
+                <a:solidFill>
+                  <a:srgbClr val="16181D"/>
+                </a:solidFill>
+                <a:latin typeface="Arial" pitchFamily="34" charset="0"/>
+                <a:ea typeface="Arial" pitchFamily="34" charset="-122"/>
+                <a:cs typeface="Arial" pitchFamily="34" charset="-120"/>
+              </a:rPr>
+              <a:t>Weitere Fachbereiche, Zeitschriften, Formulare und Seminare; Schulung der Redaktionen; Abschaltung von Pimcore 6.</a:t>
+            </a:r>
+            <a:endParaRPr lang="en-US" sz="1400" dirty="0"/>
+          </a:p>
+        </p:txBody>
+      </p:sp>
+    </p:spTree>
+  </p:cSld>
+  <p:clrMapOvr>
+    <a:masterClrMapping/>
+  </p:clrMapOvr>
+</p:sld>
+</file>
+
+<file path=ppt/slides/slide17.xml><?xml version="1.0" encoding="utf-8"?>
+<p:sld xmlns:a="http://schemas.openxmlformats.org/drawingml/2006/main" xmlns:r="http://schemas.openxmlformats.org/officeDocument/2006/relationships" xmlns:p="http://schemas.openxmlformats.org/presentationml/2006/main">
+  <p:cSld name="Slide 17">
     <p:bg>
       <p:bgPr>
         <a:solidFill>

</xml_diff>

<commit_message>
Sales: Schlussfolie 'Befähigung ist sexy!' für die Kohlhammer-Vorlage
Abschluss in Anlehnung an den Kohlhammer-Claim: Mitgestalten, Verstehen,
Unabhängig bleiben. 'Nächster Schritt' auf weißem Hintergrund.

Co-Authored-By: Claude Opus 5.5 <noreply@anthropic.com>
Claude-Session: https://claude.ai/code/session_019qs2qjmit64azXVvXyRtsJ
</commit_message>
<xml_diff>
--- a/docs/sales/kohlhammer-anypim-vs-pimcore.pptx
+++ b/docs/sales/kohlhammer-anypim-vs-pimcore.pptx
@@ -22,9 +22,10 @@
     <p:sldId id="270" r:id="rId16"/>
     <p:sldId id="271" r:id="rId17"/>
     <p:sldId id="272" r:id="rId18"/>
+    <p:sldId id="273" r:id="rId19"/>
   </p:sldIdLst>
   <p:notesMasterIdLst>
-    <p:notesMasterId r:id="rId19"/>
+    <p:notesMasterId r:id="rId20"/>
   </p:notesMasterIdLst>
   <p:sldSz cx="12192000" cy="6858000"/>
   <p:notesSz cx="6858000" cy="12192000"/>
@@ -1246,6 +1247,94 @@
             <a:fld id="{F7021451-1387-4CA6-816F-3879F97B5CBC}" type="slidenum">
               <a:rPr lang="en-US"/>
               <a:t>17</a:t>
+            </a:fld>
+            <a:endParaRPr lang="en-US"/>
+          </a:p>
+        </p:txBody>
+      </p:sp>
+    </p:spTree>
+    <p:extLst>
+      <p:ext uri="{BB962C8B-B14F-4D97-AF65-F5344CB8AC3E}">
+        <p14:creationId xmlns:p14="http://schemas.microsoft.com/office/powerpoint/2010/main" val="1024086991"/>
+      </p:ext>
+    </p:extLst>
+  </p:cSld>
+  <p:clrMapOvr>
+    <a:masterClrMapping/>
+  </p:clrMapOvr>
+</p:notes>
+</file>
+
+<file path=ppt/notesSlides/notesSlide18.xml><?xml version="1.0" encoding="utf-8"?>
+<p:notes xmlns:a="http://schemas.openxmlformats.org/drawingml/2006/main" xmlns:r="http://schemas.openxmlformats.org/officeDocument/2006/relationships" xmlns:p="http://schemas.openxmlformats.org/presentationml/2006/main">
+  <p:cSld>
+    <p:spTree>
+      <p:nvGrpSpPr>
+        <p:cNvPr id="1" name=""/>
+        <p:cNvGrpSpPr/>
+        <p:nvPr/>
+      </p:nvGrpSpPr>
+      <p:grpSpPr>
+        <a:xfrm>
+          <a:off x="0" y="0"/>
+          <a:ext cx="0" cy="0"/>
+          <a:chOff x="0" y="0"/>
+          <a:chExt cx="0" cy="0"/>
+        </a:xfrm>
+      </p:grpSpPr>
+      <p:sp>
+        <p:nvSpPr>
+          <p:cNvPr id="2" name="Slide Image Placeholder 1"/>
+          <p:cNvSpPr>
+            <a:spLocks noGrp="1" noRot="1" noChangeAspect="1"/>
+          </p:cNvSpPr>
+          <p:nvPr>
+            <p:ph type="sldImg"/>
+          </p:nvPr>
+        </p:nvSpPr>
+        <p:spPr/>
+      </p:sp>
+      <p:sp>
+        <p:nvSpPr>
+          <p:cNvPr id="3" name="Notes Placeholder 2"/>
+          <p:cNvSpPr>
+            <a:spLocks noGrp="1"/>
+          </p:cNvSpPr>
+          <p:nvPr>
+            <p:ph type="body" idx="1"/>
+          </p:nvPr>
+        </p:nvSpPr>
+        <p:spPr/>
+        <p:txBody>
+          <a:bodyPr/>
+          <a:lstStyle/>
+          <a:p>
+            <a:r>
+              <a:rPr lang="en-US" dirty="0"/>
+              <a:t>Schlussfolgerung in Anlehnung an den Kohlhammer-Claim „Wissen ist sexy!“: Befähigung ist sexy. Kohlhammer bekommt nicht nur ein neues System, sondern die Fähigkeit, es mitzugestalten, zu verstehen und unabhängig zu bleiben.</a:t>
+            </a:r>
+            <a:endParaRPr lang="en-US" dirty="0"/>
+          </a:p>
+        </p:txBody>
+      </p:sp>
+      <p:sp>
+        <p:nvSpPr>
+          <p:cNvPr id="4" name="Slide Number Placeholder 3"/>
+          <p:cNvSpPr>
+            <a:spLocks noGrp="1"/>
+          </p:cNvSpPr>
+          <p:nvPr>
+            <p:ph type="sldNum" sz="quarter" idx="10"/>
+          </p:nvPr>
+        </p:nvSpPr>
+        <p:spPr/>
+        <p:txBody>
+          <a:bodyPr/>
+          <a:lstStyle/>
+          <a:p>
+            <a:fld id="{F7021451-1387-4CA6-816F-3879F97B5CBC}" type="slidenum">
+              <a:rPr lang="en-US"/>
+              <a:t>18</a:t>
             </a:fld>
             <a:endParaRPr lang="en-US"/>
           </a:p>
@@ -14030,6 +14119,222 @@
     <p:bg>
       <p:bgPr>
         <a:solidFill>
+          <a:srgbClr val="FFFFFF"/>
+        </a:solidFill>
+      </p:bgPr>
+    </p:bg>
+    <p:spTree>
+      <p:nvGrpSpPr>
+        <p:cNvPr id="1" name=""/>
+        <p:cNvGrpSpPr/>
+        <p:nvPr/>
+      </p:nvGrpSpPr>
+      <p:grpSpPr>
+        <a:xfrm>
+          <a:off x="0" y="0"/>
+          <a:ext cx="0" cy="0"/>
+          <a:chOff x="0" y="0"/>
+          <a:chExt cx="0" cy="0"/>
+        </a:xfrm>
+      </p:grpSpPr>
+      <p:sp>
+        <p:nvSpPr>
+          <p:cNvPr id="2" name="Text 0"/>
+          <p:cNvSpPr txBox="1"/>
+          <p:nvPr/>
+        </p:nvSpPr>
+        <p:spPr>
+          <a:xfrm>
+            <a:off x="548640" y="1188720"/>
+            <a:ext cx="11094415" cy="731520"/>
+          </a:xfrm>
+          <a:prstGeom prst="rect">
+            <a:avLst/>
+          </a:prstGeom>
+          <a:noFill/>
+          <a:ln/>
+        </p:spPr>
+        <p:txBody>
+          <a:bodyPr wrap="square" lIns="0" tIns="0" rIns="0" bIns="0" rtlCol="0" anchor="t"/>
+          <a:lstStyle/>
+          <a:p>
+            <a:pPr algn="ctr" indent="0" marL="0">
+              <a:buNone/>
+            </a:pPr>
+            <a:r>
+              <a:rPr lang="en-US" sz="4000" dirty="0">
+                <a:solidFill>
+                  <a:srgbClr val="16181D"/>
+                </a:solidFill>
+                <a:latin typeface="Arial" pitchFamily="34" charset="0"/>
+                <a:ea typeface="Arial" pitchFamily="34" charset="-122"/>
+                <a:cs typeface="Arial" pitchFamily="34" charset="-120"/>
+              </a:rPr>
+              <a:t>NÄCHSTER SCHRITT</a:t>
+            </a:r>
+            <a:endParaRPr lang="en-US" sz="4000" dirty="0"/>
+          </a:p>
+        </p:txBody>
+      </p:sp>
+      <p:sp>
+        <p:nvSpPr>
+          <p:cNvPr id="3" name="Text 1"/>
+          <p:cNvSpPr txBox="1"/>
+          <p:nvPr/>
+        </p:nvSpPr>
+        <p:spPr>
+          <a:xfrm>
+            <a:off x="2194560" y="2194560"/>
+            <a:ext cx="7802575" cy="1371600"/>
+          </a:xfrm>
+          <a:prstGeom prst="rect">
+            <a:avLst/>
+          </a:prstGeom>
+          <a:noFill/>
+          <a:ln/>
+        </p:spPr>
+        <p:txBody>
+          <a:bodyPr wrap="square" lIns="0" tIns="0" rIns="0" bIns="0" rtlCol="0" anchor="t"/>
+          <a:lstStyle/>
+          <a:p>
+            <a:pPr algn="ctr" indent="0" marL="0">
+              <a:lnSpc>
+                <a:spcPct val="115000"/>
+              </a:lnSpc>
+              <a:buNone/>
+            </a:pPr>
+            <a:r>
+              <a:rPr lang="en-US" sz="1700" dirty="0">
+                <a:solidFill>
+                  <a:srgbClr val="22303C"/>
+                </a:solidFill>
+                <a:latin typeface="Arial" pitchFamily="34" charset="0"/>
+                <a:ea typeface="Arial" pitchFamily="34" charset="-122"/>
+                <a:cs typeface="Arial" pitchFamily="34" charset="-120"/>
+              </a:rPr>
+              <a:t>Ein halbtägiger Workshop mit Lektorat, Herstellung, Vertrieb und IT – danach ein Pilot mit dem Fachbereich Brandschutz auf echten Titeldaten aus Pimcore 6. Das Ergebnis ist eine belastbare Grundlage für die Entscheidung zwischen Upgrade und Wechsel.</a:t>
+            </a:r>
+            <a:endParaRPr lang="en-US" sz="1700" dirty="0"/>
+          </a:p>
+        </p:txBody>
+      </p:sp>
+      <p:sp>
+        <p:nvSpPr>
+          <p:cNvPr id="4" name="Shape 2"/>
+          <p:cNvSpPr/>
+          <p:nvPr/>
+        </p:nvSpPr>
+        <p:spPr>
+          <a:xfrm>
+            <a:off x="4175608" y="3886200"/>
+            <a:ext cx="3840480" cy="731520"/>
+          </a:xfrm>
+          <a:prstGeom prst="rect">
+            <a:avLst/>
+          </a:prstGeom>
+          <a:solidFill>
+            <a:srgbClr val="1B2D5C"/>
+          </a:solidFill>
+          <a:ln w="12700">
+            <a:solidFill>
+              <a:srgbClr val="1B2D5C"/>
+            </a:solidFill>
+            <a:prstDash val="solid"/>
+          </a:ln>
+        </p:spPr>
+      </p:sp>
+      <p:sp>
+        <p:nvSpPr>
+          <p:cNvPr id="5" name="Text 3"/>
+          <p:cNvSpPr txBox="1"/>
+          <p:nvPr/>
+        </p:nvSpPr>
+        <p:spPr>
+          <a:xfrm>
+            <a:off x="4175608" y="3886200"/>
+            <a:ext cx="3840480" cy="731520"/>
+          </a:xfrm>
+          <a:prstGeom prst="rect">
+            <a:avLst/>
+          </a:prstGeom>
+          <a:noFill/>
+          <a:ln/>
+        </p:spPr>
+        <p:txBody>
+          <a:bodyPr wrap="square" lIns="0" tIns="0" rIns="0" bIns="0" rtlCol="0" anchor="ctr"/>
+          <a:lstStyle/>
+          <a:p>
+            <a:pPr algn="ctr" indent="0" marL="0">
+              <a:buNone/>
+            </a:pPr>
+            <a:r>
+              <a:rPr lang="en-US" sz="2000" dirty="0">
+                <a:solidFill>
+                  <a:srgbClr val="FFFFFF"/>
+                </a:solidFill>
+                <a:latin typeface="Arial" pitchFamily="34" charset="0"/>
+                <a:ea typeface="Arial" pitchFamily="34" charset="-122"/>
+                <a:cs typeface="Arial" pitchFamily="34" charset="-120"/>
+              </a:rPr>
+              <a:t>Workshop vereinbaren   →</a:t>
+            </a:r>
+            <a:endParaRPr lang="en-US" sz="2000" dirty="0"/>
+          </a:p>
+        </p:txBody>
+      </p:sp>
+      <p:sp>
+        <p:nvSpPr>
+          <p:cNvPr id="6" name="Text 4"/>
+          <p:cNvSpPr txBox="1"/>
+          <p:nvPr/>
+        </p:nvSpPr>
+        <p:spPr>
+          <a:xfrm>
+            <a:off x="548640" y="5760720"/>
+            <a:ext cx="11094415" cy="731520"/>
+          </a:xfrm>
+          <a:prstGeom prst="rect">
+            <a:avLst/>
+          </a:prstGeom>
+          <a:noFill/>
+          <a:ln/>
+        </p:spPr>
+        <p:txBody>
+          <a:bodyPr wrap="square" lIns="0" tIns="0" rIns="0" bIns="0" rtlCol="0" anchor="t"/>
+          <a:lstStyle/>
+          <a:p>
+            <a:pPr algn="ctr" indent="0" marL="0">
+              <a:buNone/>
+            </a:pPr>
+            <a:r>
+              <a:rPr lang="en-US" sz="900" dirty="0">
+                <a:solidFill>
+                  <a:srgbClr val="4B5563"/>
+                </a:solidFill>
+                <a:latin typeface="Arial" pitchFamily="34" charset="0"/>
+                <a:ea typeface="Arial" pitchFamily="34" charset="-122"/>
+                <a:cs typeface="Arial" pitchFamily="34" charset="-120"/>
+              </a:rPr>
+              <a:t>Entscheidungsvorlage der incoxx GmbH, Stand September 2026. Keine Veröffentlichung der W. Kohlhammer GmbH; „Kohlhammer“ ist eine Marke der W. Kohlhammer GmbH. Titelbeispiel nach den im Kohlhammer-Shop angezeigten Angaben. Angaben zu Pimcore nach öffentlich verfügbaren Informationen (pimcore.com: Blog „Pimcore says goodbye to GPL … POCL“, Community Edition, Enterprise Open Core); aktuelle Lizenzkonditionen vor einer Entscheidung beim Hersteller prüfen.</a:t>
+            </a:r>
+            <a:endParaRPr lang="en-US" sz="900" dirty="0"/>
+          </a:p>
+        </p:txBody>
+      </p:sp>
+    </p:spTree>
+  </p:cSld>
+  <p:clrMapOvr>
+    <a:masterClrMapping/>
+  </p:clrMapOvr>
+</p:sld>
+</file>
+
+<file path=ppt/slides/slide18.xml><?xml version="1.0" encoding="utf-8"?>
+<p:sld xmlns:a="http://schemas.openxmlformats.org/drawingml/2006/main" xmlns:r="http://schemas.openxmlformats.org/officeDocument/2006/relationships" xmlns:p="http://schemas.openxmlformats.org/presentationml/2006/main">
+  <p:cSld name="Slide 18">
+    <p:bg>
+      <p:bgPr>
+        <a:solidFill>
           <a:srgbClr val="C6E6E3"/>
         </a:solidFill>
       </p:bgPr>
@@ -14050,105 +14355,24 @@
       </p:grpSpPr>
       <p:sp>
         <p:nvSpPr>
-          <p:cNvPr id="2" name="Text 0"/>
-          <p:cNvSpPr txBox="1"/>
-          <p:nvPr/>
-        </p:nvSpPr>
-        <p:spPr>
-          <a:xfrm>
-            <a:off x="548640" y="1188720"/>
-            <a:ext cx="11094415" cy="731520"/>
-          </a:xfrm>
-          <a:prstGeom prst="rect">
-            <a:avLst/>
-          </a:prstGeom>
-          <a:noFill/>
-          <a:ln/>
-        </p:spPr>
-        <p:txBody>
-          <a:bodyPr wrap="square" lIns="0" tIns="0" rIns="0" bIns="0" rtlCol="0" anchor="t"/>
-          <a:lstStyle/>
-          <a:p>
-            <a:pPr algn="ctr" indent="0" marL="0">
-              <a:buNone/>
-            </a:pPr>
-            <a:r>
-              <a:rPr lang="en-US" sz="4000" dirty="0">
-                <a:solidFill>
-                  <a:srgbClr val="16181D"/>
-                </a:solidFill>
-                <a:latin typeface="Arial" pitchFamily="34" charset="0"/>
-                <a:ea typeface="Arial" pitchFamily="34" charset="-122"/>
-                <a:cs typeface="Arial" pitchFamily="34" charset="-120"/>
-              </a:rPr>
-              <a:t>NÄCHSTER SCHRITT</a:t>
-            </a:r>
-            <a:endParaRPr lang="en-US" sz="4000" dirty="0"/>
-          </a:p>
-        </p:txBody>
-      </p:sp>
-      <p:sp>
-        <p:nvSpPr>
-          <p:cNvPr id="3" name="Text 1"/>
-          <p:cNvSpPr txBox="1"/>
-          <p:nvPr/>
-        </p:nvSpPr>
-        <p:spPr>
-          <a:xfrm>
-            <a:off x="2194560" y="2194560"/>
-            <a:ext cx="7802575" cy="1371600"/>
-          </a:xfrm>
-          <a:prstGeom prst="rect">
-            <a:avLst/>
-          </a:prstGeom>
-          <a:noFill/>
-          <a:ln/>
-        </p:spPr>
-        <p:txBody>
-          <a:bodyPr wrap="square" lIns="0" tIns="0" rIns="0" bIns="0" rtlCol="0" anchor="t"/>
-          <a:lstStyle/>
-          <a:p>
-            <a:pPr algn="ctr" indent="0" marL="0">
-              <a:lnSpc>
-                <a:spcPct val="115000"/>
-              </a:lnSpc>
-              <a:buNone/>
-            </a:pPr>
-            <a:r>
-              <a:rPr lang="en-US" sz="1700" dirty="0">
-                <a:solidFill>
-                  <a:srgbClr val="22303C"/>
-                </a:solidFill>
-                <a:latin typeface="Arial" pitchFamily="34" charset="0"/>
-                <a:ea typeface="Arial" pitchFamily="34" charset="-122"/>
-                <a:cs typeface="Arial" pitchFamily="34" charset="-120"/>
-              </a:rPr>
-              <a:t>Ein halbtägiger Workshop mit Lektorat, Herstellung, Vertrieb und IT – danach ein Pilot mit dem Fachbereich Brandschutz auf echten Titeldaten aus Pimcore 6. Das Ergebnis ist eine belastbare Grundlage für die Entscheidung zwischen Upgrade und Wechsel.</a:t>
-            </a:r>
-            <a:endParaRPr lang="en-US" sz="1700" dirty="0"/>
-          </a:p>
-        </p:txBody>
-      </p:sp>
-      <p:sp>
-        <p:nvSpPr>
-          <p:cNvPr id="4" name="Shape 2"/>
+          <p:cNvPr id="2" name="Shape 0"/>
           <p:cNvSpPr/>
           <p:nvPr/>
         </p:nvSpPr>
         <p:spPr>
           <a:xfrm>
-            <a:off x="4175608" y="3886200"/>
-            <a:ext cx="3840480" cy="731520"/>
+            <a:off x="0" y="0"/>
+            <a:ext cx="12191695" cy="868680"/>
           </a:xfrm>
           <a:prstGeom prst="rect">
             <a:avLst/>
           </a:prstGeom>
           <a:solidFill>
-            <a:srgbClr val="1B2D5C"/>
+            <a:srgbClr val="000E2F"/>
           </a:solidFill>
           <a:ln w="12700">
             <a:solidFill>
-              <a:srgbClr val="1B2D5C"/>
+              <a:srgbClr val="000E2F"/>
             </a:solidFill>
             <a:prstDash val="solid"/>
           </a:ln>
@@ -14156,53 +14380,106 @@
       </p:sp>
       <p:sp>
         <p:nvSpPr>
+          <p:cNvPr id="3" name="Text 1"/>
+          <p:cNvSpPr txBox="1"/>
+          <p:nvPr/>
+        </p:nvSpPr>
+        <p:spPr>
+          <a:xfrm>
+            <a:off x="548640" y="0"/>
+            <a:ext cx="7315200" cy="868680"/>
+          </a:xfrm>
+          <a:prstGeom prst="rect">
+            <a:avLst/>
+          </a:prstGeom>
+          <a:noFill/>
+          <a:ln/>
+        </p:spPr>
+        <p:txBody>
+          <a:bodyPr wrap="square" lIns="0" tIns="0" rIns="0" bIns="0" rtlCol="0" anchor="ctr"/>
+          <a:lstStyle/>
+          <a:p>
+            <a:pPr indent="0" marL="0">
+              <a:buNone/>
+            </a:pPr>
+            <a:r>
+              <a:rPr lang="en-US" sz="2400" b="1" dirty="0">
+                <a:solidFill>
+                  <a:srgbClr val="FFFFFF"/>
+                </a:solidFill>
+                <a:latin typeface="Arial" pitchFamily="34" charset="0"/>
+                <a:ea typeface="Arial" pitchFamily="34" charset="-122"/>
+                <a:cs typeface="Arial" pitchFamily="34" charset="-120"/>
+              </a:rPr>
+              <a:t>anyPIM</a:t>
+            </a:r>
+            <a:pPr indent="0" marL="0">
+              <a:buNone/>
+            </a:pPr>
+            <a:r>
+              <a:rPr lang="en-US" sz="2400" dirty="0">
+                <a:solidFill>
+                  <a:srgbClr val="FFFFFF"/>
+                </a:solidFill>
+                <a:latin typeface="Arial" pitchFamily="34" charset="0"/>
+                <a:ea typeface="Arial" pitchFamily="34" charset="-122"/>
+                <a:cs typeface="Arial" pitchFamily="34" charset="-120"/>
+              </a:rPr>
+              <a:t>  für Kohlhammer</a:t>
+            </a:r>
+            <a:endParaRPr lang="en-US" sz="2400" dirty="0"/>
+          </a:p>
+        </p:txBody>
+      </p:sp>
+      <p:sp>
+        <p:nvSpPr>
+          <p:cNvPr id="4" name="Text 2"/>
+          <p:cNvSpPr txBox="1"/>
+          <p:nvPr/>
+        </p:nvSpPr>
+        <p:spPr>
+          <a:xfrm>
+            <a:off x="2834640" y="1325880"/>
+            <a:ext cx="7315200" cy="914400"/>
+          </a:xfrm>
+          <a:prstGeom prst="rect">
+            <a:avLst/>
+          </a:prstGeom>
+          <a:noFill/>
+          <a:ln/>
+        </p:spPr>
+        <p:txBody>
+          <a:bodyPr wrap="square" lIns="0" tIns="0" rIns="0" bIns="0" rtlCol="0" anchor="t"/>
+          <a:lstStyle/>
+          <a:p>
+            <a:pPr indent="0" marL="0">
+              <a:buNone/>
+            </a:pPr>
+            <a:r>
+              <a:rPr lang="en-US" sz="5800" dirty="0">
+                <a:solidFill>
+                  <a:srgbClr val="2B3050"/>
+                </a:solidFill>
+                <a:latin typeface="Arial" pitchFamily="34" charset="0"/>
+                <a:ea typeface="Arial" pitchFamily="34" charset="-122"/>
+                <a:cs typeface="Arial" pitchFamily="34" charset="-120"/>
+              </a:rPr>
+              <a:t>Befähigung ist</a:t>
+            </a:r>
+            <a:endParaRPr lang="en-US" sz="5800" dirty="0"/>
+          </a:p>
+        </p:txBody>
+      </p:sp>
+      <p:sp>
+        <p:nvSpPr>
           <p:cNvPr id="5" name="Text 3"/>
           <p:cNvSpPr txBox="1"/>
           <p:nvPr/>
         </p:nvSpPr>
         <p:spPr>
           <a:xfrm>
-            <a:off x="4175608" y="3886200"/>
-            <a:ext cx="3840480" cy="731520"/>
-          </a:xfrm>
-          <a:prstGeom prst="rect">
-            <a:avLst/>
-          </a:prstGeom>
-          <a:noFill/>
-          <a:ln/>
-        </p:spPr>
-        <p:txBody>
-          <a:bodyPr wrap="square" lIns="0" tIns="0" rIns="0" bIns="0" rtlCol="0" anchor="ctr"/>
-          <a:lstStyle/>
-          <a:p>
-            <a:pPr algn="ctr" indent="0" marL="0">
-              <a:buNone/>
-            </a:pPr>
-            <a:r>
-              <a:rPr lang="en-US" sz="2000" dirty="0">
-                <a:solidFill>
-                  <a:srgbClr val="FFFFFF"/>
-                </a:solidFill>
-                <a:latin typeface="Arial" pitchFamily="34" charset="0"/>
-                <a:ea typeface="Arial" pitchFamily="34" charset="-122"/>
-                <a:cs typeface="Arial" pitchFamily="34" charset="-120"/>
-              </a:rPr>
-              <a:t>Workshop vereinbaren   →</a:t>
-            </a:r>
-            <a:endParaRPr lang="en-US" sz="2000" dirty="0"/>
-          </a:p>
-        </p:txBody>
-      </p:sp>
-      <p:sp>
-        <p:nvSpPr>
-          <p:cNvPr id="6" name="Text 4"/>
-          <p:cNvSpPr txBox="1"/>
-          <p:nvPr/>
-        </p:nvSpPr>
-        <p:spPr>
-          <a:xfrm>
-            <a:off x="548640" y="5760720"/>
-            <a:ext cx="11094415" cy="731520"/>
+            <a:off x="2286000" y="1965960"/>
+            <a:ext cx="7315200" cy="2103120"/>
           </a:xfrm>
           <a:prstGeom prst="rect">
             <a:avLst/>
@@ -14214,21 +14491,339 @@
           <a:bodyPr wrap="square" lIns="0" tIns="0" rIns="0" bIns="0" rtlCol="0" anchor="t"/>
           <a:lstStyle/>
           <a:p>
-            <a:pPr algn="ctr" indent="0" marL="0">
-              <a:buNone/>
-            </a:pPr>
-            <a:r>
-              <a:rPr lang="en-US" sz="900" dirty="0">
-                <a:solidFill>
-                  <a:srgbClr val="4B5563"/>
-                </a:solidFill>
-                <a:latin typeface="Arial" pitchFamily="34" charset="0"/>
-                <a:ea typeface="Arial" pitchFamily="34" charset="-122"/>
-                <a:cs typeface="Arial" pitchFamily="34" charset="-120"/>
-              </a:rPr>
-              <a:t>Entscheidungsvorlage der incoxx GmbH, Stand September 2026. Keine Veröffentlichung der W. Kohlhammer GmbH; „Kohlhammer“ ist eine Marke der W. Kohlhammer GmbH. Titelbeispiel nach den im Kohlhammer-Shop angezeigten Angaben. Angaben zu Pimcore nach öffentlich verfügbaren Informationen (pimcore.com: Blog „Pimcore says goodbye to GPL … POCL“, Community Edition, Enterprise Open Core); aktuelle Lizenzkonditionen vor einer Entscheidung beim Hersteller prüfen.</a:t>
-            </a:r>
-            <a:endParaRPr lang="en-US" sz="900" dirty="0"/>
+            <a:pPr indent="0" marL="0">
+              <a:buNone/>
+            </a:pPr>
+            <a:r>
+              <a:rPr lang="en-US" sz="15000" dirty="0">
+                <a:solidFill>
+                  <a:srgbClr val="2B3050"/>
+                </a:solidFill>
+                <a:latin typeface="Arial" pitchFamily="34" charset="0"/>
+                <a:ea typeface="Arial" pitchFamily="34" charset="-122"/>
+                <a:cs typeface="Arial" pitchFamily="34" charset="-120"/>
+              </a:rPr>
+              <a:t>sexy!</a:t>
+            </a:r>
+            <a:endParaRPr lang="en-US" sz="15000" dirty="0"/>
+          </a:p>
+        </p:txBody>
+      </p:sp>
+      <p:sp>
+        <p:nvSpPr>
+          <p:cNvPr id="6" name="Shape 4"/>
+          <p:cNvSpPr/>
+          <p:nvPr/>
+        </p:nvSpPr>
+        <p:spPr>
+          <a:xfrm>
+            <a:off x="548640" y="5056632"/>
+            <a:ext cx="182880" cy="182880"/>
+          </a:xfrm>
+          <a:prstGeom prst="rect">
+            <a:avLst/>
+          </a:prstGeom>
+          <a:solidFill>
+            <a:srgbClr val="000E2F"/>
+          </a:solidFill>
+          <a:ln w="12700">
+            <a:solidFill>
+              <a:srgbClr val="000E2F"/>
+            </a:solidFill>
+            <a:prstDash val="solid"/>
+          </a:ln>
+        </p:spPr>
+      </p:sp>
+      <p:sp>
+        <p:nvSpPr>
+          <p:cNvPr id="7" name="Text 5"/>
+          <p:cNvSpPr txBox="1"/>
+          <p:nvPr/>
+        </p:nvSpPr>
+        <p:spPr>
+          <a:xfrm>
+            <a:off x="914400" y="4983480"/>
+            <a:ext cx="3154680" cy="365760"/>
+          </a:xfrm>
+          <a:prstGeom prst="rect">
+            <a:avLst/>
+          </a:prstGeom>
+          <a:noFill/>
+          <a:ln/>
+        </p:spPr>
+        <p:txBody>
+          <a:bodyPr wrap="square" lIns="0" tIns="0" rIns="0" bIns="0" rtlCol="0" anchor="t"/>
+          <a:lstStyle/>
+          <a:p>
+            <a:pPr indent="0" marL="0">
+              <a:buNone/>
+            </a:pPr>
+            <a:r>
+              <a:rPr lang="en-US" sz="1700" b="1" dirty="0">
+                <a:solidFill>
+                  <a:srgbClr val="000E2F"/>
+                </a:solidFill>
+                <a:latin typeface="Arial" pitchFamily="34" charset="0"/>
+                <a:ea typeface="Arial" pitchFamily="34" charset="-122"/>
+                <a:cs typeface="Arial" pitchFamily="34" charset="-120"/>
+              </a:rPr>
+              <a:t>Mitgestalten</a:t>
+            </a:r>
+            <a:endParaRPr lang="en-US" sz="1700" dirty="0"/>
+          </a:p>
+        </p:txBody>
+      </p:sp>
+      <p:sp>
+        <p:nvSpPr>
+          <p:cNvPr id="8" name="Text 6"/>
+          <p:cNvSpPr txBox="1"/>
+          <p:nvPr/>
+        </p:nvSpPr>
+        <p:spPr>
+          <a:xfrm>
+            <a:off x="914400" y="5394960"/>
+            <a:ext cx="3154680" cy="822960"/>
+          </a:xfrm>
+          <a:prstGeom prst="rect">
+            <a:avLst/>
+          </a:prstGeom>
+          <a:noFill/>
+          <a:ln/>
+        </p:spPr>
+        <p:txBody>
+          <a:bodyPr wrap="square" lIns="0" tIns="0" rIns="0" bIns="0" rtlCol="0" anchor="t"/>
+          <a:lstStyle/>
+          <a:p>
+            <a:pPr indent="0" marL="0">
+              <a:lnSpc>
+                <a:spcPct val="110000"/>
+              </a:lnSpc>
+              <a:buNone/>
+            </a:pPr>
+            <a:r>
+              <a:rPr lang="en-US" sz="1300" dirty="0">
+                <a:solidFill>
+                  <a:srgbClr val="22303C"/>
+                </a:solidFill>
+                <a:latin typeface="Arial" pitchFamily="34" charset="0"/>
+                <a:ea typeface="Arial" pitchFamily="34" charset="-122"/>
+                <a:cs typeface="Arial" pitchFamily="34" charset="-120"/>
+              </a:rPr>
+              <a:t>Kohlhammer bringt Anforderungen ein – sie werden Standard im Produkt.</a:t>
+            </a:r>
+            <a:endParaRPr lang="en-US" sz="1300" dirty="0"/>
+          </a:p>
+        </p:txBody>
+      </p:sp>
+      <p:sp>
+        <p:nvSpPr>
+          <p:cNvPr id="9" name="Shape 7"/>
+          <p:cNvSpPr/>
+          <p:nvPr/>
+        </p:nvSpPr>
+        <p:spPr>
+          <a:xfrm>
+            <a:off x="4335628" y="5056632"/>
+            <a:ext cx="182880" cy="182880"/>
+          </a:xfrm>
+          <a:prstGeom prst="rect">
+            <a:avLst/>
+          </a:prstGeom>
+          <a:solidFill>
+            <a:srgbClr val="000E2F"/>
+          </a:solidFill>
+          <a:ln w="12700">
+            <a:solidFill>
+              <a:srgbClr val="000E2F"/>
+            </a:solidFill>
+            <a:prstDash val="solid"/>
+          </a:ln>
+        </p:spPr>
+      </p:sp>
+      <p:sp>
+        <p:nvSpPr>
+          <p:cNvPr id="10" name="Text 8"/>
+          <p:cNvSpPr txBox="1"/>
+          <p:nvPr/>
+        </p:nvSpPr>
+        <p:spPr>
+          <a:xfrm>
+            <a:off x="4701388" y="4983480"/>
+            <a:ext cx="3154680" cy="365760"/>
+          </a:xfrm>
+          <a:prstGeom prst="rect">
+            <a:avLst/>
+          </a:prstGeom>
+          <a:noFill/>
+          <a:ln/>
+        </p:spPr>
+        <p:txBody>
+          <a:bodyPr wrap="square" lIns="0" tIns="0" rIns="0" bIns="0" rtlCol="0" anchor="t"/>
+          <a:lstStyle/>
+          <a:p>
+            <a:pPr indent="0" marL="0">
+              <a:buNone/>
+            </a:pPr>
+            <a:r>
+              <a:rPr lang="en-US" sz="1700" b="1" dirty="0">
+                <a:solidFill>
+                  <a:srgbClr val="000E2F"/>
+                </a:solidFill>
+                <a:latin typeface="Arial" pitchFamily="34" charset="0"/>
+                <a:ea typeface="Arial" pitchFamily="34" charset="-122"/>
+                <a:cs typeface="Arial" pitchFamily="34" charset="-120"/>
+              </a:rPr>
+              <a:t>Verstehen</a:t>
+            </a:r>
+            <a:endParaRPr lang="en-US" sz="1700" dirty="0"/>
+          </a:p>
+        </p:txBody>
+      </p:sp>
+      <p:sp>
+        <p:nvSpPr>
+          <p:cNvPr id="11" name="Text 9"/>
+          <p:cNvSpPr txBox="1"/>
+          <p:nvPr/>
+        </p:nvSpPr>
+        <p:spPr>
+          <a:xfrm>
+            <a:off x="4701388" y="5394960"/>
+            <a:ext cx="3154680" cy="822960"/>
+          </a:xfrm>
+          <a:prstGeom prst="rect">
+            <a:avLst/>
+          </a:prstGeom>
+          <a:noFill/>
+          <a:ln/>
+        </p:spPr>
+        <p:txBody>
+          <a:bodyPr wrap="square" lIns="0" tIns="0" rIns="0" bIns="0" rtlCol="0" anchor="t"/>
+          <a:lstStyle/>
+          <a:p>
+            <a:pPr indent="0" marL="0">
+              <a:lnSpc>
+                <a:spcPct val="110000"/>
+              </a:lnSpc>
+              <a:buNone/>
+            </a:pPr>
+            <a:r>
+              <a:rPr lang="en-US" sz="1300" dirty="0">
+                <a:solidFill>
+                  <a:srgbClr val="22303C"/>
+                </a:solidFill>
+                <a:latin typeface="Arial" pitchFamily="34" charset="0"/>
+                <a:ea typeface="Arial" pitchFamily="34" charset="-122"/>
+                <a:cs typeface="Arial" pitchFamily="34" charset="-120"/>
+              </a:rPr>
+              <a:t>Mit Claude und GitHub bleibt nachvollziehbar, was das System tut – ohne Code zu lesen.</a:t>
+            </a:r>
+            <a:endParaRPr lang="en-US" sz="1300" dirty="0"/>
+          </a:p>
+        </p:txBody>
+      </p:sp>
+      <p:sp>
+        <p:nvSpPr>
+          <p:cNvPr id="12" name="Shape 10"/>
+          <p:cNvSpPr/>
+          <p:nvPr/>
+        </p:nvSpPr>
+        <p:spPr>
+          <a:xfrm>
+            <a:off x="8122615" y="5056632"/>
+            <a:ext cx="182880" cy="182880"/>
+          </a:xfrm>
+          <a:prstGeom prst="rect">
+            <a:avLst/>
+          </a:prstGeom>
+          <a:solidFill>
+            <a:srgbClr val="000E2F"/>
+          </a:solidFill>
+          <a:ln w="12700">
+            <a:solidFill>
+              <a:srgbClr val="000E2F"/>
+            </a:solidFill>
+            <a:prstDash val="solid"/>
+          </a:ln>
+        </p:spPr>
+      </p:sp>
+      <p:sp>
+        <p:nvSpPr>
+          <p:cNvPr id="13" name="Text 11"/>
+          <p:cNvSpPr txBox="1"/>
+          <p:nvPr/>
+        </p:nvSpPr>
+        <p:spPr>
+          <a:xfrm>
+            <a:off x="8488375" y="4983480"/>
+            <a:ext cx="3154680" cy="365760"/>
+          </a:xfrm>
+          <a:prstGeom prst="rect">
+            <a:avLst/>
+          </a:prstGeom>
+          <a:noFill/>
+          <a:ln/>
+        </p:spPr>
+        <p:txBody>
+          <a:bodyPr wrap="square" lIns="0" tIns="0" rIns="0" bIns="0" rtlCol="0" anchor="t"/>
+          <a:lstStyle/>
+          <a:p>
+            <a:pPr indent="0" marL="0">
+              <a:buNone/>
+            </a:pPr>
+            <a:r>
+              <a:rPr lang="en-US" sz="1700" b="1" dirty="0">
+                <a:solidFill>
+                  <a:srgbClr val="000E2F"/>
+                </a:solidFill>
+                <a:latin typeface="Arial" pitchFamily="34" charset="0"/>
+                <a:ea typeface="Arial" pitchFamily="34" charset="-122"/>
+                <a:cs typeface="Arial" pitchFamily="34" charset="-120"/>
+              </a:rPr>
+              <a:t>Unabhängig bleiben</a:t>
+            </a:r>
+            <a:endParaRPr lang="en-US" sz="1700" dirty="0"/>
+          </a:p>
+        </p:txBody>
+      </p:sp>
+      <p:sp>
+        <p:nvSpPr>
+          <p:cNvPr id="14" name="Text 12"/>
+          <p:cNvSpPr txBox="1"/>
+          <p:nvPr/>
+        </p:nvSpPr>
+        <p:spPr>
+          <a:xfrm>
+            <a:off x="8488375" y="5394960"/>
+            <a:ext cx="3154680" cy="822960"/>
+          </a:xfrm>
+          <a:prstGeom prst="rect">
+            <a:avLst/>
+          </a:prstGeom>
+          <a:noFill/>
+          <a:ln/>
+        </p:spPr>
+        <p:txBody>
+          <a:bodyPr wrap="square" lIns="0" tIns="0" rIns="0" bIns="0" rtlCol="0" anchor="t"/>
+          <a:lstStyle/>
+          <a:p>
+            <a:pPr indent="0" marL="0">
+              <a:lnSpc>
+                <a:spcPct val="110000"/>
+              </a:lnSpc>
+              <a:buNone/>
+            </a:pPr>
+            <a:r>
+              <a:rPr lang="en-US" sz="1300" dirty="0">
+                <a:solidFill>
+                  <a:srgbClr val="22303C"/>
+                </a:solidFill>
+                <a:latin typeface="Arial" pitchFamily="34" charset="0"/>
+                <a:ea typeface="Arial" pitchFamily="34" charset="-122"/>
+                <a:cs typeface="Arial" pitchFamily="34" charset="-120"/>
+              </a:rPr>
+              <a:t>Wissen im Repository, offener Code, schlanker Betrieb.</a:t>
+            </a:r>
+            <a:endParaRPr lang="en-US" sz="1300" dirty="0"/>
           </a:p>
         </p:txBody>
       </p:sp>

</xml_diff>